<commit_message>
Los decks de clase llevan solo el tema: taller y actividades evaluativas quedan en la carpeta
Co-Authored-By: Claude Opus 5.5 <noreply@anthropic.com>
</commit_message>
<xml_diff>
--- a/Arquitectura de Sistemas Computacionales/Clases/Clase 1 - Introduccion a arquitecturas cloud/Presentacion.pptx
+++ b/Arquitectura de Sistemas Computacionales/Clases/Clase 1 - Introduccion a arquitecturas cloud/Presentacion.pptx
@@ -12,27 +12,22 @@
     <p:sldId id="260" r:id="rId11"/>
     <p:sldId id="261" r:id="rId12"/>
     <p:sldId id="262" r:id="rId13"/>
-    <p:sldId id="263" r:id="rId14"/>
-    <p:sldId id="264" r:id="rId15"/>
-    <p:sldId id="265" r:id="rId16"/>
-    <p:sldId id="266" r:id="rId17"/>
-    <p:sldId id="267" r:id="rId18"/>
-    <p:sldId id="268" r:id="rId19"/>
-    <p:sldId id="269" r:id="rId20"/>
-    <p:sldId id="270" r:id="rId21"/>
-    <p:sldId id="271" r:id="rId22"/>
-    <p:sldId id="272" r:id="rId23"/>
-    <p:sldId id="273" r:id="rId24"/>
-    <p:sldId id="274" r:id="rId25"/>
-    <p:sldId id="275" r:id="rId26"/>
-    <p:sldId id="276" r:id="rId27"/>
-    <p:sldId id="277" r:id="rId28"/>
-    <p:sldId id="278" r:id="rId29"/>
-    <p:sldId id="279" r:id="rId30"/>
-    <p:sldId id="280" r:id="rId31"/>
-    <p:sldId id="281" r:id="rId32"/>
-    <p:sldId id="282" r:id="rId33"/>
-    <p:sldId id="283" r:id="rId34"/>
+    <p:sldId id="263" r:id="rId15"/>
+    <p:sldId id="264" r:id="rId16"/>
+    <p:sldId id="265" r:id="rId17"/>
+    <p:sldId id="266" r:id="rId18"/>
+    <p:sldId id="267" r:id="rId19"/>
+    <p:sldId id="268" r:id="rId20"/>
+    <p:sldId id="269" r:id="rId21"/>
+    <p:sldId id="270" r:id="rId22"/>
+    <p:sldId id="271" r:id="rId23"/>
+    <p:sldId id="272" r:id="rId24"/>
+    <p:sldId id="273" r:id="rId25"/>
+    <p:sldId id="274" r:id="rId26"/>
+    <p:sldId id="275" r:id="rId27"/>
+    <p:sldId id="276" r:id="rId28"/>
+    <p:sldId id="277" r:id="rId29"/>
+    <p:sldId id="278" r:id="rId30"/>
   </p:sldIdLst>
   <p:sldSz cx="12191695" cy="6858000" type="screen4x3"/>
   <p:notesSz cx="6858000" cy="9144000"/>
@@ -132,6 +127,766 @@
     </a:lvl9pPr>
   </p:defaultTextStyle>
 </p:presentation>
+</file>
+
+<file path=ppt/notesMasters/notesMaster1.xml><?xml version="1.0" encoding="utf-8"?>
+<p:notesMaster xmlns:a="http://schemas.openxmlformats.org/drawingml/2006/main" xmlns:p="http://schemas.openxmlformats.org/presentationml/2006/main" xmlns:r="http://schemas.openxmlformats.org/officeDocument/2006/relationships">
+  <p:cSld>
+    <p:bg>
+      <p:bgRef idx="1001">
+        <a:schemeClr val="bg1"/>
+      </p:bgRef>
+    </p:bg>
+    <p:spTree>
+      <p:nvGrpSpPr>
+        <p:cNvPr id="1" name=""/>
+        <p:cNvGrpSpPr/>
+        <p:nvPr/>
+      </p:nvGrpSpPr>
+      <p:grpSpPr>
+        <a:xfrm>
+          <a:off x="0" y="0"/>
+          <a:ext cx="0" cy="0"/>
+          <a:chOff x="0" y="0"/>
+          <a:chExt cx="0" cy="0"/>
+        </a:xfrm>
+      </p:grpSpPr>
+      <p:sp>
+        <p:nvSpPr>
+          <p:cNvPr id="2" name="Header Placeholder 1"/>
+          <p:cNvSpPr>
+            <a:spLocks noGrp="1"/>
+          </p:cNvSpPr>
+          <p:nvPr>
+            <p:ph type="hdr" sz="quarter"/>
+          </p:nvPr>
+        </p:nvSpPr>
+        <p:spPr>
+          <a:xfrm>
+            <a:off x="0" y="0"/>
+            <a:ext cx="2971800" cy="457200"/>
+          </a:xfrm>
+          <a:prstGeom prst="rect">
+            <a:avLst/>
+          </a:prstGeom>
+        </p:spPr>
+        <p:txBody>
+          <a:bodyPr vert="horz" lIns="91440" tIns="45720" rIns="91440" bIns="45720" rtlCol="0"/>
+          <a:lstStyle>
+            <a:lvl1pPr algn="l">
+              <a:defRPr sz="1200"/>
+            </a:lvl1pPr>
+          </a:lstStyle>
+          <a:p>
+            <a:endParaRPr lang="en-US"/>
+          </a:p>
+        </p:txBody>
+      </p:sp>
+      <p:sp>
+        <p:nvSpPr>
+          <p:cNvPr id="3" name="Date Placeholder 2"/>
+          <p:cNvSpPr>
+            <a:spLocks noGrp="1"/>
+          </p:cNvSpPr>
+          <p:nvPr>
+            <p:ph type="dt" idx="1"/>
+          </p:nvPr>
+        </p:nvSpPr>
+        <p:spPr>
+          <a:xfrm>
+            <a:off x="3884613" y="0"/>
+            <a:ext cx="2971800" cy="457200"/>
+          </a:xfrm>
+          <a:prstGeom prst="rect">
+            <a:avLst/>
+          </a:prstGeom>
+        </p:spPr>
+        <p:txBody>
+          <a:bodyPr vert="horz" lIns="91440" tIns="45720" rIns="91440" bIns="45720" rtlCol="0"/>
+          <a:lstStyle>
+            <a:lvl1pPr algn="r">
+              <a:defRPr sz="1200"/>
+            </a:lvl1pPr>
+          </a:lstStyle>
+          <a:p>
+            <a:fld id="{0F89C1C7-3DCD-1040-A9CF-14679D8B5DDD}" type="datetimeFigureOut">
+              <a:rPr lang="en-US" smtClean="0"/>
+              <a:t>10/17/16</a:t>
+            </a:fld>
+            <a:endParaRPr lang="en-US"/>
+          </a:p>
+        </p:txBody>
+      </p:sp>
+      <p:sp>
+        <p:nvSpPr>
+          <p:cNvPr id="4" name="Slide Image Placeholder 3"/>
+          <p:cNvSpPr>
+            <a:spLocks noGrp="1" noRot="1" noChangeAspect="1"/>
+          </p:cNvSpPr>
+          <p:nvPr>
+            <p:ph type="sldImg" idx="2"/>
+          </p:nvPr>
+        </p:nvSpPr>
+        <p:spPr>
+          <a:xfrm>
+            <a:off x="1143000" y="685800"/>
+            <a:ext cx="4572000" cy="3429000"/>
+          </a:xfrm>
+          <a:prstGeom prst="rect">
+            <a:avLst/>
+          </a:prstGeom>
+          <a:noFill/>
+          <a:ln w="12700">
+            <a:solidFill>
+              <a:prstClr val="black"/>
+            </a:solidFill>
+          </a:ln>
+        </p:spPr>
+        <p:txBody>
+          <a:bodyPr vert="horz" lIns="91440" tIns="45720" rIns="91440" bIns="45720" rtlCol="0" anchor="ctr"/>
+          <a:lstStyle/>
+          <a:p>
+            <a:endParaRPr lang="en-US"/>
+          </a:p>
+        </p:txBody>
+      </p:sp>
+      <p:sp>
+        <p:nvSpPr>
+          <p:cNvPr id="5" name="Notes Placeholder 4"/>
+          <p:cNvSpPr>
+            <a:spLocks noGrp="1"/>
+          </p:cNvSpPr>
+          <p:nvPr>
+            <p:ph type="body" sz="quarter" idx="3"/>
+          </p:nvPr>
+        </p:nvSpPr>
+        <p:spPr>
+          <a:xfrm>
+            <a:off x="685800" y="4343400"/>
+            <a:ext cx="5486400" cy="4114800"/>
+          </a:xfrm>
+          <a:prstGeom prst="rect">
+            <a:avLst/>
+          </a:prstGeom>
+        </p:spPr>
+        <p:txBody>
+          <a:bodyPr vert="horz" lIns="91440" tIns="45720" rIns="91440" bIns="45720" rtlCol="0"/>
+          <a:lstStyle/>
+          <a:p>
+            <a:pPr lvl="0"/>
+            <a:r>
+              <a:rPr lang="en-US" smtClean="0"/>
+              <a:t>Click to edit Master text styles</a:t>
+            </a:r>
+          </a:p>
+          <a:p>
+            <a:pPr lvl="1"/>
+            <a:r>
+              <a:rPr lang="en-US" smtClean="0"/>
+              <a:t>Second level</a:t>
+            </a:r>
+          </a:p>
+          <a:p>
+            <a:pPr lvl="2"/>
+            <a:r>
+              <a:rPr lang="en-US" smtClean="0"/>
+              <a:t>Third level</a:t>
+            </a:r>
+          </a:p>
+          <a:p>
+            <a:pPr lvl="3"/>
+            <a:r>
+              <a:rPr lang="en-US" smtClean="0"/>
+              <a:t>Fourth level</a:t>
+            </a:r>
+          </a:p>
+          <a:p>
+            <a:pPr lvl="4"/>
+            <a:r>
+              <a:rPr lang="en-US" smtClean="0"/>
+              <a:t>Fifth level</a:t>
+            </a:r>
+            <a:endParaRPr lang="en-US"/>
+          </a:p>
+        </p:txBody>
+      </p:sp>
+      <p:sp>
+        <p:nvSpPr>
+          <p:cNvPr id="6" name="Footer Placeholder 5"/>
+          <p:cNvSpPr>
+            <a:spLocks noGrp="1"/>
+          </p:cNvSpPr>
+          <p:nvPr>
+            <p:ph type="ftr" sz="quarter" idx="4"/>
+          </p:nvPr>
+        </p:nvSpPr>
+        <p:spPr>
+          <a:xfrm>
+            <a:off x="0" y="8685213"/>
+            <a:ext cx="2971800" cy="457200"/>
+          </a:xfrm>
+          <a:prstGeom prst="rect">
+            <a:avLst/>
+          </a:prstGeom>
+        </p:spPr>
+        <p:txBody>
+          <a:bodyPr vert="horz" lIns="91440" tIns="45720" rIns="91440" bIns="45720" rtlCol="0" anchor="b"/>
+          <a:lstStyle>
+            <a:lvl1pPr algn="l">
+              <a:defRPr sz="1200"/>
+            </a:lvl1pPr>
+          </a:lstStyle>
+          <a:p>
+            <a:endParaRPr lang="en-US"/>
+          </a:p>
+        </p:txBody>
+      </p:sp>
+      <p:sp>
+        <p:nvSpPr>
+          <p:cNvPr id="7" name="Slide Number Placeholder 6"/>
+          <p:cNvSpPr>
+            <a:spLocks noGrp="1"/>
+          </p:cNvSpPr>
+          <p:nvPr>
+            <p:ph type="sldNum" sz="quarter" idx="5"/>
+          </p:nvPr>
+        </p:nvSpPr>
+        <p:spPr>
+          <a:xfrm>
+            <a:off x="3884613" y="8685213"/>
+            <a:ext cx="2971800" cy="457200"/>
+          </a:xfrm>
+          <a:prstGeom prst="rect">
+            <a:avLst/>
+          </a:prstGeom>
+        </p:spPr>
+        <p:txBody>
+          <a:bodyPr vert="horz" lIns="91440" tIns="45720" rIns="91440" bIns="45720" rtlCol="0" anchor="b"/>
+          <a:lstStyle>
+            <a:lvl1pPr algn="r">
+              <a:defRPr sz="1200"/>
+            </a:lvl1pPr>
+          </a:lstStyle>
+          <a:p>
+            <a:fld id="{BB5E49A5-4136-284D-997B-48E1D791AD67}" type="slidenum">
+              <a:rPr lang="en-US" smtClean="0"/>
+              <a:t>‹#›</a:t>
+            </a:fld>
+            <a:endParaRPr lang="en-US"/>
+          </a:p>
+        </p:txBody>
+      </p:sp>
+    </p:spTree>
+    <p:extLst>
+      <p:ext uri="{BB962C8B-B14F-4D97-AF65-F5344CB8AC3E}">
+        <p14:creationId xmlns:p14="http://schemas.microsoft.com/office/powerpoint/2010/main" val="2623252185"/>
+      </p:ext>
+    </p:extLst>
+  </p:cSld>
+  <p:clrMap bg1="lt1" tx1="dk1" bg2="lt2" tx2="dk2" accent1="accent1" accent2="accent2" accent3="accent3" accent4="accent4" accent5="accent5" accent6="accent6" hlink="hlink" folHlink="folHlink"/>
+  <p:notesStyle>
+    <a:lvl1pPr marL="0" algn="l" defTabSz="457200" rtl="0" eaLnBrk="1" latinLnBrk="0" hangingPunct="1">
+      <a:defRPr sz="1200" kern="1200">
+        <a:solidFill>
+          <a:schemeClr val="tx1"/>
+        </a:solidFill>
+        <a:latin typeface="+mn-lt"/>
+        <a:ea typeface="+mn-ea"/>
+        <a:cs typeface="+mn-cs"/>
+      </a:defRPr>
+    </a:lvl1pPr>
+    <a:lvl2pPr marL="457200" algn="l" defTabSz="457200" rtl="0" eaLnBrk="1" latinLnBrk="0" hangingPunct="1">
+      <a:defRPr sz="1200" kern="1200">
+        <a:solidFill>
+          <a:schemeClr val="tx1"/>
+        </a:solidFill>
+        <a:latin typeface="+mn-lt"/>
+        <a:ea typeface="+mn-ea"/>
+        <a:cs typeface="+mn-cs"/>
+      </a:defRPr>
+    </a:lvl2pPr>
+    <a:lvl3pPr marL="914400" algn="l" defTabSz="457200" rtl="0" eaLnBrk="1" latinLnBrk="0" hangingPunct="1">
+      <a:defRPr sz="1200" kern="1200">
+        <a:solidFill>
+          <a:schemeClr val="tx1"/>
+        </a:solidFill>
+        <a:latin typeface="+mn-lt"/>
+        <a:ea typeface="+mn-ea"/>
+        <a:cs typeface="+mn-cs"/>
+      </a:defRPr>
+    </a:lvl3pPr>
+    <a:lvl4pPr marL="1371600" algn="l" defTabSz="457200" rtl="0" eaLnBrk="1" latinLnBrk="0" hangingPunct="1">
+      <a:defRPr sz="1200" kern="1200">
+        <a:solidFill>
+          <a:schemeClr val="tx1"/>
+        </a:solidFill>
+        <a:latin typeface="+mn-lt"/>
+        <a:ea typeface="+mn-ea"/>
+        <a:cs typeface="+mn-cs"/>
+      </a:defRPr>
+    </a:lvl4pPr>
+    <a:lvl5pPr marL="1828800" algn="l" defTabSz="457200" rtl="0" eaLnBrk="1" latinLnBrk="0" hangingPunct="1">
+      <a:defRPr sz="1200" kern="1200">
+        <a:solidFill>
+          <a:schemeClr val="tx1"/>
+        </a:solidFill>
+        <a:latin typeface="+mn-lt"/>
+        <a:ea typeface="+mn-ea"/>
+        <a:cs typeface="+mn-cs"/>
+      </a:defRPr>
+    </a:lvl5pPr>
+    <a:lvl6pPr marL="2286000" algn="l" defTabSz="457200" rtl="0" eaLnBrk="1" latinLnBrk="0" hangingPunct="1">
+      <a:defRPr sz="1200" kern="1200">
+        <a:solidFill>
+          <a:schemeClr val="tx1"/>
+        </a:solidFill>
+        <a:latin typeface="+mn-lt"/>
+        <a:ea typeface="+mn-ea"/>
+        <a:cs typeface="+mn-cs"/>
+      </a:defRPr>
+    </a:lvl6pPr>
+    <a:lvl7pPr marL="2743200" algn="l" defTabSz="457200" rtl="0" eaLnBrk="1" latinLnBrk="0" hangingPunct="1">
+      <a:defRPr sz="1200" kern="1200">
+        <a:solidFill>
+          <a:schemeClr val="tx1"/>
+        </a:solidFill>
+        <a:latin typeface="+mn-lt"/>
+        <a:ea typeface="+mn-ea"/>
+        <a:cs typeface="+mn-cs"/>
+      </a:defRPr>
+    </a:lvl7pPr>
+    <a:lvl8pPr marL="3200400" algn="l" defTabSz="457200" rtl="0" eaLnBrk="1" latinLnBrk="0" hangingPunct="1">
+      <a:defRPr sz="1200" kern="1200">
+        <a:solidFill>
+          <a:schemeClr val="tx1"/>
+        </a:solidFill>
+        <a:latin typeface="+mn-lt"/>
+        <a:ea typeface="+mn-ea"/>
+        <a:cs typeface="+mn-cs"/>
+      </a:defRPr>
+    </a:lvl8pPr>
+    <a:lvl9pPr marL="3657600" algn="l" defTabSz="457200" rtl="0" eaLnBrk="1" latinLnBrk="0" hangingPunct="1">
+      <a:defRPr sz="1200" kern="1200">
+        <a:solidFill>
+          <a:schemeClr val="tx1"/>
+        </a:solidFill>
+        <a:latin typeface="+mn-lt"/>
+        <a:ea typeface="+mn-ea"/>
+        <a:cs typeface="+mn-cs"/>
+      </a:defRPr>
+    </a:lvl9pPr>
+  </p:notesStyle>
+</p:notesMaster>
+</file>
+
+<file path=ppt/notesSlides/notesSlide1.xml><?xml version="1.0" encoding="utf-8"?>
+<p:notes xmlns:a="http://schemas.openxmlformats.org/drawingml/2006/main" xmlns:p="http://schemas.openxmlformats.org/presentationml/2006/main" xmlns:r="http://schemas.openxmlformats.org/officeDocument/2006/relationships">
+  <p:cSld>
+    <p:spTree>
+      <p:nvGrpSpPr>
+        <p:cNvPr id="1" name=""/>
+        <p:cNvGrpSpPr/>
+        <p:nvPr/>
+      </p:nvGrpSpPr>
+      <p:grpSpPr>
+        <a:xfrm>
+          <a:off x="0" y="0"/>
+          <a:ext cx="0" cy="0"/>
+          <a:chOff x="0" y="0"/>
+          <a:chExt cx="0" cy="0"/>
+        </a:xfrm>
+      </p:grpSpPr>
+      <p:sp>
+        <p:nvSpPr>
+          <p:cNvPr id="2" name="Slide Image Placeholder 1"/>
+          <p:cNvSpPr>
+            <a:spLocks noGrp="1"/>
+          </p:cNvSpPr>
+          <p:nvPr>
+            <p:ph type="sldImg" idx="2"/>
+          </p:nvPr>
+        </p:nvSpPr>
+        <p:spPr/>
+      </p:sp>
+      <p:sp>
+        <p:nvSpPr>
+          <p:cNvPr id="3" name="Notes Placeholder 2"/>
+          <p:cNvSpPr>
+            <a:spLocks noGrp="1"/>
+          </p:cNvSpPr>
+          <p:nvPr>
+            <p:ph type="body" idx="3" sz="quarter"/>
+          </p:nvPr>
+        </p:nvSpPr>
+        <p:spPr/>
+        <p:txBody>
+          <a:bodyPr/>
+          <a:lstStyle/>
+          <a:p>
+            <a:r>
+              <a:t>DOMINIO fija en una linea el problema de negocio elegido (AgendaU, BiblioLite, InventarioLab, TurnosClinica, EventosCampus u otro del mismo tamano); un dominio generico (una red social, una tienda en linea sin mas detalle) hace imposible evaluar las decisiones de las clases siguientes, porque no hay nada concreto que arquitecturar.</a:t>
+            </a:r>
+          </a:p>
+          <a:p/>
+          <a:p>
+            <a:r>
+              <a:t>SISTEMAS EXTERNOS es el bloque nuevo de este semestre: dos o tres sistemas de terceros con los que CloudLite intercambia informacion (un proveedor de identidad, un servicio de correo, una pasarela de pagos); es exactamente lo que despues aparece como System_Ext en el diagrama C4 Context de la pregunta 2 de la plataforma del curso, asi que conviene que el estudiante los escriba aqui ANTES de dibujar, no despues.</a:t>
+            </a:r>
+          </a:p>
+        </p:txBody>
+      </p:sp>
+      <p:sp>
+        <p:nvSpPr>
+          <p:cNvPr id="4" name="Slide Number Placeholder 3"/>
+          <p:cNvSpPr>
+            <a:spLocks noGrp="1"/>
+          </p:cNvSpPr>
+          <p:nvPr>
+            <p:ph type="sldNum" idx="5" sz="quarter"/>
+          </p:nvPr>
+        </p:nvSpPr>
+        <p:spPr/>
+      </p:sp>
+    </p:spTree>
+  </p:cSld>
+  <p:clrMapOvr>
+    <a:masterClrMapping/>
+  </p:clrMapOvr>
+</p:notes>
+</file>
+
+<file path=ppt/notesSlides/notesSlide2.xml><?xml version="1.0" encoding="utf-8"?>
+<p:notes xmlns:a="http://schemas.openxmlformats.org/drawingml/2006/main" xmlns:p="http://schemas.openxmlformats.org/presentationml/2006/main" xmlns:r="http://schemas.openxmlformats.org/officeDocument/2006/relationships">
+  <p:cSld>
+    <p:spTree>
+      <p:nvGrpSpPr>
+        <p:cNvPr id="1" name=""/>
+        <p:cNvGrpSpPr/>
+        <p:nvPr/>
+      </p:nvGrpSpPr>
+      <p:grpSpPr>
+        <a:xfrm>
+          <a:off x="0" y="0"/>
+          <a:ext cx="0" cy="0"/>
+          <a:chOff x="0" y="0"/>
+          <a:chExt cx="0" cy="0"/>
+        </a:xfrm>
+      </p:grpSpPr>
+      <p:sp>
+        <p:nvSpPr>
+          <p:cNvPr id="2" name="Slide Image Placeholder 1"/>
+          <p:cNvSpPr>
+            <a:spLocks noGrp="1"/>
+          </p:cNvSpPr>
+          <p:nvPr>
+            <p:ph type="sldImg" idx="2"/>
+          </p:nvPr>
+        </p:nvSpPr>
+        <p:spPr/>
+      </p:sp>
+      <p:sp>
+        <p:nvSpPr>
+          <p:cNvPr id="3" name="Notes Placeholder 2"/>
+          <p:cNvSpPr>
+            <a:spLocks noGrp="1"/>
+          </p:cNvSpPr>
+          <p:nvPr>
+            <p:ph type="body" idx="3" sz="quarter"/>
+          </p:nvPr>
+        </p:nvSpPr>
+        <p:spPr/>
+        <p:txBody>
+          <a:bodyPr/>
+          <a:lstStyle/>
+          <a:p>
+            <a:r>
+              <a:t>Esa asimetria de costo es la razon de existir de la materia: si el docente no la instala el primer dia, el curso se percibe como una coleccion de diagramas decorativos y el estudiante concluye que la arquitectura es documentacion que se produce para la nota.</a:t>
+            </a:r>
+          </a:p>
+          <a:p/>
+          <a:p>
+            <a:r>
+              <a:t>Conviene separar de entrada dos cosas que el estudiante confunde siempre: el stack tecnologico y la arquitectura.</a:t>
+            </a:r>
+          </a:p>
+          <a:p/>
+          <a:p>
+            <a:r>
+              <a:t>Nadie puede contestar, porque el stack no contiene esa informacion; las respuestas viven en la arquitectura.</a:t>
+            </a:r>
+          </a:p>
+          <a:p/>
+          <a:p>
+            <a:r>
+              <a:t>Hacer visible ese vacio en los primeros veinte minutos ahorra tres semanas de malentendidos.</a:t>
+            </a:r>
+          </a:p>
+          <a:p/>
+          <a:p>
+            <a:r>
+              <a:t>Nube no significa internet ni «el servidor de otra persona».</a:t>
+            </a:r>
+          </a:p>
+          <a:p/>
+          <a:p>
+            <a:r>
+              <a:t>Por eso en la nube el costo se convierte en un atributo de calidad tecnico y no solo administrativo, idea que el curso retoma de forma explicita en la Clase 10.</a:t>
+            </a:r>
+          </a:p>
+        </p:txBody>
+      </p:sp>
+      <p:sp>
+        <p:nvSpPr>
+          <p:cNvPr id="4" name="Slide Number Placeholder 3"/>
+          <p:cNvSpPr>
+            <a:spLocks noGrp="1"/>
+          </p:cNvSpPr>
+          <p:nvPr>
+            <p:ph type="sldNum" idx="5" sz="quarter"/>
+          </p:nvPr>
+        </p:nvSpPr>
+        <p:spPr/>
+      </p:sp>
+    </p:spTree>
+  </p:cSld>
+  <p:clrMapOvr>
+    <a:masterClrMapping/>
+  </p:clrMapOvr>
+</p:notes>
+</file>
+
+<file path=ppt/notesSlides/notesSlide3.xml><?xml version="1.0" encoding="utf-8"?>
+<p:notes xmlns:a="http://schemas.openxmlformats.org/drawingml/2006/main" xmlns:p="http://schemas.openxmlformats.org/presentationml/2006/main" xmlns:r="http://schemas.openxmlformats.org/officeDocument/2006/relationships">
+  <p:cSld>
+    <p:spTree>
+      <p:nvGrpSpPr>
+        <p:cNvPr id="1" name=""/>
+        <p:cNvGrpSpPr/>
+        <p:nvPr/>
+      </p:nvGrpSpPr>
+      <p:grpSpPr>
+        <a:xfrm>
+          <a:off x="0" y="0"/>
+          <a:ext cx="0" cy="0"/>
+          <a:chOff x="0" y="0"/>
+          <a:chExt cx="0" cy="0"/>
+        </a:xfrm>
+      </p:grpSpPr>
+      <p:sp>
+        <p:nvSpPr>
+          <p:cNvPr id="2" name="Slide Image Placeholder 1"/>
+          <p:cNvSpPr>
+            <a:spLocks noGrp="1"/>
+          </p:cNvSpPr>
+          <p:nvPr>
+            <p:ph type="sldImg" idx="2"/>
+          </p:nvPr>
+        </p:nvSpPr>
+        <p:spPr/>
+      </p:sp>
+      <p:sp>
+        <p:nvSpPr>
+          <p:cNvPr id="3" name="Notes Placeholder 2"/>
+          <p:cNvSpPr>
+            <a:spLocks noGrp="1"/>
+          </p:cNvSpPr>
+          <p:nvPr>
+            <p:ph type="body" idx="3" sz="quarter"/>
+          </p:nvPr>
+        </p:nvSpPr>
+        <p:spPr/>
+        <p:txBody>
+          <a:bodyPr/>
+          <a:lstStyle/>
+          <a:p>
+            <a:r>
+              <a:t>Aterricemos en CloudLite App, el proyecto integrador que atraviesa las quince clases.</a:t>
+            </a:r>
+          </a:p>
+          <a:p/>
+          <a:p>
+            <a:r>
+              <a:t>Supongamos que un estudiante elige como dominio la gestion de turnos de una barberia.</a:t>
+            </a:r>
+          </a:p>
+        </p:txBody>
+      </p:sp>
+      <p:sp>
+        <p:nvSpPr>
+          <p:cNvPr id="4" name="Slide Number Placeholder 3"/>
+          <p:cNvSpPr>
+            <a:spLocks noGrp="1"/>
+          </p:cNvSpPr>
+          <p:nvPr>
+            <p:ph type="sldNum" idx="5" sz="quarter"/>
+          </p:nvPr>
+        </p:nvSpPr>
+        <p:spPr/>
+      </p:sp>
+    </p:spTree>
+  </p:cSld>
+  <p:clrMapOvr>
+    <a:masterClrMapping/>
+  </p:clrMapOvr>
+</p:notes>
+</file>
+
+<file path=ppt/notesSlides/notesSlide4.xml><?xml version="1.0" encoding="utf-8"?>
+<p:notes xmlns:a="http://schemas.openxmlformats.org/drawingml/2006/main" xmlns:p="http://schemas.openxmlformats.org/presentationml/2006/main" xmlns:r="http://schemas.openxmlformats.org/officeDocument/2006/relationships">
+  <p:cSld>
+    <p:spTree>
+      <p:nvGrpSpPr>
+        <p:cNvPr id="1" name=""/>
+        <p:cNvGrpSpPr/>
+        <p:nvPr/>
+      </p:nvGrpSpPr>
+      <p:grpSpPr>
+        <a:xfrm>
+          <a:off x="0" y="0"/>
+          <a:ext cx="0" cy="0"/>
+          <a:chOff x="0" y="0"/>
+          <a:chExt cx="0" cy="0"/>
+        </a:xfrm>
+      </p:grpSpPr>
+      <p:sp>
+        <p:nvSpPr>
+          <p:cNvPr id="2" name="Slide Image Placeholder 1"/>
+          <p:cNvSpPr>
+            <a:spLocks noGrp="1"/>
+          </p:cNvSpPr>
+          <p:nvPr>
+            <p:ph type="sldImg" idx="2"/>
+          </p:nvPr>
+        </p:nvSpPr>
+        <p:spPr/>
+      </p:sp>
+      <p:sp>
+        <p:nvSpPr>
+          <p:cNvPr id="3" name="Notes Placeholder 2"/>
+          <p:cNvSpPr>
+            <a:spLocks noGrp="1"/>
+          </p:cNvSpPr>
+          <p:nvPr>
+            <p:ph type="body" idx="3" sz="quarter"/>
+          </p:nvPr>
+        </p:nvSpPr>
+        <p:spPr/>
+        <p:txBody>
+          <a:bodyPr/>
+          <a:lstStyle/>
+          <a:p>
+            <a:r>
+              <a:t>Un problema sin afectado concreto y sin magnitud produce arquitecturas que nadie puede evaluar, porque no hay contra que comparar.</a:t>
+            </a:r>
+          </a:p>
+        </p:txBody>
+      </p:sp>
+      <p:sp>
+        <p:nvSpPr>
+          <p:cNvPr id="4" name="Slide Number Placeholder 3"/>
+          <p:cNvSpPr>
+            <a:spLocks noGrp="1"/>
+          </p:cNvSpPr>
+          <p:nvPr>
+            <p:ph type="sldNum" idx="5" sz="quarter"/>
+          </p:nvPr>
+        </p:nvSpPr>
+        <p:spPr/>
+      </p:sp>
+    </p:spTree>
+  </p:cSld>
+  <p:clrMapOvr>
+    <a:masterClrMapping/>
+  </p:clrMapOvr>
+</p:notes>
+</file>
+
+<file path=ppt/notesSlides/notesSlide5.xml><?xml version="1.0" encoding="utf-8"?>
+<p:notes xmlns:a="http://schemas.openxmlformats.org/drawingml/2006/main" xmlns:p="http://schemas.openxmlformats.org/presentationml/2006/main" xmlns:r="http://schemas.openxmlformats.org/officeDocument/2006/relationships">
+  <p:cSld>
+    <p:spTree>
+      <p:nvGrpSpPr>
+        <p:cNvPr id="1" name=""/>
+        <p:cNvGrpSpPr/>
+        <p:nvPr/>
+      </p:nvGrpSpPr>
+      <p:grpSpPr>
+        <a:xfrm>
+          <a:off x="0" y="0"/>
+          <a:ext cx="0" cy="0"/>
+          <a:chOff x="0" y="0"/>
+          <a:chExt cx="0" cy="0"/>
+        </a:xfrm>
+      </p:grpSpPr>
+      <p:sp>
+        <p:nvSpPr>
+          <p:cNvPr id="2" name="Slide Image Placeholder 1"/>
+          <p:cNvSpPr>
+            <a:spLocks noGrp="1"/>
+          </p:cNvSpPr>
+          <p:nvPr>
+            <p:ph type="sldImg" idx="2"/>
+          </p:nvPr>
+        </p:nvSpPr>
+        <p:spPr/>
+      </p:sp>
+      <p:sp>
+        <p:nvSpPr>
+          <p:cNvPr id="3" name="Notes Placeholder 2"/>
+          <p:cNvSpPr>
+            <a:spLocks noGrp="1"/>
+          </p:cNvSpPr>
+          <p:nvPr>
+            <p:ph type="body" idx="3" sz="quarter"/>
+          </p:nvPr>
+        </p:nvSpPr>
+        <p:spPr/>
+        <p:txBody>
+          <a:bodyPr/>
+          <a:lstStyle/>
+          <a:p>
+            <a:r>
+              <a:t>Tres preguntas aparecen casi siempre en esta primera clase y conviene tener la respuesta lista.</a:t>
+            </a:r>
+          </a:p>
+          <a:p/>
+          <a:p>
+            <a:r>
+              <a:t>La primera: cual es la diferencia entre arquitectura y diseno.</a:t>
+            </a:r>
+          </a:p>
+          <a:p/>
+          <a:p>
+            <a:r>
+              <a:t>Lo que se decida hoy (dominio, actores, capacidades, problema) es la entrada obligatoria de la Clase 2, que se dicta la semana siguiente en sesion virtual sincrona y pide elegir entre IaaS, PaaS y SaaS registrando la decision; de la Clase 3, donde se contenerizara uno de los servicios de este mismo sistema; y sobre todo de la Clase 4, que abre la caja negra dibujada hoy para mostrar de dos a cinco contenedores logicos.</a:t>
+            </a:r>
+          </a:p>
+          <a:p/>
+          <a:p>
+            <a:r>
+              <a:t>Conviene decirlo en voz alta al cerrar: el estudiante que salga hoy sin dominio definido no tiene sobre que trabajar en las siguientes cuatro sesiones, y el docente debe negarse a dejar el tema abierto para la proxima semana.</a:t>
+            </a:r>
+          </a:p>
+        </p:txBody>
+      </p:sp>
+      <p:sp>
+        <p:nvSpPr>
+          <p:cNvPr id="4" name="Slide Number Placeholder 3"/>
+          <p:cNvSpPr>
+            <a:spLocks noGrp="1"/>
+          </p:cNvSpPr>
+          <p:nvPr>
+            <p:ph type="sldNum" idx="5" sz="quarter"/>
+          </p:nvPr>
+        </p:nvSpPr>
+        <p:spPr/>
+      </p:sp>
+    </p:spTree>
+  </p:cSld>
+  <p:clrMapOvr>
+    <a:masterClrMapping/>
+  </p:clrMapOvr>
+</p:notes>
 </file>
 
 <file path=ppt/slideLayouts/slideLayout1.xml><?xml version="1.0" encoding="utf-8"?>
@@ -3345,13 +4100,22 @@
               </a:spcAft>
             </a:pPr>
             <a:r>
+              <a:rPr sz="1500" b="0" i="0">
+                <a:solidFill>
+                  <a:srgbClr val="333333"/>
+                </a:solidFill>
+                <a:latin typeface="Calibri"/>
+              </a:rPr>
+              <a:t>Bloque </a:t>
+            </a:r>
+            <a:r>
               <a:rPr sz="1500" b="1" i="0">
                 <a:solidFill>
                   <a:srgbClr val="333333"/>
                 </a:solidFill>
                 <a:latin typeface="Calibri"/>
               </a:rPr>
-              <a:t>Hoy avanzamos el PI en:</a:t>
+              <a:t>120 min</a:t>
             </a:r>
             <a:r>
               <a:rPr sz="1500" b="0" i="0">
@@ -3360,7 +4124,25 @@
                 </a:solidFill>
                 <a:latin typeface="Calibri"/>
               </a:rPr>
-              <a:t> Definir dominio CloudLite App + 3–5 capacidades + problema en 2–3 frases</a:t>
+              <a:t> · sesión </a:t>
+            </a:r>
+            <a:r>
+              <a:rPr sz="1500" b="1" i="0">
+                <a:solidFill>
+                  <a:srgbClr val="333333"/>
+                </a:solidFill>
+                <a:latin typeface="Calibri"/>
+              </a:rPr>
+              <a:t>virtual síncrona</a:t>
+            </a:r>
+            <a:r>
+              <a:rPr sz="1500" b="0" i="0">
+                <a:solidFill>
+                  <a:srgbClr val="333333"/>
+                </a:solidFill>
+                <a:latin typeface="Calibri"/>
+              </a:rPr>
+              <a:t> por Google Meet.</a:t>
             </a:r>
           </a:p>
           <a:p>
@@ -3376,41 +4158,7 @@
                 </a:solidFill>
                 <a:latin typeface="Calibri"/>
               </a:rPr>
-              <a:t>Bloque </a:t>
-            </a:r>
-            <a:r>
-              <a:rPr sz="1500" b="1" i="0">
-                <a:solidFill>
-                  <a:srgbClr val="333333"/>
-                </a:solidFill>
-                <a:latin typeface="Calibri"/>
-              </a:rPr>
-              <a:t>120 min</a:t>
-            </a:r>
-            <a:r>
-              <a:rPr sz="1500" b="0" i="0">
-                <a:solidFill>
-                  <a:srgbClr val="333333"/>
-                </a:solidFill>
-                <a:latin typeface="Calibri"/>
-              </a:rPr>
-              <a:t> · Teoría breve · Taller PI · cierre.</a:t>
-            </a:r>
-          </a:p>
-          <a:p>
-            <a:pPr>
-              <a:spcAft>
-                <a:spcPts val="800"/>
-              </a:spcAft>
-            </a:pPr>
-            <a:r>
-              <a:rPr sz="1500" b="0" i="0">
-                <a:solidFill>
-                  <a:srgbClr val="333333"/>
-                </a:solidFill>
-                <a:latin typeface="Calibri"/>
-              </a:rPr>
-              <a:t>Herramientas gratis + navegador · sin AWS/GCP/Oracle Cloud.</a:t>
+              <a:t>Conceptos del tema, ejemplos resueltos sobre CloudLite y cierre conceptual.</a:t>
             </a:r>
           </a:p>
         </p:txBody>
@@ -6312,7 +7060,7 @@
                 </a:solidFill>
                 <a:latin typeface="Calibri"/>
               </a:rPr>
-              <a:t> Encuadre: hoy avanzamos el PI en… + entregable concreto.</a:t>
+              <a:t> Encuadre del tema y objetivos de la clase.</a:t>
             </a:r>
           </a:p>
           <a:p>
@@ -6328,7 +7076,7 @@
                 </a:solidFill>
                 <a:latin typeface="Calibri"/>
               </a:rPr>
-              <a:t>10–40</a:t>
+              <a:t>10–70</a:t>
             </a:r>
             <a:r>
               <a:rPr sz="2000" b="0" i="0">
@@ -6337,7 +7085,7 @@
                 </a:solidFill>
                 <a:latin typeface="Calibri"/>
               </a:rPr>
-              <a:t> Teoría Core breve (solo lo necesario para el taller PI).</a:t>
+              <a:t> Conceptos del tema, uno por lámina, con ejemplos sobre CloudLite.</a:t>
             </a:r>
           </a:p>
           <a:p>
@@ -6362,7 +7110,7 @@
                 </a:solidFill>
                 <a:latin typeface="Calibri"/>
               </a:rPr>
-              <a:t>40–100</a:t>
+              <a:t>70–100</a:t>
             </a:r>
             <a:r>
               <a:rPr sz="2000" b="0" i="0">
@@ -6371,7 +7119,7 @@
                 </a:solidFill>
                 <a:latin typeface="Calibri"/>
               </a:rPr>
-              <a:t> Trabajo guiado del PI (demo en vivo + avance individual).</a:t>
+              <a:t> Ejemplos resueltos y demo del docente sobre el tema.</a:t>
             </a:r>
           </a:p>
           <a:p>
@@ -6396,7 +7144,7 @@
                 </a:solidFill>
                 <a:latin typeface="Calibri"/>
               </a:rPr>
-              <a:t> Revisión de evidencias del PI.</a:t>
+              <a:t> Práctica (opcional, guía en la carpeta de la clase).</a:t>
             </a:r>
           </a:p>
           <a:p>
@@ -6421,7 +7169,7 @@
                 </a:solidFill>
                 <a:latin typeface="Calibri"/>
               </a:rPr>
-              <a:t> Cierre: criterio de éxito + plazo en la fecha que indique el docente.</a:t>
+              <a:t> Preguntas y cierre conceptual.</a:t>
             </a:r>
           </a:p>
         </p:txBody>
@@ -7620,13 +8368,13 @@
         <p:spPr>
           <a:xfrm>
             <a:off x="0" y="0"/>
-            <a:ext cx="12191695" cy="1170432"/>
+            <a:ext cx="12191695" cy="164592"/>
           </a:xfrm>
           <a:prstGeom prst="rect">
             <a:avLst/>
           </a:prstGeom>
           <a:solidFill>
-            <a:srgbClr val="095292"/>
+            <a:srgbClr val="269CCB"/>
           </a:solidFill>
           <a:ln>
             <a:noFill/>
@@ -7654,251 +8402,9 @@
           </a:p>
         </p:txBody>
       </p:sp>
-      <p:sp>
-        <p:nvSpPr>
-          <p:cNvPr id="3" name="Rectangle 2"/>
-          <p:cNvSpPr/>
-          <p:nvPr/>
-        </p:nvSpPr>
-        <p:spPr>
-          <a:xfrm>
-            <a:off x="0" y="1170432"/>
-            <a:ext cx="12191695" cy="41148"/>
-          </a:xfrm>
-          <a:prstGeom prst="rect">
-            <a:avLst/>
-          </a:prstGeom>
-          <a:solidFill>
-            <a:srgbClr val="FFD000"/>
-          </a:solidFill>
-          <a:ln>
-            <a:noFill/>
-          </a:ln>
-        </p:spPr>
-        <p:style>
-          <a:lnRef idx="1">
-            <a:schemeClr val="accent1"/>
-          </a:lnRef>
-          <a:fillRef idx="3">
-            <a:schemeClr val="accent1"/>
-          </a:fillRef>
-          <a:effectRef idx="2">
-            <a:schemeClr val="accent1"/>
-          </a:effectRef>
-          <a:fontRef idx="minor">
-            <a:schemeClr val="lt1"/>
-          </a:fontRef>
-        </p:style>
-        <p:txBody>
-          <a:bodyPr rtlCol="0" anchor="ctr"/>
-          <a:lstStyle/>
-          <a:p>
-            <a:pPr algn="ctr"/>
-          </a:p>
-        </p:txBody>
-      </p:sp>
-      <p:sp>
-        <p:nvSpPr>
-          <p:cNvPr id="4" name="TextBox 3"/>
-          <p:cNvSpPr txBox="1"/>
-          <p:nvPr/>
-        </p:nvSpPr>
-        <p:spPr>
-          <a:xfrm>
-            <a:off x="457200" y="164592"/>
-            <a:ext cx="11277295" cy="384048"/>
-          </a:xfrm>
-          <a:prstGeom prst="rect">
-            <a:avLst/>
-          </a:prstGeom>
-          <a:noFill/>
-        </p:spPr>
-        <p:txBody>
-          <a:bodyPr wrap="square">
-            <a:spAutoFit/>
-          </a:bodyPr>
-          <a:lstStyle/>
-          <a:p>
-            <a:r>
-              <a:rPr sz="2600" b="1" i="0">
-                <a:solidFill>
-                  <a:srgbClr val="FFFFFF"/>
-                </a:solidFill>
-                <a:latin typeface="Calibri"/>
-              </a:rPr>
-              <a:t>Herramientas de hoy</a:t>
-            </a:r>
-          </a:p>
-        </p:txBody>
-      </p:sp>
-      <p:sp>
-        <p:nvSpPr>
-          <p:cNvPr id="5" name="TextBox 4"/>
-          <p:cNvSpPr txBox="1"/>
-          <p:nvPr/>
-        </p:nvSpPr>
-        <p:spPr>
-          <a:xfrm>
-            <a:off x="457200" y="566928"/>
-            <a:ext cx="11277295" cy="411480"/>
-          </a:xfrm>
-          <a:prstGeom prst="rect">
-            <a:avLst/>
-          </a:prstGeom>
-          <a:noFill/>
-        </p:spPr>
-        <p:txBody>
-          <a:bodyPr wrap="square">
-            <a:spAutoFit/>
-          </a:bodyPr>
-          <a:lstStyle/>
-          <a:p>
-            <a:r>
-              <a:rPr sz="1400" b="0" i="0">
-                <a:solidFill>
-                  <a:srgbClr val="B8D8EE"/>
-                </a:solidFill>
-                <a:latin typeface="Calibri"/>
-              </a:rPr>
-              <a:t>Gratis · navegador o free tier · sin cuenta de pago</a:t>
-            </a:r>
-          </a:p>
-        </p:txBody>
-      </p:sp>
-      <p:sp>
-        <p:nvSpPr>
-          <p:cNvPr id="6" name="Rounded Rectangle 5"/>
-          <p:cNvSpPr/>
-          <p:nvPr/>
-        </p:nvSpPr>
-        <p:spPr>
-          <a:xfrm>
-            <a:off x="457200" y="1591056"/>
-            <a:ext cx="3624986" cy="2299716"/>
-          </a:xfrm>
-          <a:prstGeom prst="roundRect">
-            <a:avLst>
-              <a:gd name="adj" fmla="val 12000"/>
-            </a:avLst>
-          </a:prstGeom>
-          <a:solidFill>
-            <a:srgbClr val="F2F2F2"/>
-          </a:solidFill>
-          <a:ln>
-            <a:noFill/>
-          </a:ln>
-        </p:spPr>
-        <p:style>
-          <a:lnRef idx="1">
-            <a:schemeClr val="accent1"/>
-          </a:lnRef>
-          <a:fillRef idx="3">
-            <a:schemeClr val="accent1"/>
-          </a:fillRef>
-          <a:effectRef idx="2">
-            <a:schemeClr val="accent1"/>
-          </a:effectRef>
-          <a:fontRef idx="minor">
-            <a:schemeClr val="lt1"/>
-          </a:fontRef>
-        </p:style>
-        <p:txBody>
-          <a:bodyPr rtlCol="0" anchor="ctr"/>
-          <a:lstStyle/>
-          <a:p>
-            <a:pPr algn="ctr"/>
-          </a:p>
-        </p:txBody>
-      </p:sp>
-      <p:sp>
-        <p:nvSpPr>
-          <p:cNvPr id="7" name="Rectangle 6"/>
-          <p:cNvSpPr/>
-          <p:nvPr/>
-        </p:nvSpPr>
-        <p:spPr>
-          <a:xfrm>
-            <a:off x="457200" y="1591056"/>
-            <a:ext cx="3624986" cy="64008"/>
-          </a:xfrm>
-          <a:prstGeom prst="rect">
-            <a:avLst/>
-          </a:prstGeom>
-          <a:solidFill>
-            <a:srgbClr val="095292"/>
-          </a:solidFill>
-          <a:ln>
-            <a:noFill/>
-          </a:ln>
-        </p:spPr>
-        <p:style>
-          <a:lnRef idx="1">
-            <a:schemeClr val="accent1"/>
-          </a:lnRef>
-          <a:fillRef idx="3">
-            <a:schemeClr val="accent1"/>
-          </a:fillRef>
-          <a:effectRef idx="2">
-            <a:schemeClr val="accent1"/>
-          </a:effectRef>
-          <a:fontRef idx="minor">
-            <a:schemeClr val="lt1"/>
-          </a:fontRef>
-        </p:style>
-        <p:txBody>
-          <a:bodyPr rtlCol="0" anchor="ctr"/>
-          <a:lstStyle/>
-          <a:p>
-            <a:pPr algn="ctr"/>
-          </a:p>
-        </p:txBody>
-      </p:sp>
-      <p:sp>
-        <p:nvSpPr>
-          <p:cNvPr id="8" name="Rectangle 7"/>
-          <p:cNvSpPr/>
-          <p:nvPr/>
-        </p:nvSpPr>
-        <p:spPr>
-          <a:xfrm>
-            <a:off x="457200" y="1655064"/>
-            <a:ext cx="3624986" cy="27432"/>
-          </a:xfrm>
-          <a:prstGeom prst="rect">
-            <a:avLst/>
-          </a:prstGeom>
-          <a:solidFill>
-            <a:srgbClr val="FFD000"/>
-          </a:solidFill>
-          <a:ln>
-            <a:noFill/>
-          </a:ln>
-        </p:spPr>
-        <p:style>
-          <a:lnRef idx="1">
-            <a:schemeClr val="accent1"/>
-          </a:lnRef>
-          <a:fillRef idx="3">
-            <a:schemeClr val="accent1"/>
-          </a:fillRef>
-          <a:effectRef idx="2">
-            <a:schemeClr val="accent1"/>
-          </a:effectRef>
-          <a:fontRef idx="minor">
-            <a:schemeClr val="lt1"/>
-          </a:fontRef>
-        </p:style>
-        <p:txBody>
-          <a:bodyPr rtlCol="0" anchor="ctr"/>
-          <a:lstStyle/>
-          <a:p>
-            <a:pPr algn="ctr"/>
-          </a:p>
-        </p:txBody>
-      </p:sp>
       <p:pic>
         <p:nvPicPr>
-          <p:cNvPr id="9" name="Picture 8" descr="padlet.png"/>
+          <p:cNvPr id="3" name="Picture 2" descr="logo_uniajc_color.png"/>
           <p:cNvPicPr>
             <a:picLocks noChangeAspect="1"/>
           </p:cNvPicPr>
@@ -7912,1026 +8418,14 @@
         </p:blipFill>
         <p:spPr>
           <a:xfrm>
-            <a:off x="1659331" y="1847087"/>
-            <a:ext cx="1220724" cy="1220724"/>
+            <a:off x="10271455" y="5998464"/>
+            <a:ext cx="1463040" cy="643233"/>
           </a:xfrm>
           <a:prstGeom prst="rect">
             <a:avLst/>
           </a:prstGeom>
         </p:spPr>
       </p:pic>
-      <p:sp>
-        <p:nvSpPr>
-          <p:cNvPr id="10" name="TextBox 9"/>
-          <p:cNvSpPr txBox="1"/>
-          <p:nvPr/>
-        </p:nvSpPr>
-        <p:spPr>
-          <a:xfrm>
-            <a:off x="530352" y="3159251"/>
-            <a:ext cx="3478682" cy="621792"/>
-          </a:xfrm>
-          <a:prstGeom prst="rect">
-            <a:avLst/>
-          </a:prstGeom>
-          <a:noFill/>
-        </p:spPr>
-        <p:txBody>
-          <a:bodyPr wrap="square" anchor="t"/>
-          <a:lstStyle/>
-          <a:p>
-            <a:pPr algn="ctr"/>
-            <a:r>
-              <a:rPr sz="1300" b="1" i="0">
-                <a:solidFill>
-                  <a:srgbClr val="095292"/>
-                </a:solidFill>
-                <a:latin typeface="Calibri"/>
-              </a:rPr>
-              <a:t>Padlet</a:t>
-            </a:r>
-          </a:p>
-          <a:p>
-            <a:pPr algn="ctr">
-              <a:spcBef>
-                <a:spcPts val="200"/>
-              </a:spcBef>
-            </a:pPr>
-            <a:r>
-              <a:rPr sz="1000" b="0" i="0">
-                <a:solidFill>
-                  <a:srgbClr val="666666"/>
-                </a:solidFill>
-                <a:latin typeface="Calibri"/>
-              </a:rPr>
-              <a:t>Rompehielos</a:t>
-            </a:r>
-          </a:p>
-        </p:txBody>
-      </p:sp>
-      <p:sp>
-        <p:nvSpPr>
-          <p:cNvPr id="11" name="Rounded Rectangle 10"/>
-          <p:cNvSpPr/>
-          <p:nvPr/>
-        </p:nvSpPr>
-        <p:spPr>
-          <a:xfrm>
-            <a:off x="4283354" y="1591056"/>
-            <a:ext cx="3624986" cy="2299716"/>
-          </a:xfrm>
-          <a:prstGeom prst="roundRect">
-            <a:avLst>
-              <a:gd name="adj" fmla="val 12000"/>
-            </a:avLst>
-          </a:prstGeom>
-          <a:solidFill>
-            <a:srgbClr val="F2F2F2"/>
-          </a:solidFill>
-          <a:ln>
-            <a:noFill/>
-          </a:ln>
-        </p:spPr>
-        <p:style>
-          <a:lnRef idx="1">
-            <a:schemeClr val="accent1"/>
-          </a:lnRef>
-          <a:fillRef idx="3">
-            <a:schemeClr val="accent1"/>
-          </a:fillRef>
-          <a:effectRef idx="2">
-            <a:schemeClr val="accent1"/>
-          </a:effectRef>
-          <a:fontRef idx="minor">
-            <a:schemeClr val="lt1"/>
-          </a:fontRef>
-        </p:style>
-        <p:txBody>
-          <a:bodyPr rtlCol="0" anchor="ctr"/>
-          <a:lstStyle/>
-          <a:p>
-            <a:pPr algn="ctr"/>
-          </a:p>
-        </p:txBody>
-      </p:sp>
-      <p:sp>
-        <p:nvSpPr>
-          <p:cNvPr id="12" name="Rectangle 11"/>
-          <p:cNvSpPr/>
-          <p:nvPr/>
-        </p:nvSpPr>
-        <p:spPr>
-          <a:xfrm>
-            <a:off x="4283354" y="1591056"/>
-            <a:ext cx="3624986" cy="64008"/>
-          </a:xfrm>
-          <a:prstGeom prst="rect">
-            <a:avLst/>
-          </a:prstGeom>
-          <a:solidFill>
-            <a:srgbClr val="095292"/>
-          </a:solidFill>
-          <a:ln>
-            <a:noFill/>
-          </a:ln>
-        </p:spPr>
-        <p:style>
-          <a:lnRef idx="1">
-            <a:schemeClr val="accent1"/>
-          </a:lnRef>
-          <a:fillRef idx="3">
-            <a:schemeClr val="accent1"/>
-          </a:fillRef>
-          <a:effectRef idx="2">
-            <a:schemeClr val="accent1"/>
-          </a:effectRef>
-          <a:fontRef idx="minor">
-            <a:schemeClr val="lt1"/>
-          </a:fontRef>
-        </p:style>
-        <p:txBody>
-          <a:bodyPr rtlCol="0" anchor="ctr"/>
-          <a:lstStyle/>
-          <a:p>
-            <a:pPr algn="ctr"/>
-          </a:p>
-        </p:txBody>
-      </p:sp>
-      <p:sp>
-        <p:nvSpPr>
-          <p:cNvPr id="13" name="Rectangle 12"/>
-          <p:cNvSpPr/>
-          <p:nvPr/>
-        </p:nvSpPr>
-        <p:spPr>
-          <a:xfrm>
-            <a:off x="4283354" y="1655064"/>
-            <a:ext cx="3624986" cy="27432"/>
-          </a:xfrm>
-          <a:prstGeom prst="rect">
-            <a:avLst/>
-          </a:prstGeom>
-          <a:solidFill>
-            <a:srgbClr val="FFD000"/>
-          </a:solidFill>
-          <a:ln>
-            <a:noFill/>
-          </a:ln>
-        </p:spPr>
-        <p:style>
-          <a:lnRef idx="1">
-            <a:schemeClr val="accent1"/>
-          </a:lnRef>
-          <a:fillRef idx="3">
-            <a:schemeClr val="accent1"/>
-          </a:fillRef>
-          <a:effectRef idx="2">
-            <a:schemeClr val="accent1"/>
-          </a:effectRef>
-          <a:fontRef idx="minor">
-            <a:schemeClr val="lt1"/>
-          </a:fontRef>
-        </p:style>
-        <p:txBody>
-          <a:bodyPr rtlCol="0" anchor="ctr"/>
-          <a:lstStyle/>
-          <a:p>
-            <a:pPr algn="ctr"/>
-          </a:p>
-        </p:txBody>
-      </p:sp>
-      <p:pic>
-        <p:nvPicPr>
-          <p:cNvPr id="14" name="Picture 13" descr="excalidraw.png"/>
-          <p:cNvPicPr>
-            <a:picLocks noChangeAspect="1"/>
-          </p:cNvPicPr>
-          <p:nvPr/>
-        </p:nvPicPr>
-        <p:blipFill>
-          <a:blip r:embed="rId3"/>
-          <a:stretch>
-            <a:fillRect/>
-          </a:stretch>
-        </p:blipFill>
-        <p:spPr>
-          <a:xfrm>
-            <a:off x="5485485" y="1847087"/>
-            <a:ext cx="1220724" cy="1220724"/>
-          </a:xfrm>
-          <a:prstGeom prst="rect">
-            <a:avLst/>
-          </a:prstGeom>
-        </p:spPr>
-      </p:pic>
-      <p:sp>
-        <p:nvSpPr>
-          <p:cNvPr id="15" name="TextBox 14"/>
-          <p:cNvSpPr txBox="1"/>
-          <p:nvPr/>
-        </p:nvSpPr>
-        <p:spPr>
-          <a:xfrm>
-            <a:off x="4356506" y="3159251"/>
-            <a:ext cx="3478682" cy="621792"/>
-          </a:xfrm>
-          <a:prstGeom prst="rect">
-            <a:avLst/>
-          </a:prstGeom>
-          <a:noFill/>
-        </p:spPr>
-        <p:txBody>
-          <a:bodyPr wrap="square" anchor="t"/>
-          <a:lstStyle/>
-          <a:p>
-            <a:pPr algn="ctr"/>
-            <a:r>
-              <a:rPr sz="1300" b="1" i="0">
-                <a:solidFill>
-                  <a:srgbClr val="095292"/>
-                </a:solidFill>
-                <a:latin typeface="Calibri"/>
-              </a:rPr>
-              <a:t>Excalidraw</a:t>
-            </a:r>
-          </a:p>
-          <a:p>
-            <a:pPr algn="ctr">
-              <a:spcBef>
-                <a:spcPts val="200"/>
-              </a:spcBef>
-            </a:pPr>
-            <a:r>
-              <a:rPr sz="1000" b="0" i="0">
-                <a:solidFill>
-                  <a:srgbClr val="666666"/>
-                </a:solidFill>
-                <a:latin typeface="Calibri"/>
-              </a:rPr>
-              <a:t>Boceto rapido</a:t>
-            </a:r>
-          </a:p>
-        </p:txBody>
-      </p:sp>
-      <p:sp>
-        <p:nvSpPr>
-          <p:cNvPr id="16" name="Rounded Rectangle 15"/>
-          <p:cNvSpPr/>
-          <p:nvPr/>
-        </p:nvSpPr>
-        <p:spPr>
-          <a:xfrm>
-            <a:off x="8109508" y="1591056"/>
-            <a:ext cx="3624986" cy="2299716"/>
-          </a:xfrm>
-          <a:prstGeom prst="roundRect">
-            <a:avLst>
-              <a:gd name="adj" fmla="val 12000"/>
-            </a:avLst>
-          </a:prstGeom>
-          <a:solidFill>
-            <a:srgbClr val="F2F2F2"/>
-          </a:solidFill>
-          <a:ln>
-            <a:noFill/>
-          </a:ln>
-        </p:spPr>
-        <p:style>
-          <a:lnRef idx="1">
-            <a:schemeClr val="accent1"/>
-          </a:lnRef>
-          <a:fillRef idx="3">
-            <a:schemeClr val="accent1"/>
-          </a:fillRef>
-          <a:effectRef idx="2">
-            <a:schemeClr val="accent1"/>
-          </a:effectRef>
-          <a:fontRef idx="minor">
-            <a:schemeClr val="lt1"/>
-          </a:fontRef>
-        </p:style>
-        <p:txBody>
-          <a:bodyPr rtlCol="0" anchor="ctr"/>
-          <a:lstStyle/>
-          <a:p>
-            <a:pPr algn="ctr"/>
-          </a:p>
-        </p:txBody>
-      </p:sp>
-      <p:sp>
-        <p:nvSpPr>
-          <p:cNvPr id="17" name="Rectangle 16"/>
-          <p:cNvSpPr/>
-          <p:nvPr/>
-        </p:nvSpPr>
-        <p:spPr>
-          <a:xfrm>
-            <a:off x="8109508" y="1591056"/>
-            <a:ext cx="3624986" cy="64008"/>
-          </a:xfrm>
-          <a:prstGeom prst="rect">
-            <a:avLst/>
-          </a:prstGeom>
-          <a:solidFill>
-            <a:srgbClr val="095292"/>
-          </a:solidFill>
-          <a:ln>
-            <a:noFill/>
-          </a:ln>
-        </p:spPr>
-        <p:style>
-          <a:lnRef idx="1">
-            <a:schemeClr val="accent1"/>
-          </a:lnRef>
-          <a:fillRef idx="3">
-            <a:schemeClr val="accent1"/>
-          </a:fillRef>
-          <a:effectRef idx="2">
-            <a:schemeClr val="accent1"/>
-          </a:effectRef>
-          <a:fontRef idx="minor">
-            <a:schemeClr val="lt1"/>
-          </a:fontRef>
-        </p:style>
-        <p:txBody>
-          <a:bodyPr rtlCol="0" anchor="ctr"/>
-          <a:lstStyle/>
-          <a:p>
-            <a:pPr algn="ctr"/>
-          </a:p>
-        </p:txBody>
-      </p:sp>
-      <p:sp>
-        <p:nvSpPr>
-          <p:cNvPr id="18" name="Rectangle 17"/>
-          <p:cNvSpPr/>
-          <p:nvPr/>
-        </p:nvSpPr>
-        <p:spPr>
-          <a:xfrm>
-            <a:off x="8109508" y="1655064"/>
-            <a:ext cx="3624986" cy="27432"/>
-          </a:xfrm>
-          <a:prstGeom prst="rect">
-            <a:avLst/>
-          </a:prstGeom>
-          <a:solidFill>
-            <a:srgbClr val="FFD000"/>
-          </a:solidFill>
-          <a:ln>
-            <a:noFill/>
-          </a:ln>
-        </p:spPr>
-        <p:style>
-          <a:lnRef idx="1">
-            <a:schemeClr val="accent1"/>
-          </a:lnRef>
-          <a:fillRef idx="3">
-            <a:schemeClr val="accent1"/>
-          </a:fillRef>
-          <a:effectRef idx="2">
-            <a:schemeClr val="accent1"/>
-          </a:effectRef>
-          <a:fontRef idx="minor">
-            <a:schemeClr val="lt1"/>
-          </a:fontRef>
-        </p:style>
-        <p:txBody>
-          <a:bodyPr rtlCol="0" anchor="ctr"/>
-          <a:lstStyle/>
-          <a:p>
-            <a:pPr algn="ctr"/>
-          </a:p>
-        </p:txBody>
-      </p:sp>
-      <p:pic>
-        <p:nvPicPr>
-          <p:cNvPr id="19" name="Picture 18" descr="drawio.png"/>
-          <p:cNvPicPr>
-            <a:picLocks noChangeAspect="1"/>
-          </p:cNvPicPr>
-          <p:nvPr/>
-        </p:nvPicPr>
-        <p:blipFill>
-          <a:blip r:embed="rId4"/>
-          <a:stretch>
-            <a:fillRect/>
-          </a:stretch>
-        </p:blipFill>
-        <p:spPr>
-          <a:xfrm>
-            <a:off x="9311640" y="1847087"/>
-            <a:ext cx="1220724" cy="1220724"/>
-          </a:xfrm>
-          <a:prstGeom prst="rect">
-            <a:avLst/>
-          </a:prstGeom>
-        </p:spPr>
-      </p:pic>
-      <p:sp>
-        <p:nvSpPr>
-          <p:cNvPr id="20" name="TextBox 19"/>
-          <p:cNvSpPr txBox="1"/>
-          <p:nvPr/>
-        </p:nvSpPr>
-        <p:spPr>
-          <a:xfrm>
-            <a:off x="8182660" y="3159251"/>
-            <a:ext cx="3478682" cy="621792"/>
-          </a:xfrm>
-          <a:prstGeom prst="rect">
-            <a:avLst/>
-          </a:prstGeom>
-          <a:noFill/>
-        </p:spPr>
-        <p:txBody>
-          <a:bodyPr wrap="square" anchor="t"/>
-          <a:lstStyle/>
-          <a:p>
-            <a:pPr algn="ctr"/>
-            <a:r>
-              <a:rPr sz="1300" b="1" i="0">
-                <a:solidFill>
-                  <a:srgbClr val="095292"/>
-                </a:solidFill>
-                <a:latin typeface="Calibri"/>
-              </a:rPr>
-              <a:t>draw.io</a:t>
-            </a:r>
-          </a:p>
-          <a:p>
-            <a:pPr algn="ctr">
-              <a:spcBef>
-                <a:spcPts val="200"/>
-              </a:spcBef>
-            </a:pPr>
-            <a:r>
-              <a:rPr sz="1000" b="0" i="0">
-                <a:solidFill>
-                  <a:srgbClr val="666666"/>
-                </a:solidFill>
-                <a:latin typeface="Calibri"/>
-              </a:rPr>
-              <a:t>C4 Context</a:t>
-            </a:r>
-          </a:p>
-        </p:txBody>
-      </p:sp>
-      <p:sp>
-        <p:nvSpPr>
-          <p:cNvPr id="21" name="Rounded Rectangle 20"/>
-          <p:cNvSpPr/>
-          <p:nvPr/>
-        </p:nvSpPr>
-        <p:spPr>
-          <a:xfrm>
-            <a:off x="2370277" y="4055364"/>
-            <a:ext cx="3624986" cy="2299716"/>
-          </a:xfrm>
-          <a:prstGeom prst="roundRect">
-            <a:avLst>
-              <a:gd name="adj" fmla="val 12000"/>
-            </a:avLst>
-          </a:prstGeom>
-          <a:solidFill>
-            <a:srgbClr val="F2F2F2"/>
-          </a:solidFill>
-          <a:ln>
-            <a:noFill/>
-          </a:ln>
-        </p:spPr>
-        <p:style>
-          <a:lnRef idx="1">
-            <a:schemeClr val="accent1"/>
-          </a:lnRef>
-          <a:fillRef idx="3">
-            <a:schemeClr val="accent1"/>
-          </a:fillRef>
-          <a:effectRef idx="2">
-            <a:schemeClr val="accent1"/>
-          </a:effectRef>
-          <a:fontRef idx="minor">
-            <a:schemeClr val="lt1"/>
-          </a:fontRef>
-        </p:style>
-        <p:txBody>
-          <a:bodyPr rtlCol="0" anchor="ctr"/>
-          <a:lstStyle/>
-          <a:p>
-            <a:pPr algn="ctr"/>
-          </a:p>
-        </p:txBody>
-      </p:sp>
-      <p:sp>
-        <p:nvSpPr>
-          <p:cNvPr id="22" name="Rectangle 21"/>
-          <p:cNvSpPr/>
-          <p:nvPr/>
-        </p:nvSpPr>
-        <p:spPr>
-          <a:xfrm>
-            <a:off x="2370277" y="4055364"/>
-            <a:ext cx="3624986" cy="64008"/>
-          </a:xfrm>
-          <a:prstGeom prst="rect">
-            <a:avLst/>
-          </a:prstGeom>
-          <a:solidFill>
-            <a:srgbClr val="095292"/>
-          </a:solidFill>
-          <a:ln>
-            <a:noFill/>
-          </a:ln>
-        </p:spPr>
-        <p:style>
-          <a:lnRef idx="1">
-            <a:schemeClr val="accent1"/>
-          </a:lnRef>
-          <a:fillRef idx="3">
-            <a:schemeClr val="accent1"/>
-          </a:fillRef>
-          <a:effectRef idx="2">
-            <a:schemeClr val="accent1"/>
-          </a:effectRef>
-          <a:fontRef idx="minor">
-            <a:schemeClr val="lt1"/>
-          </a:fontRef>
-        </p:style>
-        <p:txBody>
-          <a:bodyPr rtlCol="0" anchor="ctr"/>
-          <a:lstStyle/>
-          <a:p>
-            <a:pPr algn="ctr"/>
-          </a:p>
-        </p:txBody>
-      </p:sp>
-      <p:sp>
-        <p:nvSpPr>
-          <p:cNvPr id="23" name="Rectangle 22"/>
-          <p:cNvSpPr/>
-          <p:nvPr/>
-        </p:nvSpPr>
-        <p:spPr>
-          <a:xfrm>
-            <a:off x="2370277" y="4119372"/>
-            <a:ext cx="3624986" cy="27432"/>
-          </a:xfrm>
-          <a:prstGeom prst="rect">
-            <a:avLst/>
-          </a:prstGeom>
-          <a:solidFill>
-            <a:srgbClr val="FFD000"/>
-          </a:solidFill>
-          <a:ln>
-            <a:noFill/>
-          </a:ln>
-        </p:spPr>
-        <p:style>
-          <a:lnRef idx="1">
-            <a:schemeClr val="accent1"/>
-          </a:lnRef>
-          <a:fillRef idx="3">
-            <a:schemeClr val="accent1"/>
-          </a:fillRef>
-          <a:effectRef idx="2">
-            <a:schemeClr val="accent1"/>
-          </a:effectRef>
-          <a:fontRef idx="minor">
-            <a:schemeClr val="lt1"/>
-          </a:fontRef>
-        </p:style>
-        <p:txBody>
-          <a:bodyPr rtlCol="0" anchor="ctr"/>
-          <a:lstStyle/>
-          <a:p>
-            <a:pPr algn="ctr"/>
-          </a:p>
-        </p:txBody>
-      </p:sp>
-      <p:pic>
-        <p:nvPicPr>
-          <p:cNvPr id="24" name="Picture 23" descr="mermaid.png"/>
-          <p:cNvPicPr>
-            <a:picLocks noChangeAspect="1"/>
-          </p:cNvPicPr>
-          <p:nvPr/>
-        </p:nvPicPr>
-        <p:blipFill>
-          <a:blip r:embed="rId5"/>
-          <a:stretch>
-            <a:fillRect/>
-          </a:stretch>
-        </p:blipFill>
-        <p:spPr>
-          <a:xfrm>
-            <a:off x="3572408" y="4311396"/>
-            <a:ext cx="1220724" cy="1220724"/>
-          </a:xfrm>
-          <a:prstGeom prst="rect">
-            <a:avLst/>
-          </a:prstGeom>
-        </p:spPr>
-      </p:pic>
-      <p:sp>
-        <p:nvSpPr>
-          <p:cNvPr id="25" name="TextBox 24"/>
-          <p:cNvSpPr txBox="1"/>
-          <p:nvPr/>
-        </p:nvSpPr>
-        <p:spPr>
-          <a:xfrm>
-            <a:off x="2443429" y="5623560"/>
-            <a:ext cx="3478682" cy="621792"/>
-          </a:xfrm>
-          <a:prstGeom prst="rect">
-            <a:avLst/>
-          </a:prstGeom>
-          <a:noFill/>
-        </p:spPr>
-        <p:txBody>
-          <a:bodyPr wrap="square" anchor="t"/>
-          <a:lstStyle/>
-          <a:p>
-            <a:pPr algn="ctr"/>
-            <a:r>
-              <a:rPr sz="1300" b="1" i="0">
-                <a:solidFill>
-                  <a:srgbClr val="095292"/>
-                </a:solidFill>
-                <a:latin typeface="Calibri"/>
-              </a:rPr>
-              <a:t>Mermaid</a:t>
-            </a:r>
-          </a:p>
-          <a:p>
-            <a:pPr algn="ctr">
-              <a:spcBef>
-                <a:spcPts val="200"/>
-              </a:spcBef>
-            </a:pPr>
-            <a:r>
-              <a:rPr sz="1000" b="0" i="0">
-                <a:solidFill>
-                  <a:srgbClr val="666666"/>
-                </a:solidFill>
-                <a:latin typeface="Calibri"/>
-              </a:rPr>
-              <a:t>Codigo del diagrama</a:t>
-            </a:r>
-          </a:p>
-        </p:txBody>
-      </p:sp>
-      <p:sp>
-        <p:nvSpPr>
-          <p:cNvPr id="26" name="Rounded Rectangle 25"/>
-          <p:cNvSpPr/>
-          <p:nvPr/>
-        </p:nvSpPr>
-        <p:spPr>
-          <a:xfrm>
-            <a:off x="6196431" y="4055364"/>
-            <a:ext cx="3624986" cy="2299716"/>
-          </a:xfrm>
-          <a:prstGeom prst="roundRect">
-            <a:avLst>
-              <a:gd name="adj" fmla="val 12000"/>
-            </a:avLst>
-          </a:prstGeom>
-          <a:solidFill>
-            <a:srgbClr val="F2F2F2"/>
-          </a:solidFill>
-          <a:ln>
-            <a:noFill/>
-          </a:ln>
-        </p:spPr>
-        <p:style>
-          <a:lnRef idx="1">
-            <a:schemeClr val="accent1"/>
-          </a:lnRef>
-          <a:fillRef idx="3">
-            <a:schemeClr val="accent1"/>
-          </a:fillRef>
-          <a:effectRef idx="2">
-            <a:schemeClr val="accent1"/>
-          </a:effectRef>
-          <a:fontRef idx="minor">
-            <a:schemeClr val="lt1"/>
-          </a:fontRef>
-        </p:style>
-        <p:txBody>
-          <a:bodyPr rtlCol="0" anchor="ctr"/>
-          <a:lstStyle/>
-          <a:p>
-            <a:pPr algn="ctr"/>
-          </a:p>
-        </p:txBody>
-      </p:sp>
-      <p:sp>
-        <p:nvSpPr>
-          <p:cNvPr id="27" name="Rectangle 26"/>
-          <p:cNvSpPr/>
-          <p:nvPr/>
-        </p:nvSpPr>
-        <p:spPr>
-          <a:xfrm>
-            <a:off x="6196431" y="4055364"/>
-            <a:ext cx="3624986" cy="64008"/>
-          </a:xfrm>
-          <a:prstGeom prst="rect">
-            <a:avLst/>
-          </a:prstGeom>
-          <a:solidFill>
-            <a:srgbClr val="095292"/>
-          </a:solidFill>
-          <a:ln>
-            <a:noFill/>
-          </a:ln>
-        </p:spPr>
-        <p:style>
-          <a:lnRef idx="1">
-            <a:schemeClr val="accent1"/>
-          </a:lnRef>
-          <a:fillRef idx="3">
-            <a:schemeClr val="accent1"/>
-          </a:fillRef>
-          <a:effectRef idx="2">
-            <a:schemeClr val="accent1"/>
-          </a:effectRef>
-          <a:fontRef idx="minor">
-            <a:schemeClr val="lt1"/>
-          </a:fontRef>
-        </p:style>
-        <p:txBody>
-          <a:bodyPr rtlCol="0" anchor="ctr"/>
-          <a:lstStyle/>
-          <a:p>
-            <a:pPr algn="ctr"/>
-          </a:p>
-        </p:txBody>
-      </p:sp>
-      <p:sp>
-        <p:nvSpPr>
-          <p:cNvPr id="28" name="Rectangle 27"/>
-          <p:cNvSpPr/>
-          <p:nvPr/>
-        </p:nvSpPr>
-        <p:spPr>
-          <a:xfrm>
-            <a:off x="6196431" y="4119372"/>
-            <a:ext cx="3624986" cy="27432"/>
-          </a:xfrm>
-          <a:prstGeom prst="rect">
-            <a:avLst/>
-          </a:prstGeom>
-          <a:solidFill>
-            <a:srgbClr val="FFD000"/>
-          </a:solidFill>
-          <a:ln>
-            <a:noFill/>
-          </a:ln>
-        </p:spPr>
-        <p:style>
-          <a:lnRef idx="1">
-            <a:schemeClr val="accent1"/>
-          </a:lnRef>
-          <a:fillRef idx="3">
-            <a:schemeClr val="accent1"/>
-          </a:fillRef>
-          <a:effectRef idx="2">
-            <a:schemeClr val="accent1"/>
-          </a:effectRef>
-          <a:fontRef idx="minor">
-            <a:schemeClr val="lt1"/>
-          </a:fontRef>
-        </p:style>
-        <p:txBody>
-          <a:bodyPr rtlCol="0" anchor="ctr"/>
-          <a:lstStyle/>
-          <a:p>
-            <a:pPr algn="ctr"/>
-          </a:p>
-        </p:txBody>
-      </p:sp>
-      <p:pic>
-        <p:nvPicPr>
-          <p:cNvPr id="29" name="Picture 28" descr="examlab.png"/>
-          <p:cNvPicPr>
-            <a:picLocks noChangeAspect="1"/>
-          </p:cNvPicPr>
-          <p:nvPr/>
-        </p:nvPicPr>
-        <p:blipFill>
-          <a:blip r:embed="rId6"/>
-          <a:stretch>
-            <a:fillRect/>
-          </a:stretch>
-        </p:blipFill>
-        <p:spPr>
-          <a:xfrm>
-            <a:off x="7398562" y="4311396"/>
-            <a:ext cx="1220724" cy="1220724"/>
-          </a:xfrm>
-          <a:prstGeom prst="rect">
-            <a:avLst/>
-          </a:prstGeom>
-        </p:spPr>
-      </p:pic>
-      <p:sp>
-        <p:nvSpPr>
-          <p:cNvPr id="30" name="TextBox 29"/>
-          <p:cNvSpPr txBox="1"/>
-          <p:nvPr/>
-        </p:nvSpPr>
-        <p:spPr>
-          <a:xfrm>
-            <a:off x="6269583" y="5623560"/>
-            <a:ext cx="3478682" cy="621792"/>
-          </a:xfrm>
-          <a:prstGeom prst="rect">
-            <a:avLst/>
-          </a:prstGeom>
-          <a:noFill/>
-        </p:spPr>
-        <p:txBody>
-          <a:bodyPr wrap="square" anchor="t"/>
-          <a:lstStyle/>
-          <a:p>
-            <a:pPr algn="ctr"/>
-            <a:r>
-              <a:rPr sz="1300" b="1" i="0">
-                <a:solidFill>
-                  <a:srgbClr val="095292"/>
-                </a:solidFill>
-                <a:latin typeface="Calibri"/>
-              </a:rPr>
-              <a:t>la plataforma del curso</a:t>
-            </a:r>
-          </a:p>
-          <a:p>
-            <a:pPr algn="ctr">
-              <a:spcBef>
-                <a:spcPts val="200"/>
-              </a:spcBef>
-            </a:pPr>
-            <a:r>
-              <a:rPr sz="1000" b="0" i="0">
-                <a:solidFill>
-                  <a:srgbClr val="666666"/>
-                </a:solidFill>
-                <a:latin typeface="Calibri"/>
-              </a:rPr>
-              <a:t>Donde se entrega</a:t>
-            </a:r>
-          </a:p>
-        </p:txBody>
-      </p:sp>
-      <p:sp>
-        <p:nvSpPr>
-          <p:cNvPr id="31" name="TextBox 30"/>
-          <p:cNvSpPr txBox="1"/>
-          <p:nvPr/>
-        </p:nvSpPr>
-        <p:spPr>
-          <a:xfrm>
-            <a:off x="11185855" y="6473952"/>
-            <a:ext cx="640080" cy="274320"/>
-          </a:xfrm>
-          <a:prstGeom prst="rect">
-            <a:avLst/>
-          </a:prstGeom>
-          <a:noFill/>
-        </p:spPr>
-        <p:txBody>
-          <a:bodyPr wrap="square">
-            <a:spAutoFit/>
-          </a:bodyPr>
-          <a:lstStyle/>
-          <a:p>
-            <a:pPr algn="r"/>
-            <a:r>
-              <a:rPr sz="1100" b="0" i="0">
-                <a:solidFill>
-                  <a:srgbClr val="666666"/>
-                </a:solidFill>
-                <a:latin typeface="Calibri"/>
-              </a:rPr>
-              <a:t>23</a:t>
-            </a:r>
-          </a:p>
-        </p:txBody>
-      </p:sp>
-    </p:spTree>
-  </p:cSld>
-  <p:clrMapOvr>
-    <a:masterClrMapping/>
-  </p:clrMapOvr>
-</p:sld>
-</file>
-
-<file path=ppt/slides/slide24.xml><?xml version="1.0" encoding="utf-8"?>
-<p:sld xmlns:a="http://schemas.openxmlformats.org/drawingml/2006/main" xmlns:p="http://schemas.openxmlformats.org/presentationml/2006/main" xmlns:r="http://schemas.openxmlformats.org/officeDocument/2006/relationships">
-  <p:cSld>
-    <p:bg>
-      <p:bgPr>
-        <a:solidFill>
-          <a:srgbClr val="FFFFFF"/>
-        </a:solidFill>
-        <a:effectLst/>
-      </p:bgPr>
-    </p:bg>
-    <p:spTree>
-      <p:nvGrpSpPr>
-        <p:cNvPr id="1" name=""/>
-        <p:cNvGrpSpPr/>
-        <p:nvPr/>
-      </p:nvGrpSpPr>
-      <p:grpSpPr/>
-      <p:sp>
-        <p:nvSpPr>
-          <p:cNvPr id="2" name="Rectangle 1"/>
-          <p:cNvSpPr/>
-          <p:nvPr/>
-        </p:nvSpPr>
-        <p:spPr>
-          <a:xfrm>
-            <a:off x="0" y="0"/>
-            <a:ext cx="12191695" cy="1170432"/>
-          </a:xfrm>
-          <a:prstGeom prst="rect">
-            <a:avLst/>
-          </a:prstGeom>
-          <a:solidFill>
-            <a:srgbClr val="095292"/>
-          </a:solidFill>
-          <a:ln>
-            <a:noFill/>
-          </a:ln>
-        </p:spPr>
-        <p:style>
-          <a:lnRef idx="1">
-            <a:schemeClr val="accent1"/>
-          </a:lnRef>
-          <a:fillRef idx="3">
-            <a:schemeClr val="accent1"/>
-          </a:fillRef>
-          <a:effectRef idx="2">
-            <a:schemeClr val="accent1"/>
-          </a:effectRef>
-          <a:fontRef idx="minor">
-            <a:schemeClr val="lt1"/>
-          </a:fontRef>
-        </p:style>
-        <p:txBody>
-          <a:bodyPr rtlCol="0" anchor="ctr"/>
-          <a:lstStyle/>
-          <a:p>
-            <a:pPr algn="ctr"/>
-          </a:p>
-        </p:txBody>
-      </p:sp>
-      <p:sp>
-        <p:nvSpPr>
-          <p:cNvPr id="3" name="Rectangle 2"/>
-          <p:cNvSpPr/>
-          <p:nvPr/>
-        </p:nvSpPr>
-        <p:spPr>
-          <a:xfrm>
-            <a:off x="0" y="1170432"/>
-            <a:ext cx="12191695" cy="41148"/>
-          </a:xfrm>
-          <a:prstGeom prst="rect">
-            <a:avLst/>
-          </a:prstGeom>
-          <a:solidFill>
-            <a:srgbClr val="FFD000"/>
-          </a:solidFill>
-          <a:ln>
-            <a:noFill/>
-          </a:ln>
-        </p:spPr>
-        <p:style>
-          <a:lnRef idx="1">
-            <a:schemeClr val="accent1"/>
-          </a:lnRef>
-          <a:fillRef idx="3">
-            <a:schemeClr val="accent1"/>
-          </a:fillRef>
-          <a:effectRef idx="2">
-            <a:schemeClr val="accent1"/>
-          </a:effectRef>
-          <a:fontRef idx="minor">
-            <a:schemeClr val="lt1"/>
-          </a:fontRef>
-        </p:style>
-        <p:txBody>
-          <a:bodyPr rtlCol="0" anchor="ctr"/>
-          <a:lstStyle/>
-          <a:p>
-            <a:pPr algn="ctr"/>
-          </a:p>
-        </p:txBody>
-      </p:sp>
       <p:sp>
         <p:nvSpPr>
           <p:cNvPr id="4" name="TextBox 3"/>
@@ -8940,2141 +8434,6 @@
         </p:nvSpPr>
         <p:spPr>
           <a:xfrm>
-            <a:off x="457200" y="164592"/>
-            <a:ext cx="11277295" cy="384048"/>
-          </a:xfrm>
-          <a:prstGeom prst="rect">
-            <a:avLst/>
-          </a:prstGeom>
-          <a:noFill/>
-        </p:spPr>
-        <p:txBody>
-          <a:bodyPr wrap="square">
-            <a:spAutoFit/>
-          </a:bodyPr>
-          <a:lstStyle/>
-          <a:p>
-            <a:r>
-              <a:rPr sz="2600" b="1" i="0">
-                <a:solidFill>
-                  <a:srgbClr val="FFFFFF"/>
-                </a:solidFill>
-                <a:latin typeface="Calibri"/>
-              </a:rPr>
-              <a:t>Del boceto a la plataforma del curso (diagrama)</a:t>
-            </a:r>
-          </a:p>
-        </p:txBody>
-      </p:sp>
-      <p:sp>
-        <p:nvSpPr>
-          <p:cNvPr id="5" name="TextBox 4"/>
-          <p:cNvSpPr txBox="1"/>
-          <p:nvPr/>
-        </p:nvSpPr>
-        <p:spPr>
-          <a:xfrm>
-            <a:off x="457200" y="566928"/>
-            <a:ext cx="11277295" cy="411480"/>
-          </a:xfrm>
-          <a:prstGeom prst="rect">
-            <a:avLst/>
-          </a:prstGeom>
-          <a:noFill/>
-        </p:spPr>
-        <p:txBody>
-          <a:bodyPr wrap="square">
-            <a:spAutoFit/>
-          </a:bodyPr>
-          <a:lstStyle/>
-          <a:p>
-            <a:r>
-              <a:rPr sz="1400" b="0" i="0">
-                <a:solidFill>
-                  <a:srgbClr val="B8D8EE"/>
-                </a:solidFill>
-                <a:latin typeface="Calibri"/>
-              </a:rPr>
-              <a:t>El diagrama se entrega como código Mermaid en la plataforma del curso, no como imagen</a:t>
-            </a:r>
-          </a:p>
-        </p:txBody>
-      </p:sp>
-      <p:sp>
-        <p:nvSpPr>
-          <p:cNvPr id="6" name="Rounded Rectangle 5"/>
-          <p:cNvSpPr/>
-          <p:nvPr/>
-        </p:nvSpPr>
-        <p:spPr>
-          <a:xfrm>
-            <a:off x="457200" y="1659636"/>
-            <a:ext cx="11277295" cy="1051560"/>
-          </a:xfrm>
-          <a:prstGeom prst="roundRect">
-            <a:avLst>
-              <a:gd name="adj" fmla="val 12000"/>
-            </a:avLst>
-          </a:prstGeom>
-          <a:solidFill>
-            <a:srgbClr val="F2F2F2"/>
-          </a:solidFill>
-          <a:ln>
-            <a:noFill/>
-          </a:ln>
-        </p:spPr>
-        <p:style>
-          <a:lnRef idx="1">
-            <a:schemeClr val="accent1"/>
-          </a:lnRef>
-          <a:fillRef idx="3">
-            <a:schemeClr val="accent1"/>
-          </a:fillRef>
-          <a:effectRef idx="2">
-            <a:schemeClr val="accent1"/>
-          </a:effectRef>
-          <a:fontRef idx="minor">
-            <a:schemeClr val="lt1"/>
-          </a:fontRef>
-        </p:style>
-        <p:txBody>
-          <a:bodyPr rtlCol="0" anchor="ctr"/>
-          <a:lstStyle/>
-          <a:p>
-            <a:pPr algn="ctr"/>
-          </a:p>
-        </p:txBody>
-      </p:sp>
-      <p:sp>
-        <p:nvSpPr>
-          <p:cNvPr id="7" name="Rounded Rectangle 6"/>
-          <p:cNvSpPr/>
-          <p:nvPr/>
-        </p:nvSpPr>
-        <p:spPr>
-          <a:xfrm>
-            <a:off x="594360" y="1965960"/>
-            <a:ext cx="438912" cy="438912"/>
-          </a:xfrm>
-          <a:prstGeom prst="roundRect">
-            <a:avLst>
-              <a:gd name="adj" fmla="val 12000"/>
-            </a:avLst>
-          </a:prstGeom>
-          <a:solidFill>
-            <a:srgbClr val="095292"/>
-          </a:solidFill>
-          <a:ln>
-            <a:noFill/>
-          </a:ln>
-        </p:spPr>
-        <p:style>
-          <a:lnRef idx="1">
-            <a:schemeClr val="accent1"/>
-          </a:lnRef>
-          <a:fillRef idx="3">
-            <a:schemeClr val="accent1"/>
-          </a:fillRef>
-          <a:effectRef idx="2">
-            <a:schemeClr val="accent1"/>
-          </a:effectRef>
-          <a:fontRef idx="minor">
-            <a:schemeClr val="lt1"/>
-          </a:fontRef>
-        </p:style>
-        <p:txBody>
-          <a:bodyPr rtlCol="0" anchor="ctr"/>
-          <a:lstStyle/>
-          <a:p>
-            <a:pPr algn="ctr"/>
-          </a:p>
-        </p:txBody>
-      </p:sp>
-      <p:sp>
-        <p:nvSpPr>
-          <p:cNvPr id="8" name="TextBox 7"/>
-          <p:cNvSpPr txBox="1"/>
-          <p:nvPr/>
-        </p:nvSpPr>
-        <p:spPr>
-          <a:xfrm>
-            <a:off x="594360" y="1965960"/>
-            <a:ext cx="438912" cy="438912"/>
-          </a:xfrm>
-          <a:prstGeom prst="rect">
-            <a:avLst/>
-          </a:prstGeom>
-          <a:noFill/>
-        </p:spPr>
-        <p:txBody>
-          <a:bodyPr wrap="square" anchor="ctr"/>
-          <a:lstStyle/>
-          <a:p>
-            <a:pPr algn="ctr"/>
-            <a:r>
-              <a:rPr sz="1600" b="1" i="0">
-                <a:solidFill>
-                  <a:srgbClr val="FFFFFF"/>
-                </a:solidFill>
-                <a:latin typeface="Calibri"/>
-              </a:rPr>
-              <a:t>1</a:t>
-            </a:r>
-          </a:p>
-        </p:txBody>
-      </p:sp>
-      <p:sp>
-        <p:nvSpPr>
-          <p:cNvPr id="9" name="TextBox 8"/>
-          <p:cNvSpPr txBox="1"/>
-          <p:nvPr/>
-        </p:nvSpPr>
-        <p:spPr>
-          <a:xfrm>
-            <a:off x="1188720" y="1751076"/>
-            <a:ext cx="10271455" cy="886968"/>
-          </a:xfrm>
-          <a:prstGeom prst="rect">
-            <a:avLst/>
-          </a:prstGeom>
-          <a:noFill/>
-        </p:spPr>
-        <p:txBody>
-          <a:bodyPr wrap="square" anchor="ctr"/>
-          <a:lstStyle/>
-          <a:p>
-            <a:r>
-              <a:rPr sz="1500" b="1" i="0">
-                <a:solidFill>
-                  <a:srgbClr val="095292"/>
-                </a:solidFill>
-                <a:latin typeface="Calibri"/>
-              </a:rPr>
-              <a:t>Disena visual</a:t>
-            </a:r>
-          </a:p>
-          <a:p>
-            <a:pPr>
-              <a:spcBef>
-                <a:spcPts val="200"/>
-              </a:spcBef>
-            </a:pPr>
-            <a:r>
-              <a:rPr sz="1300" b="0" i="0">
-                <a:solidFill>
-                  <a:srgbClr val="333333"/>
-                </a:solidFill>
-                <a:latin typeface="Calibri"/>
-              </a:rPr>
-              <a:t>Dibuja el diagrama como quieras en Excalidraw o draw.io: es mas rapido arrastrar cajas que escribir codigo, y ahi es donde piensas el modelo.</a:t>
-            </a:r>
-          </a:p>
-        </p:txBody>
-      </p:sp>
-      <p:sp>
-        <p:nvSpPr>
-          <p:cNvPr id="10" name="Rounded Rectangle 9"/>
-          <p:cNvSpPr/>
-          <p:nvPr/>
-        </p:nvSpPr>
-        <p:spPr>
-          <a:xfrm>
-            <a:off x="457200" y="2802636"/>
-            <a:ext cx="11277295" cy="1051560"/>
-          </a:xfrm>
-          <a:prstGeom prst="roundRect">
-            <a:avLst>
-              <a:gd name="adj" fmla="val 12000"/>
-            </a:avLst>
-          </a:prstGeom>
-          <a:solidFill>
-            <a:srgbClr val="E8F4FA"/>
-          </a:solidFill>
-          <a:ln>
-            <a:noFill/>
-          </a:ln>
-        </p:spPr>
-        <p:style>
-          <a:lnRef idx="1">
-            <a:schemeClr val="accent1"/>
-          </a:lnRef>
-          <a:fillRef idx="3">
-            <a:schemeClr val="accent1"/>
-          </a:fillRef>
-          <a:effectRef idx="2">
-            <a:schemeClr val="accent1"/>
-          </a:effectRef>
-          <a:fontRef idx="minor">
-            <a:schemeClr val="lt1"/>
-          </a:fontRef>
-        </p:style>
-        <p:txBody>
-          <a:bodyPr rtlCol="0" anchor="ctr"/>
-          <a:lstStyle/>
-          <a:p>
-            <a:pPr algn="ctr"/>
-          </a:p>
-        </p:txBody>
-      </p:sp>
-      <p:sp>
-        <p:nvSpPr>
-          <p:cNvPr id="11" name="Rounded Rectangle 10"/>
-          <p:cNvSpPr/>
-          <p:nvPr/>
-        </p:nvSpPr>
-        <p:spPr>
-          <a:xfrm>
-            <a:off x="594360" y="3108960"/>
-            <a:ext cx="438912" cy="438912"/>
-          </a:xfrm>
-          <a:prstGeom prst="roundRect">
-            <a:avLst>
-              <a:gd name="adj" fmla="val 12000"/>
-            </a:avLst>
-          </a:prstGeom>
-          <a:solidFill>
-            <a:srgbClr val="095292"/>
-          </a:solidFill>
-          <a:ln>
-            <a:noFill/>
-          </a:ln>
-        </p:spPr>
-        <p:style>
-          <a:lnRef idx="1">
-            <a:schemeClr val="accent1"/>
-          </a:lnRef>
-          <a:fillRef idx="3">
-            <a:schemeClr val="accent1"/>
-          </a:fillRef>
-          <a:effectRef idx="2">
-            <a:schemeClr val="accent1"/>
-          </a:effectRef>
-          <a:fontRef idx="minor">
-            <a:schemeClr val="lt1"/>
-          </a:fontRef>
-        </p:style>
-        <p:txBody>
-          <a:bodyPr rtlCol="0" anchor="ctr"/>
-          <a:lstStyle/>
-          <a:p>
-            <a:pPr algn="ctr"/>
-          </a:p>
-        </p:txBody>
-      </p:sp>
-      <p:sp>
-        <p:nvSpPr>
-          <p:cNvPr id="12" name="TextBox 11"/>
-          <p:cNvSpPr txBox="1"/>
-          <p:nvPr/>
-        </p:nvSpPr>
-        <p:spPr>
-          <a:xfrm>
-            <a:off x="594360" y="3108960"/>
-            <a:ext cx="438912" cy="438912"/>
-          </a:xfrm>
-          <a:prstGeom prst="rect">
-            <a:avLst/>
-          </a:prstGeom>
-          <a:noFill/>
-        </p:spPr>
-        <p:txBody>
-          <a:bodyPr wrap="square" anchor="ctr"/>
-          <a:lstStyle/>
-          <a:p>
-            <a:pPr algn="ctr"/>
-            <a:r>
-              <a:rPr sz="1600" b="1" i="0">
-                <a:solidFill>
-                  <a:srgbClr val="FFFFFF"/>
-                </a:solidFill>
-                <a:latin typeface="Calibri"/>
-              </a:rPr>
-              <a:t>2</a:t>
-            </a:r>
-          </a:p>
-        </p:txBody>
-      </p:sp>
-      <p:sp>
-        <p:nvSpPr>
-          <p:cNvPr id="13" name="TextBox 12"/>
-          <p:cNvSpPr txBox="1"/>
-          <p:nvPr/>
-        </p:nvSpPr>
-        <p:spPr>
-          <a:xfrm>
-            <a:off x="1188720" y="2894076"/>
-            <a:ext cx="10271455" cy="886968"/>
-          </a:xfrm>
-          <a:prstGeom prst="rect">
-            <a:avLst/>
-          </a:prstGeom>
-          <a:noFill/>
-        </p:spPr>
-        <p:txBody>
-          <a:bodyPr wrap="square" anchor="ctr"/>
-          <a:lstStyle/>
-          <a:p>
-            <a:r>
-              <a:rPr sz="1500" b="1" i="0">
-                <a:solidFill>
-                  <a:srgbClr val="095292"/>
-                </a:solidFill>
-                <a:latin typeface="Calibri"/>
-              </a:rPr>
-              <a:t>Traduce con IA</a:t>
-            </a:r>
-          </a:p>
-          <a:p>
-            <a:pPr>
-              <a:spcBef>
-                <a:spcPts val="200"/>
-              </a:spcBef>
-            </a:pPr>
-            <a:r>
-              <a:rPr sz="1300" b="0" i="0">
-                <a:solidFill>
-                  <a:srgbClr val="333333"/>
-                </a:solidFill>
-                <a:latin typeface="Calibri"/>
-              </a:rPr>
-              <a:t>Copia o describe tu boceto a una IA y pidele el codigo Mermaid: «convierte este diagrama a Mermaid usando C4Context». Revisa el resultado: la IA acierta la sintaxis, no tu modelo.</a:t>
-            </a:r>
-          </a:p>
-        </p:txBody>
-      </p:sp>
-      <p:sp>
-        <p:nvSpPr>
-          <p:cNvPr id="14" name="Rounded Rectangle 13"/>
-          <p:cNvSpPr/>
-          <p:nvPr/>
-        </p:nvSpPr>
-        <p:spPr>
-          <a:xfrm>
-            <a:off x="457200" y="3945636"/>
-            <a:ext cx="11277295" cy="1051560"/>
-          </a:xfrm>
-          <a:prstGeom prst="roundRect">
-            <a:avLst>
-              <a:gd name="adj" fmla="val 12000"/>
-            </a:avLst>
-          </a:prstGeom>
-          <a:solidFill>
-            <a:srgbClr val="F2F2F2"/>
-          </a:solidFill>
-          <a:ln>
-            <a:noFill/>
-          </a:ln>
-        </p:spPr>
-        <p:style>
-          <a:lnRef idx="1">
-            <a:schemeClr val="accent1"/>
-          </a:lnRef>
-          <a:fillRef idx="3">
-            <a:schemeClr val="accent1"/>
-          </a:fillRef>
-          <a:effectRef idx="2">
-            <a:schemeClr val="accent1"/>
-          </a:effectRef>
-          <a:fontRef idx="minor">
-            <a:schemeClr val="lt1"/>
-          </a:fontRef>
-        </p:style>
-        <p:txBody>
-          <a:bodyPr rtlCol="0" anchor="ctr"/>
-          <a:lstStyle/>
-          <a:p>
-            <a:pPr algn="ctr"/>
-          </a:p>
-        </p:txBody>
-      </p:sp>
-      <p:sp>
-        <p:nvSpPr>
-          <p:cNvPr id="15" name="Rounded Rectangle 14"/>
-          <p:cNvSpPr/>
-          <p:nvPr/>
-        </p:nvSpPr>
-        <p:spPr>
-          <a:xfrm>
-            <a:off x="594360" y="4251960"/>
-            <a:ext cx="438912" cy="438912"/>
-          </a:xfrm>
-          <a:prstGeom prst="roundRect">
-            <a:avLst>
-              <a:gd name="adj" fmla="val 12000"/>
-            </a:avLst>
-          </a:prstGeom>
-          <a:solidFill>
-            <a:srgbClr val="095292"/>
-          </a:solidFill>
-          <a:ln>
-            <a:noFill/>
-          </a:ln>
-        </p:spPr>
-        <p:style>
-          <a:lnRef idx="1">
-            <a:schemeClr val="accent1"/>
-          </a:lnRef>
-          <a:fillRef idx="3">
-            <a:schemeClr val="accent1"/>
-          </a:fillRef>
-          <a:effectRef idx="2">
-            <a:schemeClr val="accent1"/>
-          </a:effectRef>
-          <a:fontRef idx="minor">
-            <a:schemeClr val="lt1"/>
-          </a:fontRef>
-        </p:style>
-        <p:txBody>
-          <a:bodyPr rtlCol="0" anchor="ctr"/>
-          <a:lstStyle/>
-          <a:p>
-            <a:pPr algn="ctr"/>
-          </a:p>
-        </p:txBody>
-      </p:sp>
-      <p:sp>
-        <p:nvSpPr>
-          <p:cNvPr id="16" name="TextBox 15"/>
-          <p:cNvSpPr txBox="1"/>
-          <p:nvPr/>
-        </p:nvSpPr>
-        <p:spPr>
-          <a:xfrm>
-            <a:off x="594360" y="4251960"/>
-            <a:ext cx="438912" cy="438912"/>
-          </a:xfrm>
-          <a:prstGeom prst="rect">
-            <a:avLst/>
-          </a:prstGeom>
-          <a:noFill/>
-        </p:spPr>
-        <p:txBody>
-          <a:bodyPr wrap="square" anchor="ctr"/>
-          <a:lstStyle/>
-          <a:p>
-            <a:pPr algn="ctr"/>
-            <a:r>
-              <a:rPr sz="1600" b="1" i="0">
-                <a:solidFill>
-                  <a:srgbClr val="FFFFFF"/>
-                </a:solidFill>
-                <a:latin typeface="Calibri"/>
-              </a:rPr>
-              <a:t>3</a:t>
-            </a:r>
-          </a:p>
-        </p:txBody>
-      </p:sp>
-      <p:sp>
-        <p:nvSpPr>
-          <p:cNvPr id="17" name="TextBox 16"/>
-          <p:cNvSpPr txBox="1"/>
-          <p:nvPr/>
-        </p:nvSpPr>
-        <p:spPr>
-          <a:xfrm>
-            <a:off x="1188720" y="4037076"/>
-            <a:ext cx="10271455" cy="886968"/>
-          </a:xfrm>
-          <a:prstGeom prst="rect">
-            <a:avLst/>
-          </a:prstGeom>
-          <a:noFill/>
-        </p:spPr>
-        <p:txBody>
-          <a:bodyPr wrap="square" anchor="ctr"/>
-          <a:lstStyle/>
-          <a:p>
-            <a:r>
-              <a:rPr sz="1500" b="1" i="0">
-                <a:solidFill>
-                  <a:srgbClr val="095292"/>
-                </a:solidFill>
-                <a:latin typeface="Calibri"/>
-              </a:rPr>
-              <a:t>Pega y renderiza en la plataforma del curso</a:t>
-            </a:r>
-          </a:p>
-          <a:p>
-            <a:pPr>
-              <a:spcBef>
-                <a:spcPts val="200"/>
-              </a:spcBef>
-            </a:pPr>
-            <a:r>
-              <a:rPr sz="1300" b="0" i="0">
-                <a:solidFill>
-                  <a:srgbClr val="333333"/>
-                </a:solidFill>
-                <a:latin typeface="Calibri"/>
-              </a:rPr>
-              <a:t>Pega ese codigo en la caja de texto de la pregunta y mira como lo dibuja la plataforma. Si no renderiza, corrige ahi mismo: lo que se califica es el diagrama renderizado dentro de la plataforma del curso.</a:t>
-            </a:r>
-          </a:p>
-        </p:txBody>
-      </p:sp>
-      <p:sp>
-        <p:nvSpPr>
-          <p:cNvPr id="18" name="Rounded Rectangle 17"/>
-          <p:cNvSpPr/>
-          <p:nvPr/>
-        </p:nvSpPr>
-        <p:spPr>
-          <a:xfrm>
-            <a:off x="457200" y="5088636"/>
-            <a:ext cx="11277295" cy="1051560"/>
-          </a:xfrm>
-          <a:prstGeom prst="roundRect">
-            <a:avLst>
-              <a:gd name="adj" fmla="val 12000"/>
-            </a:avLst>
-          </a:prstGeom>
-          <a:solidFill>
-            <a:srgbClr val="E8F4FA"/>
-          </a:solidFill>
-          <a:ln>
-            <a:noFill/>
-          </a:ln>
-        </p:spPr>
-        <p:style>
-          <a:lnRef idx="1">
-            <a:schemeClr val="accent1"/>
-          </a:lnRef>
-          <a:fillRef idx="3">
-            <a:schemeClr val="accent1"/>
-          </a:fillRef>
-          <a:effectRef idx="2">
-            <a:schemeClr val="accent1"/>
-          </a:effectRef>
-          <a:fontRef idx="minor">
-            <a:schemeClr val="lt1"/>
-          </a:fontRef>
-        </p:style>
-        <p:txBody>
-          <a:bodyPr rtlCol="0" anchor="ctr"/>
-          <a:lstStyle/>
-          <a:p>
-            <a:pPr algn="ctr"/>
-          </a:p>
-        </p:txBody>
-      </p:sp>
-      <p:sp>
-        <p:nvSpPr>
-          <p:cNvPr id="19" name="Rounded Rectangle 18"/>
-          <p:cNvSpPr/>
-          <p:nvPr/>
-        </p:nvSpPr>
-        <p:spPr>
-          <a:xfrm>
-            <a:off x="594360" y="5394960"/>
-            <a:ext cx="438912" cy="438912"/>
-          </a:xfrm>
-          <a:prstGeom prst="roundRect">
-            <a:avLst>
-              <a:gd name="adj" fmla="val 12000"/>
-            </a:avLst>
-          </a:prstGeom>
-          <a:solidFill>
-            <a:srgbClr val="095292"/>
-          </a:solidFill>
-          <a:ln>
-            <a:noFill/>
-          </a:ln>
-        </p:spPr>
-        <p:style>
-          <a:lnRef idx="1">
-            <a:schemeClr val="accent1"/>
-          </a:lnRef>
-          <a:fillRef idx="3">
-            <a:schemeClr val="accent1"/>
-          </a:fillRef>
-          <a:effectRef idx="2">
-            <a:schemeClr val="accent1"/>
-          </a:effectRef>
-          <a:fontRef idx="minor">
-            <a:schemeClr val="lt1"/>
-          </a:fontRef>
-        </p:style>
-        <p:txBody>
-          <a:bodyPr rtlCol="0" anchor="ctr"/>
-          <a:lstStyle/>
-          <a:p>
-            <a:pPr algn="ctr"/>
-          </a:p>
-        </p:txBody>
-      </p:sp>
-      <p:sp>
-        <p:nvSpPr>
-          <p:cNvPr id="20" name="TextBox 19"/>
-          <p:cNvSpPr txBox="1"/>
-          <p:nvPr/>
-        </p:nvSpPr>
-        <p:spPr>
-          <a:xfrm>
-            <a:off x="594360" y="5394960"/>
-            <a:ext cx="438912" cy="438912"/>
-          </a:xfrm>
-          <a:prstGeom prst="rect">
-            <a:avLst/>
-          </a:prstGeom>
-          <a:noFill/>
-        </p:spPr>
-        <p:txBody>
-          <a:bodyPr wrap="square" anchor="ctr"/>
-          <a:lstStyle/>
-          <a:p>
-            <a:pPr algn="ctr"/>
-            <a:r>
-              <a:rPr sz="1600" b="1" i="0">
-                <a:solidFill>
-                  <a:srgbClr val="FFFFFF"/>
-                </a:solidFill>
-                <a:latin typeface="Calibri"/>
-              </a:rPr>
-              <a:t>4</a:t>
-            </a:r>
-          </a:p>
-        </p:txBody>
-      </p:sp>
-      <p:sp>
-        <p:nvSpPr>
-          <p:cNvPr id="21" name="TextBox 20"/>
-          <p:cNvSpPr txBox="1"/>
-          <p:nvPr/>
-        </p:nvSpPr>
-        <p:spPr>
-          <a:xfrm>
-            <a:off x="1188720" y="5180076"/>
-            <a:ext cx="10271455" cy="886968"/>
-          </a:xfrm>
-          <a:prstGeom prst="rect">
-            <a:avLst/>
-          </a:prstGeom>
-          <a:noFill/>
-        </p:spPr>
-        <p:txBody>
-          <a:bodyPr wrap="square" anchor="ctr"/>
-          <a:lstStyle/>
-          <a:p>
-            <a:r>
-              <a:rPr sz="1500" b="1" i="0">
-                <a:solidFill>
-                  <a:srgbClr val="095292"/>
-                </a:solidFill>
-                <a:latin typeface="Calibri"/>
-              </a:rPr>
-              <a:t>Guarda el PNG para tu PI</a:t>
-            </a:r>
-          </a:p>
-          <a:p>
-            <a:pPr>
-              <a:spcBef>
-                <a:spcPts val="200"/>
-              </a:spcBef>
-            </a:pPr>
-            <a:r>
-              <a:rPr sz="1300" b="0" i="0">
-                <a:solidFill>
-                  <a:srgbClr val="333333"/>
-                </a:solidFill>
-                <a:latin typeface="Calibri"/>
-              </a:rPr>
-              <a:t>Exporta tambien la imagen a la carpeta de tu Proyecto Integrador. Esa copia es para tu informe; no reemplaza la respuesta en la plataforma.</a:t>
-            </a:r>
-          </a:p>
-        </p:txBody>
-      </p:sp>
-      <p:sp>
-        <p:nvSpPr>
-          <p:cNvPr id="22" name="TextBox 21"/>
-          <p:cNvSpPr txBox="1"/>
-          <p:nvPr/>
-        </p:nvSpPr>
-        <p:spPr>
-          <a:xfrm>
-            <a:off x="11185855" y="6473952"/>
-            <a:ext cx="640080" cy="274320"/>
-          </a:xfrm>
-          <a:prstGeom prst="rect">
-            <a:avLst/>
-          </a:prstGeom>
-          <a:noFill/>
-        </p:spPr>
-        <p:txBody>
-          <a:bodyPr wrap="square">
-            <a:spAutoFit/>
-          </a:bodyPr>
-          <a:lstStyle/>
-          <a:p>
-            <a:pPr algn="r"/>
-            <a:r>
-              <a:rPr sz="1100" b="0" i="0">
-                <a:solidFill>
-                  <a:srgbClr val="666666"/>
-                </a:solidFill>
-                <a:latin typeface="Calibri"/>
-              </a:rPr>
-              <a:t>24</a:t>
-            </a:r>
-          </a:p>
-        </p:txBody>
-      </p:sp>
-    </p:spTree>
-  </p:cSld>
-  <p:clrMapOvr>
-    <a:masterClrMapping/>
-  </p:clrMapOvr>
-</p:sld>
-</file>
-
-<file path=ppt/slides/slide25.xml><?xml version="1.0" encoding="utf-8"?>
-<p:sld xmlns:a="http://schemas.openxmlformats.org/drawingml/2006/main" xmlns:p="http://schemas.openxmlformats.org/presentationml/2006/main" xmlns:r="http://schemas.openxmlformats.org/officeDocument/2006/relationships">
-  <p:cSld>
-    <p:bg>
-      <p:bgPr>
-        <a:solidFill>
-          <a:srgbClr val="FFFFFF"/>
-        </a:solidFill>
-        <a:effectLst/>
-      </p:bgPr>
-    </p:bg>
-    <p:spTree>
-      <p:nvGrpSpPr>
-        <p:cNvPr id="1" name=""/>
-        <p:cNvGrpSpPr/>
-        <p:nvPr/>
-      </p:nvGrpSpPr>
-      <p:grpSpPr/>
-      <p:sp>
-        <p:nvSpPr>
-          <p:cNvPr id="2" name="Rectangle 1"/>
-          <p:cNvSpPr/>
-          <p:nvPr/>
-        </p:nvSpPr>
-        <p:spPr>
-          <a:xfrm>
-            <a:off x="0" y="0"/>
-            <a:ext cx="12191695" cy="960120"/>
-          </a:xfrm>
-          <a:prstGeom prst="rect">
-            <a:avLst/>
-          </a:prstGeom>
-          <a:solidFill>
-            <a:srgbClr val="095292"/>
-          </a:solidFill>
-          <a:ln>
-            <a:noFill/>
-          </a:ln>
-        </p:spPr>
-        <p:style>
-          <a:lnRef idx="1">
-            <a:schemeClr val="accent1"/>
-          </a:lnRef>
-          <a:fillRef idx="3">
-            <a:schemeClr val="accent1"/>
-          </a:fillRef>
-          <a:effectRef idx="2">
-            <a:schemeClr val="accent1"/>
-          </a:effectRef>
-          <a:fontRef idx="minor">
-            <a:schemeClr val="lt1"/>
-          </a:fontRef>
-        </p:style>
-        <p:txBody>
-          <a:bodyPr rtlCol="0" anchor="ctr"/>
-          <a:lstStyle/>
-          <a:p>
-            <a:pPr algn="ctr"/>
-          </a:p>
-        </p:txBody>
-      </p:sp>
-      <p:sp>
-        <p:nvSpPr>
-          <p:cNvPr id="3" name="Rectangle 2"/>
-          <p:cNvSpPr/>
-          <p:nvPr/>
-        </p:nvSpPr>
-        <p:spPr>
-          <a:xfrm>
-            <a:off x="0" y="960120"/>
-            <a:ext cx="12191695" cy="41148"/>
-          </a:xfrm>
-          <a:prstGeom prst="rect">
-            <a:avLst/>
-          </a:prstGeom>
-          <a:solidFill>
-            <a:srgbClr val="FFD000"/>
-          </a:solidFill>
-          <a:ln>
-            <a:noFill/>
-          </a:ln>
-        </p:spPr>
-        <p:style>
-          <a:lnRef idx="1">
-            <a:schemeClr val="accent1"/>
-          </a:lnRef>
-          <a:fillRef idx="3">
-            <a:schemeClr val="accent1"/>
-          </a:fillRef>
-          <a:effectRef idx="2">
-            <a:schemeClr val="accent1"/>
-          </a:effectRef>
-          <a:fontRef idx="minor">
-            <a:schemeClr val="lt1"/>
-          </a:fontRef>
-        </p:style>
-        <p:txBody>
-          <a:bodyPr rtlCol="0" anchor="ctr"/>
-          <a:lstStyle/>
-          <a:p>
-            <a:pPr algn="ctr"/>
-          </a:p>
-        </p:txBody>
-      </p:sp>
-      <p:sp>
-        <p:nvSpPr>
-          <p:cNvPr id="4" name="TextBox 3"/>
-          <p:cNvSpPr txBox="1"/>
-          <p:nvPr/>
-        </p:nvSpPr>
-        <p:spPr>
-          <a:xfrm>
-            <a:off x="457200" y="164592"/>
-            <a:ext cx="11277295" cy="502920"/>
-          </a:xfrm>
-          <a:prstGeom prst="rect">
-            <a:avLst/>
-          </a:prstGeom>
-          <a:noFill/>
-        </p:spPr>
-        <p:txBody>
-          <a:bodyPr wrap="square">
-            <a:spAutoFit/>
-          </a:bodyPr>
-          <a:lstStyle/>
-          <a:p>
-            <a:r>
-              <a:rPr sz="2600" b="1" i="0">
-                <a:solidFill>
-                  <a:srgbClr val="FFFFFF"/>
-                </a:solidFill>
-                <a:latin typeface="Calibri"/>
-              </a:rPr>
-              <a:t>PI CloudLite — entregable de hoy</a:t>
-            </a:r>
-          </a:p>
-        </p:txBody>
-      </p:sp>
-      <p:sp>
-        <p:nvSpPr>
-          <p:cNvPr id="5" name="TextBox 4"/>
-          <p:cNvSpPr txBox="1"/>
-          <p:nvPr/>
-        </p:nvSpPr>
-        <p:spPr>
-          <a:xfrm>
-            <a:off x="457200" y="1170432"/>
-            <a:ext cx="11277295" cy="5230368"/>
-          </a:xfrm>
-          <a:prstGeom prst="rect">
-            <a:avLst/>
-          </a:prstGeom>
-          <a:noFill/>
-        </p:spPr>
-        <p:txBody>
-          <a:bodyPr wrap="square">
-            <a:spAutoFit/>
-          </a:bodyPr>
-          <a:lstStyle/>
-          <a:p>
-            <a:pPr>
-              <a:spcAft>
-                <a:spcPts val="800"/>
-              </a:spcAft>
-            </a:pPr>
-            <a:r>
-              <a:rPr sz="2000" b="0" i="0">
-                <a:solidFill>
-                  <a:srgbClr val="333333"/>
-                </a:solidFill>
-                <a:latin typeface="Calibri"/>
-              </a:rPr>
-              <a:t>–   </a:t>
-            </a:r>
-            <a:r>
-              <a:rPr sz="2000" b="1" i="0">
-                <a:solidFill>
-                  <a:srgbClr val="333333"/>
-                </a:solidFill>
-                <a:latin typeface="Calibri"/>
-              </a:rPr>
-              <a:t>Entregable:</a:t>
-            </a:r>
-            <a:r>
-              <a:rPr sz="2000" b="0" i="0">
-                <a:solidFill>
-                  <a:srgbClr val="333333"/>
-                </a:solidFill>
-                <a:latin typeface="Calibri"/>
-              </a:rPr>
-              <a:t> Ficha PI de 5 bloques + C4 Context en Mermaid renderizado en la plataforma (boceto previo en Excalidraw/draw.io)</a:t>
-            </a:r>
-          </a:p>
-          <a:p>
-            <a:pPr>
-              <a:spcAft>
-                <a:spcPts val="800"/>
-              </a:spcAft>
-            </a:pPr>
-            <a:r>
-              <a:rPr sz="2000" b="0" i="0">
-                <a:solidFill>
-                  <a:srgbClr val="333333"/>
-                </a:solidFill>
-                <a:latin typeface="Calibri"/>
-              </a:rPr>
-              <a:t>–   Herramienta: </a:t>
-            </a:r>
-            <a:r>
-              <a:rPr sz="2000" b="1" i="0">
-                <a:solidFill>
-                  <a:srgbClr val="333333"/>
-                </a:solidFill>
-                <a:latin typeface="Calibri"/>
-              </a:rPr>
-              <a:t>Navegador · editor de diagramas del curso · boceto libre (papel o Excalidraw) opcional</a:t>
-            </a:r>
-          </a:p>
-          <a:p>
-            <a:pPr>
-              <a:spcAft>
-                <a:spcPts val="800"/>
-              </a:spcAft>
-            </a:pPr>
-            <a:r>
-              <a:rPr sz="2000" b="0" i="0">
-                <a:solidFill>
-                  <a:srgbClr val="333333"/>
-                </a:solidFill>
-                <a:latin typeface="Calibri"/>
-              </a:rPr>
-              <a:t>–   Todo lo que construyan hoy entra al </a:t>
-            </a:r>
-            <a:r>
-              <a:rPr sz="2000" b="1" i="0">
-                <a:solidFill>
-                  <a:srgbClr val="333333"/>
-                </a:solidFill>
-                <a:latin typeface="Calibri"/>
-              </a:rPr>
-              <a:t>informe/repo del PI</a:t>
-            </a:r>
-            <a:r>
-              <a:rPr sz="2000" b="0" i="0">
-                <a:solidFill>
-                  <a:srgbClr val="333333"/>
-                </a:solidFill>
-                <a:latin typeface="Calibri"/>
-              </a:rPr>
-              <a:t> (no es lab suelto).</a:t>
-            </a:r>
-          </a:p>
-          <a:p>
-            <a:pPr>
-              <a:spcAft>
-                <a:spcPts val="800"/>
-              </a:spcAft>
-            </a:pPr>
-            <a:r>
-              <a:rPr sz="2000" b="0" i="0">
-                <a:solidFill>
-                  <a:srgbClr val="333333"/>
-                </a:solidFill>
-                <a:latin typeface="Calibri"/>
-              </a:rPr>
-              <a:t>–   Ficha de 5 bloques: DOMINIO · PROBLEMA · ACTORES (con sus sistemas externos) · CAPACIDADES · FUERA DE ALCANCE.</a:t>
-            </a:r>
-          </a:p>
-          <a:p>
-            <a:pPr>
-              <a:spcAft>
-                <a:spcPts val="800"/>
-              </a:spcAft>
-            </a:pPr>
-            <a:r>
-              <a:rPr sz="2000" b="0" i="0">
-                <a:solidFill>
-                  <a:srgbClr val="333333"/>
-                </a:solidFill>
-                <a:latin typeface="Calibri"/>
-              </a:rPr>
-              <a:t>–   Actividad individual: cada estudiante define su propio dominio CloudLite.</a:t>
-            </a:r>
-          </a:p>
-        </p:txBody>
-      </p:sp>
-      <p:sp>
-        <p:nvSpPr>
-          <p:cNvPr id="6" name="TextBox 5"/>
-          <p:cNvSpPr txBox="1"/>
-          <p:nvPr/>
-        </p:nvSpPr>
-        <p:spPr>
-          <a:xfrm>
-            <a:off x="11185855" y="6473952"/>
-            <a:ext cx="640080" cy="274320"/>
-          </a:xfrm>
-          <a:prstGeom prst="rect">
-            <a:avLst/>
-          </a:prstGeom>
-          <a:noFill/>
-        </p:spPr>
-        <p:txBody>
-          <a:bodyPr wrap="square">
-            <a:spAutoFit/>
-          </a:bodyPr>
-          <a:lstStyle/>
-          <a:p>
-            <a:pPr algn="r"/>
-            <a:r>
-              <a:rPr sz="1100" b="0" i="0">
-                <a:solidFill>
-                  <a:srgbClr val="666666"/>
-                </a:solidFill>
-                <a:latin typeface="Calibri"/>
-              </a:rPr>
-              <a:t>25</a:t>
-            </a:r>
-          </a:p>
-        </p:txBody>
-      </p:sp>
-    </p:spTree>
-  </p:cSld>
-  <p:clrMapOvr>
-    <a:masterClrMapping/>
-  </p:clrMapOvr>
-</p:sld>
-</file>
-
-<file path=ppt/slides/slide26.xml><?xml version="1.0" encoding="utf-8"?>
-<p:sld xmlns:a="http://schemas.openxmlformats.org/drawingml/2006/main" xmlns:p="http://schemas.openxmlformats.org/presentationml/2006/main" xmlns:r="http://schemas.openxmlformats.org/officeDocument/2006/relationships">
-  <p:cSld>
-    <p:bg>
-      <p:bgPr>
-        <a:solidFill>
-          <a:srgbClr val="FFFFFF"/>
-        </a:solidFill>
-        <a:effectLst/>
-      </p:bgPr>
-    </p:bg>
-    <p:spTree>
-      <p:nvGrpSpPr>
-        <p:cNvPr id="1" name=""/>
-        <p:cNvGrpSpPr/>
-        <p:nvPr/>
-      </p:nvGrpSpPr>
-      <p:grpSpPr/>
-      <p:sp>
-        <p:nvSpPr>
-          <p:cNvPr id="2" name="Rectangle 1"/>
-          <p:cNvSpPr/>
-          <p:nvPr/>
-        </p:nvSpPr>
-        <p:spPr>
-          <a:xfrm>
-            <a:off x="0" y="0"/>
-            <a:ext cx="12191695" cy="960120"/>
-          </a:xfrm>
-          <a:prstGeom prst="rect">
-            <a:avLst/>
-          </a:prstGeom>
-          <a:solidFill>
-            <a:srgbClr val="095292"/>
-          </a:solidFill>
-          <a:ln>
-            <a:noFill/>
-          </a:ln>
-        </p:spPr>
-        <p:style>
-          <a:lnRef idx="1">
-            <a:schemeClr val="accent1"/>
-          </a:lnRef>
-          <a:fillRef idx="3">
-            <a:schemeClr val="accent1"/>
-          </a:fillRef>
-          <a:effectRef idx="2">
-            <a:schemeClr val="accent1"/>
-          </a:effectRef>
-          <a:fontRef idx="minor">
-            <a:schemeClr val="lt1"/>
-          </a:fontRef>
-        </p:style>
-        <p:txBody>
-          <a:bodyPr rtlCol="0" anchor="ctr"/>
-          <a:lstStyle/>
-          <a:p>
-            <a:pPr algn="ctr"/>
-          </a:p>
-        </p:txBody>
-      </p:sp>
-      <p:sp>
-        <p:nvSpPr>
-          <p:cNvPr id="3" name="Rectangle 2"/>
-          <p:cNvSpPr/>
-          <p:nvPr/>
-        </p:nvSpPr>
-        <p:spPr>
-          <a:xfrm>
-            <a:off x="0" y="960120"/>
-            <a:ext cx="12191695" cy="41148"/>
-          </a:xfrm>
-          <a:prstGeom prst="rect">
-            <a:avLst/>
-          </a:prstGeom>
-          <a:solidFill>
-            <a:srgbClr val="FFD000"/>
-          </a:solidFill>
-          <a:ln>
-            <a:noFill/>
-          </a:ln>
-        </p:spPr>
-        <p:style>
-          <a:lnRef idx="1">
-            <a:schemeClr val="accent1"/>
-          </a:lnRef>
-          <a:fillRef idx="3">
-            <a:schemeClr val="accent1"/>
-          </a:fillRef>
-          <a:effectRef idx="2">
-            <a:schemeClr val="accent1"/>
-          </a:effectRef>
-          <a:fontRef idx="minor">
-            <a:schemeClr val="lt1"/>
-          </a:fontRef>
-        </p:style>
-        <p:txBody>
-          <a:bodyPr rtlCol="0" anchor="ctr"/>
-          <a:lstStyle/>
-          <a:p>
-            <a:pPr algn="ctr"/>
-          </a:p>
-        </p:txBody>
-      </p:sp>
-      <p:sp>
-        <p:nvSpPr>
-          <p:cNvPr id="4" name="TextBox 3"/>
-          <p:cNvSpPr txBox="1"/>
-          <p:nvPr/>
-        </p:nvSpPr>
-        <p:spPr>
-          <a:xfrm>
-            <a:off x="457200" y="164592"/>
-            <a:ext cx="11277295" cy="502920"/>
-          </a:xfrm>
-          <a:prstGeom prst="rect">
-            <a:avLst/>
-          </a:prstGeom>
-          <a:noFill/>
-        </p:spPr>
-        <p:txBody>
-          <a:bodyPr wrap="square">
-            <a:spAutoFit/>
-          </a:bodyPr>
-          <a:lstStyle/>
-          <a:p>
-            <a:r>
-              <a:rPr sz="2600" b="1" i="0">
-                <a:solidFill>
-                  <a:srgbClr val="FFFFFF"/>
-                </a:solidFill>
-                <a:latin typeface="Calibri"/>
-              </a:rPr>
-              <a:t>Manos a la obra (paso a paso)</a:t>
-            </a:r>
-          </a:p>
-        </p:txBody>
-      </p:sp>
-      <p:sp>
-        <p:nvSpPr>
-          <p:cNvPr id="5" name="TextBox 4"/>
-          <p:cNvSpPr txBox="1"/>
-          <p:nvPr/>
-        </p:nvSpPr>
-        <p:spPr>
-          <a:xfrm>
-            <a:off x="457200" y="1170432"/>
-            <a:ext cx="11277295" cy="5230368"/>
-          </a:xfrm>
-          <a:prstGeom prst="rect">
-            <a:avLst/>
-          </a:prstGeom>
-          <a:noFill/>
-        </p:spPr>
-        <p:txBody>
-          <a:bodyPr wrap="square">
-            <a:spAutoFit/>
-          </a:bodyPr>
-          <a:lstStyle/>
-          <a:p>
-            <a:pPr>
-              <a:spcAft>
-                <a:spcPts val="800"/>
-              </a:spcAft>
-            </a:pPr>
-            <a:r>
-              <a:rPr sz="1800" b="1" i="0">
-                <a:solidFill>
-                  <a:srgbClr val="333333"/>
-                </a:solidFill>
-                <a:latin typeface="Calibri"/>
-              </a:rPr>
-              <a:t>1.</a:t>
-            </a:r>
-            <a:r>
-              <a:rPr sz="1800" b="0" i="0">
-                <a:solidFill>
-                  <a:srgbClr val="333333"/>
-                </a:solidFill>
-                <a:latin typeface="Calibri"/>
-              </a:rPr>
-              <a:t> Paso 1: elija un dominio concreto entre AgendaU, BiblioLite, InventarioLab, TurnosClinica o EventosCampus (o uno propio del mismo tamano) y escriba en la pregunta 1 el problema en 2 o 3 frases, diciendo QUIEN lo sufre con un rol concreto y COMO se mide con una cifra, aunque sea estimada; verifique que su enunciado no sirva igual para cualquier otro sistema, porque entonces el dominio todavia es generico.</a:t>
-            </a:r>
-          </a:p>
-          <a:p>
-            <a:pPr>
-              <a:spcAft>
-                <a:spcPts val="800"/>
-              </a:spcAft>
-            </a:pPr>
-            <a:r>
-              <a:rPr sz="1800" b="0" i="0">
-                <a:solidFill>
-                  <a:srgbClr val="333333"/>
-                </a:solidFill>
-                <a:latin typeface="Calibri"/>
-              </a:rPr>
-              <a:t>–   </a:t>
-            </a:r>
-            <a:r>
-              <a:rPr sz="1800" b="1" i="0">
-                <a:solidFill>
-                  <a:srgbClr val="333333"/>
-                </a:solidFill>
-                <a:latin typeface="Calibri"/>
-              </a:rPr>
-              <a:t>2.</a:t>
-            </a:r>
-            <a:r>
-              <a:rPr sz="1800" b="0" i="0">
-                <a:solidFill>
-                  <a:srgbClr val="333333"/>
-                </a:solidFill>
-                <a:latin typeface="Calibri"/>
-              </a:rPr>
-              <a:t> Paso 2: complete en la pregunta 2 la ficha de cinco bloques (DOMINIO, PROBLEMA, ACTORES, CAPACIDADES, FUERA DE ALCANCE) con 3 a 5 capacidades en la forma verbo mas objeto de negocio, 2 a 3 actores con lo que espera cada uno, los sistemas externos dentro del bloque ACTORES, y lo que el sistema no hara este semestre; verifique que ninguna capacidad nombre tecnologia.</a:t>
-            </a:r>
-          </a:p>
-          <a:p>
-            <a:pPr>
-              <a:spcAft>
-                <a:spcPts val="800"/>
-              </a:spcAft>
-            </a:pPr>
-            <a:r>
-              <a:rPr sz="1800" b="0" i="0">
-                <a:solidFill>
-                  <a:srgbClr val="333333"/>
-                </a:solidFill>
-                <a:latin typeface="Calibri"/>
-              </a:rPr>
-              <a:t>–   </a:t>
-            </a:r>
-            <a:r>
-              <a:rPr sz="1800" b="1" i="0">
-                <a:solidFill>
-                  <a:srgbClr val="333333"/>
-                </a:solidFill>
-                <a:latin typeface="Calibri"/>
-              </a:rPr>
-              <a:t>3.</a:t>
-            </a:r>
-            <a:r>
-              <a:rPr sz="1800" b="0" i="0">
-                <a:solidFill>
-                  <a:srgbClr val="333333"/>
-                </a:solidFill>
-                <a:latin typeface="Calibri"/>
-              </a:rPr>
-              <a:t> Paso 3: dibuje primero el boceto del C4 Context en Excalidraw o draw.io, que es donde se piensa el modelo, y despues pidale a una IA que lo traduzca a Mermaid («convierta este diagrama a Mermaid usando C4Context»); peguelo en la pregunta 3 y verifique en el diagrama ya renderizado que el sistema sea UNA sola caja, que no aparezca ninguna caja interna (eso es la pregunta 13) y que cada flecha lleve verbo y protocolo.</a:t>
-            </a:r>
-          </a:p>
-          <a:p>
-            <a:pPr>
-              <a:spcAft>
-                <a:spcPts val="800"/>
-              </a:spcAft>
-            </a:pPr>
-            <a:r>
-              <a:rPr sz="1800" b="0" i="0">
-                <a:solidFill>
-                  <a:srgbClr val="333333"/>
-                </a:solidFill>
-                <a:latin typeface="Calibri"/>
-              </a:rPr>
-              <a:t>–   </a:t>
-            </a:r>
-            <a:r>
-              <a:rPr sz="1800" b="1" i="0">
-                <a:solidFill>
-                  <a:srgbClr val="333333"/>
-                </a:solidFill>
-                <a:latin typeface="Calibri"/>
-              </a:rPr>
-              <a:t>4.</a:t>
-            </a:r>
-            <a:r>
-              <a:rPr sz="1800" b="0" i="0">
-                <a:solidFill>
-                  <a:srgbClr val="333333"/>
-                </a:solidFill>
-                <a:latin typeface="Calibri"/>
-              </a:rPr>
-              <a:t> Paso 4: elija en la pregunta 4 dos atributos de calidad de los cuatro del curso, escriba por que pesan en SU dominio y como los mediria con un numero y una unidad, y cierre diciendo cual sacrificaria y que gana a cambio; revise ademas que los nombres de actores y de sistemas externos sean EXACTAMENTE los mismos en la ficha y en el diagrama, porque las preguntas 12 a 15 los reutilizan. Las preguntas 5 a 15 se resuelven en las Clases 2, 3 y 4: la actividad se entrega completa al cierre del Corte 1, no hoy.</a:t>
-            </a:r>
-          </a:p>
-        </p:txBody>
-      </p:sp>
-      <p:sp>
-        <p:nvSpPr>
-          <p:cNvPr id="6" name="TextBox 5"/>
-          <p:cNvSpPr txBox="1"/>
-          <p:nvPr/>
-        </p:nvSpPr>
-        <p:spPr>
-          <a:xfrm>
-            <a:off x="11185855" y="6473952"/>
-            <a:ext cx="640080" cy="274320"/>
-          </a:xfrm>
-          <a:prstGeom prst="rect">
-            <a:avLst/>
-          </a:prstGeom>
-          <a:noFill/>
-        </p:spPr>
-        <p:txBody>
-          <a:bodyPr wrap="square">
-            <a:spAutoFit/>
-          </a:bodyPr>
-          <a:lstStyle/>
-          <a:p>
-            <a:pPr algn="r"/>
-            <a:r>
-              <a:rPr sz="1100" b="0" i="0">
-                <a:solidFill>
-                  <a:srgbClr val="666666"/>
-                </a:solidFill>
-                <a:latin typeface="Calibri"/>
-              </a:rPr>
-              <a:t>26</a:t>
-            </a:r>
-          </a:p>
-        </p:txBody>
-      </p:sp>
-    </p:spTree>
-  </p:cSld>
-  <p:clrMapOvr>
-    <a:masterClrMapping/>
-  </p:clrMapOvr>
-</p:sld>
-</file>
-
-<file path=ppt/slides/slide27.xml><?xml version="1.0" encoding="utf-8"?>
-<p:sld xmlns:a="http://schemas.openxmlformats.org/drawingml/2006/main" xmlns:p="http://schemas.openxmlformats.org/presentationml/2006/main" xmlns:r="http://schemas.openxmlformats.org/officeDocument/2006/relationships">
-  <p:cSld>
-    <p:bg>
-      <p:bgPr>
-        <a:solidFill>
-          <a:srgbClr val="FFFFFF"/>
-        </a:solidFill>
-        <a:effectLst/>
-      </p:bgPr>
-    </p:bg>
-    <p:spTree>
-      <p:nvGrpSpPr>
-        <p:cNvPr id="1" name=""/>
-        <p:cNvGrpSpPr/>
-        <p:nvPr/>
-      </p:nvGrpSpPr>
-      <p:grpSpPr/>
-      <p:sp>
-        <p:nvSpPr>
-          <p:cNvPr id="2" name="Rectangle 1"/>
-          <p:cNvSpPr/>
-          <p:nvPr/>
-        </p:nvSpPr>
-        <p:spPr>
-          <a:xfrm>
-            <a:off x="0" y="0"/>
-            <a:ext cx="12191695" cy="960120"/>
-          </a:xfrm>
-          <a:prstGeom prst="rect">
-            <a:avLst/>
-          </a:prstGeom>
-          <a:solidFill>
-            <a:srgbClr val="095292"/>
-          </a:solidFill>
-          <a:ln>
-            <a:noFill/>
-          </a:ln>
-        </p:spPr>
-        <p:style>
-          <a:lnRef idx="1">
-            <a:schemeClr val="accent1"/>
-          </a:lnRef>
-          <a:fillRef idx="3">
-            <a:schemeClr val="accent1"/>
-          </a:fillRef>
-          <a:effectRef idx="2">
-            <a:schemeClr val="accent1"/>
-          </a:effectRef>
-          <a:fontRef idx="minor">
-            <a:schemeClr val="lt1"/>
-          </a:fontRef>
-        </p:style>
-        <p:txBody>
-          <a:bodyPr rtlCol="0" anchor="ctr"/>
-          <a:lstStyle/>
-          <a:p>
-            <a:pPr algn="ctr"/>
-          </a:p>
-        </p:txBody>
-      </p:sp>
-      <p:sp>
-        <p:nvSpPr>
-          <p:cNvPr id="3" name="Rectangle 2"/>
-          <p:cNvSpPr/>
-          <p:nvPr/>
-        </p:nvSpPr>
-        <p:spPr>
-          <a:xfrm>
-            <a:off x="0" y="960120"/>
-            <a:ext cx="12191695" cy="41148"/>
-          </a:xfrm>
-          <a:prstGeom prst="rect">
-            <a:avLst/>
-          </a:prstGeom>
-          <a:solidFill>
-            <a:srgbClr val="FFD000"/>
-          </a:solidFill>
-          <a:ln>
-            <a:noFill/>
-          </a:ln>
-        </p:spPr>
-        <p:style>
-          <a:lnRef idx="1">
-            <a:schemeClr val="accent1"/>
-          </a:lnRef>
-          <a:fillRef idx="3">
-            <a:schemeClr val="accent1"/>
-          </a:fillRef>
-          <a:effectRef idx="2">
-            <a:schemeClr val="accent1"/>
-          </a:effectRef>
-          <a:fontRef idx="minor">
-            <a:schemeClr val="lt1"/>
-          </a:fontRef>
-        </p:style>
-        <p:txBody>
-          <a:bodyPr rtlCol="0" anchor="ctr"/>
-          <a:lstStyle/>
-          <a:p>
-            <a:pPr algn="ctr"/>
-          </a:p>
-        </p:txBody>
-      </p:sp>
-      <p:sp>
-        <p:nvSpPr>
-          <p:cNvPr id="4" name="TextBox 3"/>
-          <p:cNvSpPr txBox="1"/>
-          <p:nvPr/>
-        </p:nvSpPr>
-        <p:spPr>
-          <a:xfrm>
-            <a:off x="457200" y="164592"/>
-            <a:ext cx="11277295" cy="502920"/>
-          </a:xfrm>
-          <a:prstGeom prst="rect">
-            <a:avLst/>
-          </a:prstGeom>
-          <a:noFill/>
-        </p:spPr>
-        <p:txBody>
-          <a:bodyPr wrap="square">
-            <a:spAutoFit/>
-          </a:bodyPr>
-          <a:lstStyle/>
-          <a:p>
-            <a:r>
-              <a:rPr sz="2600" b="1" i="0">
-                <a:solidFill>
-                  <a:srgbClr val="FFFFFF"/>
-                </a:solidFill>
-                <a:latin typeface="Calibri"/>
-              </a:rPr>
-              <a:t>Para continuar (PI)</a:t>
-            </a:r>
-          </a:p>
-        </p:txBody>
-      </p:sp>
-      <p:sp>
-        <p:nvSpPr>
-          <p:cNvPr id="5" name="Rounded Rectangle 4"/>
-          <p:cNvSpPr/>
-          <p:nvPr/>
-        </p:nvSpPr>
-        <p:spPr>
-          <a:xfrm>
-            <a:off x="457200" y="1261872"/>
-            <a:ext cx="11277295" cy="1051560"/>
-          </a:xfrm>
-          <a:prstGeom prst="roundRect">
-            <a:avLst>
-              <a:gd name="adj" fmla="val 12000"/>
-            </a:avLst>
-          </a:prstGeom>
-          <a:solidFill>
-            <a:srgbClr val="E8F4FA"/>
-          </a:solidFill>
-          <a:ln>
-            <a:noFill/>
-          </a:ln>
-        </p:spPr>
-        <p:style>
-          <a:lnRef idx="1">
-            <a:schemeClr val="accent1"/>
-          </a:lnRef>
-          <a:fillRef idx="3">
-            <a:schemeClr val="accent1"/>
-          </a:fillRef>
-          <a:effectRef idx="2">
-            <a:schemeClr val="accent1"/>
-          </a:effectRef>
-          <a:fontRef idx="minor">
-            <a:schemeClr val="lt1"/>
-          </a:fontRef>
-        </p:style>
-        <p:txBody>
-          <a:bodyPr rtlCol="0" anchor="ctr"/>
-          <a:lstStyle/>
-          <a:p>
-            <a:pPr algn="ctr"/>
-          </a:p>
-        </p:txBody>
-      </p:sp>
-      <p:sp>
-        <p:nvSpPr>
-          <p:cNvPr id="6" name="Rectangle 5"/>
-          <p:cNvSpPr/>
-          <p:nvPr/>
-        </p:nvSpPr>
-        <p:spPr>
-          <a:xfrm>
-            <a:off x="457200" y="1261872"/>
-            <a:ext cx="128016" cy="1051560"/>
-          </a:xfrm>
-          <a:prstGeom prst="rect">
-            <a:avLst/>
-          </a:prstGeom>
-          <a:solidFill>
-            <a:srgbClr val="269CCB"/>
-          </a:solidFill>
-          <a:ln>
-            <a:noFill/>
-          </a:ln>
-        </p:spPr>
-        <p:style>
-          <a:lnRef idx="1">
-            <a:schemeClr val="accent1"/>
-          </a:lnRef>
-          <a:fillRef idx="3">
-            <a:schemeClr val="accent1"/>
-          </a:fillRef>
-          <a:effectRef idx="2">
-            <a:schemeClr val="accent1"/>
-          </a:effectRef>
-          <a:fontRef idx="minor">
-            <a:schemeClr val="lt1"/>
-          </a:fontRef>
-        </p:style>
-        <p:txBody>
-          <a:bodyPr rtlCol="0" anchor="ctr"/>
-          <a:lstStyle/>
-          <a:p>
-            <a:pPr algn="ctr"/>
-          </a:p>
-        </p:txBody>
-      </p:sp>
-      <p:sp>
-        <p:nvSpPr>
-          <p:cNvPr id="7" name="TextBox 6"/>
-          <p:cNvSpPr txBox="1"/>
-          <p:nvPr/>
-        </p:nvSpPr>
-        <p:spPr>
-          <a:xfrm>
-            <a:off x="777240" y="1399031"/>
-            <a:ext cx="10774375" cy="822959"/>
-          </a:xfrm>
-          <a:prstGeom prst="rect">
-            <a:avLst/>
-          </a:prstGeom>
-          <a:noFill/>
-        </p:spPr>
-        <p:txBody>
-          <a:bodyPr wrap="square">
-            <a:spAutoFit/>
-          </a:bodyPr>
-          <a:lstStyle/>
-          <a:p>
-            <a:r>
-              <a:rPr sz="1200" b="1" i="0">
-                <a:solidFill>
-                  <a:srgbClr val="269CCB"/>
-                </a:solidFill>
-                <a:latin typeface="Calibri"/>
-              </a:rPr>
-              <a:t>Info</a:t>
-            </a:r>
-          </a:p>
-          <a:p>
-            <a:pPr>
-              <a:spcBef>
-                <a:spcPts val="400"/>
-              </a:spcBef>
-            </a:pPr>
-            <a:r>
-              <a:rPr sz="1400" b="0" i="0">
-                <a:solidFill>
-                  <a:srgbClr val="333333"/>
-                </a:solidFill>
-                <a:latin typeface="Calibri"/>
-              </a:rPr>
-              <a:t>Entregable: Ficha PI de 5 bloques + C4 Context en Mermaid renderizado en la plataforma (boceto previo en Excalidraw/draw.io)</a:t>
-            </a:r>
-          </a:p>
-        </p:txBody>
-      </p:sp>
-      <p:sp>
-        <p:nvSpPr>
-          <p:cNvPr id="8" name="Rounded Rectangle 7"/>
-          <p:cNvSpPr/>
-          <p:nvPr/>
-        </p:nvSpPr>
-        <p:spPr>
-          <a:xfrm>
-            <a:off x="457200" y="2478024"/>
-            <a:ext cx="11277295" cy="1051560"/>
-          </a:xfrm>
-          <a:prstGeom prst="roundRect">
-            <a:avLst>
-              <a:gd name="adj" fmla="val 12000"/>
-            </a:avLst>
-          </a:prstGeom>
-          <a:solidFill>
-            <a:srgbClr val="FFF8E1"/>
-          </a:solidFill>
-          <a:ln>
-            <a:noFill/>
-          </a:ln>
-        </p:spPr>
-        <p:style>
-          <a:lnRef idx="1">
-            <a:schemeClr val="accent1"/>
-          </a:lnRef>
-          <a:fillRef idx="3">
-            <a:schemeClr val="accent1"/>
-          </a:fillRef>
-          <a:effectRef idx="2">
-            <a:schemeClr val="accent1"/>
-          </a:effectRef>
-          <a:fontRef idx="minor">
-            <a:schemeClr val="lt1"/>
-          </a:fontRef>
-        </p:style>
-        <p:txBody>
-          <a:bodyPr rtlCol="0" anchor="ctr"/>
-          <a:lstStyle/>
-          <a:p>
-            <a:pPr algn="ctr"/>
-          </a:p>
-        </p:txBody>
-      </p:sp>
-      <p:sp>
-        <p:nvSpPr>
-          <p:cNvPr id="9" name="Rectangle 8"/>
-          <p:cNvSpPr/>
-          <p:nvPr/>
-        </p:nvSpPr>
-        <p:spPr>
-          <a:xfrm>
-            <a:off x="457200" y="2478024"/>
-            <a:ext cx="128016" cy="1051560"/>
-          </a:xfrm>
-          <a:prstGeom prst="rect">
-            <a:avLst/>
-          </a:prstGeom>
-          <a:solidFill>
-            <a:srgbClr val="FFD000"/>
-          </a:solidFill>
-          <a:ln>
-            <a:noFill/>
-          </a:ln>
-        </p:spPr>
-        <p:style>
-          <a:lnRef idx="1">
-            <a:schemeClr val="accent1"/>
-          </a:lnRef>
-          <a:fillRef idx="3">
-            <a:schemeClr val="accent1"/>
-          </a:fillRef>
-          <a:effectRef idx="2">
-            <a:schemeClr val="accent1"/>
-          </a:effectRef>
-          <a:fontRef idx="minor">
-            <a:schemeClr val="lt1"/>
-          </a:fontRef>
-        </p:style>
-        <p:txBody>
-          <a:bodyPr rtlCol="0" anchor="ctr"/>
-          <a:lstStyle/>
-          <a:p>
-            <a:pPr algn="ctr"/>
-          </a:p>
-        </p:txBody>
-      </p:sp>
-      <p:sp>
-        <p:nvSpPr>
-          <p:cNvPr id="10" name="TextBox 9"/>
-          <p:cNvSpPr txBox="1"/>
-          <p:nvPr/>
-        </p:nvSpPr>
-        <p:spPr>
-          <a:xfrm>
-            <a:off x="777240" y="2615184"/>
-            <a:ext cx="10774375" cy="822959"/>
-          </a:xfrm>
-          <a:prstGeom prst="rect">
-            <a:avLst/>
-          </a:prstGeom>
-          <a:noFill/>
-        </p:spPr>
-        <p:txBody>
-          <a:bodyPr wrap="square">
-            <a:spAutoFit/>
-          </a:bodyPr>
-          <a:lstStyle/>
-          <a:p>
-            <a:r>
-              <a:rPr sz="1200" b="1" i="0">
-                <a:solidFill>
-                  <a:srgbClr val="FFD000"/>
-                </a:solidFill>
-                <a:latin typeface="Calibri"/>
-              </a:rPr>
-              <a:t>Aclaración</a:t>
-            </a:r>
-          </a:p>
-          <a:p>
-            <a:pPr>
-              <a:spcBef>
-                <a:spcPts val="400"/>
-              </a:spcBef>
-            </a:pPr>
-            <a:r>
-              <a:rPr sz="1400" b="0" i="0">
-                <a:solidFill>
-                  <a:srgbClr val="333333"/>
-                </a:solidFill>
-                <a:latin typeface="Calibri"/>
-              </a:rPr>
-              <a:t>Subir evidencias al paquete CloudLite (Drive/repo) y a la plataforma del curso (la plataforma del curso) en la fecha que indique el docente.</a:t>
-            </a:r>
-          </a:p>
-        </p:txBody>
-      </p:sp>
-      <p:sp>
-        <p:nvSpPr>
-          <p:cNvPr id="11" name="Rounded Rectangle 10"/>
-          <p:cNvSpPr/>
-          <p:nvPr/>
-        </p:nvSpPr>
-        <p:spPr>
-          <a:xfrm>
-            <a:off x="457200" y="3694176"/>
-            <a:ext cx="11277295" cy="1051560"/>
-          </a:xfrm>
-          <a:prstGeom prst="roundRect">
-            <a:avLst>
-              <a:gd name="adj" fmla="val 12000"/>
-            </a:avLst>
-          </a:prstGeom>
-          <a:solidFill>
-            <a:srgbClr val="FBE4E4"/>
-          </a:solidFill>
-          <a:ln>
-            <a:noFill/>
-          </a:ln>
-        </p:spPr>
-        <p:style>
-          <a:lnRef idx="1">
-            <a:schemeClr val="accent1"/>
-          </a:lnRef>
-          <a:fillRef idx="3">
-            <a:schemeClr val="accent1"/>
-          </a:fillRef>
-          <a:effectRef idx="2">
-            <a:schemeClr val="accent1"/>
-          </a:effectRef>
-          <a:fontRef idx="minor">
-            <a:schemeClr val="lt1"/>
-          </a:fontRef>
-        </p:style>
-        <p:txBody>
-          <a:bodyPr rtlCol="0" anchor="ctr"/>
-          <a:lstStyle/>
-          <a:p>
-            <a:pPr algn="ctr"/>
-          </a:p>
-        </p:txBody>
-      </p:sp>
-      <p:sp>
-        <p:nvSpPr>
-          <p:cNvPr id="12" name="Rectangle 11"/>
-          <p:cNvSpPr/>
-          <p:nvPr/>
-        </p:nvSpPr>
-        <p:spPr>
-          <a:xfrm>
-            <a:off x="457200" y="3694176"/>
-            <a:ext cx="128016" cy="1051560"/>
-          </a:xfrm>
-          <a:prstGeom prst="rect">
-            <a:avLst/>
-          </a:prstGeom>
-          <a:solidFill>
-            <a:srgbClr val="A02030"/>
-          </a:solidFill>
-          <a:ln>
-            <a:noFill/>
-          </a:ln>
-        </p:spPr>
-        <p:style>
-          <a:lnRef idx="1">
-            <a:schemeClr val="accent1"/>
-          </a:lnRef>
-          <a:fillRef idx="3">
-            <a:schemeClr val="accent1"/>
-          </a:fillRef>
-          <a:effectRef idx="2">
-            <a:schemeClr val="accent1"/>
-          </a:effectRef>
-          <a:fontRef idx="minor">
-            <a:schemeClr val="lt1"/>
-          </a:fontRef>
-        </p:style>
-        <p:txBody>
-          <a:bodyPr rtlCol="0" anchor="ctr"/>
-          <a:lstStyle/>
-          <a:p>
-            <a:pPr algn="ctr"/>
-          </a:p>
-        </p:txBody>
-      </p:sp>
-      <p:sp>
-        <p:nvSpPr>
-          <p:cNvPr id="13" name="TextBox 12"/>
-          <p:cNvSpPr txBox="1"/>
-          <p:nvPr/>
-        </p:nvSpPr>
-        <p:spPr>
-          <a:xfrm>
-            <a:off x="777240" y="3831336"/>
-            <a:ext cx="10774375" cy="822959"/>
-          </a:xfrm>
-          <a:prstGeom prst="rect">
-            <a:avLst/>
-          </a:prstGeom>
-          <a:noFill/>
-        </p:spPr>
-        <p:txBody>
-          <a:bodyPr wrap="square">
-            <a:spAutoFit/>
-          </a:bodyPr>
-          <a:lstStyle/>
-          <a:p>
-            <a:r>
-              <a:rPr sz="1200" b="1" i="0">
-                <a:solidFill>
-                  <a:srgbClr val="A02030"/>
-                </a:solidFill>
-                <a:latin typeface="Calibri"/>
-              </a:rPr>
-              <a:t>Atención</a:t>
-            </a:r>
-          </a:p>
-          <a:p>
-            <a:pPr>
-              <a:spcBef>
-                <a:spcPts val="400"/>
-              </a:spcBef>
-            </a:pPr>
-            <a:r>
-              <a:rPr sz="1400" b="0" i="0">
-                <a:solidFill>
-                  <a:srgbClr val="333333"/>
-                </a:solidFill>
-                <a:latin typeface="Calibri"/>
-              </a:rPr>
-              <a:t>Sin cloud de pago ni instalaciones obligatorias de hipervisores/Docker Desktop.</a:t>
-            </a:r>
-          </a:p>
-        </p:txBody>
-      </p:sp>
-      <p:sp>
-        <p:nvSpPr>
-          <p:cNvPr id="14" name="TextBox 13"/>
-          <p:cNvSpPr txBox="1"/>
-          <p:nvPr/>
-        </p:nvSpPr>
-        <p:spPr>
-          <a:xfrm>
-            <a:off x="11185855" y="6473952"/>
-            <a:ext cx="640080" cy="274320"/>
-          </a:xfrm>
-          <a:prstGeom prst="rect">
-            <a:avLst/>
-          </a:prstGeom>
-          <a:noFill/>
-        </p:spPr>
-        <p:txBody>
-          <a:bodyPr wrap="square">
-            <a:spAutoFit/>
-          </a:bodyPr>
-          <a:lstStyle/>
-          <a:p>
-            <a:pPr algn="r"/>
-            <a:r>
-              <a:rPr sz="1100" b="0" i="0">
-                <a:solidFill>
-                  <a:srgbClr val="666666"/>
-                </a:solidFill>
-                <a:latin typeface="Calibri"/>
-              </a:rPr>
-              <a:t>27</a:t>
-            </a:r>
-          </a:p>
-        </p:txBody>
-      </p:sp>
-    </p:spTree>
-  </p:cSld>
-  <p:clrMapOvr>
-    <a:masterClrMapping/>
-  </p:clrMapOvr>
-</p:sld>
-</file>
-
-<file path=ppt/slides/slide28.xml><?xml version="1.0" encoding="utf-8"?>
-<p:sld xmlns:a="http://schemas.openxmlformats.org/drawingml/2006/main" xmlns:p="http://schemas.openxmlformats.org/presentationml/2006/main" xmlns:r="http://schemas.openxmlformats.org/officeDocument/2006/relationships">
-  <p:cSld>
-    <p:bg>
-      <p:bgPr>
-        <a:solidFill>
-          <a:srgbClr val="FFFFFF"/>
-        </a:solidFill>
-        <a:effectLst/>
-      </p:bgPr>
-    </p:bg>
-    <p:spTree>
-      <p:nvGrpSpPr>
-        <p:cNvPr id="1" name=""/>
-        <p:cNvGrpSpPr/>
-        <p:nvPr/>
-      </p:nvGrpSpPr>
-      <p:grpSpPr/>
-      <p:sp>
-        <p:nvSpPr>
-          <p:cNvPr id="2" name="Rectangle 1"/>
-          <p:cNvSpPr/>
-          <p:nvPr/>
-        </p:nvSpPr>
-        <p:spPr>
-          <a:xfrm>
-            <a:off x="0" y="0"/>
-            <a:ext cx="12191695" cy="164592"/>
-          </a:xfrm>
-          <a:prstGeom prst="rect">
-            <a:avLst/>
-          </a:prstGeom>
-          <a:solidFill>
-            <a:srgbClr val="269CCB"/>
-          </a:solidFill>
-          <a:ln>
-            <a:noFill/>
-          </a:ln>
-        </p:spPr>
-        <p:style>
-          <a:lnRef idx="1">
-            <a:schemeClr val="accent1"/>
-          </a:lnRef>
-          <a:fillRef idx="3">
-            <a:schemeClr val="accent1"/>
-          </a:fillRef>
-          <a:effectRef idx="2">
-            <a:schemeClr val="accent1"/>
-          </a:effectRef>
-          <a:fontRef idx="minor">
-            <a:schemeClr val="lt1"/>
-          </a:fontRef>
-        </p:style>
-        <p:txBody>
-          <a:bodyPr rtlCol="0" anchor="ctr"/>
-          <a:lstStyle/>
-          <a:p>
-            <a:pPr algn="ctr"/>
-          </a:p>
-        </p:txBody>
-      </p:sp>
-      <p:pic>
-        <p:nvPicPr>
-          <p:cNvPr id="3" name="Picture 2" descr="logo_uniajc_color.png"/>
-          <p:cNvPicPr>
-            <a:picLocks noChangeAspect="1"/>
-          </p:cNvPicPr>
-          <p:nvPr/>
-        </p:nvPicPr>
-        <p:blipFill>
-          <a:blip r:embed="rId2"/>
-          <a:stretch>
-            <a:fillRect/>
-          </a:stretch>
-        </p:blipFill>
-        <p:spPr>
-          <a:xfrm>
-            <a:off x="10271455" y="5998464"/>
-            <a:ext cx="1463040" cy="643233"/>
-          </a:xfrm>
-          <a:prstGeom prst="rect">
-            <a:avLst/>
-          </a:prstGeom>
-        </p:spPr>
-      </p:pic>
-      <p:sp>
-        <p:nvSpPr>
-          <p:cNvPr id="4" name="TextBox 3"/>
-          <p:cNvSpPr txBox="1"/>
-          <p:nvPr/>
-        </p:nvSpPr>
-        <p:spPr>
-          <a:xfrm>
             <a:off x="457200" y="1737360"/>
             <a:ext cx="11277295" cy="1097280"/>
           </a:xfrm>
@@ -11095,7 +8454,7 @@
                 </a:solidFill>
                 <a:latin typeface="Calibri"/>
               </a:rPr>
-              <a:t>Clase 1 · PI en movimiento</a:t>
+              <a:t>Clase 1 · cierre conceptual</a:t>
             </a:r>
           </a:p>
         </p:txBody>
@@ -11134,7 +8493,7 @@
                 </a:solidFill>
                 <a:latin typeface="Calibri"/>
               </a:rPr>
-              <a:t>Definir dominio CloudLite App + 3–5 capacidades + problema en 2–3 frases</a:t>
+              <a:t>Ubicar el curso como diseño de arquitecturas cloud al servicio del PI CloudLite App.</a:t>
             </a:r>
           </a:p>
           <a:p>
@@ -11150,7 +8509,7 @@
                 </a:solidFill>
                 <a:latin typeface="Calibri"/>
               </a:rPr>
-              <a:t>Evidencia: Ficha PI de 5 bloques + C4 Context en Mermaid renderizado en la plataforma (boceto previo en Excalidraw/draw.io)</a:t>
+              <a:t>Cerrar el dominio del PI en una ficha de cinco bloques, con capacidades de negocio y no piezas tecnicas.</a:t>
             </a:r>
           </a:p>
           <a:p>
@@ -11166,7 +8525,7 @@
                 </a:solidFill>
                 <a:latin typeface="Calibri"/>
               </a:rPr>
-              <a:t>Siguiente paso = siguiente hito del PI CloudLite</a:t>
+              <a:t>Dejar el dominio y alcance del PI escritos y compartibles.</a:t>
             </a:r>
           </a:p>
         </p:txBody>
@@ -11201,7 +8560,7 @@
                 </a:solidFill>
                 <a:latin typeface="Calibri"/>
               </a:rPr>
-              <a:t>Teoría al servicio del proyecto</a:t>
+              <a:t>Teoría al servicio del diseño</a:t>
             </a:r>
           </a:p>
         </p:txBody>
@@ -12529,7 +9888,7 @@
                 </a:solidFill>
                 <a:latin typeface="Calibri"/>
               </a:rPr>
-              <a:t>PI CloudLite - entregable de hoy: la ficha de 6 bloques (1/2)</a:t>
+              <a:t>La ficha de dominio de 6 bloques (1/2)</a:t>
             </a:r>
           </a:p>
         </p:txBody>
@@ -12568,7 +9927,7 @@
                 </a:solidFill>
                 <a:latin typeface="Calibri"/>
               </a:rPr>
-              <a:t>–   L presenta el entregable de hoy: una ficha individual con seis bloques rotulados que cada estudiante llena por su cuenta y que no vuelve a cambiar en el resto del semestre.</a:t>
+              <a:t>–   L presenta la ficha de dominio: una ficha individual con seis bloques rotulados que cada estudiante llena por su cuenta y que no vuelve a cambiar en el resto del semestre.</a:t>
             </a:r>
           </a:p>
           <a:p>
@@ -12781,7 +10140,7 @@
                 </a:solidFill>
                 <a:latin typeface="Calibri"/>
               </a:rPr>
-              <a:t>PI CloudLite - entregable de hoy: la ficha de 6 bloques (2/2)</a:t>
+              <a:t>La ficha de dominio de 6 bloques (2/2)</a:t>
             </a:r>
           </a:p>
         </p:txBody>
@@ -13502,4 +10861,324 @@
   </a:objectDefaults>
   <a:extraClrSchemeLst/>
 </a:theme>
+</file>
+
+<file path=ppt/theme/theme2.xml><?xml version="1.0" encoding="utf-8"?>
+<a:theme xmlns:a="http://schemas.openxmlformats.org/drawingml/2006/main" name="Office Theme">
+  <a:themeElements>
+    <a:clrScheme name="Office">
+      <a:dk1>
+        <a:sysClr val="windowText" lastClr="000000"/>
+      </a:dk1>
+      <a:lt1>
+        <a:sysClr val="window" lastClr="FFFFFF"/>
+      </a:lt1>
+      <a:dk2>
+        <a:srgbClr val="1F497D"/>
+      </a:dk2>
+      <a:lt2>
+        <a:srgbClr val="EEECE1"/>
+      </a:lt2>
+      <a:accent1>
+        <a:srgbClr val="4F81BD"/>
+      </a:accent1>
+      <a:accent2>
+        <a:srgbClr val="C0504D"/>
+      </a:accent2>
+      <a:accent3>
+        <a:srgbClr val="9BBB59"/>
+      </a:accent3>
+      <a:accent4>
+        <a:srgbClr val="8064A2"/>
+      </a:accent4>
+      <a:accent5>
+        <a:srgbClr val="4BACC6"/>
+      </a:accent5>
+      <a:accent6>
+        <a:srgbClr val="F79646"/>
+      </a:accent6>
+      <a:hlink>
+        <a:srgbClr val="0000FF"/>
+      </a:hlink>
+      <a:folHlink>
+        <a:srgbClr val="800080"/>
+      </a:folHlink>
+    </a:clrScheme>
+    <a:fontScheme name="Office">
+      <a:majorFont>
+        <a:latin typeface="Calibri"/>
+        <a:ea typeface=""/>
+        <a:cs typeface=""/>
+        <a:font script="Jpan" typeface="ＭＳ Ｐゴシック"/>
+        <a:font script="Hang" typeface="맑은 고딕"/>
+        <a:font script="Hans" typeface="宋体"/>
+        <a:font script="Hant" typeface="新細明體"/>
+        <a:font script="Arab" typeface="Times New Roman"/>
+        <a:font script="Hebr" typeface="Times New Roman"/>
+        <a:font script="Thai" typeface="Angsana New"/>
+        <a:font script="Ethi" typeface="Nyala"/>
+        <a:font script="Beng" typeface="Vrinda"/>
+        <a:font script="Gujr" typeface="Shruti"/>
+        <a:font script="Khmr" typeface="MoolBoran"/>
+        <a:font script="Knda" typeface="Tunga"/>
+        <a:font script="Guru" typeface="Raavi"/>
+        <a:font script="Cans" typeface="Euphemia"/>
+        <a:font script="Cher" typeface="Plantagenet Cherokee"/>
+        <a:font script="Yiii" typeface="Microsoft Yi Baiti"/>
+        <a:font script="Tibt" typeface="Microsoft Himalaya"/>
+        <a:font script="Thaa" typeface="MV Boli"/>
+        <a:font script="Deva" typeface="Mangal"/>
+        <a:font script="Telu" typeface="Gautami"/>
+        <a:font script="Taml" typeface="Latha"/>
+        <a:font script="Syrc" typeface="Estrangelo Edessa"/>
+        <a:font script="Orya" typeface="Kalinga"/>
+        <a:font script="Mlym" typeface="Kartika"/>
+        <a:font script="Laoo" typeface="DokChampa"/>
+        <a:font script="Sinh" typeface="Iskoola Pota"/>
+        <a:font script="Mong" typeface="Mongolian Baiti"/>
+        <a:font script="Viet" typeface="Times New Roman"/>
+        <a:font script="Uigh" typeface="Microsoft Uighur"/>
+        <a:font script="Geor" typeface="Sylfaen"/>
+      </a:majorFont>
+      <a:minorFont>
+        <a:latin typeface="Calibri"/>
+        <a:ea typeface=""/>
+        <a:cs typeface=""/>
+        <a:font script="Jpan" typeface="ＭＳ Ｐゴシック"/>
+        <a:font script="Hang" typeface="맑은 고딕"/>
+        <a:font script="Hans" typeface="宋体"/>
+        <a:font script="Hant" typeface="新細明體"/>
+        <a:font script="Arab" typeface="Arial"/>
+        <a:font script="Hebr" typeface="Arial"/>
+        <a:font script="Thai" typeface="Cordia New"/>
+        <a:font script="Ethi" typeface="Nyala"/>
+        <a:font script="Beng" typeface="Vrinda"/>
+        <a:font script="Gujr" typeface="Shruti"/>
+        <a:font script="Khmr" typeface="DaunPenh"/>
+        <a:font script="Knda" typeface="Tunga"/>
+        <a:font script="Guru" typeface="Raavi"/>
+        <a:font script="Cans" typeface="Euphemia"/>
+        <a:font script="Cher" typeface="Plantagenet Cherokee"/>
+        <a:font script="Yiii" typeface="Microsoft Yi Baiti"/>
+        <a:font script="Tibt" typeface="Microsoft Himalaya"/>
+        <a:font script="Thaa" typeface="MV Boli"/>
+        <a:font script="Deva" typeface="Mangal"/>
+        <a:font script="Telu" typeface="Gautami"/>
+        <a:font script="Taml" typeface="Latha"/>
+        <a:font script="Syrc" typeface="Estrangelo Edessa"/>
+        <a:font script="Orya" typeface="Kalinga"/>
+        <a:font script="Mlym" typeface="Kartika"/>
+        <a:font script="Laoo" typeface="DokChampa"/>
+        <a:font script="Sinh" typeface="Iskoola Pota"/>
+        <a:font script="Mong" typeface="Mongolian Baiti"/>
+        <a:font script="Viet" typeface="Arial"/>
+        <a:font script="Uigh" typeface="Microsoft Uighur"/>
+        <a:font script="Geor" typeface="Sylfaen"/>
+      </a:minorFont>
+    </a:fontScheme>
+    <a:fmtScheme name="Office">
+      <a:fillStyleLst>
+        <a:solidFill>
+          <a:schemeClr val="phClr"/>
+        </a:solidFill>
+        <a:gradFill rotWithShape="1">
+          <a:gsLst>
+            <a:gs pos="0">
+              <a:schemeClr val="phClr">
+                <a:tint val="50000"/>
+                <a:satMod val="300000"/>
+              </a:schemeClr>
+            </a:gs>
+            <a:gs pos="35000">
+              <a:schemeClr val="phClr">
+                <a:tint val="37000"/>
+                <a:satMod val="300000"/>
+              </a:schemeClr>
+            </a:gs>
+            <a:gs pos="100000">
+              <a:schemeClr val="phClr">
+                <a:tint val="15000"/>
+                <a:satMod val="350000"/>
+              </a:schemeClr>
+            </a:gs>
+          </a:gsLst>
+          <a:lin ang="16200000" scaled="1"/>
+        </a:gradFill>
+        <a:gradFill rotWithShape="1">
+          <a:gsLst>
+            <a:gs pos="0">
+              <a:schemeClr val="phClr">
+                <a:tint val="100000"/>
+                <a:shade val="100000"/>
+                <a:satMod val="130000"/>
+              </a:schemeClr>
+            </a:gs>
+            <a:gs pos="100000">
+              <a:schemeClr val="phClr">
+                <a:tint val="50000"/>
+                <a:shade val="100000"/>
+                <a:satMod val="350000"/>
+              </a:schemeClr>
+            </a:gs>
+          </a:gsLst>
+          <a:lin ang="16200000" scaled="0"/>
+        </a:gradFill>
+      </a:fillStyleLst>
+      <a:lnStyleLst>
+        <a:ln w="9525" cap="flat" cmpd="sng" algn="ctr">
+          <a:solidFill>
+            <a:schemeClr val="phClr">
+              <a:shade val="95000"/>
+              <a:satMod val="105000"/>
+            </a:schemeClr>
+          </a:solidFill>
+          <a:prstDash val="solid"/>
+        </a:ln>
+        <a:ln w="25400" cap="flat" cmpd="sng" algn="ctr">
+          <a:solidFill>
+            <a:schemeClr val="phClr"/>
+          </a:solidFill>
+          <a:prstDash val="solid"/>
+        </a:ln>
+        <a:ln w="38100" cap="flat" cmpd="sng" algn="ctr">
+          <a:solidFill>
+            <a:schemeClr val="phClr"/>
+          </a:solidFill>
+          <a:prstDash val="solid"/>
+        </a:ln>
+      </a:lnStyleLst>
+      <a:effectStyleLst>
+        <a:effectStyle>
+          <a:effectLst>
+            <a:outerShdw blurRad="40000" dist="20000" dir="5400000" rotWithShape="0">
+              <a:srgbClr val="000000">
+                <a:alpha val="38000"/>
+              </a:srgbClr>
+            </a:outerShdw>
+          </a:effectLst>
+        </a:effectStyle>
+        <a:effectStyle>
+          <a:effectLst>
+            <a:outerShdw blurRad="40000" dist="23000" dir="5400000" rotWithShape="0">
+              <a:srgbClr val="000000">
+                <a:alpha val="35000"/>
+              </a:srgbClr>
+            </a:outerShdw>
+          </a:effectLst>
+        </a:effectStyle>
+        <a:effectStyle>
+          <a:effectLst>
+            <a:outerShdw blurRad="40000" dist="23000" dir="5400000" rotWithShape="0">
+              <a:srgbClr val="000000">
+                <a:alpha val="35000"/>
+              </a:srgbClr>
+            </a:outerShdw>
+          </a:effectLst>
+          <a:scene3d>
+            <a:camera prst="orthographicFront">
+              <a:rot lat="0" lon="0" rev="0"/>
+            </a:camera>
+            <a:lightRig rig="threePt" dir="t">
+              <a:rot lat="0" lon="0" rev="1200000"/>
+            </a:lightRig>
+          </a:scene3d>
+          <a:sp3d>
+            <a:bevelT w="63500" h="25400"/>
+          </a:sp3d>
+        </a:effectStyle>
+      </a:effectStyleLst>
+      <a:bgFillStyleLst>
+        <a:solidFill>
+          <a:schemeClr val="phClr"/>
+        </a:solidFill>
+        <a:gradFill rotWithShape="1">
+          <a:gsLst>
+            <a:gs pos="0">
+              <a:schemeClr val="phClr">
+                <a:tint val="40000"/>
+                <a:satMod val="350000"/>
+              </a:schemeClr>
+            </a:gs>
+            <a:gs pos="40000">
+              <a:schemeClr val="phClr">
+                <a:tint val="45000"/>
+                <a:shade val="99000"/>
+                <a:satMod val="350000"/>
+              </a:schemeClr>
+            </a:gs>
+            <a:gs pos="100000">
+              <a:schemeClr val="phClr">
+                <a:shade val="20000"/>
+                <a:satMod val="255000"/>
+              </a:schemeClr>
+            </a:gs>
+          </a:gsLst>
+          <a:path path="circle">
+            <a:fillToRect l="50000" t="-80000" r="50000" b="180000"/>
+          </a:path>
+        </a:gradFill>
+        <a:gradFill rotWithShape="1">
+          <a:gsLst>
+            <a:gs pos="0">
+              <a:schemeClr val="phClr">
+                <a:tint val="80000"/>
+                <a:satMod val="300000"/>
+              </a:schemeClr>
+            </a:gs>
+            <a:gs pos="100000">
+              <a:schemeClr val="phClr">
+                <a:shade val="30000"/>
+                <a:satMod val="200000"/>
+              </a:schemeClr>
+            </a:gs>
+          </a:gsLst>
+          <a:path path="circle">
+            <a:fillToRect l="50000" t="50000" r="50000" b="50000"/>
+          </a:path>
+        </a:gradFill>
+      </a:bgFillStyleLst>
+    </a:fmtScheme>
+  </a:themeElements>
+  <a:objectDefaults>
+    <a:spDef>
+      <a:spPr/>
+      <a:bodyPr/>
+      <a:lstStyle/>
+      <a:style>
+        <a:lnRef idx="1">
+          <a:schemeClr val="accent1"/>
+        </a:lnRef>
+        <a:fillRef idx="3">
+          <a:schemeClr val="accent1"/>
+        </a:fillRef>
+        <a:effectRef idx="2">
+          <a:schemeClr val="accent1"/>
+        </a:effectRef>
+        <a:fontRef idx="minor">
+          <a:schemeClr val="lt1"/>
+        </a:fontRef>
+      </a:style>
+    </a:spDef>
+    <a:lnDef>
+      <a:spPr/>
+      <a:bodyPr/>
+      <a:lstStyle/>
+      <a:style>
+        <a:lnRef idx="2">
+          <a:schemeClr val="accent1"/>
+        </a:lnRef>
+        <a:fillRef idx="0">
+          <a:schemeClr val="accent1"/>
+        </a:fillRef>
+        <a:effectRef idx="1">
+          <a:schemeClr val="accent1"/>
+        </a:effectRef>
+        <a:fontRef idx="minor">
+          <a:schemeClr val="tx1"/>
+        </a:fontRef>
+      </a:style>
+    </a:lnDef>
+  </a:objectDefaults>
+  <a:extraClrSchemeLst/>
+</a:theme>
 </file>
</xml_diff>

<commit_message>
Laminas de concepto sin actividad ni plataforma, parciales genericos y logistica de Seminario C1 a notas
Co-Authored-By: Claude Opus 5.5 <noreply@anthropic.com>
</commit_message>
<xml_diff>
--- a/Arquitectura de Sistemas Computacionales/Clases/Clase 1 - Introduccion a arquitecturas cloud/Presentacion.pptx
+++ b/Arquitectura de Sistemas Computacionales/Clases/Clase 1 - Introduccion a arquitecturas cloud/Presentacion.pptx
@@ -28,6 +28,7 @@
     <p:sldId id="276" r:id="rId28"/>
     <p:sldId id="277" r:id="rId29"/>
     <p:sldId id="278" r:id="rId30"/>
+    <p:sldId id="279" r:id="rId31"/>
   </p:sldIdLst>
   <p:sldSz cx="12191695" cy="6858000" type="screen4x3"/>
   <p:notesSz cx="6858000" cy="9144000"/>
@@ -530,7 +531,7 @@
           <a:p/>
           <a:p>
             <a:r>
-              <a:t>SISTEMAS EXTERNOS es el bloque nuevo de este semestre: dos o tres sistemas de terceros con los que CloudLite intercambia informacion (un proveedor de identidad, un servicio de correo, una pasarela de pagos); es exactamente lo que despues aparece como System_Ext en el diagrama C4 Context de la pregunta 2 de la plataforma del curso, asi que conviene que el estudiante los escriba aqui ANTES de dibujar, no despues.</a:t>
+              <a:t>SISTEMAS EXTERNOS es el bloque nuevo de este semestre: dos o tres sistemas de terceros con los que CloudLite intercambia informacion (un proveedor de identidad, un servicio de correo, una pasarela de pagos); es exactamente lo que despues aparece como System_Ext en el diagrama C4 Context, asi que conviene que el estudiante los escriba aqui ANTES de dibujar, no despues.</a:t>
             </a:r>
           </a:p>
         </p:txBody>
@@ -802,6 +803,76 @@
 </file>
 
 <file path=ppt/notesSlides/notesSlide5.xml><?xml version="1.0" encoding="utf-8"?>
+<p:notes xmlns:a="http://schemas.openxmlformats.org/drawingml/2006/main" xmlns:p="http://schemas.openxmlformats.org/presentationml/2006/main" xmlns:r="http://schemas.openxmlformats.org/officeDocument/2006/relationships">
+  <p:cSld>
+    <p:spTree>
+      <p:nvGrpSpPr>
+        <p:cNvPr id="1" name=""/>
+        <p:cNvGrpSpPr/>
+        <p:nvPr/>
+      </p:nvGrpSpPr>
+      <p:grpSpPr>
+        <a:xfrm>
+          <a:off x="0" y="0"/>
+          <a:ext cx="0" cy="0"/>
+          <a:chOff x="0" y="0"/>
+          <a:chExt cx="0" cy="0"/>
+        </a:xfrm>
+      </p:grpSpPr>
+      <p:sp>
+        <p:nvSpPr>
+          <p:cNvPr id="2" name="Slide Image Placeholder 1"/>
+          <p:cNvSpPr>
+            <a:spLocks noGrp="1"/>
+          </p:cNvSpPr>
+          <p:nvPr>
+            <p:ph type="sldImg" idx="2"/>
+          </p:nvPr>
+        </p:nvSpPr>
+        <p:spPr/>
+      </p:sp>
+      <p:sp>
+        <p:nvSpPr>
+          <p:cNvPr id="3" name="Notes Placeholder 2"/>
+          <p:cNvSpPr>
+            <a:spLocks noGrp="1"/>
+          </p:cNvSpPr>
+          <p:nvPr>
+            <p:ph type="body" idx="3" sz="quarter"/>
+          </p:nvPr>
+        </p:nvSpPr>
+        <p:spPr/>
+        <p:txBody>
+          <a:bodyPr/>
+          <a:lstStyle/>
+          <a:p>
+            <a:r>
+              <a:t>(Sobre la actividad, no se proyecta) Es el mismo modelo C4 explicado arriba, ahora aplicado con nombres concretos, y sirve de puente directo hacia la pregunta 2 del taller en la plataforma del curso (el diagrama Mermaid que cada estudiante entrega hoy).</a:t>
+            </a:r>
+          </a:p>
+        </p:txBody>
+      </p:sp>
+      <p:sp>
+        <p:nvSpPr>
+          <p:cNvPr id="4" name="Slide Number Placeholder 3"/>
+          <p:cNvSpPr>
+            <a:spLocks noGrp="1"/>
+          </p:cNvSpPr>
+          <p:nvPr>
+            <p:ph type="sldNum" idx="5" sz="quarter"/>
+          </p:nvPr>
+        </p:nvSpPr>
+        <p:spPr/>
+      </p:sp>
+    </p:spTree>
+  </p:cSld>
+  <p:clrMapOvr>
+    <a:masterClrMapping/>
+  </p:clrMapOvr>
+</p:notes>
+</file>
+
+<file path=ppt/notesSlides/notesSlide6.xml><?xml version="1.0" encoding="utf-8"?>
 <p:notes xmlns:a="http://schemas.openxmlformats.org/drawingml/2006/main" xmlns:p="http://schemas.openxmlformats.org/presentationml/2006/main" xmlns:r="http://schemas.openxmlformats.org/officeDocument/2006/relationships">
   <p:cSld>
     <p:spTree>
@@ -5233,22 +5304,6 @@
               <a:t>–   Con la etiqueta «envia solicitud de cobro y recibe confirmacion»; un proveedor de correo, con la etiqueta «envia recordatorio de turno»; y quizas un servicio de mapas.</a:t>
             </a:r>
           </a:p>
-          <a:p>
-            <a:pPr>
-              <a:spcAft>
-                <a:spcPts val="800"/>
-              </a:spcAft>
-            </a:pPr>
-            <a:r>
-              <a:rPr sz="2000" b="0" i="0">
-                <a:solidFill>
-                  <a:srgbClr val="333333"/>
-                </a:solidFill>
-                <a:latin typeface="Calibri"/>
-              </a:rPr>
-              <a:t>–   Nada mas: la API, la base de datos y el almacenamiento de fotos no aparecen todavia porque son interiores.</a:t>
-            </a:r>
-          </a:p>
         </p:txBody>
       </p:sp>
       <p:sp>
@@ -5466,7 +5521,23 @@
                 </a:solidFill>
                 <a:latin typeface="Calibri"/>
               </a:rPr>
-              <a:t>–   Ese diagrama de cinco o seis elementos es el entregable de hoy, y su valor esta en que obliga a responder dos preguntas que el estudiante no se habia hecho: quien exactamente usa esto y de que terceros depende para funcionar.</a:t>
+              <a:t>–   Nada mas: la API, la base de datos y el almacenamiento de fotos no aparecen todavia porque son interiores.</a:t>
+            </a:r>
+          </a:p>
+          <a:p>
+            <a:pPr>
+              <a:spcAft>
+                <a:spcPts val="800"/>
+              </a:spcAft>
+            </a:pPr>
+            <a:r>
+              <a:rPr sz="2000" b="0" i="0">
+                <a:solidFill>
+                  <a:srgbClr val="333333"/>
+                </a:solidFill>
+                <a:latin typeface="Calibri"/>
+              </a:rPr>
+              <a:t>–   El valor de ese diagrama de cinco o seis elementos esta en que obliga a responder dos preguntas que el estudiante no se habia hecho: quien exactamente usa esto y de que terceros depende para funcionar.</a:t>
             </a:r>
           </a:p>
           <a:p>
@@ -6525,22 +6596,6 @@
               <a:t>–   Sistema y externo por el dominio de un estudiante voluntario mientras explica que en el nivel Context el sistema sigue siendo UNA sola caja, sin abrir por dentro.</a:t>
             </a:r>
           </a:p>
-          <a:p>
-            <a:pPr>
-              <a:spcAft>
-                <a:spcPts val="800"/>
-              </a:spcAft>
-            </a:pPr>
-            <a:r>
-              <a:rPr sz="2000" b="0" i="0">
-                <a:solidFill>
-                  <a:srgbClr val="333333"/>
-                </a:solidFill>
-                <a:latin typeface="Calibri"/>
-              </a:rPr>
-              <a:t>–   Es el mismo modelo C4 explicado arriba, ahora aplicado con nombres concretos, y sirve de puente directo hacia la pregunta 2 del taller en la plataforma del curso (el diagrama Mermaid que cada estudiante entrega hoy).</a:t>
-            </a:r>
-          </a:p>
         </p:txBody>
       </p:sp>
       <p:sp>
@@ -8368,6 +8423,905 @@
         <p:spPr>
           <a:xfrm>
             <a:off x="0" y="0"/>
+            <a:ext cx="12191695" cy="1170432"/>
+          </a:xfrm>
+          <a:prstGeom prst="rect">
+            <a:avLst/>
+          </a:prstGeom>
+          <a:solidFill>
+            <a:srgbClr val="095292"/>
+          </a:solidFill>
+          <a:ln>
+            <a:noFill/>
+          </a:ln>
+        </p:spPr>
+        <p:style>
+          <a:lnRef idx="1">
+            <a:schemeClr val="accent1"/>
+          </a:lnRef>
+          <a:fillRef idx="3">
+            <a:schemeClr val="accent1"/>
+          </a:fillRef>
+          <a:effectRef idx="2">
+            <a:schemeClr val="accent1"/>
+          </a:effectRef>
+          <a:fontRef idx="minor">
+            <a:schemeClr val="lt1"/>
+          </a:fontRef>
+        </p:style>
+        <p:txBody>
+          <a:bodyPr rtlCol="0" anchor="ctr"/>
+          <a:lstStyle/>
+          <a:p>
+            <a:pPr algn="ctr"/>
+          </a:p>
+        </p:txBody>
+      </p:sp>
+      <p:sp>
+        <p:nvSpPr>
+          <p:cNvPr id="3" name="Rectangle 2"/>
+          <p:cNvSpPr/>
+          <p:nvPr/>
+        </p:nvSpPr>
+        <p:spPr>
+          <a:xfrm>
+            <a:off x="0" y="1170432"/>
+            <a:ext cx="12191695" cy="41148"/>
+          </a:xfrm>
+          <a:prstGeom prst="rect">
+            <a:avLst/>
+          </a:prstGeom>
+          <a:solidFill>
+            <a:srgbClr val="FFD000"/>
+          </a:solidFill>
+          <a:ln>
+            <a:noFill/>
+          </a:ln>
+        </p:spPr>
+        <p:style>
+          <a:lnRef idx="1">
+            <a:schemeClr val="accent1"/>
+          </a:lnRef>
+          <a:fillRef idx="3">
+            <a:schemeClr val="accent1"/>
+          </a:fillRef>
+          <a:effectRef idx="2">
+            <a:schemeClr val="accent1"/>
+          </a:effectRef>
+          <a:fontRef idx="minor">
+            <a:schemeClr val="lt1"/>
+          </a:fontRef>
+        </p:style>
+        <p:txBody>
+          <a:bodyPr rtlCol="0" anchor="ctr"/>
+          <a:lstStyle/>
+          <a:p>
+            <a:pPr algn="ctr"/>
+          </a:p>
+        </p:txBody>
+      </p:sp>
+      <p:sp>
+        <p:nvSpPr>
+          <p:cNvPr id="4" name="TextBox 3"/>
+          <p:cNvSpPr txBox="1"/>
+          <p:nvPr/>
+        </p:nvSpPr>
+        <p:spPr>
+          <a:xfrm>
+            <a:off x="457200" y="164592"/>
+            <a:ext cx="11277295" cy="384048"/>
+          </a:xfrm>
+          <a:prstGeom prst="rect">
+            <a:avLst/>
+          </a:prstGeom>
+          <a:noFill/>
+        </p:spPr>
+        <p:txBody>
+          <a:bodyPr wrap="square">
+            <a:spAutoFit/>
+          </a:bodyPr>
+          <a:lstStyle/>
+          <a:p>
+            <a:r>
+              <a:rPr sz="2600" b="1" i="0">
+                <a:solidFill>
+                  <a:srgbClr val="FFFFFF"/>
+                </a:solidFill>
+                <a:latin typeface="Calibri"/>
+              </a:rPr>
+              <a:t>Del boceto al código Mermaid</a:t>
+            </a:r>
+          </a:p>
+        </p:txBody>
+      </p:sp>
+      <p:sp>
+        <p:nvSpPr>
+          <p:cNvPr id="5" name="TextBox 4"/>
+          <p:cNvSpPr txBox="1"/>
+          <p:nvPr/>
+        </p:nvSpPr>
+        <p:spPr>
+          <a:xfrm>
+            <a:off x="457200" y="566928"/>
+            <a:ext cx="11277295" cy="411480"/>
+          </a:xfrm>
+          <a:prstGeom prst="rect">
+            <a:avLst/>
+          </a:prstGeom>
+          <a:noFill/>
+        </p:spPr>
+        <p:txBody>
+          <a:bodyPr wrap="square">
+            <a:spAutoFit/>
+          </a:bodyPr>
+          <a:lstStyle/>
+          <a:p>
+            <a:r>
+              <a:rPr sz="1400" b="0" i="0">
+                <a:solidFill>
+                  <a:srgbClr val="B8D8EE"/>
+                </a:solidFill>
+                <a:latin typeface="Calibri"/>
+              </a:rPr>
+              <a:t>El diagrama se escribe como código: se versiona, se compara y se corrige</a:t>
+            </a:r>
+          </a:p>
+        </p:txBody>
+      </p:sp>
+      <p:sp>
+        <p:nvSpPr>
+          <p:cNvPr id="6" name="Rounded Rectangle 5"/>
+          <p:cNvSpPr/>
+          <p:nvPr/>
+        </p:nvSpPr>
+        <p:spPr>
+          <a:xfrm>
+            <a:off x="457200" y="1659636"/>
+            <a:ext cx="11277295" cy="1051560"/>
+          </a:xfrm>
+          <a:prstGeom prst="roundRect">
+            <a:avLst>
+              <a:gd name="adj" fmla="val 12000"/>
+            </a:avLst>
+          </a:prstGeom>
+          <a:solidFill>
+            <a:srgbClr val="F2F2F2"/>
+          </a:solidFill>
+          <a:ln>
+            <a:noFill/>
+          </a:ln>
+        </p:spPr>
+        <p:style>
+          <a:lnRef idx="1">
+            <a:schemeClr val="accent1"/>
+          </a:lnRef>
+          <a:fillRef idx="3">
+            <a:schemeClr val="accent1"/>
+          </a:fillRef>
+          <a:effectRef idx="2">
+            <a:schemeClr val="accent1"/>
+          </a:effectRef>
+          <a:fontRef idx="minor">
+            <a:schemeClr val="lt1"/>
+          </a:fontRef>
+        </p:style>
+        <p:txBody>
+          <a:bodyPr rtlCol="0" anchor="ctr"/>
+          <a:lstStyle/>
+          <a:p>
+            <a:pPr algn="ctr"/>
+          </a:p>
+        </p:txBody>
+      </p:sp>
+      <p:sp>
+        <p:nvSpPr>
+          <p:cNvPr id="7" name="Rounded Rectangle 6"/>
+          <p:cNvSpPr/>
+          <p:nvPr/>
+        </p:nvSpPr>
+        <p:spPr>
+          <a:xfrm>
+            <a:off x="594360" y="1965960"/>
+            <a:ext cx="438912" cy="438912"/>
+          </a:xfrm>
+          <a:prstGeom prst="roundRect">
+            <a:avLst>
+              <a:gd name="adj" fmla="val 12000"/>
+            </a:avLst>
+          </a:prstGeom>
+          <a:solidFill>
+            <a:srgbClr val="095292"/>
+          </a:solidFill>
+          <a:ln>
+            <a:noFill/>
+          </a:ln>
+        </p:spPr>
+        <p:style>
+          <a:lnRef idx="1">
+            <a:schemeClr val="accent1"/>
+          </a:lnRef>
+          <a:fillRef idx="3">
+            <a:schemeClr val="accent1"/>
+          </a:fillRef>
+          <a:effectRef idx="2">
+            <a:schemeClr val="accent1"/>
+          </a:effectRef>
+          <a:fontRef idx="minor">
+            <a:schemeClr val="lt1"/>
+          </a:fontRef>
+        </p:style>
+        <p:txBody>
+          <a:bodyPr rtlCol="0" anchor="ctr"/>
+          <a:lstStyle/>
+          <a:p>
+            <a:pPr algn="ctr"/>
+          </a:p>
+        </p:txBody>
+      </p:sp>
+      <p:sp>
+        <p:nvSpPr>
+          <p:cNvPr id="8" name="TextBox 7"/>
+          <p:cNvSpPr txBox="1"/>
+          <p:nvPr/>
+        </p:nvSpPr>
+        <p:spPr>
+          <a:xfrm>
+            <a:off x="594360" y="1965960"/>
+            <a:ext cx="438912" cy="438912"/>
+          </a:xfrm>
+          <a:prstGeom prst="rect">
+            <a:avLst/>
+          </a:prstGeom>
+          <a:noFill/>
+        </p:spPr>
+        <p:txBody>
+          <a:bodyPr wrap="square" anchor="ctr"/>
+          <a:lstStyle/>
+          <a:p>
+            <a:pPr algn="ctr"/>
+            <a:r>
+              <a:rPr sz="1600" b="1" i="0">
+                <a:solidFill>
+                  <a:srgbClr val="FFFFFF"/>
+                </a:solidFill>
+                <a:latin typeface="Calibri"/>
+              </a:rPr>
+              <a:t>1</a:t>
+            </a:r>
+          </a:p>
+        </p:txBody>
+      </p:sp>
+      <p:sp>
+        <p:nvSpPr>
+          <p:cNvPr id="9" name="TextBox 8"/>
+          <p:cNvSpPr txBox="1"/>
+          <p:nvPr/>
+        </p:nvSpPr>
+        <p:spPr>
+          <a:xfrm>
+            <a:off x="1188720" y="1751076"/>
+            <a:ext cx="10271455" cy="886968"/>
+          </a:xfrm>
+          <a:prstGeom prst="rect">
+            <a:avLst/>
+          </a:prstGeom>
+          <a:noFill/>
+        </p:spPr>
+        <p:txBody>
+          <a:bodyPr wrap="square" anchor="ctr"/>
+          <a:lstStyle/>
+          <a:p>
+            <a:r>
+              <a:rPr sz="1500" b="1" i="0">
+                <a:solidFill>
+                  <a:srgbClr val="095292"/>
+                </a:solidFill>
+                <a:latin typeface="Calibri"/>
+              </a:rPr>
+              <a:t>Diseña visual</a:t>
+            </a:r>
+          </a:p>
+          <a:p>
+            <a:pPr>
+              <a:spcBef>
+                <a:spcPts val="200"/>
+              </a:spcBef>
+            </a:pPr>
+            <a:r>
+              <a:rPr sz="1300" b="0" i="0">
+                <a:solidFill>
+                  <a:srgbClr val="333333"/>
+                </a:solidFill>
+                <a:latin typeface="Calibri"/>
+              </a:rPr>
+              <a:t>Dibuja el diagrama como quieras en Excalidraw o draw.io: es más rápido arrastrar cajas que escribir código, y ahí es donde se piensa el modelo.</a:t>
+            </a:r>
+          </a:p>
+        </p:txBody>
+      </p:sp>
+      <p:sp>
+        <p:nvSpPr>
+          <p:cNvPr id="10" name="Rounded Rectangle 9"/>
+          <p:cNvSpPr/>
+          <p:nvPr/>
+        </p:nvSpPr>
+        <p:spPr>
+          <a:xfrm>
+            <a:off x="457200" y="2802636"/>
+            <a:ext cx="11277295" cy="1051560"/>
+          </a:xfrm>
+          <a:prstGeom prst="roundRect">
+            <a:avLst>
+              <a:gd name="adj" fmla="val 12000"/>
+            </a:avLst>
+          </a:prstGeom>
+          <a:solidFill>
+            <a:srgbClr val="E8F4FA"/>
+          </a:solidFill>
+          <a:ln>
+            <a:noFill/>
+          </a:ln>
+        </p:spPr>
+        <p:style>
+          <a:lnRef idx="1">
+            <a:schemeClr val="accent1"/>
+          </a:lnRef>
+          <a:fillRef idx="3">
+            <a:schemeClr val="accent1"/>
+          </a:fillRef>
+          <a:effectRef idx="2">
+            <a:schemeClr val="accent1"/>
+          </a:effectRef>
+          <a:fontRef idx="minor">
+            <a:schemeClr val="lt1"/>
+          </a:fontRef>
+        </p:style>
+        <p:txBody>
+          <a:bodyPr rtlCol="0" anchor="ctr"/>
+          <a:lstStyle/>
+          <a:p>
+            <a:pPr algn="ctr"/>
+          </a:p>
+        </p:txBody>
+      </p:sp>
+      <p:sp>
+        <p:nvSpPr>
+          <p:cNvPr id="11" name="Rounded Rectangle 10"/>
+          <p:cNvSpPr/>
+          <p:nvPr/>
+        </p:nvSpPr>
+        <p:spPr>
+          <a:xfrm>
+            <a:off x="594360" y="3108960"/>
+            <a:ext cx="438912" cy="438912"/>
+          </a:xfrm>
+          <a:prstGeom prst="roundRect">
+            <a:avLst>
+              <a:gd name="adj" fmla="val 12000"/>
+            </a:avLst>
+          </a:prstGeom>
+          <a:solidFill>
+            <a:srgbClr val="095292"/>
+          </a:solidFill>
+          <a:ln>
+            <a:noFill/>
+          </a:ln>
+        </p:spPr>
+        <p:style>
+          <a:lnRef idx="1">
+            <a:schemeClr val="accent1"/>
+          </a:lnRef>
+          <a:fillRef idx="3">
+            <a:schemeClr val="accent1"/>
+          </a:fillRef>
+          <a:effectRef idx="2">
+            <a:schemeClr val="accent1"/>
+          </a:effectRef>
+          <a:fontRef idx="minor">
+            <a:schemeClr val="lt1"/>
+          </a:fontRef>
+        </p:style>
+        <p:txBody>
+          <a:bodyPr rtlCol="0" anchor="ctr"/>
+          <a:lstStyle/>
+          <a:p>
+            <a:pPr algn="ctr"/>
+          </a:p>
+        </p:txBody>
+      </p:sp>
+      <p:sp>
+        <p:nvSpPr>
+          <p:cNvPr id="12" name="TextBox 11"/>
+          <p:cNvSpPr txBox="1"/>
+          <p:nvPr/>
+        </p:nvSpPr>
+        <p:spPr>
+          <a:xfrm>
+            <a:off x="594360" y="3108960"/>
+            <a:ext cx="438912" cy="438912"/>
+          </a:xfrm>
+          <a:prstGeom prst="rect">
+            <a:avLst/>
+          </a:prstGeom>
+          <a:noFill/>
+        </p:spPr>
+        <p:txBody>
+          <a:bodyPr wrap="square" anchor="ctr"/>
+          <a:lstStyle/>
+          <a:p>
+            <a:pPr algn="ctr"/>
+            <a:r>
+              <a:rPr sz="1600" b="1" i="0">
+                <a:solidFill>
+                  <a:srgbClr val="FFFFFF"/>
+                </a:solidFill>
+                <a:latin typeface="Calibri"/>
+              </a:rPr>
+              <a:t>2</a:t>
+            </a:r>
+          </a:p>
+        </p:txBody>
+      </p:sp>
+      <p:sp>
+        <p:nvSpPr>
+          <p:cNvPr id="13" name="TextBox 12"/>
+          <p:cNvSpPr txBox="1"/>
+          <p:nvPr/>
+        </p:nvSpPr>
+        <p:spPr>
+          <a:xfrm>
+            <a:off x="1188720" y="2894076"/>
+            <a:ext cx="10271455" cy="886968"/>
+          </a:xfrm>
+          <a:prstGeom prst="rect">
+            <a:avLst/>
+          </a:prstGeom>
+          <a:noFill/>
+        </p:spPr>
+        <p:txBody>
+          <a:bodyPr wrap="square" anchor="ctr"/>
+          <a:lstStyle/>
+          <a:p>
+            <a:r>
+              <a:rPr sz="1500" b="1" i="0">
+                <a:solidFill>
+                  <a:srgbClr val="095292"/>
+                </a:solidFill>
+                <a:latin typeface="Calibri"/>
+              </a:rPr>
+              <a:t>Traduce con IA</a:t>
+            </a:r>
+          </a:p>
+          <a:p>
+            <a:pPr>
+              <a:spcBef>
+                <a:spcPts val="200"/>
+              </a:spcBef>
+            </a:pPr>
+            <a:r>
+              <a:rPr sz="1300" b="0" i="0">
+                <a:solidFill>
+                  <a:srgbClr val="333333"/>
+                </a:solidFill>
+                <a:latin typeface="Calibri"/>
+              </a:rPr>
+              <a:t>Describe tu boceto a una IA y pídele el código Mermaid usando C4Context. Revisa el resultado: la IA acierta la sintaxis, no tu modelo.</a:t>
+            </a:r>
+          </a:p>
+        </p:txBody>
+      </p:sp>
+      <p:sp>
+        <p:nvSpPr>
+          <p:cNvPr id="14" name="Rounded Rectangle 13"/>
+          <p:cNvSpPr/>
+          <p:nvPr/>
+        </p:nvSpPr>
+        <p:spPr>
+          <a:xfrm>
+            <a:off x="457200" y="3945636"/>
+            <a:ext cx="11277295" cy="1051560"/>
+          </a:xfrm>
+          <a:prstGeom prst="roundRect">
+            <a:avLst>
+              <a:gd name="adj" fmla="val 12000"/>
+            </a:avLst>
+          </a:prstGeom>
+          <a:solidFill>
+            <a:srgbClr val="F2F2F2"/>
+          </a:solidFill>
+          <a:ln>
+            <a:noFill/>
+          </a:ln>
+        </p:spPr>
+        <p:style>
+          <a:lnRef idx="1">
+            <a:schemeClr val="accent1"/>
+          </a:lnRef>
+          <a:fillRef idx="3">
+            <a:schemeClr val="accent1"/>
+          </a:fillRef>
+          <a:effectRef idx="2">
+            <a:schemeClr val="accent1"/>
+          </a:effectRef>
+          <a:fontRef idx="minor">
+            <a:schemeClr val="lt1"/>
+          </a:fontRef>
+        </p:style>
+        <p:txBody>
+          <a:bodyPr rtlCol="0" anchor="ctr"/>
+          <a:lstStyle/>
+          <a:p>
+            <a:pPr algn="ctr"/>
+          </a:p>
+        </p:txBody>
+      </p:sp>
+      <p:sp>
+        <p:nvSpPr>
+          <p:cNvPr id="15" name="Rounded Rectangle 14"/>
+          <p:cNvSpPr/>
+          <p:nvPr/>
+        </p:nvSpPr>
+        <p:spPr>
+          <a:xfrm>
+            <a:off x="594360" y="4251960"/>
+            <a:ext cx="438912" cy="438912"/>
+          </a:xfrm>
+          <a:prstGeom prst="roundRect">
+            <a:avLst>
+              <a:gd name="adj" fmla="val 12000"/>
+            </a:avLst>
+          </a:prstGeom>
+          <a:solidFill>
+            <a:srgbClr val="095292"/>
+          </a:solidFill>
+          <a:ln>
+            <a:noFill/>
+          </a:ln>
+        </p:spPr>
+        <p:style>
+          <a:lnRef idx="1">
+            <a:schemeClr val="accent1"/>
+          </a:lnRef>
+          <a:fillRef idx="3">
+            <a:schemeClr val="accent1"/>
+          </a:fillRef>
+          <a:effectRef idx="2">
+            <a:schemeClr val="accent1"/>
+          </a:effectRef>
+          <a:fontRef idx="minor">
+            <a:schemeClr val="lt1"/>
+          </a:fontRef>
+        </p:style>
+        <p:txBody>
+          <a:bodyPr rtlCol="0" anchor="ctr"/>
+          <a:lstStyle/>
+          <a:p>
+            <a:pPr algn="ctr"/>
+          </a:p>
+        </p:txBody>
+      </p:sp>
+      <p:sp>
+        <p:nvSpPr>
+          <p:cNvPr id="16" name="TextBox 15"/>
+          <p:cNvSpPr txBox="1"/>
+          <p:nvPr/>
+        </p:nvSpPr>
+        <p:spPr>
+          <a:xfrm>
+            <a:off x="594360" y="4251960"/>
+            <a:ext cx="438912" cy="438912"/>
+          </a:xfrm>
+          <a:prstGeom prst="rect">
+            <a:avLst/>
+          </a:prstGeom>
+          <a:noFill/>
+        </p:spPr>
+        <p:txBody>
+          <a:bodyPr wrap="square" anchor="ctr"/>
+          <a:lstStyle/>
+          <a:p>
+            <a:pPr algn="ctr"/>
+            <a:r>
+              <a:rPr sz="1600" b="1" i="0">
+                <a:solidFill>
+                  <a:srgbClr val="FFFFFF"/>
+                </a:solidFill>
+                <a:latin typeface="Calibri"/>
+              </a:rPr>
+              <a:t>3</a:t>
+            </a:r>
+          </a:p>
+        </p:txBody>
+      </p:sp>
+      <p:sp>
+        <p:nvSpPr>
+          <p:cNvPr id="17" name="TextBox 16"/>
+          <p:cNvSpPr txBox="1"/>
+          <p:nvPr/>
+        </p:nvSpPr>
+        <p:spPr>
+          <a:xfrm>
+            <a:off x="1188720" y="4037076"/>
+            <a:ext cx="10271455" cy="886968"/>
+          </a:xfrm>
+          <a:prstGeom prst="rect">
+            <a:avLst/>
+          </a:prstGeom>
+          <a:noFill/>
+        </p:spPr>
+        <p:txBody>
+          <a:bodyPr wrap="square" anchor="ctr"/>
+          <a:lstStyle/>
+          <a:p>
+            <a:r>
+              <a:rPr sz="1500" b="1" i="0">
+                <a:solidFill>
+                  <a:srgbClr val="095292"/>
+                </a:solidFill>
+                <a:latin typeface="Calibri"/>
+              </a:rPr>
+              <a:t>Renderiza en un visor</a:t>
+            </a:r>
+          </a:p>
+          <a:p>
+            <a:pPr>
+              <a:spcBef>
+                <a:spcPts val="200"/>
+              </a:spcBef>
+            </a:pPr>
+            <a:r>
+              <a:rPr sz="1300" b="0" i="0">
+                <a:solidFill>
+                  <a:srgbClr val="333333"/>
+                </a:solidFill>
+                <a:latin typeface="Calibri"/>
+              </a:rPr>
+              <a:t>Pega el código en un visor Mermaid (mermaid.live o la vista previa de tu editor) y míralo dibujado. Si no renderiza, corrige ahí: un end faltante o un rótulo sin comillas.</a:t>
+            </a:r>
+          </a:p>
+        </p:txBody>
+      </p:sp>
+      <p:sp>
+        <p:nvSpPr>
+          <p:cNvPr id="18" name="Rounded Rectangle 17"/>
+          <p:cNvSpPr/>
+          <p:nvPr/>
+        </p:nvSpPr>
+        <p:spPr>
+          <a:xfrm>
+            <a:off x="457200" y="5088636"/>
+            <a:ext cx="11277295" cy="1051560"/>
+          </a:xfrm>
+          <a:prstGeom prst="roundRect">
+            <a:avLst>
+              <a:gd name="adj" fmla="val 12000"/>
+            </a:avLst>
+          </a:prstGeom>
+          <a:solidFill>
+            <a:srgbClr val="E8F4FA"/>
+          </a:solidFill>
+          <a:ln>
+            <a:noFill/>
+          </a:ln>
+        </p:spPr>
+        <p:style>
+          <a:lnRef idx="1">
+            <a:schemeClr val="accent1"/>
+          </a:lnRef>
+          <a:fillRef idx="3">
+            <a:schemeClr val="accent1"/>
+          </a:fillRef>
+          <a:effectRef idx="2">
+            <a:schemeClr val="accent1"/>
+          </a:effectRef>
+          <a:fontRef idx="minor">
+            <a:schemeClr val="lt1"/>
+          </a:fontRef>
+        </p:style>
+        <p:txBody>
+          <a:bodyPr rtlCol="0" anchor="ctr"/>
+          <a:lstStyle/>
+          <a:p>
+            <a:pPr algn="ctr"/>
+          </a:p>
+        </p:txBody>
+      </p:sp>
+      <p:sp>
+        <p:nvSpPr>
+          <p:cNvPr id="19" name="Rounded Rectangle 18"/>
+          <p:cNvSpPr/>
+          <p:nvPr/>
+        </p:nvSpPr>
+        <p:spPr>
+          <a:xfrm>
+            <a:off x="594360" y="5394960"/>
+            <a:ext cx="438912" cy="438912"/>
+          </a:xfrm>
+          <a:prstGeom prst="roundRect">
+            <a:avLst>
+              <a:gd name="adj" fmla="val 12000"/>
+            </a:avLst>
+          </a:prstGeom>
+          <a:solidFill>
+            <a:srgbClr val="095292"/>
+          </a:solidFill>
+          <a:ln>
+            <a:noFill/>
+          </a:ln>
+        </p:spPr>
+        <p:style>
+          <a:lnRef idx="1">
+            <a:schemeClr val="accent1"/>
+          </a:lnRef>
+          <a:fillRef idx="3">
+            <a:schemeClr val="accent1"/>
+          </a:fillRef>
+          <a:effectRef idx="2">
+            <a:schemeClr val="accent1"/>
+          </a:effectRef>
+          <a:fontRef idx="minor">
+            <a:schemeClr val="lt1"/>
+          </a:fontRef>
+        </p:style>
+        <p:txBody>
+          <a:bodyPr rtlCol="0" anchor="ctr"/>
+          <a:lstStyle/>
+          <a:p>
+            <a:pPr algn="ctr"/>
+          </a:p>
+        </p:txBody>
+      </p:sp>
+      <p:sp>
+        <p:nvSpPr>
+          <p:cNvPr id="20" name="TextBox 19"/>
+          <p:cNvSpPr txBox="1"/>
+          <p:nvPr/>
+        </p:nvSpPr>
+        <p:spPr>
+          <a:xfrm>
+            <a:off x="594360" y="5394960"/>
+            <a:ext cx="438912" cy="438912"/>
+          </a:xfrm>
+          <a:prstGeom prst="rect">
+            <a:avLst/>
+          </a:prstGeom>
+          <a:noFill/>
+        </p:spPr>
+        <p:txBody>
+          <a:bodyPr wrap="square" anchor="ctr"/>
+          <a:lstStyle/>
+          <a:p>
+            <a:pPr algn="ctr"/>
+            <a:r>
+              <a:rPr sz="1600" b="1" i="0">
+                <a:solidFill>
+                  <a:srgbClr val="FFFFFF"/>
+                </a:solidFill>
+                <a:latin typeface="Calibri"/>
+              </a:rPr>
+              <a:t>4</a:t>
+            </a:r>
+          </a:p>
+        </p:txBody>
+      </p:sp>
+      <p:sp>
+        <p:nvSpPr>
+          <p:cNvPr id="21" name="TextBox 20"/>
+          <p:cNvSpPr txBox="1"/>
+          <p:nvPr/>
+        </p:nvSpPr>
+        <p:spPr>
+          <a:xfrm>
+            <a:off x="1188720" y="5180076"/>
+            <a:ext cx="10271455" cy="886968"/>
+          </a:xfrm>
+          <a:prstGeom prst="rect">
+            <a:avLst/>
+          </a:prstGeom>
+          <a:noFill/>
+        </p:spPr>
+        <p:txBody>
+          <a:bodyPr wrap="square" anchor="ctr"/>
+          <a:lstStyle/>
+          <a:p>
+            <a:r>
+              <a:rPr sz="1500" b="1" i="0">
+                <a:solidFill>
+                  <a:srgbClr val="095292"/>
+                </a:solidFill>
+                <a:latin typeface="Calibri"/>
+              </a:rPr>
+              <a:t>Guarda código e imagen</a:t>
+            </a:r>
+          </a:p>
+          <a:p>
+            <a:pPr>
+              <a:spcBef>
+                <a:spcPts val="200"/>
+              </a:spcBef>
+            </a:pPr>
+            <a:r>
+              <a:rPr sz="1300" b="0" i="0">
+                <a:solidFill>
+                  <a:srgbClr val="333333"/>
+                </a:solidFill>
+                <a:latin typeface="Calibri"/>
+              </a:rPr>
+              <a:t>El código es la fuente del diagrama: guárdalo con tu proyecto junto con el PNG exportado.</a:t>
+            </a:r>
+          </a:p>
+        </p:txBody>
+      </p:sp>
+      <p:sp>
+        <p:nvSpPr>
+          <p:cNvPr id="22" name="TextBox 21"/>
+          <p:cNvSpPr txBox="1"/>
+          <p:nvPr/>
+        </p:nvSpPr>
+        <p:spPr>
+          <a:xfrm>
+            <a:off x="11185855" y="6473952"/>
+            <a:ext cx="640080" cy="274320"/>
+          </a:xfrm>
+          <a:prstGeom prst="rect">
+            <a:avLst/>
+          </a:prstGeom>
+          <a:noFill/>
+        </p:spPr>
+        <p:txBody>
+          <a:bodyPr wrap="square">
+            <a:spAutoFit/>
+          </a:bodyPr>
+          <a:lstStyle/>
+          <a:p>
+            <a:pPr algn="r"/>
+            <a:r>
+              <a:rPr sz="1100" b="0" i="0">
+                <a:solidFill>
+                  <a:srgbClr val="666666"/>
+                </a:solidFill>
+                <a:latin typeface="Calibri"/>
+              </a:rPr>
+              <a:t>23</a:t>
+            </a:r>
+          </a:p>
+        </p:txBody>
+      </p:sp>
+    </p:spTree>
+  </p:cSld>
+  <p:clrMapOvr>
+    <a:masterClrMapping/>
+  </p:clrMapOvr>
+</p:sld>
+</file>
+
+<file path=ppt/slides/slide24.xml><?xml version="1.0" encoding="utf-8"?>
+<p:sld xmlns:a="http://schemas.openxmlformats.org/drawingml/2006/main" xmlns:p="http://schemas.openxmlformats.org/presentationml/2006/main" xmlns:r="http://schemas.openxmlformats.org/officeDocument/2006/relationships">
+  <p:cSld>
+    <p:bg>
+      <p:bgPr>
+        <a:solidFill>
+          <a:srgbClr val="FFFFFF"/>
+        </a:solidFill>
+        <a:effectLst/>
+      </p:bgPr>
+    </p:bg>
+    <p:spTree>
+      <p:nvGrpSpPr>
+        <p:cNvPr id="1" name=""/>
+        <p:cNvGrpSpPr/>
+        <p:nvPr/>
+      </p:nvGrpSpPr>
+      <p:grpSpPr/>
+      <p:sp>
+        <p:nvSpPr>
+          <p:cNvPr id="2" name="Rectangle 1"/>
+          <p:cNvSpPr/>
+          <p:nvPr/>
+        </p:nvSpPr>
+        <p:spPr>
+          <a:xfrm>
+            <a:off x="0" y="0"/>
             <a:ext cx="12191695" cy="164592"/>
           </a:xfrm>
           <a:prstGeom prst="rect">
@@ -9371,7 +10325,7 @@
                 </a:solidFill>
                 <a:latin typeface="Calibri"/>
               </a:rPr>
-              <a:t>–   Entregables del semestre: diagramas + contenedor (lab) + CI/CD conceptual + informe.</a:t>
+              <a:t>–   Lo que se construye en el semestre: diagramas + contenedor (lab) + CI/CD conceptual + informe.</a:t>
             </a:r>
           </a:p>
           <a:p>

</xml_diff>

<commit_message>
Laminas de concepto de Arquitectura y BD II completadas a 400+ caracteres, y BD II sin sintaxis Oracle
Co-Authored-By: Claude Opus 5.5 <noreply@anthropic.com>
</commit_message>
<xml_diff>
--- a/Arquitectura de Sistemas Computacionales/Clases/Clase 1 - Introduccion a arquitecturas cloud/Presentacion.pptx
+++ b/Arquitectura de Sistemas Computacionales/Clases/Clase 1 - Introduccion a arquitecturas cloud/Presentacion.pptx
@@ -845,6 +845,12 @@
         <p:txBody>
           <a:bodyPr/>
           <a:lstStyle/>
+          <a:p>
+            <a:r>
+              <a:t>En el diagrama proyectado (System, dos Person, System_Ext) el nivel Context muestra el sistema como UNA sola caja, sin abrir por dentro.</a:t>
+            </a:r>
+          </a:p>
+          <a:p/>
           <a:p>
             <a:r>
               <a:t>(Sobre la actividad, no se proyecta) Es el mismo modelo C4 explicado arriba, ahora aplicado con nombres concretos, y sirve de puente directo hacia la pregunta 2 del taller en la plataforma del curso (el diagrama Mermaid que cada estudiante entrega hoy).</a:t>
@@ -6577,7 +6583,7 @@
                 </a:solidFill>
                 <a:latin typeface="Calibri"/>
               </a:rPr>
-              <a:t>–   Use el diagrama proyectado (System, dos Person, System_Ext) como plantilla en vivo: reemplace actor</a:t>
+              <a:t>–   Un diagrama de contexto tiene tres tipos de elemento: Person, System y System_Ext.</a:t>
             </a:r>
           </a:p>
           <a:p>
@@ -6593,7 +6599,39 @@
                 </a:solidFill>
                 <a:latin typeface="Calibri"/>
               </a:rPr>
-              <a:t>–   Sistema y externo por el dominio de un estudiante voluntario mientras explica que en el nivel Context el sistema sigue siendo UNA sola caja, sin abrir por dentro.</a:t>
+              <a:t>–   Cada flecha lleva un verbo de negocio, por ejemplo «Cliente reserva turno en CloudLite Turnos» o «CloudLite Turnos envia recordatorio por el proveedor de correo».</a:t>
+            </a:r>
+          </a:p>
+          <a:p>
+            <a:pPr>
+              <a:spcAft>
+                <a:spcPts val="800"/>
+              </a:spcAft>
+            </a:pPr>
+            <a:r>
+              <a:rPr sz="2000" b="0" i="0">
+                <a:solidFill>
+                  <a:srgbClr val="333333"/>
+                </a:solidFill>
+                <a:latin typeface="Calibri"/>
+              </a:rPr>
+              <a:t>–   El error mas comun es dibujar la base de datos o la API en este nivel: son piezas internas y pertenecen al nivel 2, Containers.</a:t>
+            </a:r>
+          </a:p>
+          <a:p>
+            <a:pPr>
+              <a:spcAft>
+                <a:spcPts val="800"/>
+              </a:spcAft>
+            </a:pPr>
+            <a:r>
+              <a:rPr sz="2000" b="0" i="0">
+                <a:solidFill>
+                  <a:srgbClr val="333333"/>
+                </a:solidFill>
+                <a:latin typeface="Calibri"/>
+              </a:rPr>
+              <a:t>–   Un Context legible tiene entre 4 y 8 elementos; si tiene mas, la caja del sistema ya se esta abriendo.</a:t>
             </a:r>
           </a:p>
         </p:txBody>
@@ -8007,7 +8045,7 @@
                 </a:solidFill>
                 <a:latin typeface="Calibri"/>
               </a:rPr>
-              <a:t>Reemplacen actor / sistema / externo por su propio dominio CloudLite</a:t>
+              <a:t>Actor, sistema y sistema externo: el mismo esquema sirve para cualquier dominio CloudLite</a:t>
             </a:r>
           </a:p>
         </p:txBody>
@@ -8348,7 +8386,7 @@
                 </a:solidFill>
                 <a:latin typeface="Calibri"/>
               </a:rPr>
-              <a:t>Nivel Context: el sistema es UNA caja (sin abrir por dentro). Actores a la izquierda, sistemas externos a la derecha. El interior se dibuja en Clase 4 (Containers).</a:t>
+              <a:t>Nivel Context: el sistema es UNA caja (sin abrir por dentro). Actores a la izquierda, sistemas externos a la derecha. El interior se dibuja en Clase 4 (Containers). Cada flecha lleva un verbo de negocio («reserva turno», «envía recordatorio»); la API y la base de datos no aparecen aquí porque son piezas interiores.</a:t>
             </a:r>
           </a:p>
         </p:txBody>
@@ -10092,6 +10130,128 @@
               <a:t>–   Bloques tipicos: cliente → API → lógica → datos → observabilidad.</a:t>
             </a:r>
           </a:p>
+          <a:p>
+            <a:pPr>
+              <a:spcAft>
+                <a:spcPts val="800"/>
+              </a:spcAft>
+            </a:pPr>
+            <a:r>
+              <a:rPr sz="2000" b="0" i="0">
+                <a:solidFill>
+                  <a:srgbClr val="333333"/>
+                </a:solidFill>
+                <a:latin typeface="Calibri"/>
+              </a:rPr>
+              <a:t>–   Una decisión es </a:t>
+            </a:r>
+            <a:r>
+              <a:rPr sz="2000" b="1" i="0">
+                <a:solidFill>
+                  <a:srgbClr val="333333"/>
+                </a:solidFill>
+                <a:latin typeface="Calibri"/>
+              </a:rPr>
+              <a:t>arquitectónica</a:t>
+            </a:r>
+            <a:r>
+              <a:rPr sz="2000" b="0" i="0">
+                <a:solidFill>
+                  <a:srgbClr val="333333"/>
+                </a:solidFill>
+                <a:latin typeface="Calibri"/>
+              </a:rPr>
+              <a:t> si es cara de revertir: cambiar la base de datos a los 3 meses lo es; cambiar el color de un botón, no.</a:t>
+            </a:r>
+          </a:p>
+          <a:p>
+            <a:pPr>
+              <a:spcAft>
+                <a:spcPts val="800"/>
+              </a:spcAft>
+            </a:pPr>
+            <a:r>
+              <a:rPr sz="2000" b="0" i="0">
+                <a:solidFill>
+                  <a:srgbClr val="333333"/>
+                </a:solidFill>
+                <a:latin typeface="Calibri"/>
+              </a:rPr>
+              <a:t>–   Atributos de calidad del curso: </a:t>
+            </a:r>
+            <a:r>
+              <a:rPr sz="2000" b="1" i="0">
+                <a:solidFill>
+                  <a:srgbClr val="333333"/>
+                </a:solidFill>
+                <a:latin typeface="Calibri"/>
+              </a:rPr>
+              <a:t>rendimiento</a:t>
+            </a:r>
+            <a:r>
+              <a:rPr sz="2000" b="0" i="0">
+                <a:solidFill>
+                  <a:srgbClr val="333333"/>
+                </a:solidFill>
+                <a:latin typeface="Calibri"/>
+              </a:rPr>
+              <a:t>, </a:t>
+            </a:r>
+            <a:r>
+              <a:rPr sz="2000" b="1" i="0">
+                <a:solidFill>
+                  <a:srgbClr val="333333"/>
+                </a:solidFill>
+                <a:latin typeface="Calibri"/>
+              </a:rPr>
+              <a:t>disponibilidad</a:t>
+            </a:r>
+            <a:r>
+              <a:rPr sz="2000" b="0" i="0">
+                <a:solidFill>
+                  <a:srgbClr val="333333"/>
+                </a:solidFill>
+                <a:latin typeface="Calibri"/>
+              </a:rPr>
+              <a:t>, </a:t>
+            </a:r>
+            <a:r>
+              <a:rPr sz="2000" b="1" i="0">
+                <a:solidFill>
+                  <a:srgbClr val="333333"/>
+                </a:solidFill>
+                <a:latin typeface="Calibri"/>
+              </a:rPr>
+              <a:t>seguridad</a:t>
+            </a:r>
+            <a:r>
+              <a:rPr sz="2000" b="0" i="0">
+                <a:solidFill>
+                  <a:srgbClr val="333333"/>
+                </a:solidFill>
+                <a:latin typeface="Calibri"/>
+              </a:rPr>
+              <a:t> y </a:t>
+            </a:r>
+            <a:r>
+              <a:rPr sz="2000" b="1" i="0">
+                <a:solidFill>
+                  <a:srgbClr val="333333"/>
+                </a:solidFill>
+                <a:latin typeface="Calibri"/>
+              </a:rPr>
+              <a:t>costo</a:t>
+            </a:r>
+            <a:r>
+              <a:rPr sz="2000" b="0" i="0">
+                <a:solidFill>
+                  <a:srgbClr val="333333"/>
+                </a:solidFill>
+                <a:latin typeface="Calibri"/>
+              </a:rPr>
+              <a:t>.</a:t>
+            </a:r>
+          </a:p>
         </p:txBody>
       </p:sp>
       <p:sp>
@@ -10378,6 +10538,56 @@
               <a:t>–   Sin AWS/GCP/Oracle: draw.io, Killercoda, GitHub Actions.</a:t>
             </a:r>
           </a:p>
+          <a:p>
+            <a:pPr>
+              <a:spcAft>
+                <a:spcPts val="800"/>
+              </a:spcAft>
+            </a:pPr>
+            <a:r>
+              <a:rPr sz="2000" b="0" i="0">
+                <a:solidFill>
+                  <a:srgbClr val="333333"/>
+                </a:solidFill>
+                <a:latin typeface="Calibri"/>
+              </a:rPr>
+              <a:t>–   Ejemplo de dominio: </a:t>
+            </a:r>
+            <a:r>
+              <a:rPr sz="2000" b="1" i="0">
+                <a:solidFill>
+                  <a:srgbClr val="333333"/>
+                </a:solidFill>
+                <a:latin typeface="Calibri"/>
+              </a:rPr>
+              <a:t>CloudLite Turnos</a:t>
+            </a:r>
+            <a:r>
+              <a:rPr sz="2000" b="0" i="0">
+                <a:solidFill>
+                  <a:srgbClr val="333333"/>
+                </a:solidFill>
+                <a:latin typeface="Calibri"/>
+              </a:rPr>
+              <a:t> — el cliente reserva turno, el barbero ve su agenda, el administrador fija horarios.</a:t>
+            </a:r>
+          </a:p>
+          <a:p>
+            <a:pPr>
+              <a:spcAft>
+                <a:spcPts val="800"/>
+              </a:spcAft>
+            </a:pPr>
+            <a:r>
+              <a:rPr sz="2000" b="0" i="0">
+                <a:solidFill>
+                  <a:srgbClr val="333333"/>
+                </a:solidFill>
+                <a:latin typeface="Calibri"/>
+              </a:rPr>
+              <a:t>–   Error común: un dominio infinito (una red social completa) no cabe en un semestre.</a:t>
+            </a:r>
+          </a:p>
         </p:txBody>
       </p:sp>
       <p:sp>
@@ -10662,6 +10872,74 @@
                 <a:latin typeface="Calibri"/>
               </a:rPr>
               <a:t>–   Salida: diagrama C4 Context (sistema + actores externos).</a:t>
+            </a:r>
+          </a:p>
+          <a:p>
+            <a:pPr>
+              <a:spcAft>
+                <a:spcPts val="800"/>
+              </a:spcAft>
+            </a:pPr>
+            <a:r>
+              <a:rPr sz="2000" b="0" i="0">
+                <a:solidFill>
+                  <a:srgbClr val="333333"/>
+                </a:solidFill>
+                <a:latin typeface="Calibri"/>
+              </a:rPr>
+              <a:t>–   </a:t>
+            </a:r>
+            <a:r>
+              <a:rPr sz="2000" b="1" i="0">
+                <a:solidFill>
+                  <a:srgbClr val="333333"/>
+                </a:solidFill>
+                <a:latin typeface="Calibri"/>
+              </a:rPr>
+              <a:t>Núcleo</a:t>
+            </a:r>
+            <a:r>
+              <a:rPr sz="2000" b="0" i="0">
+                <a:solidFill>
+                  <a:srgbClr val="333333"/>
+                </a:solidFill>
+                <a:latin typeface="Calibri"/>
+              </a:rPr>
+              <a:t> = lo que diferencia al dominio (la agenda de turnos); </a:t>
+            </a:r>
+            <a:r>
+              <a:rPr sz="2000" b="1" i="0">
+                <a:solidFill>
+                  <a:srgbClr val="333333"/>
+                </a:solidFill>
+                <a:latin typeface="Calibri"/>
+              </a:rPr>
+              <a:t>satélite</a:t>
+            </a:r>
+            <a:r>
+              <a:rPr sz="2000" b="0" i="0">
+                <a:solidFill>
+                  <a:srgbClr val="333333"/>
+                </a:solidFill>
+                <a:latin typeface="Calibri"/>
+              </a:rPr>
+              <a:t> = lo genérico que se delega (correo, autenticación).</a:t>
+            </a:r>
+          </a:p>
+          <a:p>
+            <a:pPr>
+              <a:spcAft>
+                <a:spcPts val="800"/>
+              </a:spcAft>
+            </a:pPr>
+            <a:r>
+              <a:rPr sz="2000" b="0" i="0">
+                <a:solidFill>
+                  <a:srgbClr val="333333"/>
+                </a:solidFill>
+                <a:latin typeface="Calibri"/>
+              </a:rPr>
+              <a:t>–   Error común: empezar por la tecnología («usaremos Kubernetes») antes de nombrar actor y problema.</a:t>
             </a:r>
           </a:p>
         </p:txBody>

</xml_diff>

<commit_message>
Los decks de clase no nombran el proyecto: ejemplos genericos, tambien en el codigo proyectado
Co-Authored-By: Claude Opus 5.5 <noreply@anthropic.com>
</commit_message>
<xml_diff>
--- a/Arquitectura de Sistemas Computacionales/Clases/Clase 1 - Introduccion a arquitecturas cloud/Presentacion.pptx
+++ b/Arquitectura de Sistemas Computacionales/Clases/Clase 1 - Introduccion a arquitecturas cloud/Presentacion.pptx
@@ -4144,7 +4144,7 @@
                 </a:solidFill>
                 <a:latin typeface="Calibri"/>
               </a:rPr>
-              <a:t>Diagnóstico · CloudLite App · primer boceto</a:t>
+              <a:t>Diagnóstico · la app · primer boceto</a:t>
             </a:r>
           </a:p>
         </p:txBody>
@@ -4235,7 +4235,7 @@
                 </a:solidFill>
                 <a:latin typeface="Calibri"/>
               </a:rPr>
-              <a:t>Conceptos del tema, ejemplos resueltos sobre CloudLite y cierre conceptual.</a:t>
+              <a:t>Conceptos del tema, ejemplos resueltos sobre la app y cierre conceptual.</a:t>
             </a:r>
           </a:p>
         </p:txBody>
@@ -5236,7 +5236,7 @@
                 </a:solidFill>
                 <a:latin typeface="Calibri"/>
               </a:rPr>
-              <a:t>CloudLite App - el hilo conductor (1/2)</a:t>
+              <a:t>La app - el hilo conductor (1/2)</a:t>
             </a:r>
           </a:p>
         </p:txBody>
@@ -5275,7 +5275,7 @@
                 </a:solidFill>
                 <a:latin typeface="Calibri"/>
               </a:rPr>
-              <a:t>–   El diagrama de contexto correcto tiene una sola caja llamada CloudLite Turnos, tres actores alrededor (el cliente que reserva</a:t>
+              <a:t>–   El diagrama de contexto correcto tiene una sola caja llamada Turnos, tres actores alrededor (el cliente que reserva</a:t>
             </a:r>
           </a:p>
           <a:p>
@@ -5488,7 +5488,7 @@
                 </a:solidFill>
                 <a:latin typeface="Calibri"/>
               </a:rPr>
-              <a:t>CloudLite App - el hilo conductor (2/2)</a:t>
+              <a:t>La app - el hilo conductor (2/2)</a:t>
             </a:r>
           </a:p>
         </p:txBody>
@@ -6599,7 +6599,7 @@
                 </a:solidFill>
                 <a:latin typeface="Calibri"/>
               </a:rPr>
-              <a:t>–   Cada flecha lleva un verbo de negocio, por ejemplo «Cliente reserva turno en CloudLite Turnos» o «CloudLite Turnos envia recordatorio por el proveedor de correo».</a:t>
+              <a:t>–   Cada flecha lleva un verbo de negocio, por ejemplo «Cliente reserva turno en la app de turnos» o «la app de turnos envia recordatorio por el proveedor de correo».</a:t>
             </a:r>
           </a:p>
           <a:p>
@@ -7178,7 +7178,7 @@
                 </a:solidFill>
                 <a:latin typeface="Calibri"/>
               </a:rPr>
-              <a:t> Conceptos del tema, uno por lámina, con ejemplos sobre CloudLite.</a:t>
+              <a:t> Conceptos del tema, uno por lámina, con ejemplos sobre la app.</a:t>
             </a:r>
           </a:p>
           <a:p>
@@ -8045,7 +8045,7 @@
                 </a:solidFill>
                 <a:latin typeface="Calibri"/>
               </a:rPr>
-              <a:t>Actor, sistema y sistema externo: el mismo esquema sirve para cualquier dominio CloudLite</a:t>
+              <a:t>Actor, sistema y sistema externo: el mismo esquema sirve para cualquier dominio</a:t>
             </a:r>
           </a:p>
         </p:txBody>
@@ -8154,7 +8154,7 @@
                 </a:solidFill>
                 <a:latin typeface="Calibri"/>
               </a:rPr>
-              <a:t>CloudLite App
+              <a:t>La app
 (el sistema = una sola caja)</a:t>
             </a:r>
           </a:p>
@@ -9485,7 +9485,7 @@
                 </a:solidFill>
                 <a:latin typeface="Calibri"/>
               </a:rPr>
-              <a:t>Ubicar el curso como diseño de arquitecturas cloud al servicio del PI CloudLite App.</a:t>
+              <a:t>Ubicar el curso como diseño de arquitecturas cloud al servicio de la app.</a:t>
             </a:r>
           </a:p>
           <a:p>
@@ -9501,7 +9501,7 @@
                 </a:solidFill>
                 <a:latin typeface="Calibri"/>
               </a:rPr>
-              <a:t>Cerrar el dominio del PI en una ficha de cinco bloques, con capacidades de negocio y no piezas tecnicas.</a:t>
+              <a:t>Cerrar el dominio en una ficha de cinco bloques, con capacidades de negocio y no piezas tecnicas.</a:t>
             </a:r>
           </a:p>
           <a:p>
@@ -9517,7 +9517,7 @@
                 </a:solidFill>
                 <a:latin typeface="Calibri"/>
               </a:rPr>
-              <a:t>Dejar el dominio y alcance del PI escritos y compartibles.</a:t>
+              <a:t>Dejar el dominio y alcance escritos y compartibles.</a:t>
             </a:r>
           </a:p>
         </p:txBody>
@@ -9746,7 +9746,7 @@
                 </a:solidFill>
                 <a:latin typeface="Calibri"/>
               </a:rPr>
-              <a:t>PI CloudLite App</a:t>
+              <a:t>La app</a:t>
             </a:r>
             <a:r>
               <a:rPr sz="2000" b="0" i="0">
@@ -9771,7 +9771,7 @@
                 </a:solidFill>
                 <a:latin typeface="Calibri"/>
               </a:rPr>
-              <a:t>–   Cerrar el dominio del PI en una ficha de cinco bloques, con capacidades de negocio y no piezas tecnicas.</a:t>
+              <a:t>–   Cerrar el dominio en una ficha de cinco bloques, con capacidades de negocio y no piezas tecnicas.</a:t>
             </a:r>
           </a:p>
           <a:p>
@@ -9805,7 +9805,7 @@
                 </a:solidFill>
                 <a:latin typeface="Calibri"/>
               </a:rPr>
-              <a:t> del PI escritos y compartibles.</a:t>
+              <a:t> escritos y compartibles.</a:t>
             </a:r>
           </a:p>
         </p:txBody>
@@ -10093,7 +10093,7 @@
                 </a:solidFill>
                 <a:latin typeface="Calibri"/>
               </a:rPr>
-              <a:t>–   Para CloudLite App: no «comprar servidores»; </a:t>
+              <a:t>–   Para la app: no «comprar servidores»; </a:t>
             </a:r>
             <a:r>
               <a:rPr sz="2000" b="1" i="0">
@@ -10430,7 +10430,7 @@
                 </a:solidFill>
                 <a:latin typeface="Calibri"/>
               </a:rPr>
-              <a:t>CloudLite App — el hilo conductor</a:t>
+              <a:t>La app — el hilo conductor</a:t>
             </a:r>
           </a:p>
         </p:txBody>
@@ -10560,7 +10560,7 @@
                 </a:solidFill>
                 <a:latin typeface="Calibri"/>
               </a:rPr>
-              <a:t>CloudLite Turnos</a:t>
+              <a:t>La app de turnos</a:t>
             </a:r>
             <a:r>
               <a:rPr sz="2000" b="0" i="0">
@@ -11175,7 +11175,7 @@
                 </a:solidFill>
                 <a:latin typeface="Calibri"/>
               </a:rPr>
-              <a:t>–   PROBLEMA obliga a nombrar en tres frases quien sufre la situacion, como se resuelve hoy sin CloudLite y una cifra medible del dolor; sin esa cifra el problema es una opinion y no algo que un diseno pueda mejorar o empeorar de forma verificable.</a:t>
+              <a:t>–   PROBLEMA obliga a nombrar en tres frases quien sufre la situacion, como se resuelve hoy sin la app y una cifra medible del dolor; sin esa cifra el problema es una opinion y no algo que un diseno pueda mejorar o empeorar de forma verificable.</a:t>
             </a:r>
           </a:p>
           <a:p>
@@ -11427,7 +11427,7 @@
                 </a:solidFill>
                 <a:latin typeface="Calibri"/>
               </a:rPr>
-              <a:t>–   FUERA DE ALCANCE cierra la ficha nombrando tres cosas que CloudLite no hara este semestre; ese bloque evita que el alcance crezca sin control clase a clase y es lo primero que hay que revisar cuando un estudiante pida mas tiempo en una entrega futura.</a:t>
+              <a:t>–   FUERA DE ALCANCE cierra la ficha nombrando tres cosas que la app no hara este semestre; ese bloque evita que el alcance crezca sin control clase a clase y es lo primero que hay que revisar cuando un estudiante pida mas tiempo en una entrega futura.</a:t>
             </a:r>
           </a:p>
         </p:txBody>

</xml_diff>

<commit_message>
Codigo del Kit igual al proyectado, frases al docente a notas y laminas sin evaluacion en los cinco cursos
Co-Authored-By: Claude Opus 5.5 <noreply@anthropic.com>
</commit_message>
<xml_diff>
--- a/Arquitectura de Sistemas Computacionales/Clases/Clase 1 - Introduccion a arquitecturas cloud/Presentacion.pptx
+++ b/Arquitectura de Sistemas Computacionales/Clases/Clase 1 - Introduccion a arquitecturas cloud/Presentacion.pptx
@@ -26,9 +26,6 @@
     <p:sldId id="274" r:id="rId26"/>
     <p:sldId id="275" r:id="rId27"/>
     <p:sldId id="276" r:id="rId28"/>
-    <p:sldId id="277" r:id="rId29"/>
-    <p:sldId id="278" r:id="rId30"/>
-    <p:sldId id="279" r:id="rId31"/>
   </p:sldIdLst>
   <p:sldSz cx="12191695" cy="6858000" type="screen4x3"/>
   <p:notesSz cx="6858000" cy="9144000"/>
@@ -531,7 +528,7 @@
           <a:p/>
           <a:p>
             <a:r>
-              <a:t>SISTEMAS EXTERNOS es el bloque nuevo de este semestre: dos o tres sistemas de terceros con los que CloudLite intercambia informacion (un proveedor de identidad, un servicio de correo, una pasarela de pagos); es exactamente lo que despues aparece como System_Ext en el diagrama C4 Context, asi que conviene que el estudiante los escriba aqui ANTES de dibujar, no despues.</a:t>
+              <a:t>(No se proyecta) SISTEMAS EXTERNOS es el bloque nuevo de este semestre: dos o tres sistemas de terceros con los que CloudLite intercambia informacion (un proveedor de identidad, un servicio de correo, una pasarela de pagos); es exactamente lo que despues aparece como System_Ext en el diagrama C4 Context, asi que conviene que el estudiante los escriba aqui ANTES de dibujar, no despues.</a:t>
             </a:r>
           </a:p>
         </p:txBody>
@@ -601,37 +598,61 @@
           <a:lstStyle/>
           <a:p>
             <a:r>
-              <a:t>Esa asimetria de costo es la razon de existir de la materia: si el docente no la instala el primer dia, el curso se percibe como una coleccion de diagramas decorativos y el estudiante concluye que la arquitectura es documentacion que se produce para la nota.</a:t>
+              <a:t>Nadie puede contestar, porque el stack no contiene esa informacion; las respuestas viven en la arquitectura.</a:t>
             </a:r>
           </a:p>
           <a:p/>
           <a:p>
             <a:r>
-              <a:t>Conviene separar de entrada dos cosas que el estudiante confunde siempre: el stack tecnologico y la arquitectura.</a:t>
+              <a:t>Hacer visible ese vacio en los primeros veinte minutos ahorra tres semanas de malentendidos.</a:t>
             </a:r>
           </a:p>
           <a:p/>
           <a:p>
             <a:r>
-              <a:t>Nadie puede contestar, porque el stack no contiene esa informacion; las respuestas viven en la arquitectura.</a:t>
+              <a:t>Nube no significa internet ni «el servidor de otra persona».</a:t>
             </a:r>
           </a:p>
           <a:p/>
           <a:p>
             <a:r>
-              <a:t>Hacer visible ese vacio en los primeros veinte minutos ahorra tres semanas de malentendidos.</a:t>
+              <a:t>(No se proyecta) Esa asimetria de costo es la razon de existir de la materia: si el docente no la instala el primer dia, el curso se percibe como una coleccion de diagramas decorativos y el estudiante concluye que la arquitectura es documentacion que se produce para la nota.</a:t>
             </a:r>
           </a:p>
           <a:p/>
           <a:p>
             <a:r>
-              <a:t>Nube no significa internet ni «el servidor de otra persona».</a:t>
+              <a:t>(No se proyecta) Conviene separar de entrada dos cosas que el estudiante confunde siempre: el stack tecnologico y la arquitectura.</a:t>
             </a:r>
           </a:p>
           <a:p/>
           <a:p>
             <a:r>
-              <a:t>Por eso en la nube el costo se convierte en un atributo de calidad tecnico y no solo administrativo, idea que el curso retoma de forma explicita en la Clase 10.</a:t>
+              <a:t>(No se proyecta) Una forma rapida de demostrarlo es escribir en el tablero «React + Node + PostgreSQL» y preguntar al curso cuantos usuarios simultaneos soporta eso, o que ocurre si la base de datos deja de responder.</a:t>
+            </a:r>
+          </a:p>
+          <a:p/>
+          <a:p>
+            <a:r>
+              <a:t>(No se proyecta) Rendimiento se expresa en tiempo de respuesta: una convencion de usabilidad ampliamente aceptada dice que una interaccion web se siente inmediata por debajo de 100 milisegundos, aceptable hasta unos 300 y claramente lenta por encima de 1 segundo; son convenciones, no leyes fisicas, y conviene decirlo asi.</a:t>
+            </a:r>
+          </a:p>
+          <a:p/>
+          <a:p>
+            <a:r>
+              <a:t>(No se proyecta) Vale hacer ese calculo en el tablero, porque 43 minutos al mes es un dato que el estudiante recuerda, mientras que la expresion «alta disponibilidad» no significa nada.</a:t>
+            </a:r>
+          </a:p>
+          <a:p/>
+          <a:p>
+            <a:r>
+              <a:t>(No se proyecta) Es un modelo operativo con cinco rasgos que conviene enunciar tal cual, porque son el estandar con el que se define el termino: autoservicio bajo demanda, es decir que quien necesita recursos los aprovisiona sin pedir permiso ni esperar dias; acceso amplio por red; agrupacion de recursos, donde el proveedor comparte hardware fisico entre muchos clientes mediante virtualizacion, tema de la Clase 3; elasticidad rapida, con capacidad que sube y baja en minutos y no en semanas; y medicion del servicio, o pago por lo consumido.</a:t>
+            </a:r>
+          </a:p>
+          <a:p/>
+          <a:p>
+            <a:r>
+              <a:t>(No se proyecta) Por eso en la nube el costo se convierte en un atributo de calidad tecnico y no solo administrativo, idea que el curso retoma de forma explicita en la Clase 10.</a:t>
             </a:r>
           </a:p>
         </p:txBody>
@@ -710,6 +731,12 @@
               <a:t>Supongamos que un estudiante elige como dominio la gestion de turnos de una barberia.</a:t>
             </a:r>
           </a:p>
+          <a:p/>
+          <a:p>
+            <a:r>
+              <a:t>(No se proyecta) El valor de ese diagrama de cinco o seis elementos esta en que obliga a responder dos preguntas que el estudiante no se habia hecho: quien exactamente usa esto y de que terceros depende para funcionar.</a:t>
+            </a:r>
+          </a:p>
         </p:txBody>
       </p:sp>
       <p:sp>
@@ -780,6 +807,12 @@
               <a:t>Un problema sin afectado concreto y sin magnitud produce arquitecturas que nadie puede evaluar, porque no hay contra que comparar.</a:t>
             </a:r>
           </a:p>
+          <a:p/>
+          <a:p>
+            <a:r>
+              <a:t>(No se proyecta) Hoy se trabaja unicamente el nivel 1, y la regla es estricta: si en el diagrama de contexto aparecen las palabras PostgreSQL, Docker o Redis, el diagrama esta mal, porque eso es interior del sistema y corresponde al nivel 2 de la Clase 4.</a:t>
+            </a:r>
+          </a:p>
         </p:txBody>
       </p:sp>
       <p:sp>
@@ -853,7 +886,7 @@
           <a:p/>
           <a:p>
             <a:r>
-              <a:t>(Sobre la actividad, no se proyecta) Es el mismo modelo C4 explicado arriba, ahora aplicado con nombres concretos, y sirve de puente directo hacia la pregunta 2 del taller en la plataforma del curso (el diagrama Mermaid que cada estudiante entrega hoy).</a:t>
+              <a:t>(No se proyecta) Es el mismo modelo C4 explicado arriba, ahora aplicado con nombres concretos, y sirve de puente directo hacia la pregunta 2 del taller en la plataforma del curso (el diagrama Mermaid que cada estudiante entrega hoy).</a:t>
             </a:r>
           </a:p>
         </p:txBody>
@@ -923,25 +956,7 @@
           <a:lstStyle/>
           <a:p>
             <a:r>
-              <a:t>Tres preguntas aparecen casi siempre en esta primera clase y conviene tener la respuesta lista.</a:t>
-            </a:r>
-          </a:p>
-          <a:p/>
-          <a:p>
-            <a:r>
               <a:t>La primera: cual es la diferencia entre arquitectura y diseno.</a:t>
-            </a:r>
-          </a:p>
-          <a:p/>
-          <a:p>
-            <a:r>
-              <a:t>Lo que se decida hoy (dominio, actores, capacidades, problema) es la entrada obligatoria de la Clase 2, que se dicta la semana siguiente en sesion virtual sincrona y pide elegir entre IaaS, PaaS y SaaS registrando la decision; de la Clase 3, donde se contenerizara uno de los servicios de este mismo sistema; y sobre todo de la Clase 4, que abre la caja negra dibujada hoy para mostrar de dos a cinco contenedores logicos.</a:t>
-            </a:r>
-          </a:p>
-          <a:p/>
-          <a:p>
-            <a:r>
-              <a:t>Conviene decirlo en voz alta al cerrar: el estudiante que salga hoy sin dominio definido no tiene sobre que trabajar en las siguientes cuatro sesiones, y el docente debe negarse a dejar el tema abierto para la proxima semana.</a:t>
             </a:r>
           </a:p>
         </p:txBody>
@@ -4416,7 +4431,7 @@
                 </a:solidFill>
                 <a:latin typeface="Calibri"/>
               </a:rPr>
-              <a:t>Que es arquitectura cloud (mapa mental) (2/4)</a:t>
+              <a:t>Que es arquitectura cloud (mapa mental) (2/3)</a:t>
             </a:r>
           </a:p>
         </p:txBody>
@@ -4455,7 +4470,7 @@
                 </a:solidFill>
                 <a:latin typeface="Calibri"/>
               </a:rPr>
-              <a:t>–   Una forma rapida de demostrarlo es escribir en el tablero «React + Node + PostgreSQL» y preguntar al curso cuantos usuarios simultaneos soporta eso, o que ocurre si la base de datos deja de responder.</a:t>
+              <a:t>–   Dos proyectos pueden usar el mismo stack y tener arquitecturas opuestas: uno con un solo proceso que hace todo, otro con tres servicios que se comunican por red.</a:t>
             </a:r>
           </a:p>
           <a:p>
@@ -4503,23 +4518,7 @@
                 </a:solidFill>
                 <a:latin typeface="Calibri"/>
               </a:rPr>
-              <a:t>–   Rendimiento se expresa en tiempo de respuesta: una convencion de usabilidad ampliamente aceptada dice que una interaccion web se siente inmediata por debajo de 100 milisegundos</a:t>
-            </a:r>
-          </a:p>
-          <a:p>
-            <a:pPr>
-              <a:spcAft>
-                <a:spcPts val="800"/>
-              </a:spcAft>
-            </a:pPr>
-            <a:r>
-              <a:rPr sz="2000" b="0" i="0">
-                <a:solidFill>
-                  <a:srgbClr val="333333"/>
-                </a:solidFill>
-                <a:latin typeface="Calibri"/>
-              </a:rPr>
-              <a:t>–   Aceptable hasta unos 300 y claramente lenta por encima de 1 segundo; son convenciones, no leyes fisicas, y conviene decirlo asi.</a:t>
+              <a:t>–   Disponibilidad se expresa como porcentaje de tiempo en que el sistema responde, y ahi el numero si es aritmetica exacta: 99 % permite unas 7 horas de caida al mes, 99,9 % (los llamados tres nueves) alrededor de 43 minutos, y 99,99 % poco mas de 4 minutos.</a:t>
             </a:r>
           </a:p>
         </p:txBody>
@@ -4700,7 +4699,7 @@
                 </a:solidFill>
                 <a:latin typeface="Calibri"/>
               </a:rPr>
-              <a:t>Que es arquitectura cloud (mapa mental) (3/4)</a:t>
+              <a:t>Que es arquitectura cloud (mapa mental) (3/3)</a:t>
             </a:r>
           </a:p>
         </p:txBody>
@@ -4739,7 +4738,7 @@
                 </a:solidFill>
                 <a:latin typeface="Calibri"/>
               </a:rPr>
-              <a:t>–   Disponibilidad se expresa como porcentaje de tiempo en que el sistema responde, y ahi el numero si es aritmetica exacta: 99 % permite unas 7 horas de caida al mes, 99,9 % (los llamados tres nueves) alrededor de 43 minutos, y 99,99 % poco mas de 4 minutos.</a:t>
+              <a:t>–   El punto central es que estos atributos compiten entre si: mas disponibilidad exige redundancia, la redundancia cuesta dinero, y por eso la arquitectura es sobre todo el oficio de elegir que se sacrifica.</a:t>
             </a:r>
           </a:p>
           <a:p>
@@ -4755,55 +4754,7 @@
                 </a:solidFill>
                 <a:latin typeface="Calibri"/>
               </a:rPr>
-              <a:t>–   Vale hacer ese calculo en el tablero, porque 43 minutos al mes es un dato que el estudiante recuerda, mientras que la expresion «alta disponibilidad» no significa nada.</a:t>
-            </a:r>
-          </a:p>
-          <a:p>
-            <a:pPr>
-              <a:spcAft>
-                <a:spcPts val="800"/>
-              </a:spcAft>
-            </a:pPr>
-            <a:r>
-              <a:rPr sz="2000" b="0" i="0">
-                <a:solidFill>
-                  <a:srgbClr val="333333"/>
-                </a:solidFill>
-                <a:latin typeface="Calibri"/>
-              </a:rPr>
-              <a:t>–   El punto central es que estos atributos compiten entre si: mas disponibilidad exige redundancia, la redundancia cuesta dinero, y por eso la arquitectura es sobre todo el oficio de elegir que se sacrifica.</a:t>
-            </a:r>
-          </a:p>
-          <a:p>
-            <a:pPr>
-              <a:spcAft>
-                <a:spcPts val="800"/>
-              </a:spcAft>
-            </a:pPr>
-            <a:r>
-              <a:rPr sz="2000" b="0" i="0">
-                <a:solidFill>
-                  <a:srgbClr val="333333"/>
-                </a:solidFill>
-                <a:latin typeface="Calibri"/>
-              </a:rPr>
-              <a:t>–   Es un modelo operativo con cinco rasgos que conviene enunciar tal cual</a:t>
-            </a:r>
-          </a:p>
-          <a:p>
-            <a:pPr>
-              <a:spcAft>
-                <a:spcPts val="800"/>
-              </a:spcAft>
-            </a:pPr>
-            <a:r>
-              <a:rPr sz="2000" b="0" i="0">
-                <a:solidFill>
-                  <a:srgbClr val="333333"/>
-                </a:solidFill>
-                <a:latin typeface="Calibri"/>
-              </a:rPr>
-              <a:t>–   Porque son el estandar con el que se define el termino: autoservicio bajo demanda, es decir que quien necesita recursos los aprovisiona sin pedir permiso ni esperar dias; acceso amplio por red</a:t>
+              <a:t>–   El cambio economico que esto produce es lo relevante para la arquitectura, porque la infraestructura deja de ser una compra que se hace por adelantado y se amortiza a largo plazo, y pasa a ser un gasto operativo que cambia con cada decision de diseno.</a:t>
             </a:r>
           </a:p>
         </p:txBody>
@@ -4984,7 +4935,7 @@
                 </a:solidFill>
                 <a:latin typeface="Calibri"/>
               </a:rPr>
-              <a:t>Que es arquitectura cloud (mapa mental) (4/4)</a:t>
+              <a:t>La app - el hilo conductor</a:t>
             </a:r>
           </a:p>
         </p:txBody>
@@ -5023,7 +4974,7 @@
                 </a:solidFill>
                 <a:latin typeface="Calibri"/>
               </a:rPr>
-              <a:t>–   Agrupacion de recursos, donde el proveedor comparte hardware fisico entre muchos clientes mediante virtualizacion, tema de la Clase 3</a:t>
+              <a:t>–   El diagrama de contexto correcto tiene una sola caja llamada Turnos, tres actores alrededor (el cliente que reserva</a:t>
             </a:r>
           </a:p>
           <a:p>
@@ -5039,7 +4990,7 @@
                 </a:solidFill>
                 <a:latin typeface="Calibri"/>
               </a:rPr>
-              <a:t>–   Elasticidad rapida, con capacidad que sube y baja en minutos y no en semanas; y medicion del servicio, o pago por lo consumido.</a:t>
+              <a:t>–   El barbero que consulta su agenda del dia y el administrador que configura horarios y precios) y dos o tres sistemas externos con la flecha etiquetada: una pasarela de pagos</a:t>
             </a:r>
           </a:p>
           <a:p>
@@ -5055,7 +5006,39 @@
                 </a:solidFill>
                 <a:latin typeface="Calibri"/>
               </a:rPr>
-              <a:t>–   El cambio economico que esto produce es lo relevante para la arquitectura, porque la infraestructura deja de ser una compra que se hace por adelantado y se amortiza a largo plazo, y pasa a ser un gasto operativo que cambia con cada decision de diseno.</a:t>
+              <a:t>–   Con la etiqueta «envia solicitud de cobro y recibe confirmacion»; un proveedor de correo, con la etiqueta «envia recordatorio de turno»; y quizas un servicio de mapas.</a:t>
+            </a:r>
+          </a:p>
+          <a:p>
+            <a:pPr>
+              <a:spcAft>
+                <a:spcPts val="800"/>
+              </a:spcAft>
+            </a:pPr>
+            <a:r>
+              <a:rPr sz="2000" b="0" i="0">
+                <a:solidFill>
+                  <a:srgbClr val="333333"/>
+                </a:solidFill>
+                <a:latin typeface="Calibri"/>
+              </a:rPr>
+              <a:t>–   Nada mas: la API, la base de datos y el almacenamiento de fotos no aparecen todavia porque son interiores.</a:t>
+            </a:r>
+          </a:p>
+          <a:p>
+            <a:pPr>
+              <a:spcAft>
+                <a:spcPts val="800"/>
+              </a:spcAft>
+            </a:pPr>
+            <a:r>
+              <a:rPr sz="2000" b="0" i="0">
+                <a:solidFill>
+                  <a:srgbClr val="333333"/>
+                </a:solidFill>
+                <a:latin typeface="Calibri"/>
+              </a:rPr>
+              <a:t>–   Un sistema que depende de una pasarela de pagos hereda su disponibilidad, y esa herencia es una decision arquitectonica aunque nadie la haya escrito.</a:t>
             </a:r>
           </a:p>
         </p:txBody>
@@ -5236,7 +5219,7 @@
                 </a:solidFill>
                 <a:latin typeface="Calibri"/>
               </a:rPr>
-              <a:t>La app - el hilo conductor (1/2)</a:t>
+              <a:t>De dominio a arquitectura (mini-metodo) (1/3)</a:t>
             </a:r>
           </a:p>
         </p:txBody>
@@ -5275,7 +5258,7 @@
                 </a:solidFill>
                 <a:latin typeface="Calibri"/>
               </a:rPr>
-              <a:t>–   El diagrama de contexto correcto tiene una sola caja llamada Turnos, tres actores alrededor (el cliente que reserva</a:t>
+              <a:t>–   El modelo C4 es la notacion que este curso usa para dibujar arquitectura, y su virtud es ofrecer cuatro niveles de zoom con reglas claras sobre que se muestra en cada uno, en lugar de un unico diagrama que mezcla todo.</a:t>
             </a:r>
           </a:p>
           <a:p>
@@ -5291,7 +5274,7 @@
                 </a:solidFill>
                 <a:latin typeface="Calibri"/>
               </a:rPr>
-              <a:t>–   El barbero que consulta su agenda del dia y el administrador que configura horarios y precios) y dos o tres sistemas externos con la flecha etiquetada: una pasarela de pagos</a:t>
+              <a:t>–   Nivel 1, Contexto: el sistema es una sola caja negra y alrededor aparecen unicamente las personas que lo usan y los sistemas externos con los que intercambia informacion.</a:t>
             </a:r>
           </a:p>
           <a:p>
@@ -5307,7 +5290,23 @@
                 </a:solidFill>
                 <a:latin typeface="Calibri"/>
               </a:rPr>
-              <a:t>–   Con la etiqueta «envia solicitud de cobro y recibe confirmacion»; un proveedor de correo, con la etiqueta «envia recordatorio de turno»; y quizas un servicio de mapas.</a:t>
+              <a:t>–   Nivel 2, Contenedores: se abre esa caja y se ven las aplicaciones, servicios y bases de datos que la componen.</a:t>
+            </a:r>
+          </a:p>
+          <a:p>
+            <a:pPr>
+              <a:spcAft>
+                <a:spcPts val="800"/>
+              </a:spcAft>
+            </a:pPr>
+            <a:r>
+              <a:rPr sz="2000" b="0" i="0">
+                <a:solidFill>
+                  <a:srgbClr val="333333"/>
+                </a:solidFill>
+                <a:latin typeface="Calibri"/>
+              </a:rPr>
+              <a:t>–   Nivel 3, Componentes: se abre un contenedor y se ven sus modulos internos.</a:t>
             </a:r>
           </a:p>
         </p:txBody>
@@ -5488,7 +5487,7 @@
                 </a:solidFill>
                 <a:latin typeface="Calibri"/>
               </a:rPr>
-              <a:t>La app - el hilo conductor (2/2)</a:t>
+              <a:t>De dominio a arquitectura (mini-metodo) (2/3)</a:t>
             </a:r>
           </a:p>
         </p:txBody>
@@ -5527,7 +5526,7 @@
                 </a:solidFill>
                 <a:latin typeface="Calibri"/>
               </a:rPr>
-              <a:t>–   Nada mas: la API, la base de datos y el almacenamiento de fotos no aparecen todavia porque son interiores.</a:t>
+              <a:t>–   Nivel 4, Codigo: clases y funciones, que en la practica casi nunca se dibuja porque el codigo mismo ya lo documenta.</a:t>
             </a:r>
           </a:p>
           <a:p>
@@ -5543,7 +5542,7 @@
                 </a:solidFill>
                 <a:latin typeface="Calibri"/>
               </a:rPr>
-              <a:t>–   El valor de ese diagrama de cinco o seis elementos esta en que obliga a responder dos preguntas que el estudiante no se habia hecho: quien exactamente usa esto y de que terceros depende para funcionar.</a:t>
+              <a:t>–   El segundo artefacto de hoy es la ficha con cuatro capacidades y el problema en tres frases.</a:t>
             </a:r>
           </a:p>
           <a:p>
@@ -5559,7 +5558,23 @@
                 </a:solidFill>
                 <a:latin typeface="Calibri"/>
               </a:rPr>
-              <a:t>–   Un sistema que depende de una pasarela de pagos hereda su disponibilidad, y esa herencia es una decision arquitectonica aunque nadie la haya escrito.</a:t>
+              <a:t>–   Una capacidad se escribe como un verbo de negocio que el usuario puede ejecutar, no como una pieza tecnica: «reservar un turno disponible», «cancelar o reprogramar hasta dos horas antes», «consultar la agenda del dia» y «cobrar un anticipo» son capacidades</a:t>
+            </a:r>
+          </a:p>
+          <a:p>
+            <a:pPr>
+              <a:spcAft>
+                <a:spcPts val="800"/>
+              </a:spcAft>
+            </a:pPr>
+            <a:r>
+              <a:rPr sz="2000" b="0" i="0">
+                <a:solidFill>
+                  <a:srgbClr val="333333"/>
+                </a:solidFill>
+                <a:latin typeface="Calibri"/>
+              </a:rPr>
+              <a:t>–   «tener login con JWT», «usar cache» o «tener panel administrativo» no lo son, porque son medios y no fines.</a:t>
             </a:r>
           </a:p>
         </p:txBody>
@@ -5740,7 +5755,7 @@
                 </a:solidFill>
                 <a:latin typeface="Calibri"/>
               </a:rPr>
-              <a:t>De dominio a arquitectura (mini-metodo) (1/3)</a:t>
+              <a:t>De dominio a arquitectura (mini-metodo) (3/3)</a:t>
             </a:r>
           </a:p>
         </p:txBody>
@@ -5779,7 +5794,7 @@
                 </a:solidFill>
                 <a:latin typeface="Calibri"/>
               </a:rPr>
-              <a:t>–   El modelo C4 es la notacion que este curso usa para dibujar arquitectura, y su virtud es ofrecer cuatro niveles de zoom con reglas claras sobre que se muestra en cada uno, en lugar de un unico diagrama que mezcla todo.</a:t>
+              <a:t>–   El limite de cuatro capacidades es una decision pedagogica deliberada y no una regla de la industria: con cada estudiante trabajando de forma individual durante doce semanas, un alcance de ocho capacidades garantiza que el proyecto no llegue a ninguna parte.</a:t>
             </a:r>
           </a:p>
           <a:p>
@@ -5795,7 +5810,7 @@
                 </a:solidFill>
                 <a:latin typeface="Calibri"/>
               </a:rPr>
-              <a:t>–   Nivel 1, Contexto: el sistema es una sola caja negra y alrededor aparecen unicamente las personas que lo usan y los sistemas externos con los que intercambia informacion.</a:t>
+              <a:t>–   El enunciado del problema debe nombrar a quien le duele y que pierde hoy, con alguna cifra aunque sea estimada: «la barberia agenda por mensajeria instantanea</a:t>
             </a:r>
           </a:p>
           <a:p>
@@ -5811,39 +5826,7 @@
                 </a:solidFill>
                 <a:latin typeface="Calibri"/>
               </a:rPr>
-              <a:t>–   Nivel 2, Contenedores: se abre esa caja y se ven las aplicaciones, servicios y bases de datos que la componen.</a:t>
-            </a:r>
-          </a:p>
-          <a:p>
-            <a:pPr>
-              <a:spcAft>
-                <a:spcPts val="800"/>
-              </a:spcAft>
-            </a:pPr>
-            <a:r>
-              <a:rPr sz="2000" b="0" i="0">
-                <a:solidFill>
-                  <a:srgbClr val="333333"/>
-                </a:solidFill>
-                <a:latin typeface="Calibri"/>
-              </a:rPr>
-              <a:t>–   Nivel 3, Componentes: se abre un contenedor y se ven sus modulos internos.</a:t>
-            </a:r>
-          </a:p>
-          <a:p>
-            <a:pPr>
-              <a:spcAft>
-                <a:spcPts val="800"/>
-              </a:spcAft>
-            </a:pPr>
-            <a:r>
-              <a:rPr sz="2000" b="0" i="0">
-                <a:solidFill>
-                  <a:srgbClr val="333333"/>
-                </a:solidFill>
-                <a:latin typeface="Calibri"/>
-              </a:rPr>
-              <a:t>–   Nivel 4, Codigo: clases y funciones, que en la practica casi nunca se dibuja porque el codigo mismo ya lo documenta.</a:t>
+              <a:t>–   Pierde alrededor de tres turnos diarios por doble reserva y no tiene registro de cuantos clientes no se presentaron».</a:t>
             </a:r>
           </a:p>
         </p:txBody>
@@ -6024,7 +6007,7 @@
                 </a:solidFill>
                 <a:latin typeface="Calibri"/>
               </a:rPr>
-              <a:t>De dominio a arquitectura (mini-metodo) (2/3)</a:t>
+              <a:t>Ejemplo de diagrama C4 - nivel Context</a:t>
             </a:r>
           </a:p>
         </p:txBody>
@@ -6063,7 +6046,7 @@
                 </a:solidFill>
                 <a:latin typeface="Calibri"/>
               </a:rPr>
-              <a:t>–   Hoy se trabaja unicamente el nivel 1, y la regla es estricta: si en el diagrama de contexto aparecen las palabras PostgreSQL, Docker o Redis, el diagrama esta mal, porque eso es interior del sistema y corresponde al nivel 2 de la Clase 4.</a:t>
+              <a:t>–   Un diagrama de contexto tiene tres tipos de elemento: Person, System y System_Ext.</a:t>
             </a:r>
           </a:p>
           <a:p>
@@ -6079,7 +6062,7 @@
                 </a:solidFill>
                 <a:latin typeface="Calibri"/>
               </a:rPr>
-              <a:t>–   El segundo artefacto de hoy es la ficha con cuatro capacidades y el problema en tres frases.</a:t>
+              <a:t>–   Cada flecha lleva un verbo de negocio, por ejemplo «Cliente reserva turno en la app de turnos» o «la app de turnos envia recordatorio por el proveedor de correo».</a:t>
             </a:r>
           </a:p>
           <a:p>
@@ -6095,7 +6078,7 @@
                 </a:solidFill>
                 <a:latin typeface="Calibri"/>
               </a:rPr>
-              <a:t>–   Una capacidad se escribe como un verbo de negocio que el usuario puede ejecutar, no como una pieza tecnica: «reservar un turno disponible», «cancelar o reprogramar hasta dos horas antes», «consultar la agenda del dia» y «cobrar un anticipo» son capacidades</a:t>
+              <a:t>–   El error mas comun es dibujar la base de datos o la API en este nivel: son piezas internas y pertenecen al nivel 2, Containers.</a:t>
             </a:r>
           </a:p>
           <a:p>
@@ -6111,7 +6094,7 @@
                 </a:solidFill>
                 <a:latin typeface="Calibri"/>
               </a:rPr>
-              <a:t>–   «tener login con JWT», «usar cache» o «tener panel administrativo» no lo son, porque son medios y no fines.</a:t>
+              <a:t>–   Un Context legible tiene entre 4 y 8 elementos; si tiene mas, la caja del sistema ya se esta abriendo.</a:t>
             </a:r>
           </a:p>
         </p:txBody>
@@ -6292,7 +6275,7 @@
                 </a:solidFill>
                 <a:latin typeface="Calibri"/>
               </a:rPr>
-              <a:t>De dominio a arquitectura (mini-metodo) (3/3)</a:t>
+              <a:t>Preguntas frecuentes y cierre conceptual (1/2)</a:t>
             </a:r>
           </a:p>
         </p:txBody>
@@ -6331,7 +6314,7 @@
                 </a:solidFill>
                 <a:latin typeface="Calibri"/>
               </a:rPr>
-              <a:t>–   El limite de cuatro capacidades es una decision pedagogica deliberada y no una regla de la industria: con cada estudiante trabajando de forma individual durante doce semanas, un alcance de ocho capacidades garantiza que el proyecto no llegue a ninguna parte.</a:t>
+              <a:t>–   Respuesta: es una diferencia de alcance y de reversibilidad, no de naturaleza</a:t>
             </a:r>
           </a:p>
           <a:p>
@@ -6347,7 +6330,7 @@
                 </a:solidFill>
                 <a:latin typeface="Calibri"/>
               </a:rPr>
-              <a:t>–   El enunciado del problema debe nombrar a quien le duele y que pierde hoy, con alguna cifra aunque sea estimada: «la barberia agenda por mensajeria instantanea</a:t>
+              <a:t>–   Arquitectura son las decisiones que afectan a todo el sistema y son caras de revertir, diseno son las decisiones internas de un componente que se pueden cambiar sin tocar a los demas.</a:t>
             </a:r>
           </a:p>
           <a:p>
@@ -6363,7 +6346,23 @@
                 </a:solidFill>
                 <a:latin typeface="Calibri"/>
               </a:rPr>
-              <a:t>–   Pierde alrededor de tres turnos diarios por doble reserva y no tiene registro de cuantos clientes no se presentaron».</a:t>
+              <a:t>–   La segunda: por que no usamos una cuenta real de un proveedor de nube.</a:t>
+            </a:r>
+          </a:p>
+          <a:p>
+            <a:pPr>
+              <a:spcAft>
+                <a:spcPts val="800"/>
+              </a:spcAft>
+            </a:pPr>
+            <a:r>
+              <a:rPr sz="2000" b="0" i="0">
+                <a:solidFill>
+                  <a:srgbClr val="333333"/>
+                </a:solidFill>
+                <a:latin typeface="Calibri"/>
+              </a:rPr>
+              <a:t>–   Respuesta, y hay que darla sin disculparse: porque este curso evalua razonamiento arquitectonico y no el manejo de una consola que cambia de aspecto cada semestre</a:t>
             </a:r>
           </a:p>
         </p:txBody>
@@ -6544,7 +6543,7 @@
                 </a:solidFill>
                 <a:latin typeface="Calibri"/>
               </a:rPr>
-              <a:t>Ejemplo de diagrama C4 - nivel Context</a:t>
+              <a:t>Preguntas frecuentes y cierre conceptual (2/2)</a:t>
             </a:r>
           </a:p>
         </p:txBody>
@@ -6583,7 +6582,7 @@
                 </a:solidFill>
                 <a:latin typeface="Calibri"/>
               </a:rPr>
-              <a:t>–   Un diagrama de contexto tiene tres tipos de elemento: Person, System y System_Ext.</a:t>
+              <a:t>–   Ninguna actividad exigira tarjeta de credito ni cuenta de pago, todo se hace con draw.io, Excalidraw, Killercoda y el nivel gratuito de GitHub Actions, y quien aprende a justificar un trade-off lo aplica luego en cualquier proveedor en una tarde.</a:t>
             </a:r>
           </a:p>
           <a:p>
@@ -6599,7 +6598,7 @@
                 </a:solidFill>
                 <a:latin typeface="Calibri"/>
               </a:rPr>
-              <a:t>–   Cada flecha lleva un verbo de negocio, por ejemplo «Cliente reserva turno en la app de turnos» o «la app de turnos envia recordatorio por el proveedor de correo».</a:t>
+              <a:t>–   La tercera: cuantas cajas debe tener mi diagrama.</a:t>
             </a:r>
           </a:p>
           <a:p>
@@ -6615,23 +6614,7 @@
                 </a:solidFill>
                 <a:latin typeface="Calibri"/>
               </a:rPr>
-              <a:t>–   El error mas comun es dibujar la base de datos o la API en este nivel: son piezas internas y pertenecen al nivel 2, Containers.</a:t>
-            </a:r>
-          </a:p>
-          <a:p>
-            <a:pPr>
-              <a:spcAft>
-                <a:spcPts val="800"/>
-              </a:spcAft>
-            </a:pPr>
-            <a:r>
-              <a:rPr sz="2000" b="0" i="0">
-                <a:solidFill>
-                  <a:srgbClr val="333333"/>
-                </a:solidFill>
-                <a:latin typeface="Calibri"/>
-              </a:rPr>
-              <a:t>–   Un Context legible tiene entre 4 y 8 elementos; si tiene mas, la caja del sistema ya se esta abriendo.</a:t>
+              <a:t>–   Respuesta: en el nivel de contexto, entre cuatro y ocho elementos en total; si hay veinte, es casi seguro que se colaron piezas internas.</a:t>
             </a:r>
           </a:p>
         </p:txBody>
@@ -6706,7 +6689,7 @@
         <p:spPr>
           <a:xfrm>
             <a:off x="0" y="0"/>
-            <a:ext cx="12191695" cy="960120"/>
+            <a:ext cx="12191695" cy="1170432"/>
           </a:xfrm>
           <a:prstGeom prst="rect">
             <a:avLst/>
@@ -6748,7 +6731,7 @@
         </p:nvSpPr>
         <p:spPr>
           <a:xfrm>
-            <a:off x="0" y="960120"/>
+            <a:off x="0" y="1170432"/>
             <a:ext cx="12191695" cy="41148"/>
           </a:xfrm>
           <a:prstGeom prst="rect">
@@ -6792,7 +6775,7 @@
         <p:spPr>
           <a:xfrm>
             <a:off x="457200" y="164592"/>
-            <a:ext cx="11277295" cy="502920"/>
+            <a:ext cx="11277295" cy="384048"/>
           </a:xfrm>
           <a:prstGeom prst="rect">
             <a:avLst/>
@@ -6812,7 +6795,7 @@
                 </a:solidFill>
                 <a:latin typeface="Calibri"/>
               </a:rPr>
-              <a:t>Preguntas frecuentes y cierre conceptual () (1/3)</a:t>
+              <a:t>Ejemplo de diagrama C4 — nivel Context</a:t>
             </a:r>
           </a:p>
         </p:txBody>
@@ -6825,8 +6808,8 @@
         </p:nvSpPr>
         <p:spPr>
           <a:xfrm>
-            <a:off x="457200" y="1170432"/>
-            <a:ext cx="11277295" cy="5230368"/>
+            <a:off x="457200" y="566928"/>
+            <a:ext cx="11277295" cy="411480"/>
           </a:xfrm>
           <a:prstGeom prst="rect">
             <a:avLst/>
@@ -6839,90 +6822,362 @@
           </a:bodyPr>
           <a:lstStyle/>
           <a:p>
-            <a:pPr>
-              <a:spcAft>
-                <a:spcPts val="800"/>
-              </a:spcAft>
-            </a:pPr>
-            <a:r>
-              <a:rPr sz="2000" b="0" i="0">
-                <a:solidFill>
-                  <a:srgbClr val="333333"/>
-                </a:solidFill>
-                <a:latin typeface="Calibri"/>
-              </a:rPr>
-              <a:t>–   Respuesta: es una diferencia de alcance y de reversibilidad, no de naturaleza</a:t>
-            </a:r>
-          </a:p>
-          <a:p>
-            <a:pPr>
-              <a:spcAft>
-                <a:spcPts val="800"/>
-              </a:spcAft>
-            </a:pPr>
-            <a:r>
-              <a:rPr sz="2000" b="0" i="0">
-                <a:solidFill>
-                  <a:srgbClr val="333333"/>
-                </a:solidFill>
-                <a:latin typeface="Calibri"/>
-              </a:rPr>
-              <a:t>–   Arquitectura son las decisiones que afectan a todo el sistema y son caras de revertir, diseno son las decisiones internas de un componente que se pueden cambiar sin tocar a los demas.</a:t>
-            </a:r>
-          </a:p>
-          <a:p>
-            <a:pPr>
-              <a:spcAft>
-                <a:spcPts val="800"/>
-              </a:spcAft>
-            </a:pPr>
-            <a:r>
-              <a:rPr sz="2000" b="0" i="0">
-                <a:solidFill>
-                  <a:srgbClr val="333333"/>
-                </a:solidFill>
-                <a:latin typeface="Calibri"/>
-              </a:rPr>
-              <a:t>–   La segunda: por que no usamos una cuenta real de un proveedor de nube.</a:t>
-            </a:r>
-          </a:p>
-          <a:p>
-            <a:pPr>
-              <a:spcAft>
-                <a:spcPts val="800"/>
-              </a:spcAft>
-            </a:pPr>
-            <a:r>
-              <a:rPr sz="2000" b="0" i="0">
-                <a:solidFill>
-                  <a:srgbClr val="333333"/>
-                </a:solidFill>
-                <a:latin typeface="Calibri"/>
-              </a:rPr>
-              <a:t>–   Respuesta, y hay que darla sin disculparse: porque este curso evalua razonamiento arquitectonico y no el manejo de una consola que cambia de aspecto cada semestre</a:t>
-            </a:r>
-          </a:p>
-          <a:p>
-            <a:pPr>
-              <a:spcAft>
-                <a:spcPts val="800"/>
-              </a:spcAft>
-            </a:pPr>
-            <a:r>
-              <a:rPr sz="2000" b="0" i="0">
-                <a:solidFill>
-                  <a:srgbClr val="333333"/>
-                </a:solidFill>
-                <a:latin typeface="Calibri"/>
-              </a:rPr>
-              <a:t>–   Ninguna actividad exigira tarjeta de credito ni cuenta de pago, todo se hace con draw.io, Excalidraw, Killercoda y el nivel gratuito de GitHub Actions, y quien aprende a justificar un trade-off lo aplica luego en cualquier proveedor en una tarde.</a:t>
-            </a:r>
-          </a:p>
-        </p:txBody>
-      </p:sp>
-      <p:sp>
-        <p:nvSpPr>
-          <p:cNvPr id="6" name="TextBox 5"/>
+            <a:r>
+              <a:rPr sz="1400" b="0" i="0">
+                <a:solidFill>
+                  <a:srgbClr val="B8D8EE"/>
+                </a:solidFill>
+                <a:latin typeface="Calibri"/>
+              </a:rPr>
+              <a:t>Actor, sistema y sistema externo: el mismo esquema sirve para cualquier dominio</a:t>
+            </a:r>
+          </a:p>
+        </p:txBody>
+      </p:sp>
+      <p:sp>
+        <p:nvSpPr>
+          <p:cNvPr id="6" name="Rounded Rectangle 5"/>
+          <p:cNvSpPr/>
+          <p:nvPr/>
+        </p:nvSpPr>
+        <p:spPr>
+          <a:xfrm>
+            <a:off x="822960" y="2743200"/>
+            <a:ext cx="2103120" cy="1097280"/>
+          </a:xfrm>
+          <a:prstGeom prst="roundRect">
+            <a:avLst>
+              <a:gd name="adj" fmla="val 12000"/>
+            </a:avLst>
+          </a:prstGeom>
+          <a:solidFill>
+            <a:srgbClr val="FFD000"/>
+          </a:solidFill>
+          <a:ln>
+            <a:noFill/>
+          </a:ln>
+        </p:spPr>
+        <p:style>
+          <a:lnRef idx="1">
+            <a:schemeClr val="accent1"/>
+          </a:lnRef>
+          <a:fillRef idx="3">
+            <a:schemeClr val="accent1"/>
+          </a:fillRef>
+          <a:effectRef idx="2">
+            <a:schemeClr val="accent1"/>
+          </a:effectRef>
+          <a:fontRef idx="minor">
+            <a:schemeClr val="lt1"/>
+          </a:fontRef>
+        </p:style>
+        <p:txBody>
+          <a:bodyPr rtlCol="0" anchor="ctr" wrap="square"/>
+          <a:lstStyle/>
+          <a:p>
+            <a:pPr algn="ctr"/>
+            <a:r>
+              <a:rPr sz="1300" b="1" i="0">
+                <a:solidFill>
+                  <a:srgbClr val="095292"/>
+                </a:solidFill>
+                <a:latin typeface="Calibri"/>
+              </a:rPr>
+              <a:t>Estudiante
+(actor)</a:t>
+            </a:r>
+          </a:p>
+        </p:txBody>
+      </p:sp>
+      <p:sp>
+        <p:nvSpPr>
+          <p:cNvPr id="7" name="Rounded Rectangle 6"/>
+          <p:cNvSpPr/>
+          <p:nvPr/>
+        </p:nvSpPr>
+        <p:spPr>
+          <a:xfrm>
+            <a:off x="4846320" y="2377440"/>
+            <a:ext cx="2834640" cy="1645920"/>
+          </a:xfrm>
+          <a:prstGeom prst="roundRect">
+            <a:avLst>
+              <a:gd name="adj" fmla="val 12000"/>
+            </a:avLst>
+          </a:prstGeom>
+          <a:solidFill>
+            <a:srgbClr val="095292"/>
+          </a:solidFill>
+          <a:ln>
+            <a:noFill/>
+          </a:ln>
+        </p:spPr>
+        <p:style>
+          <a:lnRef idx="1">
+            <a:schemeClr val="accent1"/>
+          </a:lnRef>
+          <a:fillRef idx="3">
+            <a:schemeClr val="accent1"/>
+          </a:fillRef>
+          <a:effectRef idx="2">
+            <a:schemeClr val="accent1"/>
+          </a:effectRef>
+          <a:fontRef idx="minor">
+            <a:schemeClr val="lt1"/>
+          </a:fontRef>
+        </p:style>
+        <p:txBody>
+          <a:bodyPr rtlCol="0" anchor="ctr" wrap="square"/>
+          <a:lstStyle/>
+          <a:p>
+            <a:pPr algn="ctr"/>
+            <a:r>
+              <a:rPr sz="1300" b="1" i="0">
+                <a:solidFill>
+                  <a:srgbClr val="FFFFFF"/>
+                </a:solidFill>
+                <a:latin typeface="Calibri"/>
+              </a:rPr>
+              <a:t>La app
+(el sistema = una sola caja)</a:t>
+            </a:r>
+          </a:p>
+        </p:txBody>
+      </p:sp>
+      <p:sp>
+        <p:nvSpPr>
+          <p:cNvPr id="8" name="Rounded Rectangle 7"/>
+          <p:cNvSpPr/>
+          <p:nvPr/>
+        </p:nvSpPr>
+        <p:spPr>
+          <a:xfrm>
+            <a:off x="9235440" y="2743200"/>
+            <a:ext cx="2286000" cy="1097280"/>
+          </a:xfrm>
+          <a:prstGeom prst="roundRect">
+            <a:avLst>
+              <a:gd name="adj" fmla="val 12000"/>
+            </a:avLst>
+          </a:prstGeom>
+          <a:solidFill>
+            <a:srgbClr val="269CCB"/>
+          </a:solidFill>
+          <a:ln>
+            <a:noFill/>
+          </a:ln>
+        </p:spPr>
+        <p:style>
+          <a:lnRef idx="1">
+            <a:schemeClr val="accent1"/>
+          </a:lnRef>
+          <a:fillRef idx="3">
+            <a:schemeClr val="accent1"/>
+          </a:fillRef>
+          <a:effectRef idx="2">
+            <a:schemeClr val="accent1"/>
+          </a:effectRef>
+          <a:fontRef idx="minor">
+            <a:schemeClr val="lt1"/>
+          </a:fontRef>
+        </p:style>
+        <p:txBody>
+          <a:bodyPr rtlCol="0" anchor="ctr" wrap="square"/>
+          <a:lstStyle/>
+          <a:p>
+            <a:pPr algn="ctr"/>
+            <a:r>
+              <a:rPr sz="1300" b="1" i="0">
+                <a:solidFill>
+                  <a:srgbClr val="FFFFFF"/>
+                </a:solidFill>
+                <a:latin typeface="Calibri"/>
+              </a:rPr>
+              <a:t>Sistema externo
+(ej. correo, auth)</a:t>
+            </a:r>
+          </a:p>
+        </p:txBody>
+      </p:sp>
+      <p:cxnSp>
+        <p:nvCxnSpPr>
+          <p:cNvPr id="9" name="Connector 8"/>
+          <p:cNvCxnSpPr/>
+          <p:nvPr/>
+        </p:nvCxnSpPr>
+        <p:spPr>
+          <a:xfrm flipV="1">
+            <a:off x="2926079" y="3200400"/>
+            <a:ext cx="1920241" cy="91440"/>
+          </a:xfrm>
+          <a:prstGeom prst="line">
+            <a:avLst/>
+          </a:prstGeom>
+          <a:ln w="22225">
+            <a:solidFill>
+              <a:srgbClr val="666666"/>
+            </a:solidFill>
+            <a:tailEnd type="triangle" w="med" len="med"/>
+          </a:ln>
+        </p:spPr>
+        <p:style>
+          <a:lnRef idx="2">
+            <a:schemeClr val="accent1"/>
+          </a:lnRef>
+          <a:fillRef idx="0">
+            <a:schemeClr val="accent1"/>
+          </a:fillRef>
+          <a:effectRef idx="1">
+            <a:schemeClr val="accent1"/>
+          </a:effectRef>
+          <a:fontRef idx="minor">
+            <a:schemeClr val="tx1"/>
+          </a:fontRef>
+        </p:style>
+      </p:cxnSp>
+      <p:sp>
+        <p:nvSpPr>
+          <p:cNvPr id="10" name="TextBox 9"/>
+          <p:cNvSpPr txBox="1"/>
+          <p:nvPr/>
+        </p:nvSpPr>
+        <p:spPr>
+          <a:xfrm>
+            <a:off x="3063240" y="3044951"/>
+            <a:ext cx="1645920" cy="320040"/>
+          </a:xfrm>
+          <a:prstGeom prst="rect">
+            <a:avLst/>
+          </a:prstGeom>
+          <a:noFill/>
+        </p:spPr>
+        <p:txBody>
+          <a:bodyPr wrap="square">
+            <a:spAutoFit/>
+          </a:bodyPr>
+          <a:lstStyle/>
+          <a:p>
+            <a:pPr algn="ctr"/>
+            <a:r>
+              <a:rPr sz="1000" b="0" i="1">
+                <a:solidFill>
+                  <a:srgbClr val="666666"/>
+                </a:solidFill>
+                <a:latin typeface="Calibri"/>
+              </a:rPr>
+              <a:t>usa</a:t>
+            </a:r>
+          </a:p>
+        </p:txBody>
+      </p:sp>
+      <p:cxnSp>
+        <p:nvCxnSpPr>
+          <p:cNvPr id="11" name="Connector 10"/>
+          <p:cNvCxnSpPr/>
+          <p:nvPr/>
+        </p:nvCxnSpPr>
+        <p:spPr>
+          <a:xfrm>
+            <a:off x="7680960" y="3200400"/>
+            <a:ext cx="1554480" cy="91440"/>
+          </a:xfrm>
+          <a:prstGeom prst="line">
+            <a:avLst/>
+          </a:prstGeom>
+          <a:ln w="22225">
+            <a:solidFill>
+              <a:srgbClr val="666666"/>
+            </a:solidFill>
+            <a:tailEnd type="triangle" w="med" len="med"/>
+          </a:ln>
+        </p:spPr>
+        <p:style>
+          <a:lnRef idx="2">
+            <a:schemeClr val="accent1"/>
+          </a:lnRef>
+          <a:fillRef idx="0">
+            <a:schemeClr val="accent1"/>
+          </a:fillRef>
+          <a:effectRef idx="1">
+            <a:schemeClr val="accent1"/>
+          </a:effectRef>
+          <a:fontRef idx="minor">
+            <a:schemeClr val="tx1"/>
+          </a:fontRef>
+        </p:style>
+      </p:cxnSp>
+      <p:sp>
+        <p:nvSpPr>
+          <p:cNvPr id="12" name="TextBox 11"/>
+          <p:cNvSpPr txBox="1"/>
+          <p:nvPr/>
+        </p:nvSpPr>
+        <p:spPr>
+          <a:xfrm>
+            <a:off x="7635240" y="3044951"/>
+            <a:ext cx="1645920" cy="320040"/>
+          </a:xfrm>
+          <a:prstGeom prst="rect">
+            <a:avLst/>
+          </a:prstGeom>
+          <a:noFill/>
+        </p:spPr>
+        <p:txBody>
+          <a:bodyPr wrap="square">
+            <a:spAutoFit/>
+          </a:bodyPr>
+          <a:lstStyle/>
+          <a:p>
+            <a:pPr algn="ctr"/>
+            <a:r>
+              <a:rPr sz="1000" b="0" i="1">
+                <a:solidFill>
+                  <a:srgbClr val="666666"/>
+                </a:solidFill>
+                <a:latin typeface="Calibri"/>
+              </a:rPr>
+              <a:t>notifica / consume</a:t>
+            </a:r>
+          </a:p>
+        </p:txBody>
+      </p:sp>
+      <p:sp>
+        <p:nvSpPr>
+          <p:cNvPr id="13" name="TextBox 12"/>
+          <p:cNvSpPr txBox="1"/>
+          <p:nvPr/>
+        </p:nvSpPr>
+        <p:spPr>
+          <a:xfrm>
+            <a:off x="457200" y="6263640"/>
+            <a:ext cx="11277295" cy="411480"/>
+          </a:xfrm>
+          <a:prstGeom prst="rect">
+            <a:avLst/>
+          </a:prstGeom>
+          <a:noFill/>
+        </p:spPr>
+        <p:txBody>
+          <a:bodyPr wrap="square">
+            <a:spAutoFit/>
+          </a:bodyPr>
+          <a:lstStyle/>
+          <a:p>
+            <a:r>
+              <a:rPr sz="1100" b="0" i="1">
+                <a:solidFill>
+                  <a:srgbClr val="666666"/>
+                </a:solidFill>
+                <a:latin typeface="Calibri"/>
+              </a:rPr>
+              <a:t>Nivel Context: el sistema es UNA caja (sin abrir por dentro). Actores a la izquierda, sistemas externos a la derecha. El interior se dibuja en Clase 4 (Containers). Cada flecha lleva un verbo de negocio («reserva turno», «envía recordatorio»); la API y la base de datos no aparecen aquí porque son piezas interiores.</a:t>
+            </a:r>
+          </a:p>
+        </p:txBody>
+      </p:sp>
+      <p:sp>
+        <p:nvSpPr>
+          <p:cNvPr id="14" name="TextBox 13"/>
           <p:cNvSpPr txBox="1"/>
           <p:nvPr/>
         </p:nvSpPr>
@@ -7212,7 +7467,7 @@
                 </a:solidFill>
                 <a:latin typeface="Calibri"/>
               </a:rPr>
-              <a:t> Ejemplos resueltos y demo del docente sobre el tema.</a:t>
+              <a:t> Ejemplos resueltos y demostración sobre el tema.</a:t>
             </a:r>
           </a:p>
           <a:p>
@@ -7337,7 +7592,7 @@
         <p:spPr>
           <a:xfrm>
             <a:off x="0" y="0"/>
-            <a:ext cx="12191695" cy="960120"/>
+            <a:ext cx="12191695" cy="1170432"/>
           </a:xfrm>
           <a:prstGeom prst="rect">
             <a:avLst/>
@@ -7379,7 +7634,7 @@
         </p:nvSpPr>
         <p:spPr>
           <a:xfrm>
-            <a:off x="0" y="960120"/>
+            <a:off x="0" y="1170432"/>
             <a:ext cx="12191695" cy="41148"/>
           </a:xfrm>
           <a:prstGeom prst="rect">
@@ -7423,7 +7678,7 @@
         <p:spPr>
           <a:xfrm>
             <a:off x="457200" y="164592"/>
-            <a:ext cx="11277295" cy="502920"/>
+            <a:ext cx="11277295" cy="384048"/>
           </a:xfrm>
           <a:prstGeom prst="rect">
             <a:avLst/>
@@ -7443,7 +7698,7 @@
                 </a:solidFill>
                 <a:latin typeface="Calibri"/>
               </a:rPr>
-              <a:t>Preguntas frecuentes y cierre conceptual () (2/3)</a:t>
+              <a:t>Del boceto al código Mermaid</a:t>
             </a:r>
           </a:p>
         </p:txBody>
@@ -7456,8 +7711,8 @@
         </p:nvSpPr>
         <p:spPr>
           <a:xfrm>
-            <a:off x="457200" y="1170432"/>
-            <a:ext cx="11277295" cy="5230368"/>
+            <a:off x="457200" y="566928"/>
+            <a:ext cx="11277295" cy="411480"/>
           </a:xfrm>
           <a:prstGeom prst="rect">
             <a:avLst/>
@@ -7470,106 +7725,705 @@
           </a:bodyPr>
           <a:lstStyle/>
           <a:p>
+            <a:r>
+              <a:rPr sz="1400" b="0" i="0">
+                <a:solidFill>
+                  <a:srgbClr val="B8D8EE"/>
+                </a:solidFill>
+                <a:latin typeface="Calibri"/>
+              </a:rPr>
+              <a:t>El diagrama se escribe como código: se versiona, se compara y se corrige</a:t>
+            </a:r>
+          </a:p>
+        </p:txBody>
+      </p:sp>
+      <p:sp>
+        <p:nvSpPr>
+          <p:cNvPr id="6" name="Rounded Rectangle 5"/>
+          <p:cNvSpPr/>
+          <p:nvPr/>
+        </p:nvSpPr>
+        <p:spPr>
+          <a:xfrm>
+            <a:off x="457200" y="1659636"/>
+            <a:ext cx="11277295" cy="1051560"/>
+          </a:xfrm>
+          <a:prstGeom prst="roundRect">
+            <a:avLst>
+              <a:gd name="adj" fmla="val 12000"/>
+            </a:avLst>
+          </a:prstGeom>
+          <a:solidFill>
+            <a:srgbClr val="F2F2F2"/>
+          </a:solidFill>
+          <a:ln>
+            <a:noFill/>
+          </a:ln>
+        </p:spPr>
+        <p:style>
+          <a:lnRef idx="1">
+            <a:schemeClr val="accent1"/>
+          </a:lnRef>
+          <a:fillRef idx="3">
+            <a:schemeClr val="accent1"/>
+          </a:fillRef>
+          <a:effectRef idx="2">
+            <a:schemeClr val="accent1"/>
+          </a:effectRef>
+          <a:fontRef idx="minor">
+            <a:schemeClr val="lt1"/>
+          </a:fontRef>
+        </p:style>
+        <p:txBody>
+          <a:bodyPr rtlCol="0" anchor="ctr"/>
+          <a:lstStyle/>
+          <a:p>
+            <a:pPr algn="ctr"/>
+          </a:p>
+        </p:txBody>
+      </p:sp>
+      <p:sp>
+        <p:nvSpPr>
+          <p:cNvPr id="7" name="Rounded Rectangle 6"/>
+          <p:cNvSpPr/>
+          <p:nvPr/>
+        </p:nvSpPr>
+        <p:spPr>
+          <a:xfrm>
+            <a:off x="594360" y="1965960"/>
+            <a:ext cx="438912" cy="438912"/>
+          </a:xfrm>
+          <a:prstGeom prst="roundRect">
+            <a:avLst>
+              <a:gd name="adj" fmla="val 12000"/>
+            </a:avLst>
+          </a:prstGeom>
+          <a:solidFill>
+            <a:srgbClr val="095292"/>
+          </a:solidFill>
+          <a:ln>
+            <a:noFill/>
+          </a:ln>
+        </p:spPr>
+        <p:style>
+          <a:lnRef idx="1">
+            <a:schemeClr val="accent1"/>
+          </a:lnRef>
+          <a:fillRef idx="3">
+            <a:schemeClr val="accent1"/>
+          </a:fillRef>
+          <a:effectRef idx="2">
+            <a:schemeClr val="accent1"/>
+          </a:effectRef>
+          <a:fontRef idx="minor">
+            <a:schemeClr val="lt1"/>
+          </a:fontRef>
+        </p:style>
+        <p:txBody>
+          <a:bodyPr rtlCol="0" anchor="ctr"/>
+          <a:lstStyle/>
+          <a:p>
+            <a:pPr algn="ctr"/>
+          </a:p>
+        </p:txBody>
+      </p:sp>
+      <p:sp>
+        <p:nvSpPr>
+          <p:cNvPr id="8" name="TextBox 7"/>
+          <p:cNvSpPr txBox="1"/>
+          <p:nvPr/>
+        </p:nvSpPr>
+        <p:spPr>
+          <a:xfrm>
+            <a:off x="594360" y="1965960"/>
+            <a:ext cx="438912" cy="438912"/>
+          </a:xfrm>
+          <a:prstGeom prst="rect">
+            <a:avLst/>
+          </a:prstGeom>
+          <a:noFill/>
+        </p:spPr>
+        <p:txBody>
+          <a:bodyPr wrap="square" anchor="ctr"/>
+          <a:lstStyle/>
+          <a:p>
+            <a:pPr algn="ctr"/>
+            <a:r>
+              <a:rPr sz="1600" b="1" i="0">
+                <a:solidFill>
+                  <a:srgbClr val="FFFFFF"/>
+                </a:solidFill>
+                <a:latin typeface="Calibri"/>
+              </a:rPr>
+              <a:t>1</a:t>
+            </a:r>
+          </a:p>
+        </p:txBody>
+      </p:sp>
+      <p:sp>
+        <p:nvSpPr>
+          <p:cNvPr id="9" name="TextBox 8"/>
+          <p:cNvSpPr txBox="1"/>
+          <p:nvPr/>
+        </p:nvSpPr>
+        <p:spPr>
+          <a:xfrm>
+            <a:off x="1188720" y="1751076"/>
+            <a:ext cx="10271455" cy="886968"/>
+          </a:xfrm>
+          <a:prstGeom prst="rect">
+            <a:avLst/>
+          </a:prstGeom>
+          <a:noFill/>
+        </p:spPr>
+        <p:txBody>
+          <a:bodyPr wrap="square" anchor="ctr"/>
+          <a:lstStyle/>
+          <a:p>
+            <a:r>
+              <a:rPr sz="1500" b="1" i="0">
+                <a:solidFill>
+                  <a:srgbClr val="095292"/>
+                </a:solidFill>
+                <a:latin typeface="Calibri"/>
+              </a:rPr>
+              <a:t>Diseña visual</a:t>
+            </a:r>
+          </a:p>
+          <a:p>
             <a:pPr>
-              <a:spcAft>
-                <a:spcPts val="800"/>
-              </a:spcAft>
+              <a:spcBef>
+                <a:spcPts val="200"/>
+              </a:spcBef>
             </a:pPr>
             <a:r>
-              <a:rPr sz="2000" b="0" i="0">
-                <a:solidFill>
-                  <a:srgbClr val="333333"/>
-                </a:solidFill>
-                <a:latin typeface="Calibri"/>
-              </a:rPr>
-              <a:t>–   La tercera: cuantas cajas debe tener mi diagrama.</a:t>
+              <a:rPr sz="1300" b="0" i="0">
+                <a:solidFill>
+                  <a:srgbClr val="333333"/>
+                </a:solidFill>
+                <a:latin typeface="Calibri"/>
+              </a:rPr>
+              <a:t>Dibuja el diagrama como quieras en Excalidraw o draw.io: es más rápido arrastrar cajas que escribir código, y ahí es donde se piensa el modelo.</a:t>
+            </a:r>
+          </a:p>
+        </p:txBody>
+      </p:sp>
+      <p:sp>
+        <p:nvSpPr>
+          <p:cNvPr id="10" name="Rounded Rectangle 9"/>
+          <p:cNvSpPr/>
+          <p:nvPr/>
+        </p:nvSpPr>
+        <p:spPr>
+          <a:xfrm>
+            <a:off x="457200" y="2802636"/>
+            <a:ext cx="11277295" cy="1051560"/>
+          </a:xfrm>
+          <a:prstGeom prst="roundRect">
+            <a:avLst>
+              <a:gd name="adj" fmla="val 12000"/>
+            </a:avLst>
+          </a:prstGeom>
+          <a:solidFill>
+            <a:srgbClr val="E8F4FA"/>
+          </a:solidFill>
+          <a:ln>
+            <a:noFill/>
+          </a:ln>
+        </p:spPr>
+        <p:style>
+          <a:lnRef idx="1">
+            <a:schemeClr val="accent1"/>
+          </a:lnRef>
+          <a:fillRef idx="3">
+            <a:schemeClr val="accent1"/>
+          </a:fillRef>
+          <a:effectRef idx="2">
+            <a:schemeClr val="accent1"/>
+          </a:effectRef>
+          <a:fontRef idx="minor">
+            <a:schemeClr val="lt1"/>
+          </a:fontRef>
+        </p:style>
+        <p:txBody>
+          <a:bodyPr rtlCol="0" anchor="ctr"/>
+          <a:lstStyle/>
+          <a:p>
+            <a:pPr algn="ctr"/>
+          </a:p>
+        </p:txBody>
+      </p:sp>
+      <p:sp>
+        <p:nvSpPr>
+          <p:cNvPr id="11" name="Rounded Rectangle 10"/>
+          <p:cNvSpPr/>
+          <p:nvPr/>
+        </p:nvSpPr>
+        <p:spPr>
+          <a:xfrm>
+            <a:off x="594360" y="3108960"/>
+            <a:ext cx="438912" cy="438912"/>
+          </a:xfrm>
+          <a:prstGeom prst="roundRect">
+            <a:avLst>
+              <a:gd name="adj" fmla="val 12000"/>
+            </a:avLst>
+          </a:prstGeom>
+          <a:solidFill>
+            <a:srgbClr val="095292"/>
+          </a:solidFill>
+          <a:ln>
+            <a:noFill/>
+          </a:ln>
+        </p:spPr>
+        <p:style>
+          <a:lnRef idx="1">
+            <a:schemeClr val="accent1"/>
+          </a:lnRef>
+          <a:fillRef idx="3">
+            <a:schemeClr val="accent1"/>
+          </a:fillRef>
+          <a:effectRef idx="2">
+            <a:schemeClr val="accent1"/>
+          </a:effectRef>
+          <a:fontRef idx="minor">
+            <a:schemeClr val="lt1"/>
+          </a:fontRef>
+        </p:style>
+        <p:txBody>
+          <a:bodyPr rtlCol="0" anchor="ctr"/>
+          <a:lstStyle/>
+          <a:p>
+            <a:pPr algn="ctr"/>
+          </a:p>
+        </p:txBody>
+      </p:sp>
+      <p:sp>
+        <p:nvSpPr>
+          <p:cNvPr id="12" name="TextBox 11"/>
+          <p:cNvSpPr txBox="1"/>
+          <p:nvPr/>
+        </p:nvSpPr>
+        <p:spPr>
+          <a:xfrm>
+            <a:off x="594360" y="3108960"/>
+            <a:ext cx="438912" cy="438912"/>
+          </a:xfrm>
+          <a:prstGeom prst="rect">
+            <a:avLst/>
+          </a:prstGeom>
+          <a:noFill/>
+        </p:spPr>
+        <p:txBody>
+          <a:bodyPr wrap="square" anchor="ctr"/>
+          <a:lstStyle/>
+          <a:p>
+            <a:pPr algn="ctr"/>
+            <a:r>
+              <a:rPr sz="1600" b="1" i="0">
+                <a:solidFill>
+                  <a:srgbClr val="FFFFFF"/>
+                </a:solidFill>
+                <a:latin typeface="Calibri"/>
+              </a:rPr>
+              <a:t>2</a:t>
+            </a:r>
+          </a:p>
+        </p:txBody>
+      </p:sp>
+      <p:sp>
+        <p:nvSpPr>
+          <p:cNvPr id="13" name="TextBox 12"/>
+          <p:cNvSpPr txBox="1"/>
+          <p:nvPr/>
+        </p:nvSpPr>
+        <p:spPr>
+          <a:xfrm>
+            <a:off x="1188720" y="2894076"/>
+            <a:ext cx="10271455" cy="886968"/>
+          </a:xfrm>
+          <a:prstGeom prst="rect">
+            <a:avLst/>
+          </a:prstGeom>
+          <a:noFill/>
+        </p:spPr>
+        <p:txBody>
+          <a:bodyPr wrap="square" anchor="ctr"/>
+          <a:lstStyle/>
+          <a:p>
+            <a:r>
+              <a:rPr sz="1500" b="1" i="0">
+                <a:solidFill>
+                  <a:srgbClr val="095292"/>
+                </a:solidFill>
+                <a:latin typeface="Calibri"/>
+              </a:rPr>
+              <a:t>Traduce con IA</a:t>
             </a:r>
           </a:p>
           <a:p>
             <a:pPr>
-              <a:spcAft>
-                <a:spcPts val="800"/>
-              </a:spcAft>
+              <a:spcBef>
+                <a:spcPts val="200"/>
+              </a:spcBef>
             </a:pPr>
             <a:r>
-              <a:rPr sz="2000" b="0" i="0">
-                <a:solidFill>
-                  <a:srgbClr val="333333"/>
-                </a:solidFill>
-                <a:latin typeface="Calibri"/>
-              </a:rPr>
-              <a:t>–   Respuesta: en el nivel de contexto, entre cuatro y ocho elementos en total; si hay veinte, es casi seguro que se colaron piezas internas.</a:t>
+              <a:rPr sz="1300" b="0" i="0">
+                <a:solidFill>
+                  <a:srgbClr val="333333"/>
+                </a:solidFill>
+                <a:latin typeface="Calibri"/>
+              </a:rPr>
+              <a:t>Describe tu boceto a una IA y pídele el código Mermaid usando C4Context. Revisa el resultado: la IA acierta la sintaxis, no tu modelo.</a:t>
+            </a:r>
+          </a:p>
+        </p:txBody>
+      </p:sp>
+      <p:sp>
+        <p:nvSpPr>
+          <p:cNvPr id="14" name="Rounded Rectangle 13"/>
+          <p:cNvSpPr/>
+          <p:nvPr/>
+        </p:nvSpPr>
+        <p:spPr>
+          <a:xfrm>
+            <a:off x="457200" y="3945636"/>
+            <a:ext cx="11277295" cy="1051560"/>
+          </a:xfrm>
+          <a:prstGeom prst="roundRect">
+            <a:avLst>
+              <a:gd name="adj" fmla="val 12000"/>
+            </a:avLst>
+          </a:prstGeom>
+          <a:solidFill>
+            <a:srgbClr val="F2F2F2"/>
+          </a:solidFill>
+          <a:ln>
+            <a:noFill/>
+          </a:ln>
+        </p:spPr>
+        <p:style>
+          <a:lnRef idx="1">
+            <a:schemeClr val="accent1"/>
+          </a:lnRef>
+          <a:fillRef idx="3">
+            <a:schemeClr val="accent1"/>
+          </a:fillRef>
+          <a:effectRef idx="2">
+            <a:schemeClr val="accent1"/>
+          </a:effectRef>
+          <a:fontRef idx="minor">
+            <a:schemeClr val="lt1"/>
+          </a:fontRef>
+        </p:style>
+        <p:txBody>
+          <a:bodyPr rtlCol="0" anchor="ctr"/>
+          <a:lstStyle/>
+          <a:p>
+            <a:pPr algn="ctr"/>
+          </a:p>
+        </p:txBody>
+      </p:sp>
+      <p:sp>
+        <p:nvSpPr>
+          <p:cNvPr id="15" name="Rounded Rectangle 14"/>
+          <p:cNvSpPr/>
+          <p:nvPr/>
+        </p:nvSpPr>
+        <p:spPr>
+          <a:xfrm>
+            <a:off x="594360" y="4251960"/>
+            <a:ext cx="438912" cy="438912"/>
+          </a:xfrm>
+          <a:prstGeom prst="roundRect">
+            <a:avLst>
+              <a:gd name="adj" fmla="val 12000"/>
+            </a:avLst>
+          </a:prstGeom>
+          <a:solidFill>
+            <a:srgbClr val="095292"/>
+          </a:solidFill>
+          <a:ln>
+            <a:noFill/>
+          </a:ln>
+        </p:spPr>
+        <p:style>
+          <a:lnRef idx="1">
+            <a:schemeClr val="accent1"/>
+          </a:lnRef>
+          <a:fillRef idx="3">
+            <a:schemeClr val="accent1"/>
+          </a:fillRef>
+          <a:effectRef idx="2">
+            <a:schemeClr val="accent1"/>
+          </a:effectRef>
+          <a:fontRef idx="minor">
+            <a:schemeClr val="lt1"/>
+          </a:fontRef>
+        </p:style>
+        <p:txBody>
+          <a:bodyPr rtlCol="0" anchor="ctr"/>
+          <a:lstStyle/>
+          <a:p>
+            <a:pPr algn="ctr"/>
+          </a:p>
+        </p:txBody>
+      </p:sp>
+      <p:sp>
+        <p:nvSpPr>
+          <p:cNvPr id="16" name="TextBox 15"/>
+          <p:cNvSpPr txBox="1"/>
+          <p:nvPr/>
+        </p:nvSpPr>
+        <p:spPr>
+          <a:xfrm>
+            <a:off x="594360" y="4251960"/>
+            <a:ext cx="438912" cy="438912"/>
+          </a:xfrm>
+          <a:prstGeom prst="rect">
+            <a:avLst/>
+          </a:prstGeom>
+          <a:noFill/>
+        </p:spPr>
+        <p:txBody>
+          <a:bodyPr wrap="square" anchor="ctr"/>
+          <a:lstStyle/>
+          <a:p>
+            <a:pPr algn="ctr"/>
+            <a:r>
+              <a:rPr sz="1600" b="1" i="0">
+                <a:solidFill>
+                  <a:srgbClr val="FFFFFF"/>
+                </a:solidFill>
+                <a:latin typeface="Calibri"/>
+              </a:rPr>
+              <a:t>3</a:t>
+            </a:r>
+          </a:p>
+        </p:txBody>
+      </p:sp>
+      <p:sp>
+        <p:nvSpPr>
+          <p:cNvPr id="17" name="TextBox 16"/>
+          <p:cNvSpPr txBox="1"/>
+          <p:nvPr/>
+        </p:nvSpPr>
+        <p:spPr>
+          <a:xfrm>
+            <a:off x="1188720" y="4037076"/>
+            <a:ext cx="10271455" cy="886968"/>
+          </a:xfrm>
+          <a:prstGeom prst="rect">
+            <a:avLst/>
+          </a:prstGeom>
+          <a:noFill/>
+        </p:spPr>
+        <p:txBody>
+          <a:bodyPr wrap="square" anchor="ctr"/>
+          <a:lstStyle/>
+          <a:p>
+            <a:r>
+              <a:rPr sz="1500" b="1" i="0">
+                <a:solidFill>
+                  <a:srgbClr val="095292"/>
+                </a:solidFill>
+                <a:latin typeface="Calibri"/>
+              </a:rPr>
+              <a:t>Renderiza en un visor</a:t>
             </a:r>
           </a:p>
           <a:p>
             <a:pPr>
-              <a:spcAft>
-                <a:spcPts val="800"/>
-              </a:spcAft>
+              <a:spcBef>
+                <a:spcPts val="200"/>
+              </a:spcBef>
             </a:pPr>
             <a:r>
-              <a:rPr sz="2000" b="0" i="0">
-                <a:solidFill>
-                  <a:srgbClr val="333333"/>
-                </a:solidFill>
-                <a:latin typeface="Calibri"/>
-              </a:rPr>
-              <a:t>–   Y vale cerrar ubicando al docente en el mapa del curso, porque la Clase 1 no es una introduccion suelta sino el cimiento de una cadena.</a:t>
+              <a:rPr sz="1300" b="0" i="0">
+                <a:solidFill>
+                  <a:srgbClr val="333333"/>
+                </a:solidFill>
+                <a:latin typeface="Calibri"/>
+              </a:rPr>
+              <a:t>Pega el código en un visor Mermaid (mermaid.live o la vista previa de tu editor) y míralo dibujado. Si no renderiza, corrige ahí: un end faltante o un rótulo sin comillas.</a:t>
+            </a:r>
+          </a:p>
+        </p:txBody>
+      </p:sp>
+      <p:sp>
+        <p:nvSpPr>
+          <p:cNvPr id="18" name="Rounded Rectangle 17"/>
+          <p:cNvSpPr/>
+          <p:nvPr/>
+        </p:nvSpPr>
+        <p:spPr>
+          <a:xfrm>
+            <a:off x="457200" y="5088636"/>
+            <a:ext cx="11277295" cy="1051560"/>
+          </a:xfrm>
+          <a:prstGeom prst="roundRect">
+            <a:avLst>
+              <a:gd name="adj" fmla="val 12000"/>
+            </a:avLst>
+          </a:prstGeom>
+          <a:solidFill>
+            <a:srgbClr val="E8F4FA"/>
+          </a:solidFill>
+          <a:ln>
+            <a:noFill/>
+          </a:ln>
+        </p:spPr>
+        <p:style>
+          <a:lnRef idx="1">
+            <a:schemeClr val="accent1"/>
+          </a:lnRef>
+          <a:fillRef idx="3">
+            <a:schemeClr val="accent1"/>
+          </a:fillRef>
+          <a:effectRef idx="2">
+            <a:schemeClr val="accent1"/>
+          </a:effectRef>
+          <a:fontRef idx="minor">
+            <a:schemeClr val="lt1"/>
+          </a:fontRef>
+        </p:style>
+        <p:txBody>
+          <a:bodyPr rtlCol="0" anchor="ctr"/>
+          <a:lstStyle/>
+          <a:p>
+            <a:pPr algn="ctr"/>
+          </a:p>
+        </p:txBody>
+      </p:sp>
+      <p:sp>
+        <p:nvSpPr>
+          <p:cNvPr id="19" name="Rounded Rectangle 18"/>
+          <p:cNvSpPr/>
+          <p:nvPr/>
+        </p:nvSpPr>
+        <p:spPr>
+          <a:xfrm>
+            <a:off x="594360" y="5394960"/>
+            <a:ext cx="438912" cy="438912"/>
+          </a:xfrm>
+          <a:prstGeom prst="roundRect">
+            <a:avLst>
+              <a:gd name="adj" fmla="val 12000"/>
+            </a:avLst>
+          </a:prstGeom>
+          <a:solidFill>
+            <a:srgbClr val="095292"/>
+          </a:solidFill>
+          <a:ln>
+            <a:noFill/>
+          </a:ln>
+        </p:spPr>
+        <p:style>
+          <a:lnRef idx="1">
+            <a:schemeClr val="accent1"/>
+          </a:lnRef>
+          <a:fillRef idx="3">
+            <a:schemeClr val="accent1"/>
+          </a:fillRef>
+          <a:effectRef idx="2">
+            <a:schemeClr val="accent1"/>
+          </a:effectRef>
+          <a:fontRef idx="minor">
+            <a:schemeClr val="lt1"/>
+          </a:fontRef>
+        </p:style>
+        <p:txBody>
+          <a:bodyPr rtlCol="0" anchor="ctr"/>
+          <a:lstStyle/>
+          <a:p>
+            <a:pPr algn="ctr"/>
+          </a:p>
+        </p:txBody>
+      </p:sp>
+      <p:sp>
+        <p:nvSpPr>
+          <p:cNvPr id="20" name="TextBox 19"/>
+          <p:cNvSpPr txBox="1"/>
+          <p:nvPr/>
+        </p:nvSpPr>
+        <p:spPr>
+          <a:xfrm>
+            <a:off x="594360" y="5394960"/>
+            <a:ext cx="438912" cy="438912"/>
+          </a:xfrm>
+          <a:prstGeom prst="rect">
+            <a:avLst/>
+          </a:prstGeom>
+          <a:noFill/>
+        </p:spPr>
+        <p:txBody>
+          <a:bodyPr wrap="square" anchor="ctr"/>
+          <a:lstStyle/>
+          <a:p>
+            <a:pPr algn="ctr"/>
+            <a:r>
+              <a:rPr sz="1600" b="1" i="0">
+                <a:solidFill>
+                  <a:srgbClr val="FFFFFF"/>
+                </a:solidFill>
+                <a:latin typeface="Calibri"/>
+              </a:rPr>
+              <a:t>4</a:t>
+            </a:r>
+          </a:p>
+        </p:txBody>
+      </p:sp>
+      <p:sp>
+        <p:nvSpPr>
+          <p:cNvPr id="21" name="TextBox 20"/>
+          <p:cNvSpPr txBox="1"/>
+          <p:nvPr/>
+        </p:nvSpPr>
+        <p:spPr>
+          <a:xfrm>
+            <a:off x="1188720" y="5180076"/>
+            <a:ext cx="10271455" cy="886968"/>
+          </a:xfrm>
+          <a:prstGeom prst="rect">
+            <a:avLst/>
+          </a:prstGeom>
+          <a:noFill/>
+        </p:spPr>
+        <p:txBody>
+          <a:bodyPr wrap="square" anchor="ctr"/>
+          <a:lstStyle/>
+          <a:p>
+            <a:r>
+              <a:rPr sz="1500" b="1" i="0">
+                <a:solidFill>
+                  <a:srgbClr val="095292"/>
+                </a:solidFill>
+                <a:latin typeface="Calibri"/>
+              </a:rPr>
+              <a:t>Guarda código e imagen</a:t>
             </a:r>
           </a:p>
           <a:p>
             <a:pPr>
-              <a:spcAft>
-                <a:spcPts val="800"/>
-              </a:spcAft>
+              <a:spcBef>
+                <a:spcPts val="200"/>
+              </a:spcBef>
             </a:pPr>
             <a:r>
-              <a:rPr sz="2000" b="0" i="0">
-                <a:solidFill>
-                  <a:srgbClr val="333333"/>
-                </a:solidFill>
-                <a:latin typeface="Calibri"/>
-              </a:rPr>
-              <a:t>–   La Clase 5 es el primer parcial y evalua justamente este vocabulario.</a:t>
-            </a:r>
-          </a:p>
-          <a:p>
-            <a:pPr>
-              <a:spcAft>
-                <a:spcPts val="800"/>
-              </a:spcAft>
-            </a:pPr>
-            <a:r>
-              <a:rPr sz="2000" b="0" i="0">
-                <a:solidFill>
-                  <a:srgbClr val="333333"/>
-                </a:solidFill>
-                <a:latin typeface="Calibri"/>
-              </a:rPr>
-              <a:t>–   Error tipico del docente que no domina el tema: confundir arquitectura con stack tecnologico y permitir que el estudiante presente una lista de tecnologias como si fuera una arquitectura.</a:t>
-            </a:r>
-          </a:p>
-          <a:p>
-            <a:pPr>
-              <a:spcAft>
-                <a:spcPts val="800"/>
-              </a:spcAft>
-            </a:pPr>
-            <a:r>
-              <a:rPr sz="2000" b="0" i="0">
-                <a:solidFill>
-                  <a:srgbClr val="333333"/>
-                </a:solidFill>
-                <a:latin typeface="Calibri"/>
-              </a:rPr>
-              <a:t>–   La consecuencia aguas abajo es directa: en la Clase 2 ese estudiante no podra sustentar su registro de decision, porque nunca hizo explicito un atributo de calidad que la justifique</a:t>
-            </a:r>
-          </a:p>
-        </p:txBody>
-      </p:sp>
-      <p:sp>
-        <p:nvSpPr>
-          <p:cNvPr id="6" name="TextBox 5"/>
+              <a:rPr sz="1300" b="0" i="0">
+                <a:solidFill>
+                  <a:srgbClr val="333333"/>
+                </a:solidFill>
+                <a:latin typeface="Calibri"/>
+              </a:rPr>
+              <a:t>El código es la fuente del diagrama: guárdalo con tu proyecto junto con el PNG exportado.</a:t>
+            </a:r>
+          </a:p>
+        </p:txBody>
+      </p:sp>
+      <p:sp>
+        <p:nvSpPr>
+          <p:cNvPr id="22" name="TextBox 21"/>
           <p:cNvSpPr txBox="1"/>
           <p:nvPr/>
         </p:nvSpPr>
@@ -7637,1729 +8491,6 @@
         <p:spPr>
           <a:xfrm>
             <a:off x="0" y="0"/>
-            <a:ext cx="12191695" cy="960120"/>
-          </a:xfrm>
-          <a:prstGeom prst="rect">
-            <a:avLst/>
-          </a:prstGeom>
-          <a:solidFill>
-            <a:srgbClr val="095292"/>
-          </a:solidFill>
-          <a:ln>
-            <a:noFill/>
-          </a:ln>
-        </p:spPr>
-        <p:style>
-          <a:lnRef idx="1">
-            <a:schemeClr val="accent1"/>
-          </a:lnRef>
-          <a:fillRef idx="3">
-            <a:schemeClr val="accent1"/>
-          </a:fillRef>
-          <a:effectRef idx="2">
-            <a:schemeClr val="accent1"/>
-          </a:effectRef>
-          <a:fontRef idx="minor">
-            <a:schemeClr val="lt1"/>
-          </a:fontRef>
-        </p:style>
-        <p:txBody>
-          <a:bodyPr rtlCol="0" anchor="ctr"/>
-          <a:lstStyle/>
-          <a:p>
-            <a:pPr algn="ctr"/>
-          </a:p>
-        </p:txBody>
-      </p:sp>
-      <p:sp>
-        <p:nvSpPr>
-          <p:cNvPr id="3" name="Rectangle 2"/>
-          <p:cNvSpPr/>
-          <p:nvPr/>
-        </p:nvSpPr>
-        <p:spPr>
-          <a:xfrm>
-            <a:off x="0" y="960120"/>
-            <a:ext cx="12191695" cy="41148"/>
-          </a:xfrm>
-          <a:prstGeom prst="rect">
-            <a:avLst/>
-          </a:prstGeom>
-          <a:solidFill>
-            <a:srgbClr val="FFD000"/>
-          </a:solidFill>
-          <a:ln>
-            <a:noFill/>
-          </a:ln>
-        </p:spPr>
-        <p:style>
-          <a:lnRef idx="1">
-            <a:schemeClr val="accent1"/>
-          </a:lnRef>
-          <a:fillRef idx="3">
-            <a:schemeClr val="accent1"/>
-          </a:fillRef>
-          <a:effectRef idx="2">
-            <a:schemeClr val="accent1"/>
-          </a:effectRef>
-          <a:fontRef idx="minor">
-            <a:schemeClr val="lt1"/>
-          </a:fontRef>
-        </p:style>
-        <p:txBody>
-          <a:bodyPr rtlCol="0" anchor="ctr"/>
-          <a:lstStyle/>
-          <a:p>
-            <a:pPr algn="ctr"/>
-          </a:p>
-        </p:txBody>
-      </p:sp>
-      <p:sp>
-        <p:nvSpPr>
-          <p:cNvPr id="4" name="TextBox 3"/>
-          <p:cNvSpPr txBox="1"/>
-          <p:nvPr/>
-        </p:nvSpPr>
-        <p:spPr>
-          <a:xfrm>
-            <a:off x="457200" y="164592"/>
-            <a:ext cx="11277295" cy="502920"/>
-          </a:xfrm>
-          <a:prstGeom prst="rect">
-            <a:avLst/>
-          </a:prstGeom>
-          <a:noFill/>
-        </p:spPr>
-        <p:txBody>
-          <a:bodyPr wrap="square">
-            <a:spAutoFit/>
-          </a:bodyPr>
-          <a:lstStyle/>
-          <a:p>
-            <a:r>
-              <a:rPr sz="2600" b="1" i="0">
-                <a:solidFill>
-                  <a:srgbClr val="FFFFFF"/>
-                </a:solidFill>
-                <a:latin typeface="Calibri"/>
-              </a:rPr>
-              <a:t>Preguntas frecuentes y cierre conceptual () (3/3)</a:t>
-            </a:r>
-          </a:p>
-        </p:txBody>
-      </p:sp>
-      <p:sp>
-        <p:nvSpPr>
-          <p:cNvPr id="5" name="TextBox 4"/>
-          <p:cNvSpPr txBox="1"/>
-          <p:nvPr/>
-        </p:nvSpPr>
-        <p:spPr>
-          <a:xfrm>
-            <a:off x="457200" y="1170432"/>
-            <a:ext cx="11277295" cy="5230368"/>
-          </a:xfrm>
-          <a:prstGeom prst="rect">
-            <a:avLst/>
-          </a:prstGeom>
-          <a:noFill/>
-        </p:spPr>
-        <p:txBody>
-          <a:bodyPr wrap="square">
-            <a:spAutoFit/>
-          </a:bodyPr>
-          <a:lstStyle/>
-          <a:p>
-            <a:pPr>
-              <a:spcAft>
-                <a:spcPts val="800"/>
-              </a:spcAft>
-            </a:pPr>
-            <a:r>
-              <a:rPr sz="2000" b="0" i="0">
-                <a:solidFill>
-                  <a:srgbClr val="333333"/>
-                </a:solidFill>
-                <a:latin typeface="Calibri"/>
-              </a:rPr>
-              <a:t>–   Y en la Clase 4 producira un diagrama de contenedores que es un inventario de herramientas sin fronteras de responsabilidad.</a:t>
-            </a:r>
-          </a:p>
-          <a:p>
-            <a:pPr>
-              <a:spcAft>
-                <a:spcPts val="800"/>
-              </a:spcAft>
-            </a:pPr>
-            <a:r>
-              <a:rPr sz="2000" b="0" i="0">
-                <a:solidFill>
-                  <a:srgbClr val="333333"/>
-                </a:solidFill>
-                <a:latin typeface="Calibri"/>
-              </a:rPr>
-              <a:t>–   El segundo error es aceptar diagramas de contexto contaminados con piezas internas (base de datos, cache, balanceador) porque «se ven mas completos»</a:t>
-            </a:r>
-          </a:p>
-          <a:p>
-            <a:pPr>
-              <a:spcAft>
-                <a:spcPts val="800"/>
-              </a:spcAft>
-            </a:pPr>
-            <a:r>
-              <a:rPr sz="2000" b="0" i="0">
-                <a:solidFill>
-                  <a:srgbClr val="333333"/>
-                </a:solidFill>
-                <a:latin typeface="Calibri"/>
-              </a:rPr>
-              <a:t>–   Si eso se aprueba hoy, el nivel de contenedores de la Clase 4 pierde todo sentido, ya que no habra nada nuevo que revelar</a:t>
-            </a:r>
-          </a:p>
-          <a:p>
-            <a:pPr>
-              <a:spcAft>
-                <a:spcPts val="800"/>
-              </a:spcAft>
-            </a:pPr>
-            <a:r>
-              <a:rPr sz="2000" b="0" i="0">
-                <a:solidFill>
-                  <a:srgbClr val="333333"/>
-                </a:solidFill>
-                <a:latin typeface="Calibri"/>
-              </a:rPr>
-              <a:t>–   Y la sustentacion final de la Clase 15 terminara siendo un unico diagrama ilegible en el que el estudiante no sabe a que nivel de zoom esta hablando.</a:t>
-            </a:r>
-          </a:p>
-        </p:txBody>
-      </p:sp>
-      <p:sp>
-        <p:nvSpPr>
-          <p:cNvPr id="6" name="TextBox 5"/>
-          <p:cNvSpPr txBox="1"/>
-          <p:nvPr/>
-        </p:nvSpPr>
-        <p:spPr>
-          <a:xfrm>
-            <a:off x="11185855" y="6473952"/>
-            <a:ext cx="640080" cy="274320"/>
-          </a:xfrm>
-          <a:prstGeom prst="rect">
-            <a:avLst/>
-          </a:prstGeom>
-          <a:noFill/>
-        </p:spPr>
-        <p:txBody>
-          <a:bodyPr wrap="square">
-            <a:spAutoFit/>
-          </a:bodyPr>
-          <a:lstStyle/>
-          <a:p>
-            <a:pPr algn="r"/>
-            <a:r>
-              <a:rPr sz="1100" b="0" i="0">
-                <a:solidFill>
-                  <a:srgbClr val="666666"/>
-                </a:solidFill>
-                <a:latin typeface="Calibri"/>
-              </a:rPr>
-              <a:t>21</a:t>
-            </a:r>
-          </a:p>
-        </p:txBody>
-      </p:sp>
-    </p:spTree>
-  </p:cSld>
-  <p:clrMapOvr>
-    <a:masterClrMapping/>
-  </p:clrMapOvr>
-</p:sld>
-</file>
-
-<file path=ppt/slides/slide22.xml><?xml version="1.0" encoding="utf-8"?>
-<p:sld xmlns:a="http://schemas.openxmlformats.org/drawingml/2006/main" xmlns:p="http://schemas.openxmlformats.org/presentationml/2006/main" xmlns:r="http://schemas.openxmlformats.org/officeDocument/2006/relationships">
-  <p:cSld>
-    <p:bg>
-      <p:bgPr>
-        <a:solidFill>
-          <a:srgbClr val="FFFFFF"/>
-        </a:solidFill>
-        <a:effectLst/>
-      </p:bgPr>
-    </p:bg>
-    <p:spTree>
-      <p:nvGrpSpPr>
-        <p:cNvPr id="1" name=""/>
-        <p:cNvGrpSpPr/>
-        <p:nvPr/>
-      </p:nvGrpSpPr>
-      <p:grpSpPr/>
-      <p:sp>
-        <p:nvSpPr>
-          <p:cNvPr id="2" name="Rectangle 1"/>
-          <p:cNvSpPr/>
-          <p:nvPr/>
-        </p:nvSpPr>
-        <p:spPr>
-          <a:xfrm>
-            <a:off x="0" y="0"/>
-            <a:ext cx="12191695" cy="1170432"/>
-          </a:xfrm>
-          <a:prstGeom prst="rect">
-            <a:avLst/>
-          </a:prstGeom>
-          <a:solidFill>
-            <a:srgbClr val="095292"/>
-          </a:solidFill>
-          <a:ln>
-            <a:noFill/>
-          </a:ln>
-        </p:spPr>
-        <p:style>
-          <a:lnRef idx="1">
-            <a:schemeClr val="accent1"/>
-          </a:lnRef>
-          <a:fillRef idx="3">
-            <a:schemeClr val="accent1"/>
-          </a:fillRef>
-          <a:effectRef idx="2">
-            <a:schemeClr val="accent1"/>
-          </a:effectRef>
-          <a:fontRef idx="minor">
-            <a:schemeClr val="lt1"/>
-          </a:fontRef>
-        </p:style>
-        <p:txBody>
-          <a:bodyPr rtlCol="0" anchor="ctr"/>
-          <a:lstStyle/>
-          <a:p>
-            <a:pPr algn="ctr"/>
-          </a:p>
-        </p:txBody>
-      </p:sp>
-      <p:sp>
-        <p:nvSpPr>
-          <p:cNvPr id="3" name="Rectangle 2"/>
-          <p:cNvSpPr/>
-          <p:nvPr/>
-        </p:nvSpPr>
-        <p:spPr>
-          <a:xfrm>
-            <a:off x="0" y="1170432"/>
-            <a:ext cx="12191695" cy="41148"/>
-          </a:xfrm>
-          <a:prstGeom prst="rect">
-            <a:avLst/>
-          </a:prstGeom>
-          <a:solidFill>
-            <a:srgbClr val="FFD000"/>
-          </a:solidFill>
-          <a:ln>
-            <a:noFill/>
-          </a:ln>
-        </p:spPr>
-        <p:style>
-          <a:lnRef idx="1">
-            <a:schemeClr val="accent1"/>
-          </a:lnRef>
-          <a:fillRef idx="3">
-            <a:schemeClr val="accent1"/>
-          </a:fillRef>
-          <a:effectRef idx="2">
-            <a:schemeClr val="accent1"/>
-          </a:effectRef>
-          <a:fontRef idx="minor">
-            <a:schemeClr val="lt1"/>
-          </a:fontRef>
-        </p:style>
-        <p:txBody>
-          <a:bodyPr rtlCol="0" anchor="ctr"/>
-          <a:lstStyle/>
-          <a:p>
-            <a:pPr algn="ctr"/>
-          </a:p>
-        </p:txBody>
-      </p:sp>
-      <p:sp>
-        <p:nvSpPr>
-          <p:cNvPr id="4" name="TextBox 3"/>
-          <p:cNvSpPr txBox="1"/>
-          <p:nvPr/>
-        </p:nvSpPr>
-        <p:spPr>
-          <a:xfrm>
-            <a:off x="457200" y="164592"/>
-            <a:ext cx="11277295" cy="384048"/>
-          </a:xfrm>
-          <a:prstGeom prst="rect">
-            <a:avLst/>
-          </a:prstGeom>
-          <a:noFill/>
-        </p:spPr>
-        <p:txBody>
-          <a:bodyPr wrap="square">
-            <a:spAutoFit/>
-          </a:bodyPr>
-          <a:lstStyle/>
-          <a:p>
-            <a:r>
-              <a:rPr sz="2600" b="1" i="0">
-                <a:solidFill>
-                  <a:srgbClr val="FFFFFF"/>
-                </a:solidFill>
-                <a:latin typeface="Calibri"/>
-              </a:rPr>
-              <a:t>Ejemplo de diagrama C4 — nivel Context</a:t>
-            </a:r>
-          </a:p>
-        </p:txBody>
-      </p:sp>
-      <p:sp>
-        <p:nvSpPr>
-          <p:cNvPr id="5" name="TextBox 4"/>
-          <p:cNvSpPr txBox="1"/>
-          <p:nvPr/>
-        </p:nvSpPr>
-        <p:spPr>
-          <a:xfrm>
-            <a:off x="457200" y="566928"/>
-            <a:ext cx="11277295" cy="411480"/>
-          </a:xfrm>
-          <a:prstGeom prst="rect">
-            <a:avLst/>
-          </a:prstGeom>
-          <a:noFill/>
-        </p:spPr>
-        <p:txBody>
-          <a:bodyPr wrap="square">
-            <a:spAutoFit/>
-          </a:bodyPr>
-          <a:lstStyle/>
-          <a:p>
-            <a:r>
-              <a:rPr sz="1400" b="0" i="0">
-                <a:solidFill>
-                  <a:srgbClr val="B8D8EE"/>
-                </a:solidFill>
-                <a:latin typeface="Calibri"/>
-              </a:rPr>
-              <a:t>Actor, sistema y sistema externo: el mismo esquema sirve para cualquier dominio</a:t>
-            </a:r>
-          </a:p>
-        </p:txBody>
-      </p:sp>
-      <p:sp>
-        <p:nvSpPr>
-          <p:cNvPr id="6" name="Rounded Rectangle 5"/>
-          <p:cNvSpPr/>
-          <p:nvPr/>
-        </p:nvSpPr>
-        <p:spPr>
-          <a:xfrm>
-            <a:off x="822960" y="2743200"/>
-            <a:ext cx="2103120" cy="1097280"/>
-          </a:xfrm>
-          <a:prstGeom prst="roundRect">
-            <a:avLst>
-              <a:gd name="adj" fmla="val 12000"/>
-            </a:avLst>
-          </a:prstGeom>
-          <a:solidFill>
-            <a:srgbClr val="FFD000"/>
-          </a:solidFill>
-          <a:ln>
-            <a:noFill/>
-          </a:ln>
-        </p:spPr>
-        <p:style>
-          <a:lnRef idx="1">
-            <a:schemeClr val="accent1"/>
-          </a:lnRef>
-          <a:fillRef idx="3">
-            <a:schemeClr val="accent1"/>
-          </a:fillRef>
-          <a:effectRef idx="2">
-            <a:schemeClr val="accent1"/>
-          </a:effectRef>
-          <a:fontRef idx="minor">
-            <a:schemeClr val="lt1"/>
-          </a:fontRef>
-        </p:style>
-        <p:txBody>
-          <a:bodyPr rtlCol="0" anchor="ctr" wrap="square"/>
-          <a:lstStyle/>
-          <a:p>
-            <a:pPr algn="ctr"/>
-            <a:r>
-              <a:rPr sz="1300" b="1" i="0">
-                <a:solidFill>
-                  <a:srgbClr val="095292"/>
-                </a:solidFill>
-                <a:latin typeface="Calibri"/>
-              </a:rPr>
-              <a:t>Estudiante
-(actor)</a:t>
-            </a:r>
-          </a:p>
-        </p:txBody>
-      </p:sp>
-      <p:sp>
-        <p:nvSpPr>
-          <p:cNvPr id="7" name="Rounded Rectangle 6"/>
-          <p:cNvSpPr/>
-          <p:nvPr/>
-        </p:nvSpPr>
-        <p:spPr>
-          <a:xfrm>
-            <a:off x="4846320" y="2377440"/>
-            <a:ext cx="2834640" cy="1645920"/>
-          </a:xfrm>
-          <a:prstGeom prst="roundRect">
-            <a:avLst>
-              <a:gd name="adj" fmla="val 12000"/>
-            </a:avLst>
-          </a:prstGeom>
-          <a:solidFill>
-            <a:srgbClr val="095292"/>
-          </a:solidFill>
-          <a:ln>
-            <a:noFill/>
-          </a:ln>
-        </p:spPr>
-        <p:style>
-          <a:lnRef idx="1">
-            <a:schemeClr val="accent1"/>
-          </a:lnRef>
-          <a:fillRef idx="3">
-            <a:schemeClr val="accent1"/>
-          </a:fillRef>
-          <a:effectRef idx="2">
-            <a:schemeClr val="accent1"/>
-          </a:effectRef>
-          <a:fontRef idx="minor">
-            <a:schemeClr val="lt1"/>
-          </a:fontRef>
-        </p:style>
-        <p:txBody>
-          <a:bodyPr rtlCol="0" anchor="ctr" wrap="square"/>
-          <a:lstStyle/>
-          <a:p>
-            <a:pPr algn="ctr"/>
-            <a:r>
-              <a:rPr sz="1300" b="1" i="0">
-                <a:solidFill>
-                  <a:srgbClr val="FFFFFF"/>
-                </a:solidFill>
-                <a:latin typeface="Calibri"/>
-              </a:rPr>
-              <a:t>La app
-(el sistema = una sola caja)</a:t>
-            </a:r>
-          </a:p>
-        </p:txBody>
-      </p:sp>
-      <p:sp>
-        <p:nvSpPr>
-          <p:cNvPr id="8" name="Rounded Rectangle 7"/>
-          <p:cNvSpPr/>
-          <p:nvPr/>
-        </p:nvSpPr>
-        <p:spPr>
-          <a:xfrm>
-            <a:off x="9235440" y="2743200"/>
-            <a:ext cx="2286000" cy="1097280"/>
-          </a:xfrm>
-          <a:prstGeom prst="roundRect">
-            <a:avLst>
-              <a:gd name="adj" fmla="val 12000"/>
-            </a:avLst>
-          </a:prstGeom>
-          <a:solidFill>
-            <a:srgbClr val="269CCB"/>
-          </a:solidFill>
-          <a:ln>
-            <a:noFill/>
-          </a:ln>
-        </p:spPr>
-        <p:style>
-          <a:lnRef idx="1">
-            <a:schemeClr val="accent1"/>
-          </a:lnRef>
-          <a:fillRef idx="3">
-            <a:schemeClr val="accent1"/>
-          </a:fillRef>
-          <a:effectRef idx="2">
-            <a:schemeClr val="accent1"/>
-          </a:effectRef>
-          <a:fontRef idx="minor">
-            <a:schemeClr val="lt1"/>
-          </a:fontRef>
-        </p:style>
-        <p:txBody>
-          <a:bodyPr rtlCol="0" anchor="ctr" wrap="square"/>
-          <a:lstStyle/>
-          <a:p>
-            <a:pPr algn="ctr"/>
-            <a:r>
-              <a:rPr sz="1300" b="1" i="0">
-                <a:solidFill>
-                  <a:srgbClr val="FFFFFF"/>
-                </a:solidFill>
-                <a:latin typeface="Calibri"/>
-              </a:rPr>
-              <a:t>Sistema externo
-(ej. correo, auth)</a:t>
-            </a:r>
-          </a:p>
-        </p:txBody>
-      </p:sp>
-      <p:cxnSp>
-        <p:nvCxnSpPr>
-          <p:cNvPr id="9" name="Connector 8"/>
-          <p:cNvCxnSpPr/>
-          <p:nvPr/>
-        </p:nvCxnSpPr>
-        <p:spPr>
-          <a:xfrm flipV="1">
-            <a:off x="2926079" y="3200400"/>
-            <a:ext cx="1920241" cy="91440"/>
-          </a:xfrm>
-          <a:prstGeom prst="line">
-            <a:avLst/>
-          </a:prstGeom>
-          <a:ln w="22225">
-            <a:solidFill>
-              <a:srgbClr val="666666"/>
-            </a:solidFill>
-            <a:tailEnd type="triangle" w="med" len="med"/>
-          </a:ln>
-        </p:spPr>
-        <p:style>
-          <a:lnRef idx="2">
-            <a:schemeClr val="accent1"/>
-          </a:lnRef>
-          <a:fillRef idx="0">
-            <a:schemeClr val="accent1"/>
-          </a:fillRef>
-          <a:effectRef idx="1">
-            <a:schemeClr val="accent1"/>
-          </a:effectRef>
-          <a:fontRef idx="minor">
-            <a:schemeClr val="tx1"/>
-          </a:fontRef>
-        </p:style>
-      </p:cxnSp>
-      <p:sp>
-        <p:nvSpPr>
-          <p:cNvPr id="10" name="TextBox 9"/>
-          <p:cNvSpPr txBox="1"/>
-          <p:nvPr/>
-        </p:nvSpPr>
-        <p:spPr>
-          <a:xfrm>
-            <a:off x="3063240" y="3044951"/>
-            <a:ext cx="1645920" cy="320040"/>
-          </a:xfrm>
-          <a:prstGeom prst="rect">
-            <a:avLst/>
-          </a:prstGeom>
-          <a:noFill/>
-        </p:spPr>
-        <p:txBody>
-          <a:bodyPr wrap="square">
-            <a:spAutoFit/>
-          </a:bodyPr>
-          <a:lstStyle/>
-          <a:p>
-            <a:pPr algn="ctr"/>
-            <a:r>
-              <a:rPr sz="1000" b="0" i="1">
-                <a:solidFill>
-                  <a:srgbClr val="666666"/>
-                </a:solidFill>
-                <a:latin typeface="Calibri"/>
-              </a:rPr>
-              <a:t>usa</a:t>
-            </a:r>
-          </a:p>
-        </p:txBody>
-      </p:sp>
-      <p:cxnSp>
-        <p:nvCxnSpPr>
-          <p:cNvPr id="11" name="Connector 10"/>
-          <p:cNvCxnSpPr/>
-          <p:nvPr/>
-        </p:nvCxnSpPr>
-        <p:spPr>
-          <a:xfrm>
-            <a:off x="7680960" y="3200400"/>
-            <a:ext cx="1554480" cy="91440"/>
-          </a:xfrm>
-          <a:prstGeom prst="line">
-            <a:avLst/>
-          </a:prstGeom>
-          <a:ln w="22225">
-            <a:solidFill>
-              <a:srgbClr val="666666"/>
-            </a:solidFill>
-            <a:tailEnd type="triangle" w="med" len="med"/>
-          </a:ln>
-        </p:spPr>
-        <p:style>
-          <a:lnRef idx="2">
-            <a:schemeClr val="accent1"/>
-          </a:lnRef>
-          <a:fillRef idx="0">
-            <a:schemeClr val="accent1"/>
-          </a:fillRef>
-          <a:effectRef idx="1">
-            <a:schemeClr val="accent1"/>
-          </a:effectRef>
-          <a:fontRef idx="minor">
-            <a:schemeClr val="tx1"/>
-          </a:fontRef>
-        </p:style>
-      </p:cxnSp>
-      <p:sp>
-        <p:nvSpPr>
-          <p:cNvPr id="12" name="TextBox 11"/>
-          <p:cNvSpPr txBox="1"/>
-          <p:nvPr/>
-        </p:nvSpPr>
-        <p:spPr>
-          <a:xfrm>
-            <a:off x="7635240" y="3044951"/>
-            <a:ext cx="1645920" cy="320040"/>
-          </a:xfrm>
-          <a:prstGeom prst="rect">
-            <a:avLst/>
-          </a:prstGeom>
-          <a:noFill/>
-        </p:spPr>
-        <p:txBody>
-          <a:bodyPr wrap="square">
-            <a:spAutoFit/>
-          </a:bodyPr>
-          <a:lstStyle/>
-          <a:p>
-            <a:pPr algn="ctr"/>
-            <a:r>
-              <a:rPr sz="1000" b="0" i="1">
-                <a:solidFill>
-                  <a:srgbClr val="666666"/>
-                </a:solidFill>
-                <a:latin typeface="Calibri"/>
-              </a:rPr>
-              <a:t>notifica / consume</a:t>
-            </a:r>
-          </a:p>
-        </p:txBody>
-      </p:sp>
-      <p:sp>
-        <p:nvSpPr>
-          <p:cNvPr id="13" name="TextBox 12"/>
-          <p:cNvSpPr txBox="1"/>
-          <p:nvPr/>
-        </p:nvSpPr>
-        <p:spPr>
-          <a:xfrm>
-            <a:off x="457200" y="6263640"/>
-            <a:ext cx="11277295" cy="411480"/>
-          </a:xfrm>
-          <a:prstGeom prst="rect">
-            <a:avLst/>
-          </a:prstGeom>
-          <a:noFill/>
-        </p:spPr>
-        <p:txBody>
-          <a:bodyPr wrap="square">
-            <a:spAutoFit/>
-          </a:bodyPr>
-          <a:lstStyle/>
-          <a:p>
-            <a:r>
-              <a:rPr sz="1100" b="0" i="1">
-                <a:solidFill>
-                  <a:srgbClr val="666666"/>
-                </a:solidFill>
-                <a:latin typeface="Calibri"/>
-              </a:rPr>
-              <a:t>Nivel Context: el sistema es UNA caja (sin abrir por dentro). Actores a la izquierda, sistemas externos a la derecha. El interior se dibuja en Clase 4 (Containers). Cada flecha lleva un verbo de negocio («reserva turno», «envía recordatorio»); la API y la base de datos no aparecen aquí porque son piezas interiores.</a:t>
-            </a:r>
-          </a:p>
-        </p:txBody>
-      </p:sp>
-      <p:sp>
-        <p:nvSpPr>
-          <p:cNvPr id="14" name="TextBox 13"/>
-          <p:cNvSpPr txBox="1"/>
-          <p:nvPr/>
-        </p:nvSpPr>
-        <p:spPr>
-          <a:xfrm>
-            <a:off x="11185855" y="6473952"/>
-            <a:ext cx="640080" cy="274320"/>
-          </a:xfrm>
-          <a:prstGeom prst="rect">
-            <a:avLst/>
-          </a:prstGeom>
-          <a:noFill/>
-        </p:spPr>
-        <p:txBody>
-          <a:bodyPr wrap="square">
-            <a:spAutoFit/>
-          </a:bodyPr>
-          <a:lstStyle/>
-          <a:p>
-            <a:pPr algn="r"/>
-            <a:r>
-              <a:rPr sz="1100" b="0" i="0">
-                <a:solidFill>
-                  <a:srgbClr val="666666"/>
-                </a:solidFill>
-                <a:latin typeface="Calibri"/>
-              </a:rPr>
-              <a:t>22</a:t>
-            </a:r>
-          </a:p>
-        </p:txBody>
-      </p:sp>
-    </p:spTree>
-  </p:cSld>
-  <p:clrMapOvr>
-    <a:masterClrMapping/>
-  </p:clrMapOvr>
-</p:sld>
-</file>
-
-<file path=ppt/slides/slide23.xml><?xml version="1.0" encoding="utf-8"?>
-<p:sld xmlns:a="http://schemas.openxmlformats.org/drawingml/2006/main" xmlns:p="http://schemas.openxmlformats.org/presentationml/2006/main" xmlns:r="http://schemas.openxmlformats.org/officeDocument/2006/relationships">
-  <p:cSld>
-    <p:bg>
-      <p:bgPr>
-        <a:solidFill>
-          <a:srgbClr val="FFFFFF"/>
-        </a:solidFill>
-        <a:effectLst/>
-      </p:bgPr>
-    </p:bg>
-    <p:spTree>
-      <p:nvGrpSpPr>
-        <p:cNvPr id="1" name=""/>
-        <p:cNvGrpSpPr/>
-        <p:nvPr/>
-      </p:nvGrpSpPr>
-      <p:grpSpPr/>
-      <p:sp>
-        <p:nvSpPr>
-          <p:cNvPr id="2" name="Rectangle 1"/>
-          <p:cNvSpPr/>
-          <p:nvPr/>
-        </p:nvSpPr>
-        <p:spPr>
-          <a:xfrm>
-            <a:off x="0" y="0"/>
-            <a:ext cx="12191695" cy="1170432"/>
-          </a:xfrm>
-          <a:prstGeom prst="rect">
-            <a:avLst/>
-          </a:prstGeom>
-          <a:solidFill>
-            <a:srgbClr val="095292"/>
-          </a:solidFill>
-          <a:ln>
-            <a:noFill/>
-          </a:ln>
-        </p:spPr>
-        <p:style>
-          <a:lnRef idx="1">
-            <a:schemeClr val="accent1"/>
-          </a:lnRef>
-          <a:fillRef idx="3">
-            <a:schemeClr val="accent1"/>
-          </a:fillRef>
-          <a:effectRef idx="2">
-            <a:schemeClr val="accent1"/>
-          </a:effectRef>
-          <a:fontRef idx="minor">
-            <a:schemeClr val="lt1"/>
-          </a:fontRef>
-        </p:style>
-        <p:txBody>
-          <a:bodyPr rtlCol="0" anchor="ctr"/>
-          <a:lstStyle/>
-          <a:p>
-            <a:pPr algn="ctr"/>
-          </a:p>
-        </p:txBody>
-      </p:sp>
-      <p:sp>
-        <p:nvSpPr>
-          <p:cNvPr id="3" name="Rectangle 2"/>
-          <p:cNvSpPr/>
-          <p:nvPr/>
-        </p:nvSpPr>
-        <p:spPr>
-          <a:xfrm>
-            <a:off x="0" y="1170432"/>
-            <a:ext cx="12191695" cy="41148"/>
-          </a:xfrm>
-          <a:prstGeom prst="rect">
-            <a:avLst/>
-          </a:prstGeom>
-          <a:solidFill>
-            <a:srgbClr val="FFD000"/>
-          </a:solidFill>
-          <a:ln>
-            <a:noFill/>
-          </a:ln>
-        </p:spPr>
-        <p:style>
-          <a:lnRef idx="1">
-            <a:schemeClr val="accent1"/>
-          </a:lnRef>
-          <a:fillRef idx="3">
-            <a:schemeClr val="accent1"/>
-          </a:fillRef>
-          <a:effectRef idx="2">
-            <a:schemeClr val="accent1"/>
-          </a:effectRef>
-          <a:fontRef idx="minor">
-            <a:schemeClr val="lt1"/>
-          </a:fontRef>
-        </p:style>
-        <p:txBody>
-          <a:bodyPr rtlCol="0" anchor="ctr"/>
-          <a:lstStyle/>
-          <a:p>
-            <a:pPr algn="ctr"/>
-          </a:p>
-        </p:txBody>
-      </p:sp>
-      <p:sp>
-        <p:nvSpPr>
-          <p:cNvPr id="4" name="TextBox 3"/>
-          <p:cNvSpPr txBox="1"/>
-          <p:nvPr/>
-        </p:nvSpPr>
-        <p:spPr>
-          <a:xfrm>
-            <a:off x="457200" y="164592"/>
-            <a:ext cx="11277295" cy="384048"/>
-          </a:xfrm>
-          <a:prstGeom prst="rect">
-            <a:avLst/>
-          </a:prstGeom>
-          <a:noFill/>
-        </p:spPr>
-        <p:txBody>
-          <a:bodyPr wrap="square">
-            <a:spAutoFit/>
-          </a:bodyPr>
-          <a:lstStyle/>
-          <a:p>
-            <a:r>
-              <a:rPr sz="2600" b="1" i="0">
-                <a:solidFill>
-                  <a:srgbClr val="FFFFFF"/>
-                </a:solidFill>
-                <a:latin typeface="Calibri"/>
-              </a:rPr>
-              <a:t>Del boceto al código Mermaid</a:t>
-            </a:r>
-          </a:p>
-        </p:txBody>
-      </p:sp>
-      <p:sp>
-        <p:nvSpPr>
-          <p:cNvPr id="5" name="TextBox 4"/>
-          <p:cNvSpPr txBox="1"/>
-          <p:nvPr/>
-        </p:nvSpPr>
-        <p:spPr>
-          <a:xfrm>
-            <a:off x="457200" y="566928"/>
-            <a:ext cx="11277295" cy="411480"/>
-          </a:xfrm>
-          <a:prstGeom prst="rect">
-            <a:avLst/>
-          </a:prstGeom>
-          <a:noFill/>
-        </p:spPr>
-        <p:txBody>
-          <a:bodyPr wrap="square">
-            <a:spAutoFit/>
-          </a:bodyPr>
-          <a:lstStyle/>
-          <a:p>
-            <a:r>
-              <a:rPr sz="1400" b="0" i="0">
-                <a:solidFill>
-                  <a:srgbClr val="B8D8EE"/>
-                </a:solidFill>
-                <a:latin typeface="Calibri"/>
-              </a:rPr>
-              <a:t>El diagrama se escribe como código: se versiona, se compara y se corrige</a:t>
-            </a:r>
-          </a:p>
-        </p:txBody>
-      </p:sp>
-      <p:sp>
-        <p:nvSpPr>
-          <p:cNvPr id="6" name="Rounded Rectangle 5"/>
-          <p:cNvSpPr/>
-          <p:nvPr/>
-        </p:nvSpPr>
-        <p:spPr>
-          <a:xfrm>
-            <a:off x="457200" y="1659636"/>
-            <a:ext cx="11277295" cy="1051560"/>
-          </a:xfrm>
-          <a:prstGeom prst="roundRect">
-            <a:avLst>
-              <a:gd name="adj" fmla="val 12000"/>
-            </a:avLst>
-          </a:prstGeom>
-          <a:solidFill>
-            <a:srgbClr val="F2F2F2"/>
-          </a:solidFill>
-          <a:ln>
-            <a:noFill/>
-          </a:ln>
-        </p:spPr>
-        <p:style>
-          <a:lnRef idx="1">
-            <a:schemeClr val="accent1"/>
-          </a:lnRef>
-          <a:fillRef idx="3">
-            <a:schemeClr val="accent1"/>
-          </a:fillRef>
-          <a:effectRef idx="2">
-            <a:schemeClr val="accent1"/>
-          </a:effectRef>
-          <a:fontRef idx="minor">
-            <a:schemeClr val="lt1"/>
-          </a:fontRef>
-        </p:style>
-        <p:txBody>
-          <a:bodyPr rtlCol="0" anchor="ctr"/>
-          <a:lstStyle/>
-          <a:p>
-            <a:pPr algn="ctr"/>
-          </a:p>
-        </p:txBody>
-      </p:sp>
-      <p:sp>
-        <p:nvSpPr>
-          <p:cNvPr id="7" name="Rounded Rectangle 6"/>
-          <p:cNvSpPr/>
-          <p:nvPr/>
-        </p:nvSpPr>
-        <p:spPr>
-          <a:xfrm>
-            <a:off x="594360" y="1965960"/>
-            <a:ext cx="438912" cy="438912"/>
-          </a:xfrm>
-          <a:prstGeom prst="roundRect">
-            <a:avLst>
-              <a:gd name="adj" fmla="val 12000"/>
-            </a:avLst>
-          </a:prstGeom>
-          <a:solidFill>
-            <a:srgbClr val="095292"/>
-          </a:solidFill>
-          <a:ln>
-            <a:noFill/>
-          </a:ln>
-        </p:spPr>
-        <p:style>
-          <a:lnRef idx="1">
-            <a:schemeClr val="accent1"/>
-          </a:lnRef>
-          <a:fillRef idx="3">
-            <a:schemeClr val="accent1"/>
-          </a:fillRef>
-          <a:effectRef idx="2">
-            <a:schemeClr val="accent1"/>
-          </a:effectRef>
-          <a:fontRef idx="minor">
-            <a:schemeClr val="lt1"/>
-          </a:fontRef>
-        </p:style>
-        <p:txBody>
-          <a:bodyPr rtlCol="0" anchor="ctr"/>
-          <a:lstStyle/>
-          <a:p>
-            <a:pPr algn="ctr"/>
-          </a:p>
-        </p:txBody>
-      </p:sp>
-      <p:sp>
-        <p:nvSpPr>
-          <p:cNvPr id="8" name="TextBox 7"/>
-          <p:cNvSpPr txBox="1"/>
-          <p:nvPr/>
-        </p:nvSpPr>
-        <p:spPr>
-          <a:xfrm>
-            <a:off x="594360" y="1965960"/>
-            <a:ext cx="438912" cy="438912"/>
-          </a:xfrm>
-          <a:prstGeom prst="rect">
-            <a:avLst/>
-          </a:prstGeom>
-          <a:noFill/>
-        </p:spPr>
-        <p:txBody>
-          <a:bodyPr wrap="square" anchor="ctr"/>
-          <a:lstStyle/>
-          <a:p>
-            <a:pPr algn="ctr"/>
-            <a:r>
-              <a:rPr sz="1600" b="1" i="0">
-                <a:solidFill>
-                  <a:srgbClr val="FFFFFF"/>
-                </a:solidFill>
-                <a:latin typeface="Calibri"/>
-              </a:rPr>
-              <a:t>1</a:t>
-            </a:r>
-          </a:p>
-        </p:txBody>
-      </p:sp>
-      <p:sp>
-        <p:nvSpPr>
-          <p:cNvPr id="9" name="TextBox 8"/>
-          <p:cNvSpPr txBox="1"/>
-          <p:nvPr/>
-        </p:nvSpPr>
-        <p:spPr>
-          <a:xfrm>
-            <a:off x="1188720" y="1751076"/>
-            <a:ext cx="10271455" cy="886968"/>
-          </a:xfrm>
-          <a:prstGeom prst="rect">
-            <a:avLst/>
-          </a:prstGeom>
-          <a:noFill/>
-        </p:spPr>
-        <p:txBody>
-          <a:bodyPr wrap="square" anchor="ctr"/>
-          <a:lstStyle/>
-          <a:p>
-            <a:r>
-              <a:rPr sz="1500" b="1" i="0">
-                <a:solidFill>
-                  <a:srgbClr val="095292"/>
-                </a:solidFill>
-                <a:latin typeface="Calibri"/>
-              </a:rPr>
-              <a:t>Diseña visual</a:t>
-            </a:r>
-          </a:p>
-          <a:p>
-            <a:pPr>
-              <a:spcBef>
-                <a:spcPts val="200"/>
-              </a:spcBef>
-            </a:pPr>
-            <a:r>
-              <a:rPr sz="1300" b="0" i="0">
-                <a:solidFill>
-                  <a:srgbClr val="333333"/>
-                </a:solidFill>
-                <a:latin typeface="Calibri"/>
-              </a:rPr>
-              <a:t>Dibuja el diagrama como quieras en Excalidraw o draw.io: es más rápido arrastrar cajas que escribir código, y ahí es donde se piensa el modelo.</a:t>
-            </a:r>
-          </a:p>
-        </p:txBody>
-      </p:sp>
-      <p:sp>
-        <p:nvSpPr>
-          <p:cNvPr id="10" name="Rounded Rectangle 9"/>
-          <p:cNvSpPr/>
-          <p:nvPr/>
-        </p:nvSpPr>
-        <p:spPr>
-          <a:xfrm>
-            <a:off x="457200" y="2802636"/>
-            <a:ext cx="11277295" cy="1051560"/>
-          </a:xfrm>
-          <a:prstGeom prst="roundRect">
-            <a:avLst>
-              <a:gd name="adj" fmla="val 12000"/>
-            </a:avLst>
-          </a:prstGeom>
-          <a:solidFill>
-            <a:srgbClr val="E8F4FA"/>
-          </a:solidFill>
-          <a:ln>
-            <a:noFill/>
-          </a:ln>
-        </p:spPr>
-        <p:style>
-          <a:lnRef idx="1">
-            <a:schemeClr val="accent1"/>
-          </a:lnRef>
-          <a:fillRef idx="3">
-            <a:schemeClr val="accent1"/>
-          </a:fillRef>
-          <a:effectRef idx="2">
-            <a:schemeClr val="accent1"/>
-          </a:effectRef>
-          <a:fontRef idx="minor">
-            <a:schemeClr val="lt1"/>
-          </a:fontRef>
-        </p:style>
-        <p:txBody>
-          <a:bodyPr rtlCol="0" anchor="ctr"/>
-          <a:lstStyle/>
-          <a:p>
-            <a:pPr algn="ctr"/>
-          </a:p>
-        </p:txBody>
-      </p:sp>
-      <p:sp>
-        <p:nvSpPr>
-          <p:cNvPr id="11" name="Rounded Rectangle 10"/>
-          <p:cNvSpPr/>
-          <p:nvPr/>
-        </p:nvSpPr>
-        <p:spPr>
-          <a:xfrm>
-            <a:off x="594360" y="3108960"/>
-            <a:ext cx="438912" cy="438912"/>
-          </a:xfrm>
-          <a:prstGeom prst="roundRect">
-            <a:avLst>
-              <a:gd name="adj" fmla="val 12000"/>
-            </a:avLst>
-          </a:prstGeom>
-          <a:solidFill>
-            <a:srgbClr val="095292"/>
-          </a:solidFill>
-          <a:ln>
-            <a:noFill/>
-          </a:ln>
-        </p:spPr>
-        <p:style>
-          <a:lnRef idx="1">
-            <a:schemeClr val="accent1"/>
-          </a:lnRef>
-          <a:fillRef idx="3">
-            <a:schemeClr val="accent1"/>
-          </a:fillRef>
-          <a:effectRef idx="2">
-            <a:schemeClr val="accent1"/>
-          </a:effectRef>
-          <a:fontRef idx="minor">
-            <a:schemeClr val="lt1"/>
-          </a:fontRef>
-        </p:style>
-        <p:txBody>
-          <a:bodyPr rtlCol="0" anchor="ctr"/>
-          <a:lstStyle/>
-          <a:p>
-            <a:pPr algn="ctr"/>
-          </a:p>
-        </p:txBody>
-      </p:sp>
-      <p:sp>
-        <p:nvSpPr>
-          <p:cNvPr id="12" name="TextBox 11"/>
-          <p:cNvSpPr txBox="1"/>
-          <p:nvPr/>
-        </p:nvSpPr>
-        <p:spPr>
-          <a:xfrm>
-            <a:off x="594360" y="3108960"/>
-            <a:ext cx="438912" cy="438912"/>
-          </a:xfrm>
-          <a:prstGeom prst="rect">
-            <a:avLst/>
-          </a:prstGeom>
-          <a:noFill/>
-        </p:spPr>
-        <p:txBody>
-          <a:bodyPr wrap="square" anchor="ctr"/>
-          <a:lstStyle/>
-          <a:p>
-            <a:pPr algn="ctr"/>
-            <a:r>
-              <a:rPr sz="1600" b="1" i="0">
-                <a:solidFill>
-                  <a:srgbClr val="FFFFFF"/>
-                </a:solidFill>
-                <a:latin typeface="Calibri"/>
-              </a:rPr>
-              <a:t>2</a:t>
-            </a:r>
-          </a:p>
-        </p:txBody>
-      </p:sp>
-      <p:sp>
-        <p:nvSpPr>
-          <p:cNvPr id="13" name="TextBox 12"/>
-          <p:cNvSpPr txBox="1"/>
-          <p:nvPr/>
-        </p:nvSpPr>
-        <p:spPr>
-          <a:xfrm>
-            <a:off x="1188720" y="2894076"/>
-            <a:ext cx="10271455" cy="886968"/>
-          </a:xfrm>
-          <a:prstGeom prst="rect">
-            <a:avLst/>
-          </a:prstGeom>
-          <a:noFill/>
-        </p:spPr>
-        <p:txBody>
-          <a:bodyPr wrap="square" anchor="ctr"/>
-          <a:lstStyle/>
-          <a:p>
-            <a:r>
-              <a:rPr sz="1500" b="1" i="0">
-                <a:solidFill>
-                  <a:srgbClr val="095292"/>
-                </a:solidFill>
-                <a:latin typeface="Calibri"/>
-              </a:rPr>
-              <a:t>Traduce con IA</a:t>
-            </a:r>
-          </a:p>
-          <a:p>
-            <a:pPr>
-              <a:spcBef>
-                <a:spcPts val="200"/>
-              </a:spcBef>
-            </a:pPr>
-            <a:r>
-              <a:rPr sz="1300" b="0" i="0">
-                <a:solidFill>
-                  <a:srgbClr val="333333"/>
-                </a:solidFill>
-                <a:latin typeface="Calibri"/>
-              </a:rPr>
-              <a:t>Describe tu boceto a una IA y pídele el código Mermaid usando C4Context. Revisa el resultado: la IA acierta la sintaxis, no tu modelo.</a:t>
-            </a:r>
-          </a:p>
-        </p:txBody>
-      </p:sp>
-      <p:sp>
-        <p:nvSpPr>
-          <p:cNvPr id="14" name="Rounded Rectangle 13"/>
-          <p:cNvSpPr/>
-          <p:nvPr/>
-        </p:nvSpPr>
-        <p:spPr>
-          <a:xfrm>
-            <a:off x="457200" y="3945636"/>
-            <a:ext cx="11277295" cy="1051560"/>
-          </a:xfrm>
-          <a:prstGeom prst="roundRect">
-            <a:avLst>
-              <a:gd name="adj" fmla="val 12000"/>
-            </a:avLst>
-          </a:prstGeom>
-          <a:solidFill>
-            <a:srgbClr val="F2F2F2"/>
-          </a:solidFill>
-          <a:ln>
-            <a:noFill/>
-          </a:ln>
-        </p:spPr>
-        <p:style>
-          <a:lnRef idx="1">
-            <a:schemeClr val="accent1"/>
-          </a:lnRef>
-          <a:fillRef idx="3">
-            <a:schemeClr val="accent1"/>
-          </a:fillRef>
-          <a:effectRef idx="2">
-            <a:schemeClr val="accent1"/>
-          </a:effectRef>
-          <a:fontRef idx="minor">
-            <a:schemeClr val="lt1"/>
-          </a:fontRef>
-        </p:style>
-        <p:txBody>
-          <a:bodyPr rtlCol="0" anchor="ctr"/>
-          <a:lstStyle/>
-          <a:p>
-            <a:pPr algn="ctr"/>
-          </a:p>
-        </p:txBody>
-      </p:sp>
-      <p:sp>
-        <p:nvSpPr>
-          <p:cNvPr id="15" name="Rounded Rectangle 14"/>
-          <p:cNvSpPr/>
-          <p:nvPr/>
-        </p:nvSpPr>
-        <p:spPr>
-          <a:xfrm>
-            <a:off x="594360" y="4251960"/>
-            <a:ext cx="438912" cy="438912"/>
-          </a:xfrm>
-          <a:prstGeom prst="roundRect">
-            <a:avLst>
-              <a:gd name="adj" fmla="val 12000"/>
-            </a:avLst>
-          </a:prstGeom>
-          <a:solidFill>
-            <a:srgbClr val="095292"/>
-          </a:solidFill>
-          <a:ln>
-            <a:noFill/>
-          </a:ln>
-        </p:spPr>
-        <p:style>
-          <a:lnRef idx="1">
-            <a:schemeClr val="accent1"/>
-          </a:lnRef>
-          <a:fillRef idx="3">
-            <a:schemeClr val="accent1"/>
-          </a:fillRef>
-          <a:effectRef idx="2">
-            <a:schemeClr val="accent1"/>
-          </a:effectRef>
-          <a:fontRef idx="minor">
-            <a:schemeClr val="lt1"/>
-          </a:fontRef>
-        </p:style>
-        <p:txBody>
-          <a:bodyPr rtlCol="0" anchor="ctr"/>
-          <a:lstStyle/>
-          <a:p>
-            <a:pPr algn="ctr"/>
-          </a:p>
-        </p:txBody>
-      </p:sp>
-      <p:sp>
-        <p:nvSpPr>
-          <p:cNvPr id="16" name="TextBox 15"/>
-          <p:cNvSpPr txBox="1"/>
-          <p:nvPr/>
-        </p:nvSpPr>
-        <p:spPr>
-          <a:xfrm>
-            <a:off x="594360" y="4251960"/>
-            <a:ext cx="438912" cy="438912"/>
-          </a:xfrm>
-          <a:prstGeom prst="rect">
-            <a:avLst/>
-          </a:prstGeom>
-          <a:noFill/>
-        </p:spPr>
-        <p:txBody>
-          <a:bodyPr wrap="square" anchor="ctr"/>
-          <a:lstStyle/>
-          <a:p>
-            <a:pPr algn="ctr"/>
-            <a:r>
-              <a:rPr sz="1600" b="1" i="0">
-                <a:solidFill>
-                  <a:srgbClr val="FFFFFF"/>
-                </a:solidFill>
-                <a:latin typeface="Calibri"/>
-              </a:rPr>
-              <a:t>3</a:t>
-            </a:r>
-          </a:p>
-        </p:txBody>
-      </p:sp>
-      <p:sp>
-        <p:nvSpPr>
-          <p:cNvPr id="17" name="TextBox 16"/>
-          <p:cNvSpPr txBox="1"/>
-          <p:nvPr/>
-        </p:nvSpPr>
-        <p:spPr>
-          <a:xfrm>
-            <a:off x="1188720" y="4037076"/>
-            <a:ext cx="10271455" cy="886968"/>
-          </a:xfrm>
-          <a:prstGeom prst="rect">
-            <a:avLst/>
-          </a:prstGeom>
-          <a:noFill/>
-        </p:spPr>
-        <p:txBody>
-          <a:bodyPr wrap="square" anchor="ctr"/>
-          <a:lstStyle/>
-          <a:p>
-            <a:r>
-              <a:rPr sz="1500" b="1" i="0">
-                <a:solidFill>
-                  <a:srgbClr val="095292"/>
-                </a:solidFill>
-                <a:latin typeface="Calibri"/>
-              </a:rPr>
-              <a:t>Renderiza en un visor</a:t>
-            </a:r>
-          </a:p>
-          <a:p>
-            <a:pPr>
-              <a:spcBef>
-                <a:spcPts val="200"/>
-              </a:spcBef>
-            </a:pPr>
-            <a:r>
-              <a:rPr sz="1300" b="0" i="0">
-                <a:solidFill>
-                  <a:srgbClr val="333333"/>
-                </a:solidFill>
-                <a:latin typeface="Calibri"/>
-              </a:rPr>
-              <a:t>Pega el código en un visor Mermaid (mermaid.live o la vista previa de tu editor) y míralo dibujado. Si no renderiza, corrige ahí: un end faltante o un rótulo sin comillas.</a:t>
-            </a:r>
-          </a:p>
-        </p:txBody>
-      </p:sp>
-      <p:sp>
-        <p:nvSpPr>
-          <p:cNvPr id="18" name="Rounded Rectangle 17"/>
-          <p:cNvSpPr/>
-          <p:nvPr/>
-        </p:nvSpPr>
-        <p:spPr>
-          <a:xfrm>
-            <a:off x="457200" y="5088636"/>
-            <a:ext cx="11277295" cy="1051560"/>
-          </a:xfrm>
-          <a:prstGeom prst="roundRect">
-            <a:avLst>
-              <a:gd name="adj" fmla="val 12000"/>
-            </a:avLst>
-          </a:prstGeom>
-          <a:solidFill>
-            <a:srgbClr val="E8F4FA"/>
-          </a:solidFill>
-          <a:ln>
-            <a:noFill/>
-          </a:ln>
-        </p:spPr>
-        <p:style>
-          <a:lnRef idx="1">
-            <a:schemeClr val="accent1"/>
-          </a:lnRef>
-          <a:fillRef idx="3">
-            <a:schemeClr val="accent1"/>
-          </a:fillRef>
-          <a:effectRef idx="2">
-            <a:schemeClr val="accent1"/>
-          </a:effectRef>
-          <a:fontRef idx="minor">
-            <a:schemeClr val="lt1"/>
-          </a:fontRef>
-        </p:style>
-        <p:txBody>
-          <a:bodyPr rtlCol="0" anchor="ctr"/>
-          <a:lstStyle/>
-          <a:p>
-            <a:pPr algn="ctr"/>
-          </a:p>
-        </p:txBody>
-      </p:sp>
-      <p:sp>
-        <p:nvSpPr>
-          <p:cNvPr id="19" name="Rounded Rectangle 18"/>
-          <p:cNvSpPr/>
-          <p:nvPr/>
-        </p:nvSpPr>
-        <p:spPr>
-          <a:xfrm>
-            <a:off x="594360" y="5394960"/>
-            <a:ext cx="438912" cy="438912"/>
-          </a:xfrm>
-          <a:prstGeom prst="roundRect">
-            <a:avLst>
-              <a:gd name="adj" fmla="val 12000"/>
-            </a:avLst>
-          </a:prstGeom>
-          <a:solidFill>
-            <a:srgbClr val="095292"/>
-          </a:solidFill>
-          <a:ln>
-            <a:noFill/>
-          </a:ln>
-        </p:spPr>
-        <p:style>
-          <a:lnRef idx="1">
-            <a:schemeClr val="accent1"/>
-          </a:lnRef>
-          <a:fillRef idx="3">
-            <a:schemeClr val="accent1"/>
-          </a:fillRef>
-          <a:effectRef idx="2">
-            <a:schemeClr val="accent1"/>
-          </a:effectRef>
-          <a:fontRef idx="minor">
-            <a:schemeClr val="lt1"/>
-          </a:fontRef>
-        </p:style>
-        <p:txBody>
-          <a:bodyPr rtlCol="0" anchor="ctr"/>
-          <a:lstStyle/>
-          <a:p>
-            <a:pPr algn="ctr"/>
-          </a:p>
-        </p:txBody>
-      </p:sp>
-      <p:sp>
-        <p:nvSpPr>
-          <p:cNvPr id="20" name="TextBox 19"/>
-          <p:cNvSpPr txBox="1"/>
-          <p:nvPr/>
-        </p:nvSpPr>
-        <p:spPr>
-          <a:xfrm>
-            <a:off x="594360" y="5394960"/>
-            <a:ext cx="438912" cy="438912"/>
-          </a:xfrm>
-          <a:prstGeom prst="rect">
-            <a:avLst/>
-          </a:prstGeom>
-          <a:noFill/>
-        </p:spPr>
-        <p:txBody>
-          <a:bodyPr wrap="square" anchor="ctr"/>
-          <a:lstStyle/>
-          <a:p>
-            <a:pPr algn="ctr"/>
-            <a:r>
-              <a:rPr sz="1600" b="1" i="0">
-                <a:solidFill>
-                  <a:srgbClr val="FFFFFF"/>
-                </a:solidFill>
-                <a:latin typeface="Calibri"/>
-              </a:rPr>
-              <a:t>4</a:t>
-            </a:r>
-          </a:p>
-        </p:txBody>
-      </p:sp>
-      <p:sp>
-        <p:nvSpPr>
-          <p:cNvPr id="21" name="TextBox 20"/>
-          <p:cNvSpPr txBox="1"/>
-          <p:nvPr/>
-        </p:nvSpPr>
-        <p:spPr>
-          <a:xfrm>
-            <a:off x="1188720" y="5180076"/>
-            <a:ext cx="10271455" cy="886968"/>
-          </a:xfrm>
-          <a:prstGeom prst="rect">
-            <a:avLst/>
-          </a:prstGeom>
-          <a:noFill/>
-        </p:spPr>
-        <p:txBody>
-          <a:bodyPr wrap="square" anchor="ctr"/>
-          <a:lstStyle/>
-          <a:p>
-            <a:r>
-              <a:rPr sz="1500" b="1" i="0">
-                <a:solidFill>
-                  <a:srgbClr val="095292"/>
-                </a:solidFill>
-                <a:latin typeface="Calibri"/>
-              </a:rPr>
-              <a:t>Guarda código e imagen</a:t>
-            </a:r>
-          </a:p>
-          <a:p>
-            <a:pPr>
-              <a:spcBef>
-                <a:spcPts val="200"/>
-              </a:spcBef>
-            </a:pPr>
-            <a:r>
-              <a:rPr sz="1300" b="0" i="0">
-                <a:solidFill>
-                  <a:srgbClr val="333333"/>
-                </a:solidFill>
-                <a:latin typeface="Calibri"/>
-              </a:rPr>
-              <a:t>El código es la fuente del diagrama: guárdalo con tu proyecto junto con el PNG exportado.</a:t>
-            </a:r>
-          </a:p>
-        </p:txBody>
-      </p:sp>
-      <p:sp>
-        <p:nvSpPr>
-          <p:cNvPr id="22" name="TextBox 21"/>
-          <p:cNvSpPr txBox="1"/>
-          <p:nvPr/>
-        </p:nvSpPr>
-        <p:spPr>
-          <a:xfrm>
-            <a:off x="11185855" y="6473952"/>
-            <a:ext cx="640080" cy="274320"/>
-          </a:xfrm>
-          <a:prstGeom prst="rect">
-            <a:avLst/>
-          </a:prstGeom>
-          <a:noFill/>
-        </p:spPr>
-        <p:txBody>
-          <a:bodyPr wrap="square">
-            <a:spAutoFit/>
-          </a:bodyPr>
-          <a:lstStyle/>
-          <a:p>
-            <a:pPr algn="r"/>
-            <a:r>
-              <a:rPr sz="1100" b="0" i="0">
-                <a:solidFill>
-                  <a:srgbClr val="666666"/>
-                </a:solidFill>
-                <a:latin typeface="Calibri"/>
-              </a:rPr>
-              <a:t>23</a:t>
-            </a:r>
-          </a:p>
-        </p:txBody>
-      </p:sp>
-    </p:spTree>
-  </p:cSld>
-  <p:clrMapOvr>
-    <a:masterClrMapping/>
-  </p:clrMapOvr>
-</p:sld>
-</file>
-
-<file path=ppt/slides/slide24.xml><?xml version="1.0" encoding="utf-8"?>
-<p:sld xmlns:a="http://schemas.openxmlformats.org/drawingml/2006/main" xmlns:p="http://schemas.openxmlformats.org/presentationml/2006/main" xmlns:r="http://schemas.openxmlformats.org/officeDocument/2006/relationships">
-  <p:cSld>
-    <p:bg>
-      <p:bgPr>
-        <a:solidFill>
-          <a:srgbClr val="FFFFFF"/>
-        </a:solidFill>
-        <a:effectLst/>
-      </p:bgPr>
-    </p:bg>
-    <p:spTree>
-      <p:nvGrpSpPr>
-        <p:cNvPr id="1" name=""/>
-        <p:cNvGrpSpPr/>
-        <p:nvPr/>
-      </p:nvGrpSpPr>
-      <p:grpSpPr/>
-      <p:sp>
-        <p:nvSpPr>
-          <p:cNvPr id="2" name="Rectangle 1"/>
-          <p:cNvSpPr/>
-          <p:nvPr/>
-        </p:nvSpPr>
-        <p:spPr>
-          <a:xfrm>
-            <a:off x="0" y="0"/>
             <a:ext cx="12191695" cy="164592"/>
           </a:xfrm>
           <a:prstGeom prst="rect">
@@ -11608,7 +10739,7 @@
                 </a:solidFill>
                 <a:latin typeface="Calibri"/>
               </a:rPr>
-              <a:t>Que es arquitectura cloud (mapa mental) (1/4)</a:t>
+              <a:t>Que es arquitectura cloud (mapa mental) (1/3)</a:t>
             </a:r>
           </a:p>
         </p:txBody>
@@ -11712,22 +10843,6 @@
                 <a:latin typeface="Calibri"/>
               </a:rPr>
               <a:t>–   El stack es la lista de tecnologias concretas; la arquitectura es la estructura y las razones.</a:t>
-            </a:r>
-          </a:p>
-          <a:p>
-            <a:pPr>
-              <a:spcAft>
-                <a:spcPts val="800"/>
-              </a:spcAft>
-            </a:pPr>
-            <a:r>
-              <a:rPr sz="2000" b="0" i="0">
-                <a:solidFill>
-                  <a:srgbClr val="333333"/>
-                </a:solidFill>
-                <a:latin typeface="Calibri"/>
-              </a:rPr>
-              <a:t>–   Dos proyectos pueden usar el mismo stack y tener arquitecturas opuestas: uno con un solo proceso que hace todo, otro con tres servicios que se comunican por red.</a:t>
             </a:r>
           </a:p>
         </p:txBody>

</xml_diff>

<commit_message>
BD II Clase 4: animaciones con pasos logicos e ilustraciones generadas; Pexels retirado
Co-Authored-By: Claude Opus 5.5 <noreply@anthropic.com>
</commit_message>
<xml_diff>
--- a/Arquitectura de Sistemas Computacionales/Clases/Clase 1 - Introduccion a arquitecturas cloud/Presentacion.pptx
+++ b/Arquitectura de Sistemas Computacionales/Clases/Clase 1 - Introduccion a arquitecturas cloud/Presentacion.pptx
@@ -631,48 +631,6 @@
           <a:lstStyle/>
           <a:p>
             <a:r>
-              <a:t>TEXTO COMPLETO DE LA LÁMINA (se proyecta resumido):</a:t>
-            </a:r>
-          </a:p>
-          <a:p/>
-          <a:p>
-            <a:r>
-              <a:t>Arquitectura = componentes + relaciones + despliegue + calidad (seguridad, escala, costo).</a:t>
-            </a:r>
-          </a:p>
-          <a:p/>
-          <a:p>
-            <a:r>
-              <a:t>Cloud: recursos bajo demanda, multi-tenant, API/automatización.</a:t>
-            </a:r>
-          </a:p>
-          <a:p/>
-          <a:p>
-            <a:r>
-              <a:t>Para CloudLite App: no «comprar servidores»; diseñar capas y simular en labs gratis.</a:t>
-            </a:r>
-          </a:p>
-          <a:p/>
-          <a:p>
-            <a:r>
-              <a:t>Bloques tipicos: cliente → API → lógica → datos → observabilidad.</a:t>
-            </a:r>
-          </a:p>
-          <a:p/>
-          <a:p>
-            <a:r>
-              <a:t>Una decisión es arquitectónica si es cara de revertir: cambiar la base de datos a los 3 meses lo es; cambiar el color de un botón, no.</a:t>
-            </a:r>
-          </a:p>
-          <a:p/>
-          <a:p>
-            <a:r>
-              <a:t>Atributos de calidad del curso: rendimiento, disponibilidad, seguridad y costo.</a:t>
-            </a:r>
-          </a:p>
-          <a:p/>
-          <a:p>
-            <a:r>
               <a:t>DESARROLLO (para explicarlo, no se proyecta):</a:t>
             </a:r>
           </a:p>
@@ -875,48 +833,6 @@
           <a:lstStyle/>
           <a:p>
             <a:r>
-              <a:t>TEXTO COMPLETO DE LA LÁMINA (se proyecta resumido):</a:t>
-            </a:r>
-          </a:p>
-          <a:p/>
-          <a:p>
-            <a:r>
-              <a:t>Aplicación web/API de un dominio realista (citas, academia, inventario liviano…).</a:t>
-            </a:r>
-          </a:p>
-          <a:p/>
-          <a:p>
-            <a:r>
-              <a:t>Lo que se construye en el semestre: diagramas + contenedor (lab) + CI/CD conceptual + informe.</a:t>
-            </a:r>
-          </a:p>
-          <a:p/>
-          <a:p>
-            <a:r>
-              <a:t>Hoy solo: problema + capacidades + boceto de contexto.</a:t>
-            </a:r>
-          </a:p>
-          <a:p/>
-          <a:p>
-            <a:r>
-              <a:t>Sin AWS/GCP/Oracle: draw.io, Killercoda, GitHub Actions.</a:t>
-            </a:r>
-          </a:p>
-          <a:p/>
-          <a:p>
-            <a:r>
-              <a:t>Ejemplo de dominio: CloudLite Turnos — el cliente reserva turno, el barbero ve su agenda, el administrador fija horarios.</a:t>
-            </a:r>
-          </a:p>
-          <a:p/>
-          <a:p>
-            <a:r>
-              <a:t>Error común: un dominio infinito (una red social completa) no cabe en un semestre.</a:t>
-            </a:r>
-          </a:p>
-          <a:p/>
-          <a:p>
-            <a:r>
               <a:t>DESARROLLO (para explicarlo, no se proyecta):</a:t>
             </a:r>
           </a:p>
@@ -1039,48 +955,6 @@
         <p:txBody>
           <a:bodyPr/>
           <a:lstStyle/>
-          <a:p>
-            <a:r>
-              <a:t>TEXTO COMPLETO DE LA LÁMINA (se proyecta resumido):</a:t>
-            </a:r>
-          </a:p>
-          <a:p/>
-          <a:p>
-            <a:r>
-              <a:t>1) Actor y problema. 2) Capacidades. 3) Contenedores lógicos. 4) Datos. 5) Riesgos.</a:t>
-            </a:r>
-          </a:p>
-          <a:p/>
-          <a:p>
-            <a:r>
-              <a:t>Ejemplo: *AgendaU* — estudiantes reservan tutoría; API + auth + agenda + notificaciones.</a:t>
-            </a:r>
-          </a:p>
-          <a:p/>
-          <a:p>
-            <a:r>
-              <a:t>Pregunta de diseño: ¿qué es núcleo vs satélite?</a:t>
-            </a:r>
-          </a:p>
-          <a:p/>
-          <a:p>
-            <a:r>
-              <a:t>Salida: diagrama C4 Context (sistema + actores externos).</a:t>
-            </a:r>
-          </a:p>
-          <a:p/>
-          <a:p>
-            <a:r>
-              <a:t>Núcleo = lo que diferencia al dominio (la agenda de turnos); satélite = lo genérico que se delega (correo, autenticación).</a:t>
-            </a:r>
-          </a:p>
-          <a:p/>
-          <a:p>
-            <a:r>
-              <a:t>Error común: empezar por la tecnología («usaremos Kubernetes») antes de nombrar actor y problema.</a:t>
-            </a:r>
-          </a:p>
-          <a:p/>
           <a:p>
             <a:r>
               <a:t>DESARROLLO (para explicarlo, no se proyecta):</a:t>
@@ -6843,118 +6717,14 @@
       </p:sp>
       <p:sp>
         <p:nvSpPr>
-          <p:cNvPr id="5" name="Rounded Rectangle 4"/>
-          <p:cNvSpPr/>
-          <p:nvPr/>
-        </p:nvSpPr>
-        <p:spPr>
-          <a:xfrm>
-            <a:off x="5797149" y="1573813"/>
-            <a:ext cx="6010497" cy="4057845"/>
-          </a:xfrm>
-          <a:prstGeom prst="roundRect">
-            <a:avLst>
-              <a:gd name="adj" fmla="val 4000"/>
-            </a:avLst>
-          </a:prstGeom>
-          <a:solidFill>
-            <a:srgbClr val="E8EEF4"/>
-          </a:solidFill>
-          <a:ln>
-            <a:noFill/>
-          </a:ln>
-        </p:spPr>
-        <p:style>
-          <a:lnRef idx="1">
-            <a:schemeClr val="accent1"/>
-          </a:lnRef>
-          <a:fillRef idx="3">
-            <a:schemeClr val="accent1"/>
-          </a:fillRef>
-          <a:effectRef idx="2">
-            <a:schemeClr val="accent1"/>
-          </a:effectRef>
-          <a:fontRef idx="minor">
-            <a:schemeClr val="lt1"/>
-          </a:fontRef>
-        </p:style>
-        <p:txBody>
-          <a:bodyPr rtlCol="0" anchor="ctr"/>
-          <a:lstStyle/>
-          <a:p>
-            <a:pPr algn="ctr"/>
-          </a:p>
-        </p:txBody>
-      </p:sp>
-      <p:pic>
-        <p:nvPicPr>
-          <p:cNvPr id="6" name="Picture 5" descr="students-learning-laptops-classroom.jpg"/>
-          <p:cNvPicPr>
-            <a:picLocks noChangeAspect="1"/>
-          </p:cNvPicPr>
-          <p:nvPr/>
-        </p:nvPicPr>
-        <p:blipFill>
-          <a:blip r:embed="rId2"/>
-          <a:stretch>
-            <a:fillRect/>
-          </a:stretch>
-        </p:blipFill>
-        <p:spPr>
-          <a:xfrm>
-            <a:off x="5870301" y="1646965"/>
-            <a:ext cx="5864193" cy="3911541"/>
-          </a:xfrm>
-          <a:prstGeom prst="rect">
-            <a:avLst/>
-          </a:prstGeom>
-        </p:spPr>
-      </p:pic>
-      <p:sp>
-        <p:nvSpPr>
-          <p:cNvPr id="7" name="TextBox 6"/>
+          <p:cNvPr id="5" name="TextBox 4"/>
           <p:cNvSpPr txBox="1"/>
           <p:nvPr/>
         </p:nvSpPr>
         <p:spPr>
           <a:xfrm>
-            <a:off x="5870301" y="5961888"/>
-            <a:ext cx="5864193" cy="320040"/>
-          </a:xfrm>
-          <a:prstGeom prst="rect">
-            <a:avLst/>
-          </a:prstGeom>
-          <a:noFill/>
-        </p:spPr>
-        <p:txBody>
-          <a:bodyPr wrap="square">
-            <a:spAutoFit/>
-          </a:bodyPr>
-          <a:lstStyle/>
-          <a:p>
-            <a:pPr algn="ctr"/>
-            <a:r>
-              <a:rPr sz="1100" b="0" i="1">
-                <a:solidFill>
-                  <a:srgbClr val="666666"/>
-                </a:solidFill>
-                <a:latin typeface="Calibri"/>
-              </a:rPr>
-              <a:t>Foto: Mikhail Nilov · Pexels</a:t>
-            </a:r>
-          </a:p>
-        </p:txBody>
-      </p:sp>
-      <p:sp>
-        <p:nvSpPr>
-          <p:cNvPr id="8" name="TextBox 7"/>
-          <p:cNvSpPr txBox="1"/>
-          <p:nvPr/>
-        </p:nvSpPr>
-        <p:spPr>
-          <a:xfrm>
-            <a:off x="457200" y="1353312"/>
-            <a:ext cx="5093061" cy="5047488"/>
+            <a:off x="457200" y="1170432"/>
+            <a:ext cx="11277295" cy="5230368"/>
           </a:xfrm>
           <a:prstGeom prst="rect">
             <a:avLst/>
@@ -7054,7 +6824,7 @@
       </p:sp>
       <p:sp>
         <p:nvSpPr>
-          <p:cNvPr id="9" name="TextBox 8"/>
+          <p:cNvPr id="6" name="TextBox 5"/>
           <p:cNvSpPr txBox="1"/>
           <p:nvPr/>
         </p:nvSpPr>
@@ -7775,118 +7545,14 @@
       </p:sp>
       <p:sp>
         <p:nvSpPr>
-          <p:cNvPr id="5" name="Rounded Rectangle 4"/>
-          <p:cNvSpPr/>
-          <p:nvPr/>
-        </p:nvSpPr>
-        <p:spPr>
-          <a:xfrm>
-            <a:off x="5797149" y="1580051"/>
-            <a:ext cx="6010497" cy="4045368"/>
-          </a:xfrm>
-          <a:prstGeom prst="roundRect">
-            <a:avLst>
-              <a:gd name="adj" fmla="val 4000"/>
-            </a:avLst>
-          </a:prstGeom>
-          <a:solidFill>
-            <a:srgbClr val="E8EEF4"/>
-          </a:solidFill>
-          <a:ln>
-            <a:noFill/>
-          </a:ln>
-        </p:spPr>
-        <p:style>
-          <a:lnRef idx="1">
-            <a:schemeClr val="accent1"/>
-          </a:lnRef>
-          <a:fillRef idx="3">
-            <a:schemeClr val="accent1"/>
-          </a:fillRef>
-          <a:effectRef idx="2">
-            <a:schemeClr val="accent1"/>
-          </a:effectRef>
-          <a:fontRef idx="minor">
-            <a:schemeClr val="lt1"/>
-          </a:fontRef>
-        </p:style>
-        <p:txBody>
-          <a:bodyPr rtlCol="0" anchor="ctr"/>
-          <a:lstStyle/>
-          <a:p>
-            <a:pPr algn="ctr"/>
-          </a:p>
-        </p:txBody>
-      </p:sp>
-      <p:pic>
-        <p:nvPicPr>
-          <p:cNvPr id="6" name="Picture 5" descr="cloud-computing-data-center.jpg"/>
-          <p:cNvPicPr>
-            <a:picLocks noChangeAspect="1"/>
-          </p:cNvPicPr>
-          <p:nvPr/>
-        </p:nvPicPr>
-        <p:blipFill>
-          <a:blip r:embed="rId2"/>
-          <a:stretch>
-            <a:fillRect/>
-          </a:stretch>
-        </p:blipFill>
-        <p:spPr>
-          <a:xfrm>
-            <a:off x="5870301" y="1653203"/>
-            <a:ext cx="5864193" cy="3899064"/>
-          </a:xfrm>
-          <a:prstGeom prst="rect">
-            <a:avLst/>
-          </a:prstGeom>
-        </p:spPr>
-      </p:pic>
-      <p:sp>
-        <p:nvSpPr>
-          <p:cNvPr id="7" name="TextBox 6"/>
+          <p:cNvPr id="5" name="TextBox 4"/>
           <p:cNvSpPr txBox="1"/>
           <p:nvPr/>
         </p:nvSpPr>
         <p:spPr>
           <a:xfrm>
-            <a:off x="5870301" y="5961888"/>
-            <a:ext cx="5864193" cy="320040"/>
-          </a:xfrm>
-          <a:prstGeom prst="rect">
-            <a:avLst/>
-          </a:prstGeom>
-          <a:noFill/>
-        </p:spPr>
-        <p:txBody>
-          <a:bodyPr wrap="square">
-            <a:spAutoFit/>
-          </a:bodyPr>
-          <a:lstStyle/>
-          <a:p>
-            <a:pPr algn="ctr"/>
-            <a:r>
-              <a:rPr sz="1100" b="0" i="1">
-                <a:solidFill>
-                  <a:srgbClr val="666666"/>
-                </a:solidFill>
-                <a:latin typeface="Calibri"/>
-              </a:rPr>
-              <a:t>Foto: panumas nikhomkhai · Pexels</a:t>
-            </a:r>
-          </a:p>
-        </p:txBody>
-      </p:sp>
-      <p:sp>
-        <p:nvSpPr>
-          <p:cNvPr id="8" name="TextBox 7"/>
-          <p:cNvSpPr txBox="1"/>
-          <p:nvPr/>
-        </p:nvSpPr>
-        <p:spPr>
-          <a:xfrm>
-            <a:off x="457200" y="1353312"/>
-            <a:ext cx="5093061" cy="5047488"/>
+            <a:off x="457200" y="1170432"/>
+            <a:ext cx="11277295" cy="5230368"/>
           </a:xfrm>
           <a:prstGeom prst="rect">
             <a:avLst/>
@@ -8016,11 +7682,133 @@
               <a:t>–   Bloques tipicos: cliente → API → lógica → datos → observabilidad.</a:t>
             </a:r>
           </a:p>
-        </p:txBody>
-      </p:sp>
-      <p:sp>
-        <p:nvSpPr>
-          <p:cNvPr id="9" name="TextBox 8"/>
+          <a:p>
+            <a:pPr>
+              <a:spcAft>
+                <a:spcPts val="800"/>
+              </a:spcAft>
+            </a:pPr>
+            <a:r>
+              <a:rPr sz="2000" b="0" i="0">
+                <a:solidFill>
+                  <a:srgbClr val="333333"/>
+                </a:solidFill>
+                <a:latin typeface="Calibri"/>
+              </a:rPr>
+              <a:t>–   Una decisión es </a:t>
+            </a:r>
+            <a:r>
+              <a:rPr sz="2000" b="1" i="0">
+                <a:solidFill>
+                  <a:srgbClr val="333333"/>
+                </a:solidFill>
+                <a:latin typeface="Calibri"/>
+              </a:rPr>
+              <a:t>arquitectónica</a:t>
+            </a:r>
+            <a:r>
+              <a:rPr sz="2000" b="0" i="0">
+                <a:solidFill>
+                  <a:srgbClr val="333333"/>
+                </a:solidFill>
+                <a:latin typeface="Calibri"/>
+              </a:rPr>
+              <a:t> si es cara de revertir: cambiar la base de datos a los 3 meses lo es; cambiar el color de un botón, no.</a:t>
+            </a:r>
+          </a:p>
+          <a:p>
+            <a:pPr>
+              <a:spcAft>
+                <a:spcPts val="800"/>
+              </a:spcAft>
+            </a:pPr>
+            <a:r>
+              <a:rPr sz="2000" b="0" i="0">
+                <a:solidFill>
+                  <a:srgbClr val="333333"/>
+                </a:solidFill>
+                <a:latin typeface="Calibri"/>
+              </a:rPr>
+              <a:t>–   Atributos de calidad del curso: </a:t>
+            </a:r>
+            <a:r>
+              <a:rPr sz="2000" b="1" i="0">
+                <a:solidFill>
+                  <a:srgbClr val="333333"/>
+                </a:solidFill>
+                <a:latin typeface="Calibri"/>
+              </a:rPr>
+              <a:t>rendimiento</a:t>
+            </a:r>
+            <a:r>
+              <a:rPr sz="2000" b="0" i="0">
+                <a:solidFill>
+                  <a:srgbClr val="333333"/>
+                </a:solidFill>
+                <a:latin typeface="Calibri"/>
+              </a:rPr>
+              <a:t>, </a:t>
+            </a:r>
+            <a:r>
+              <a:rPr sz="2000" b="1" i="0">
+                <a:solidFill>
+                  <a:srgbClr val="333333"/>
+                </a:solidFill>
+                <a:latin typeface="Calibri"/>
+              </a:rPr>
+              <a:t>disponibilidad</a:t>
+            </a:r>
+            <a:r>
+              <a:rPr sz="2000" b="0" i="0">
+                <a:solidFill>
+                  <a:srgbClr val="333333"/>
+                </a:solidFill>
+                <a:latin typeface="Calibri"/>
+              </a:rPr>
+              <a:t>, </a:t>
+            </a:r>
+            <a:r>
+              <a:rPr sz="2000" b="1" i="0">
+                <a:solidFill>
+                  <a:srgbClr val="333333"/>
+                </a:solidFill>
+                <a:latin typeface="Calibri"/>
+              </a:rPr>
+              <a:t>seguridad</a:t>
+            </a:r>
+            <a:r>
+              <a:rPr sz="2000" b="0" i="0">
+                <a:solidFill>
+                  <a:srgbClr val="333333"/>
+                </a:solidFill>
+                <a:latin typeface="Calibri"/>
+              </a:rPr>
+              <a:t> y </a:t>
+            </a:r>
+            <a:r>
+              <a:rPr sz="2000" b="1" i="0">
+                <a:solidFill>
+                  <a:srgbClr val="333333"/>
+                </a:solidFill>
+                <a:latin typeface="Calibri"/>
+              </a:rPr>
+              <a:t>costo</a:t>
+            </a:r>
+            <a:r>
+              <a:rPr sz="2000" b="0" i="0">
+                <a:solidFill>
+                  <a:srgbClr val="333333"/>
+                </a:solidFill>
+                <a:latin typeface="Calibri"/>
+              </a:rPr>
+              <a:t>.</a:t>
+            </a:r>
+          </a:p>
+        </p:txBody>
+      </p:sp>
+      <p:sp>
+        <p:nvSpPr>
+          <p:cNvPr id="6" name="TextBox 5"/>
           <p:cNvSpPr txBox="1"/>
           <p:nvPr/>
         </p:nvSpPr>
@@ -8201,118 +7989,14 @@
       </p:sp>
       <p:sp>
         <p:nvSpPr>
-          <p:cNvPr id="5" name="Rounded Rectangle 4"/>
-          <p:cNvSpPr/>
-          <p:nvPr/>
-        </p:nvSpPr>
-        <p:spPr>
-          <a:xfrm>
-            <a:off x="5797149" y="1573813"/>
-            <a:ext cx="6010497" cy="4057845"/>
-          </a:xfrm>
-          <a:prstGeom prst="roundRect">
-            <a:avLst>
-              <a:gd name="adj" fmla="val 4000"/>
-            </a:avLst>
-          </a:prstGeom>
-          <a:solidFill>
-            <a:srgbClr val="E8EEF4"/>
-          </a:solidFill>
-          <a:ln>
-            <a:noFill/>
-          </a:ln>
-        </p:spPr>
-        <p:style>
-          <a:lnRef idx="1">
-            <a:schemeClr val="accent1"/>
-          </a:lnRef>
-          <a:fillRef idx="3">
-            <a:schemeClr val="accent1"/>
-          </a:fillRef>
-          <a:effectRef idx="2">
-            <a:schemeClr val="accent1"/>
-          </a:effectRef>
-          <a:fontRef idx="minor">
-            <a:schemeClr val="lt1"/>
-          </a:fontRef>
-        </p:style>
-        <p:txBody>
-          <a:bodyPr rtlCol="0" anchor="ctr"/>
-          <a:lstStyle/>
-          <a:p>
-            <a:pPr algn="ctr"/>
-          </a:p>
-        </p:txBody>
-      </p:sp>
-      <p:pic>
-        <p:nvPicPr>
-          <p:cNvPr id="6" name="Picture 5" descr="appointment-booking-app-smartphone.jpg"/>
-          <p:cNvPicPr>
-            <a:picLocks noChangeAspect="1"/>
-          </p:cNvPicPr>
-          <p:nvPr/>
-        </p:nvPicPr>
-        <p:blipFill>
-          <a:blip r:embed="rId2"/>
-          <a:stretch>
-            <a:fillRect/>
-          </a:stretch>
-        </p:blipFill>
-        <p:spPr>
-          <a:xfrm>
-            <a:off x="5870301" y="1646965"/>
-            <a:ext cx="5864193" cy="3911541"/>
-          </a:xfrm>
-          <a:prstGeom prst="rect">
-            <a:avLst/>
-          </a:prstGeom>
-        </p:spPr>
-      </p:pic>
-      <p:sp>
-        <p:nvSpPr>
-          <p:cNvPr id="7" name="TextBox 6"/>
+          <p:cNvPr id="5" name="TextBox 4"/>
           <p:cNvSpPr txBox="1"/>
           <p:nvPr/>
         </p:nvSpPr>
         <p:spPr>
           <a:xfrm>
-            <a:off x="5870301" y="5961888"/>
-            <a:ext cx="5864193" cy="320040"/>
-          </a:xfrm>
-          <a:prstGeom prst="rect">
-            <a:avLst/>
-          </a:prstGeom>
-          <a:noFill/>
-        </p:spPr>
-        <p:txBody>
-          <a:bodyPr wrap="square">
-            <a:spAutoFit/>
-          </a:bodyPr>
-          <a:lstStyle/>
-          <a:p>
-            <a:pPr algn="ctr"/>
-            <a:r>
-              <a:rPr sz="1100" b="0" i="1">
-                <a:solidFill>
-                  <a:srgbClr val="666666"/>
-                </a:solidFill>
-                <a:latin typeface="Calibri"/>
-              </a:rPr>
-              <a:t>Foto: HUUM  │sauna heaters · Pexels</a:t>
-            </a:r>
-          </a:p>
-        </p:txBody>
-      </p:sp>
-      <p:sp>
-        <p:nvSpPr>
-          <p:cNvPr id="8" name="TextBox 7"/>
-          <p:cNvSpPr txBox="1"/>
-          <p:nvPr/>
-        </p:nvSpPr>
-        <p:spPr>
-          <a:xfrm>
-            <a:off x="457200" y="1353312"/>
-            <a:ext cx="5093061" cy="5047488"/>
+            <a:off x="457200" y="1170432"/>
+            <a:ext cx="11277295" cy="5230368"/>
           </a:xfrm>
           <a:prstGeom prst="rect">
             <a:avLst/>
@@ -8406,11 +8090,61 @@
               <a:t>–   Sin AWS/GCP/Oracle: draw.io, Killercoda, GitHub Actions.</a:t>
             </a:r>
           </a:p>
-        </p:txBody>
-      </p:sp>
-      <p:sp>
-        <p:nvSpPr>
-          <p:cNvPr id="9" name="TextBox 8"/>
+          <a:p>
+            <a:pPr>
+              <a:spcAft>
+                <a:spcPts val="800"/>
+              </a:spcAft>
+            </a:pPr>
+            <a:r>
+              <a:rPr sz="2000" b="0" i="0">
+                <a:solidFill>
+                  <a:srgbClr val="333333"/>
+                </a:solidFill>
+                <a:latin typeface="Calibri"/>
+              </a:rPr>
+              <a:t>–   Ejemplo de dominio: </a:t>
+            </a:r>
+            <a:r>
+              <a:rPr sz="2000" b="1" i="0">
+                <a:solidFill>
+                  <a:srgbClr val="333333"/>
+                </a:solidFill>
+                <a:latin typeface="Calibri"/>
+              </a:rPr>
+              <a:t>La app de turnos</a:t>
+            </a:r>
+            <a:r>
+              <a:rPr sz="2000" b="0" i="0">
+                <a:solidFill>
+                  <a:srgbClr val="333333"/>
+                </a:solidFill>
+                <a:latin typeface="Calibri"/>
+              </a:rPr>
+              <a:t> — el cliente reserva turno, el barbero ve su agenda, el administrador fija horarios.</a:t>
+            </a:r>
+          </a:p>
+          <a:p>
+            <a:pPr>
+              <a:spcAft>
+                <a:spcPts val="800"/>
+              </a:spcAft>
+            </a:pPr>
+            <a:r>
+              <a:rPr sz="2000" b="0" i="0">
+                <a:solidFill>
+                  <a:srgbClr val="333333"/>
+                </a:solidFill>
+                <a:latin typeface="Calibri"/>
+              </a:rPr>
+              <a:t>–   Error común: un dominio infinito (una red social completa) no cabe en un semestre.</a:t>
+            </a:r>
+          </a:p>
+        </p:txBody>
+      </p:sp>
+      <p:sp>
+        <p:nvSpPr>
+          <p:cNvPr id="6" name="TextBox 5"/>
           <p:cNvSpPr txBox="1"/>
           <p:nvPr/>
         </p:nvSpPr>
@@ -8591,118 +8325,14 @@
       </p:sp>
       <p:sp>
         <p:nvSpPr>
-          <p:cNvPr id="5" name="Rounded Rectangle 4"/>
-          <p:cNvSpPr/>
-          <p:nvPr/>
-        </p:nvSpPr>
-        <p:spPr>
-          <a:xfrm>
-            <a:off x="5797149" y="1573813"/>
-            <a:ext cx="6010497" cy="4057845"/>
-          </a:xfrm>
-          <a:prstGeom prst="roundRect">
-            <a:avLst>
-              <a:gd name="adj" fmla="val 4000"/>
-            </a:avLst>
-          </a:prstGeom>
-          <a:solidFill>
-            <a:srgbClr val="E8EEF4"/>
-          </a:solidFill>
-          <a:ln>
-            <a:noFill/>
-          </a:ln>
-        </p:spPr>
-        <p:style>
-          <a:lnRef idx="1">
-            <a:schemeClr val="accent1"/>
-          </a:lnRef>
-          <a:fillRef idx="3">
-            <a:schemeClr val="accent1"/>
-          </a:fillRef>
-          <a:effectRef idx="2">
-            <a:schemeClr val="accent1"/>
-          </a:effectRef>
-          <a:fontRef idx="minor">
-            <a:schemeClr val="lt1"/>
-          </a:fontRef>
-        </p:style>
-        <p:txBody>
-          <a:bodyPr rtlCol="0" anchor="ctr"/>
-          <a:lstStyle/>
-          <a:p>
-            <a:pPr algn="ctr"/>
-          </a:p>
-        </p:txBody>
-      </p:sp>
-      <p:pic>
-        <p:nvPicPr>
-          <p:cNvPr id="6" name="Picture 5" descr="software-architect-whiteboard-diagram.jpg"/>
-          <p:cNvPicPr>
-            <a:picLocks noChangeAspect="1"/>
-          </p:cNvPicPr>
-          <p:nvPr/>
-        </p:nvPicPr>
-        <p:blipFill>
-          <a:blip r:embed="rId2"/>
-          <a:stretch>
-            <a:fillRect/>
-          </a:stretch>
-        </p:blipFill>
-        <p:spPr>
-          <a:xfrm>
-            <a:off x="5870301" y="1646965"/>
-            <a:ext cx="5864193" cy="3911541"/>
-          </a:xfrm>
-          <a:prstGeom prst="rect">
-            <a:avLst/>
-          </a:prstGeom>
-        </p:spPr>
-      </p:pic>
-      <p:sp>
-        <p:nvSpPr>
-          <p:cNvPr id="7" name="TextBox 6"/>
+          <p:cNvPr id="5" name="TextBox 4"/>
           <p:cNvSpPr txBox="1"/>
           <p:nvPr/>
         </p:nvSpPr>
         <p:spPr>
           <a:xfrm>
-            <a:off x="5870301" y="5961888"/>
-            <a:ext cx="5864193" cy="320040"/>
-          </a:xfrm>
-          <a:prstGeom prst="rect">
-            <a:avLst/>
-          </a:prstGeom>
-          <a:noFill/>
-        </p:spPr>
-        <p:txBody>
-          <a:bodyPr wrap="square">
-            <a:spAutoFit/>
-          </a:bodyPr>
-          <a:lstStyle/>
-          <a:p>
-            <a:pPr algn="ctr"/>
-            <a:r>
-              <a:rPr sz="1100" b="0" i="1">
-                <a:solidFill>
-                  <a:srgbClr val="666666"/>
-                </a:solidFill>
-                <a:latin typeface="Calibri"/>
-              </a:rPr>
-              <a:t>Foto: Startup Stock Photos · Pexels</a:t>
-            </a:r>
-          </a:p>
-        </p:txBody>
-      </p:sp>
-      <p:sp>
-        <p:nvSpPr>
-          <p:cNvPr id="8" name="TextBox 7"/>
-          <p:cNvSpPr txBox="1"/>
-          <p:nvPr/>
-        </p:nvSpPr>
-        <p:spPr>
-          <a:xfrm>
-            <a:off x="457200" y="1353312"/>
-            <a:ext cx="5093061" cy="5047488"/>
+            <a:off x="457200" y="1170432"/>
+            <a:ext cx="11277295" cy="5230368"/>
           </a:xfrm>
           <a:prstGeom prst="rect">
             <a:avLst/>
@@ -8796,11 +8426,79 @@
               <a:t>–   Salida: diagrama C4 Context (sistema + actores externos).</a:t>
             </a:r>
           </a:p>
-        </p:txBody>
-      </p:sp>
-      <p:sp>
-        <p:nvSpPr>
-          <p:cNvPr id="9" name="TextBox 8"/>
+          <a:p>
+            <a:pPr>
+              <a:spcAft>
+                <a:spcPts val="800"/>
+              </a:spcAft>
+            </a:pPr>
+            <a:r>
+              <a:rPr sz="2000" b="0" i="0">
+                <a:solidFill>
+                  <a:srgbClr val="333333"/>
+                </a:solidFill>
+                <a:latin typeface="Calibri"/>
+              </a:rPr>
+              <a:t>–   </a:t>
+            </a:r>
+            <a:r>
+              <a:rPr sz="2000" b="1" i="0">
+                <a:solidFill>
+                  <a:srgbClr val="333333"/>
+                </a:solidFill>
+                <a:latin typeface="Calibri"/>
+              </a:rPr>
+              <a:t>Núcleo</a:t>
+            </a:r>
+            <a:r>
+              <a:rPr sz="2000" b="0" i="0">
+                <a:solidFill>
+                  <a:srgbClr val="333333"/>
+                </a:solidFill>
+                <a:latin typeface="Calibri"/>
+              </a:rPr>
+              <a:t> = lo que diferencia al dominio (la agenda de turnos); </a:t>
+            </a:r>
+            <a:r>
+              <a:rPr sz="2000" b="1" i="0">
+                <a:solidFill>
+                  <a:srgbClr val="333333"/>
+                </a:solidFill>
+                <a:latin typeface="Calibri"/>
+              </a:rPr>
+              <a:t>satélite</a:t>
+            </a:r>
+            <a:r>
+              <a:rPr sz="2000" b="0" i="0">
+                <a:solidFill>
+                  <a:srgbClr val="333333"/>
+                </a:solidFill>
+                <a:latin typeface="Calibri"/>
+              </a:rPr>
+              <a:t> = lo genérico que se delega (correo, autenticación).</a:t>
+            </a:r>
+          </a:p>
+          <a:p>
+            <a:pPr>
+              <a:spcAft>
+                <a:spcPts val="800"/>
+              </a:spcAft>
+            </a:pPr>
+            <a:r>
+              <a:rPr sz="2000" b="0" i="0">
+                <a:solidFill>
+                  <a:srgbClr val="333333"/>
+                </a:solidFill>
+                <a:latin typeface="Calibri"/>
+              </a:rPr>
+              <a:t>–   Error común: empezar por la tecnología («usaremos Kubernetes») antes de nombrar actor y problema.</a:t>
+            </a:r>
+          </a:p>
+        </p:txBody>
+      </p:sp>
+      <p:sp>
+        <p:nvSpPr>
+          <p:cNvPr id="6" name="TextBox 5"/>
           <p:cNvSpPr txBox="1"/>
           <p:nvPr/>
         </p:nvSpPr>

</xml_diff>

<commit_message>
Pasos logicos e ilustraciones generadas en Arquitectura, Programacion II, Seminario e Introduccion
Co-Authored-By: Claude Opus 5.5 <noreply@anthropic.com>
</commit_message>
<xml_diff>
--- a/Arquitectura de Sistemas Computacionales/Clases/Clase 1 - Introduccion a arquitecturas cloud/Presentacion.pptx
+++ b/Arquitectura de Sistemas Computacionales/Clases/Clase 1 - Introduccion a arquitecturas cloud/Presentacion.pptx
@@ -631,6 +631,48 @@
           <a:lstStyle/>
           <a:p>
             <a:r>
+              <a:t>TEXTO COMPLETO DE LA LÁMINA (se proyecta resumido):</a:t>
+            </a:r>
+          </a:p>
+          <a:p/>
+          <a:p>
+            <a:r>
+              <a:t>Arquitectura = componentes + relaciones + despliegue + calidad (seguridad, escala, costo).</a:t>
+            </a:r>
+          </a:p>
+          <a:p/>
+          <a:p>
+            <a:r>
+              <a:t>Cloud: recursos bajo demanda, multi-tenant, API/automatización.</a:t>
+            </a:r>
+          </a:p>
+          <a:p/>
+          <a:p>
+            <a:r>
+              <a:t>Para CloudLite App: no «comprar servidores»; diseñar capas y simular en labs gratis.</a:t>
+            </a:r>
+          </a:p>
+          <a:p/>
+          <a:p>
+            <a:r>
+              <a:t>Bloques tipicos: cliente → API → lógica → datos → observabilidad.</a:t>
+            </a:r>
+          </a:p>
+          <a:p/>
+          <a:p>
+            <a:r>
+              <a:t>Una decisión es arquitectónica si es cara de revertir: cambiar la base de datos a los 3 meses lo es; cambiar el color de un botón, no.</a:t>
+            </a:r>
+          </a:p>
+          <a:p/>
+          <a:p>
+            <a:r>
+              <a:t>Atributos de calidad del curso: rendimiento, disponibilidad, seguridad y costo.</a:t>
+            </a:r>
+          </a:p>
+          <a:p/>
+          <a:p>
+            <a:r>
               <a:t>DESARROLLO (para explicarlo, no se proyecta):</a:t>
             </a:r>
           </a:p>
@@ -833,6 +875,48 @@
           <a:lstStyle/>
           <a:p>
             <a:r>
+              <a:t>TEXTO COMPLETO DE LA LÁMINA (se proyecta resumido):</a:t>
+            </a:r>
+          </a:p>
+          <a:p/>
+          <a:p>
+            <a:r>
+              <a:t>Aplicación web/API de un dominio realista (citas, academia, inventario liviano…).</a:t>
+            </a:r>
+          </a:p>
+          <a:p/>
+          <a:p>
+            <a:r>
+              <a:t>Lo que se construye en el semestre: diagramas + contenedor (lab) + CI/CD conceptual + informe.</a:t>
+            </a:r>
+          </a:p>
+          <a:p/>
+          <a:p>
+            <a:r>
+              <a:t>Hoy solo: problema + capacidades + boceto de contexto.</a:t>
+            </a:r>
+          </a:p>
+          <a:p/>
+          <a:p>
+            <a:r>
+              <a:t>Sin AWS/GCP/Oracle: draw.io, Killercoda, GitHub Actions.</a:t>
+            </a:r>
+          </a:p>
+          <a:p/>
+          <a:p>
+            <a:r>
+              <a:t>Ejemplo de dominio: CloudLite Turnos — el cliente reserva turno, el barbero ve su agenda, el administrador fija horarios.</a:t>
+            </a:r>
+          </a:p>
+          <a:p/>
+          <a:p>
+            <a:r>
+              <a:t>Error común: un dominio infinito (una red social completa) no cabe en un semestre.</a:t>
+            </a:r>
+          </a:p>
+          <a:p/>
+          <a:p>
+            <a:r>
               <a:t>DESARROLLO (para explicarlo, no se proyecta):</a:t>
             </a:r>
           </a:p>
@@ -955,6 +1039,48 @@
         <p:txBody>
           <a:bodyPr/>
           <a:lstStyle/>
+          <a:p>
+            <a:r>
+              <a:t>TEXTO COMPLETO DE LA LÁMINA (se proyecta resumido):</a:t>
+            </a:r>
+          </a:p>
+          <a:p/>
+          <a:p>
+            <a:r>
+              <a:t>1) Actor y problema. 2) Capacidades. 3) Contenedores lógicos. 4) Datos. 5) Riesgos.</a:t>
+            </a:r>
+          </a:p>
+          <a:p/>
+          <a:p>
+            <a:r>
+              <a:t>Ejemplo: *AgendaU* — estudiantes reservan tutoría; API + auth + agenda + notificaciones.</a:t>
+            </a:r>
+          </a:p>
+          <a:p/>
+          <a:p>
+            <a:r>
+              <a:t>Pregunta de diseño: ¿qué es núcleo vs satélite?</a:t>
+            </a:r>
+          </a:p>
+          <a:p/>
+          <a:p>
+            <a:r>
+              <a:t>Salida: diagrama C4 Context (sistema + actores externos).</a:t>
+            </a:r>
+          </a:p>
+          <a:p/>
+          <a:p>
+            <a:r>
+              <a:t>Núcleo = lo que diferencia al dominio (la agenda de turnos); satélite = lo genérico que se delega (correo, autenticación).</a:t>
+            </a:r>
+          </a:p>
+          <a:p/>
+          <a:p>
+            <a:r>
+              <a:t>Error común: empezar por la tecnología («usaremos Kubernetes») antes de nombrar actor y problema.</a:t>
+            </a:r>
+          </a:p>
+          <a:p/>
           <a:p>
             <a:r>
               <a:t>DESARROLLO (para explicarlo, no se proyecta):</a:t>
@@ -7120,9 +7246,33 @@
           </a:prstGeom>
         </p:spPr>
       </p:pic>
-      <p:sp>
-        <p:nvSpPr>
-          <p:cNvPr id="13" name="TextBox 12"/>
+      <p:pic>
+        <p:nvPicPr>
+          <p:cNvPr id="9" name="Picture 8" descr="ficha-cinco-bloques-paso4.png"/>
+          <p:cNvPicPr>
+            <a:picLocks noChangeAspect="1"/>
+          </p:cNvPicPr>
+          <p:nvPr/>
+        </p:nvPicPr>
+        <p:blipFill>
+          <a:blip r:embed="rId5"/>
+          <a:stretch>
+            <a:fillRect/>
+          </a:stretch>
+        </p:blipFill>
+        <p:spPr>
+          <a:xfrm>
+            <a:off x="5876318" y="1261872"/>
+            <a:ext cx="5852160" cy="4681728"/>
+          </a:xfrm>
+          <a:prstGeom prst="rect">
+            <a:avLst/>
+          </a:prstGeom>
+        </p:spPr>
+      </p:pic>
+      <p:sp>
+        <p:nvSpPr>
+          <p:cNvPr id="18" name="TextBox 17"/>
           <p:cNvSpPr txBox="1"/>
           <p:nvPr/>
         </p:nvSpPr>
@@ -7157,7 +7307,7 @@
       </p:sp>
       <p:sp>
         <p:nvSpPr>
-          <p:cNvPr id="14" name="TextBox 13"/>
+          <p:cNvPr id="19" name="TextBox 18"/>
           <p:cNvSpPr txBox="1"/>
           <p:nvPr/>
         </p:nvSpPr>
@@ -7228,7 +7378,7 @@
       </p:sp>
       <p:sp>
         <p:nvSpPr>
-          <p:cNvPr id="15" name="TextBox 14"/>
+          <p:cNvPr id="20" name="TextBox 19"/>
           <p:cNvSpPr txBox="1"/>
           <p:nvPr/>
         </p:nvSpPr>
@@ -7380,6 +7530,59 @@
                       </p:childTnLst>
                     </p:cTn>
                   </p:par>
+                  <p:par>
+                    <p:cTn id="13" fill="hold">
+                      <p:stCondLst>
+                        <p:cond delay="indefinite"/>
+                      </p:stCondLst>
+                      <p:childTnLst>
+                        <p:par>
+                          <p:cTn id="14" fill="hold">
+                            <p:stCondLst>
+                              <p:cond delay="0"/>
+                            </p:stCondLst>
+                            <p:childTnLst>
+                              <p:par>
+                                <p:cTn id="15" presetID="10" presetClass="entr" presetSubtype="0" fill="hold" nodeType="clickEffect">
+                                  <p:stCondLst>
+                                    <p:cond delay="0"/>
+                                  </p:stCondLst>
+                                  <p:childTnLst>
+                                    <p:set>
+                                      <p:cBhvr>
+                                        <p:cTn id="16" dur="1" fill="hold">
+                                          <p:stCondLst>
+                                            <p:cond delay="0"/>
+                                          </p:stCondLst>
+                                        </p:cTn>
+                                        <p:tgtEl>
+                                          <p:spTgt spid="9"/>
+                                        </p:tgtEl>
+                                        <p:attrNameLst>
+                                          <p:attrName>style.visibility</p:attrName>
+                                        </p:attrNameLst>
+                                      </p:cBhvr>
+                                      <p:to>
+                                        <p:strVal val="visible"/>
+                                      </p:to>
+                                    </p:set>
+                                    <p:animEffect transition="in" filter="fade">
+                                      <p:cBhvr>
+                                        <p:cTn id="17" dur="450"/>
+                                        <p:tgtEl>
+                                          <p:spTgt spid="9"/>
+                                        </p:tgtEl>
+                                      </p:cBhvr>
+                                    </p:animEffect>
+                                  </p:childTnLst>
+                                </p:cTn>
+                              </p:par>
+                            </p:childTnLst>
+                          </p:cTn>
+                        </p:par>
+                      </p:childTnLst>
+                    </p:cTn>
+                  </p:par>
                 </p:childTnLst>
               </p:cTn>
               <p:prevCondLst>
@@ -7545,14 +7748,83 @@
       </p:sp>
       <p:sp>
         <p:nvSpPr>
-          <p:cNvPr id="5" name="TextBox 4"/>
+          <p:cNvPr id="5" name="Rounded Rectangle 4"/>
+          <p:cNvSpPr/>
+          <p:nvPr/>
+        </p:nvSpPr>
+        <p:spPr>
+          <a:xfrm>
+            <a:off x="5797149" y="1343926"/>
+            <a:ext cx="6010497" cy="4837658"/>
+          </a:xfrm>
+          <a:prstGeom prst="roundRect">
+            <a:avLst>
+              <a:gd name="adj" fmla="val 4000"/>
+            </a:avLst>
+          </a:prstGeom>
+          <a:solidFill>
+            <a:srgbClr val="E8EEF4"/>
+          </a:solidFill>
+          <a:ln>
+            <a:noFill/>
+          </a:ln>
+        </p:spPr>
+        <p:style>
+          <a:lnRef idx="1">
+            <a:schemeClr val="accent1"/>
+          </a:lnRef>
+          <a:fillRef idx="3">
+            <a:schemeClr val="accent1"/>
+          </a:fillRef>
+          <a:effectRef idx="2">
+            <a:schemeClr val="accent1"/>
+          </a:effectRef>
+          <a:fontRef idx="minor">
+            <a:schemeClr val="lt1"/>
+          </a:fontRef>
+        </p:style>
+        <p:txBody>
+          <a:bodyPr rtlCol="0" anchor="ctr"/>
+          <a:lstStyle/>
+          <a:p>
+            <a:pPr algn="ctr"/>
+          </a:p>
+        </p:txBody>
+      </p:sp>
+      <p:pic>
+        <p:nvPicPr>
+          <p:cNvPr id="6" name="Picture 5" descr="ilus-mapa-cloud-paso1.png"/>
+          <p:cNvPicPr>
+            <a:picLocks noChangeAspect="1"/>
+          </p:cNvPicPr>
+          <p:nvPr/>
+        </p:nvPicPr>
+        <p:blipFill>
+          <a:blip r:embed="rId2"/>
+          <a:stretch>
+            <a:fillRect/>
+          </a:stretch>
+        </p:blipFill>
+        <p:spPr>
+          <a:xfrm>
+            <a:off x="5870301" y="1417078"/>
+            <a:ext cx="5864193" cy="4691354"/>
+          </a:xfrm>
+          <a:prstGeom prst="rect">
+            <a:avLst/>
+          </a:prstGeom>
+        </p:spPr>
+      </p:pic>
+      <p:sp>
+        <p:nvSpPr>
+          <p:cNvPr id="7" name="TextBox 6"/>
           <p:cNvSpPr txBox="1"/>
           <p:nvPr/>
         </p:nvSpPr>
         <p:spPr>
           <a:xfrm>
-            <a:off x="457200" y="1170432"/>
-            <a:ext cx="11277295" cy="5230368"/>
+            <a:off x="457200" y="1353312"/>
+            <a:ext cx="5093061" cy="5047488"/>
           </a:xfrm>
           <a:prstGeom prst="rect">
             <a:avLst/>
@@ -7682,133 +7954,11 @@
               <a:t>–   Bloques tipicos: cliente → API → lógica → datos → observabilidad.</a:t>
             </a:r>
           </a:p>
-          <a:p>
-            <a:pPr>
-              <a:spcAft>
-                <a:spcPts val="800"/>
-              </a:spcAft>
-            </a:pPr>
-            <a:r>
-              <a:rPr sz="2000" b="0" i="0">
-                <a:solidFill>
-                  <a:srgbClr val="333333"/>
-                </a:solidFill>
-                <a:latin typeface="Calibri"/>
-              </a:rPr>
-              <a:t>–   Una decisión es </a:t>
-            </a:r>
-            <a:r>
-              <a:rPr sz="2000" b="1" i="0">
-                <a:solidFill>
-                  <a:srgbClr val="333333"/>
-                </a:solidFill>
-                <a:latin typeface="Calibri"/>
-              </a:rPr>
-              <a:t>arquitectónica</a:t>
-            </a:r>
-            <a:r>
-              <a:rPr sz="2000" b="0" i="0">
-                <a:solidFill>
-                  <a:srgbClr val="333333"/>
-                </a:solidFill>
-                <a:latin typeface="Calibri"/>
-              </a:rPr>
-              <a:t> si es cara de revertir: cambiar la base de datos a los 3 meses lo es; cambiar el color de un botón, no.</a:t>
-            </a:r>
-          </a:p>
-          <a:p>
-            <a:pPr>
-              <a:spcAft>
-                <a:spcPts val="800"/>
-              </a:spcAft>
-            </a:pPr>
-            <a:r>
-              <a:rPr sz="2000" b="0" i="0">
-                <a:solidFill>
-                  <a:srgbClr val="333333"/>
-                </a:solidFill>
-                <a:latin typeface="Calibri"/>
-              </a:rPr>
-              <a:t>–   Atributos de calidad del curso: </a:t>
-            </a:r>
-            <a:r>
-              <a:rPr sz="2000" b="1" i="0">
-                <a:solidFill>
-                  <a:srgbClr val="333333"/>
-                </a:solidFill>
-                <a:latin typeface="Calibri"/>
-              </a:rPr>
-              <a:t>rendimiento</a:t>
-            </a:r>
-            <a:r>
-              <a:rPr sz="2000" b="0" i="0">
-                <a:solidFill>
-                  <a:srgbClr val="333333"/>
-                </a:solidFill>
-                <a:latin typeface="Calibri"/>
-              </a:rPr>
-              <a:t>, </a:t>
-            </a:r>
-            <a:r>
-              <a:rPr sz="2000" b="1" i="0">
-                <a:solidFill>
-                  <a:srgbClr val="333333"/>
-                </a:solidFill>
-                <a:latin typeface="Calibri"/>
-              </a:rPr>
-              <a:t>disponibilidad</a:t>
-            </a:r>
-            <a:r>
-              <a:rPr sz="2000" b="0" i="0">
-                <a:solidFill>
-                  <a:srgbClr val="333333"/>
-                </a:solidFill>
-                <a:latin typeface="Calibri"/>
-              </a:rPr>
-              <a:t>, </a:t>
-            </a:r>
-            <a:r>
-              <a:rPr sz="2000" b="1" i="0">
-                <a:solidFill>
-                  <a:srgbClr val="333333"/>
-                </a:solidFill>
-                <a:latin typeface="Calibri"/>
-              </a:rPr>
-              <a:t>seguridad</a:t>
-            </a:r>
-            <a:r>
-              <a:rPr sz="2000" b="0" i="0">
-                <a:solidFill>
-                  <a:srgbClr val="333333"/>
-                </a:solidFill>
-                <a:latin typeface="Calibri"/>
-              </a:rPr>
-              <a:t> y </a:t>
-            </a:r>
-            <a:r>
-              <a:rPr sz="2000" b="1" i="0">
-                <a:solidFill>
-                  <a:srgbClr val="333333"/>
-                </a:solidFill>
-                <a:latin typeface="Calibri"/>
-              </a:rPr>
-              <a:t>costo</a:t>
-            </a:r>
-            <a:r>
-              <a:rPr sz="2000" b="0" i="0">
-                <a:solidFill>
-                  <a:srgbClr val="333333"/>
-                </a:solidFill>
-                <a:latin typeface="Calibri"/>
-              </a:rPr>
-              <a:t>.</a:t>
-            </a:r>
-          </a:p>
-        </p:txBody>
-      </p:sp>
-      <p:sp>
-        <p:nvSpPr>
-          <p:cNvPr id="6" name="TextBox 5"/>
+        </p:txBody>
+      </p:sp>
+      <p:sp>
+        <p:nvSpPr>
+          <p:cNvPr id="8" name="TextBox 7"/>
           <p:cNvSpPr txBox="1"/>
           <p:nvPr/>
         </p:nvSpPr>
@@ -7989,14 +8139,83 @@
       </p:sp>
       <p:sp>
         <p:nvSpPr>
-          <p:cNvPr id="5" name="TextBox 4"/>
+          <p:cNvPr id="5" name="Rounded Rectangle 4"/>
+          <p:cNvSpPr/>
+          <p:nvPr/>
+        </p:nvSpPr>
+        <p:spPr>
+          <a:xfrm>
+            <a:off x="5797149" y="1343926"/>
+            <a:ext cx="6010497" cy="4837658"/>
+          </a:xfrm>
+          <a:prstGeom prst="roundRect">
+            <a:avLst>
+              <a:gd name="adj" fmla="val 4000"/>
+            </a:avLst>
+          </a:prstGeom>
+          <a:solidFill>
+            <a:srgbClr val="E8EEF4"/>
+          </a:solidFill>
+          <a:ln>
+            <a:noFill/>
+          </a:ln>
+        </p:spPr>
+        <p:style>
+          <a:lnRef idx="1">
+            <a:schemeClr val="accent1"/>
+          </a:lnRef>
+          <a:fillRef idx="3">
+            <a:schemeClr val="accent1"/>
+          </a:fillRef>
+          <a:effectRef idx="2">
+            <a:schemeClr val="accent1"/>
+          </a:effectRef>
+          <a:fontRef idx="minor">
+            <a:schemeClr val="lt1"/>
+          </a:fontRef>
+        </p:style>
+        <p:txBody>
+          <a:bodyPr rtlCol="0" anchor="ctr"/>
+          <a:lstStyle/>
+          <a:p>
+            <a:pPr algn="ctr"/>
+          </a:p>
+        </p:txBody>
+      </p:sp>
+      <p:pic>
+        <p:nvPicPr>
+          <p:cNvPr id="6" name="Picture 5" descr="ilus-hilo-conductor-paso1.png"/>
+          <p:cNvPicPr>
+            <a:picLocks noChangeAspect="1"/>
+          </p:cNvPicPr>
+          <p:nvPr/>
+        </p:nvPicPr>
+        <p:blipFill>
+          <a:blip r:embed="rId2"/>
+          <a:stretch>
+            <a:fillRect/>
+          </a:stretch>
+        </p:blipFill>
+        <p:spPr>
+          <a:xfrm>
+            <a:off x="5870301" y="1417078"/>
+            <a:ext cx="5864193" cy="4691354"/>
+          </a:xfrm>
+          <a:prstGeom prst="rect">
+            <a:avLst/>
+          </a:prstGeom>
+        </p:spPr>
+      </p:pic>
+      <p:sp>
+        <p:nvSpPr>
+          <p:cNvPr id="7" name="TextBox 6"/>
           <p:cNvSpPr txBox="1"/>
           <p:nvPr/>
         </p:nvSpPr>
         <p:spPr>
           <a:xfrm>
-            <a:off x="457200" y="1170432"/>
-            <a:ext cx="11277295" cy="5230368"/>
+            <a:off x="457200" y="1353312"/>
+            <a:ext cx="5093061" cy="5047488"/>
           </a:xfrm>
           <a:prstGeom prst="rect">
             <a:avLst/>
@@ -8090,61 +8309,11 @@
               <a:t>–   Sin AWS/GCP/Oracle: draw.io, Killercoda, GitHub Actions.</a:t>
             </a:r>
           </a:p>
-          <a:p>
-            <a:pPr>
-              <a:spcAft>
-                <a:spcPts val="800"/>
-              </a:spcAft>
-            </a:pPr>
-            <a:r>
-              <a:rPr sz="2000" b="0" i="0">
-                <a:solidFill>
-                  <a:srgbClr val="333333"/>
-                </a:solidFill>
-                <a:latin typeface="Calibri"/>
-              </a:rPr>
-              <a:t>–   Ejemplo de dominio: </a:t>
-            </a:r>
-            <a:r>
-              <a:rPr sz="2000" b="1" i="0">
-                <a:solidFill>
-                  <a:srgbClr val="333333"/>
-                </a:solidFill>
-                <a:latin typeface="Calibri"/>
-              </a:rPr>
-              <a:t>La app de turnos</a:t>
-            </a:r>
-            <a:r>
-              <a:rPr sz="2000" b="0" i="0">
-                <a:solidFill>
-                  <a:srgbClr val="333333"/>
-                </a:solidFill>
-                <a:latin typeface="Calibri"/>
-              </a:rPr>
-              <a:t> — el cliente reserva turno, el barbero ve su agenda, el administrador fija horarios.</a:t>
-            </a:r>
-          </a:p>
-          <a:p>
-            <a:pPr>
-              <a:spcAft>
-                <a:spcPts val="800"/>
-              </a:spcAft>
-            </a:pPr>
-            <a:r>
-              <a:rPr sz="2000" b="0" i="0">
-                <a:solidFill>
-                  <a:srgbClr val="333333"/>
-                </a:solidFill>
-                <a:latin typeface="Calibri"/>
-              </a:rPr>
-              <a:t>–   Error común: un dominio infinito (una red social completa) no cabe en un semestre.</a:t>
-            </a:r>
-          </a:p>
-        </p:txBody>
-      </p:sp>
-      <p:sp>
-        <p:nvSpPr>
-          <p:cNvPr id="6" name="TextBox 5"/>
+        </p:txBody>
+      </p:sp>
+      <p:sp>
+        <p:nvSpPr>
+          <p:cNvPr id="8" name="TextBox 7"/>
           <p:cNvSpPr txBox="1"/>
           <p:nvPr/>
         </p:nvSpPr>
@@ -8325,14 +8494,83 @@
       </p:sp>
       <p:sp>
         <p:nvSpPr>
-          <p:cNvPr id="5" name="TextBox 4"/>
+          <p:cNvPr id="5" name="Rounded Rectangle 4"/>
+          <p:cNvSpPr/>
+          <p:nvPr/>
+        </p:nvSpPr>
+        <p:spPr>
+          <a:xfrm>
+            <a:off x="5797149" y="1343926"/>
+            <a:ext cx="6010497" cy="4837658"/>
+          </a:xfrm>
+          <a:prstGeom prst="roundRect">
+            <a:avLst>
+              <a:gd name="adj" fmla="val 4000"/>
+            </a:avLst>
+          </a:prstGeom>
+          <a:solidFill>
+            <a:srgbClr val="E8EEF4"/>
+          </a:solidFill>
+          <a:ln>
+            <a:noFill/>
+          </a:ln>
+        </p:spPr>
+        <p:style>
+          <a:lnRef idx="1">
+            <a:schemeClr val="accent1"/>
+          </a:lnRef>
+          <a:fillRef idx="3">
+            <a:schemeClr val="accent1"/>
+          </a:fillRef>
+          <a:effectRef idx="2">
+            <a:schemeClr val="accent1"/>
+          </a:effectRef>
+          <a:fontRef idx="minor">
+            <a:schemeClr val="lt1"/>
+          </a:fontRef>
+        </p:style>
+        <p:txBody>
+          <a:bodyPr rtlCol="0" anchor="ctr"/>
+          <a:lstStyle/>
+          <a:p>
+            <a:pPr algn="ctr"/>
+          </a:p>
+        </p:txBody>
+      </p:sp>
+      <p:pic>
+        <p:nvPicPr>
+          <p:cNvPr id="6" name="Picture 5" descr="ilus-mini-metodo-paso1.png"/>
+          <p:cNvPicPr>
+            <a:picLocks noChangeAspect="1"/>
+          </p:cNvPicPr>
+          <p:nvPr/>
+        </p:nvPicPr>
+        <p:blipFill>
+          <a:blip r:embed="rId2"/>
+          <a:stretch>
+            <a:fillRect/>
+          </a:stretch>
+        </p:blipFill>
+        <p:spPr>
+          <a:xfrm>
+            <a:off x="5870301" y="1417078"/>
+            <a:ext cx="5864193" cy="4691354"/>
+          </a:xfrm>
+          <a:prstGeom prst="rect">
+            <a:avLst/>
+          </a:prstGeom>
+        </p:spPr>
+      </p:pic>
+      <p:sp>
+        <p:nvSpPr>
+          <p:cNvPr id="7" name="TextBox 6"/>
           <p:cNvSpPr txBox="1"/>
           <p:nvPr/>
         </p:nvSpPr>
         <p:spPr>
           <a:xfrm>
-            <a:off x="457200" y="1170432"/>
-            <a:ext cx="11277295" cy="5230368"/>
+            <a:off x="457200" y="1353312"/>
+            <a:ext cx="5093061" cy="5047488"/>
           </a:xfrm>
           <a:prstGeom prst="rect">
             <a:avLst/>
@@ -8426,79 +8664,11 @@
               <a:t>–   Salida: diagrama C4 Context (sistema + actores externos).</a:t>
             </a:r>
           </a:p>
-          <a:p>
-            <a:pPr>
-              <a:spcAft>
-                <a:spcPts val="800"/>
-              </a:spcAft>
-            </a:pPr>
-            <a:r>
-              <a:rPr sz="2000" b="0" i="0">
-                <a:solidFill>
-                  <a:srgbClr val="333333"/>
-                </a:solidFill>
-                <a:latin typeface="Calibri"/>
-              </a:rPr>
-              <a:t>–   </a:t>
-            </a:r>
-            <a:r>
-              <a:rPr sz="2000" b="1" i="0">
-                <a:solidFill>
-                  <a:srgbClr val="333333"/>
-                </a:solidFill>
-                <a:latin typeface="Calibri"/>
-              </a:rPr>
-              <a:t>Núcleo</a:t>
-            </a:r>
-            <a:r>
-              <a:rPr sz="2000" b="0" i="0">
-                <a:solidFill>
-                  <a:srgbClr val="333333"/>
-                </a:solidFill>
-                <a:latin typeface="Calibri"/>
-              </a:rPr>
-              <a:t> = lo que diferencia al dominio (la agenda de turnos); </a:t>
-            </a:r>
-            <a:r>
-              <a:rPr sz="2000" b="1" i="0">
-                <a:solidFill>
-                  <a:srgbClr val="333333"/>
-                </a:solidFill>
-                <a:latin typeface="Calibri"/>
-              </a:rPr>
-              <a:t>satélite</a:t>
-            </a:r>
-            <a:r>
-              <a:rPr sz="2000" b="0" i="0">
-                <a:solidFill>
-                  <a:srgbClr val="333333"/>
-                </a:solidFill>
-                <a:latin typeface="Calibri"/>
-              </a:rPr>
-              <a:t> = lo genérico que se delega (correo, autenticación).</a:t>
-            </a:r>
-          </a:p>
-          <a:p>
-            <a:pPr>
-              <a:spcAft>
-                <a:spcPts val="800"/>
-              </a:spcAft>
-            </a:pPr>
-            <a:r>
-              <a:rPr sz="2000" b="0" i="0">
-                <a:solidFill>
-                  <a:srgbClr val="333333"/>
-                </a:solidFill>
-                <a:latin typeface="Calibri"/>
-              </a:rPr>
-              <a:t>–   Error común: empezar por la tecnología («usaremos Kubernetes») antes de nombrar actor y problema.</a:t>
-            </a:r>
-          </a:p>
-        </p:txBody>
-      </p:sp>
-      <p:sp>
-        <p:nvSpPr>
-          <p:cNvPr id="6" name="TextBox 5"/>
+        </p:txBody>
+      </p:sp>
+      <p:sp>
+        <p:nvSpPr>
+          <p:cNvPr id="8" name="TextBox 7"/>
           <p:cNvSpPr txBox="1"/>
           <p:nvPr/>
         </p:nvSpPr>

</xml_diff>

<commit_message>
Codigo de diagramas junto al dibujo que produce en Arquitectura, BD II y Seminario; codigo sin lineas partidas en los cinco cursos
Co-Authored-By: Claude Opus 5.5 <noreply@anthropic.com>
</commit_message>
<xml_diff>
--- a/Arquitectura de Sistemas Computacionales/Clases/Clase 1 - Introduccion a arquitecturas cloud/Presentacion.pptx
+++ b/Arquitectura de Sistemas Computacionales/Clases/Clase 1 - Introduccion a arquitecturas cloud/Presentacion.pptx
@@ -9396,7 +9396,7 @@
         <p:spPr>
           <a:xfrm>
             <a:off x="457200" y="1261872"/>
-            <a:ext cx="11277295" cy="4917043"/>
+            <a:ext cx="6991923" cy="3614797"/>
           </a:xfrm>
           <a:prstGeom prst="roundRect">
             <a:avLst>
@@ -9441,7 +9441,7 @@
         <p:spPr>
           <a:xfrm>
             <a:off x="457200" y="1261872"/>
-            <a:ext cx="11277295" cy="365760"/>
+            <a:ext cx="6991923" cy="365760"/>
           </a:xfrm>
           <a:prstGeom prst="rect">
             <a:avLst/>
@@ -9613,7 +9613,7 @@
         <p:spPr>
           <a:xfrm>
             <a:off x="1371600" y="1298448"/>
-            <a:ext cx="10180015" cy="292608"/>
+            <a:ext cx="5894643" cy="292608"/>
           </a:xfrm>
           <a:prstGeom prst="rect">
             <a:avLst/>
@@ -9646,7 +9646,7 @@
         <p:spPr>
           <a:xfrm>
             <a:off x="685800" y="1719072"/>
-            <a:ext cx="502920" cy="4322683"/>
+            <a:ext cx="502920" cy="3020437"/>
           </a:xfrm>
           <a:prstGeom prst="rect">
             <a:avLst/>
@@ -9661,11 +9661,11 @@
           <a:p>
             <a:pPr algn="r">
               <a:spcAft>
-                <a:spcPts val="428"/>
+                <a:spcPts val="278"/>
               </a:spcAft>
             </a:pPr>
             <a:r>
-              <a:rPr sz="2000" i="0" b="0">
+              <a:rPr sz="1300" i="0" b="0">
                 <a:solidFill>
                   <a:srgbClr val="858585"/>
                 </a:solidFill>
@@ -9677,11 +9677,11 @@
           <a:p>
             <a:pPr algn="r">
               <a:spcAft>
-                <a:spcPts val="428"/>
+                <a:spcPts val="278"/>
               </a:spcAft>
             </a:pPr>
             <a:r>
-              <a:rPr sz="2000" i="0" b="0">
+              <a:rPr sz="1300" i="0" b="0">
                 <a:solidFill>
                   <a:srgbClr val="858585"/>
                 </a:solidFill>
@@ -9693,11 +9693,11 @@
           <a:p>
             <a:pPr algn="r">
               <a:spcAft>
-                <a:spcPts val="428"/>
+                <a:spcPts val="278"/>
               </a:spcAft>
             </a:pPr>
             <a:r>
-              <a:rPr sz="2000" i="0" b="0">
+              <a:rPr sz="1300" i="0" b="0">
                 <a:solidFill>
                   <a:srgbClr val="858585"/>
                 </a:solidFill>
@@ -9709,11 +9709,11 @@
           <a:p>
             <a:pPr algn="r">
               <a:spcAft>
-                <a:spcPts val="428"/>
+                <a:spcPts val="278"/>
               </a:spcAft>
             </a:pPr>
             <a:r>
-              <a:rPr sz="2000" i="0" b="0">
+              <a:rPr sz="1300" i="0" b="0">
                 <a:solidFill>
                   <a:srgbClr val="858585"/>
                 </a:solidFill>
@@ -9725,11 +9725,11 @@
           <a:p>
             <a:pPr algn="r">
               <a:spcAft>
-                <a:spcPts val="428"/>
+                <a:spcPts val="278"/>
               </a:spcAft>
             </a:pPr>
             <a:r>
-              <a:rPr sz="2000" i="0" b="0">
+              <a:rPr sz="1300" i="0" b="0">
                 <a:solidFill>
                   <a:srgbClr val="858585"/>
                 </a:solidFill>
@@ -9741,11 +9741,11 @@
           <a:p>
             <a:pPr algn="r">
               <a:spcAft>
-                <a:spcPts val="428"/>
+                <a:spcPts val="278"/>
               </a:spcAft>
             </a:pPr>
             <a:r>
-              <a:rPr sz="2000" i="0" b="0">
+              <a:rPr sz="1300" i="0" b="0">
                 <a:solidFill>
                   <a:srgbClr val="858585"/>
                 </a:solidFill>
@@ -9757,11 +9757,11 @@
           <a:p>
             <a:pPr algn="r">
               <a:spcAft>
-                <a:spcPts val="428"/>
+                <a:spcPts val="278"/>
               </a:spcAft>
             </a:pPr>
             <a:r>
-              <a:rPr sz="2000" i="0" b="0">
+              <a:rPr sz="1300" i="0" b="0">
                 <a:solidFill>
                   <a:srgbClr val="858585"/>
                 </a:solidFill>
@@ -9773,11 +9773,11 @@
           <a:p>
             <a:pPr algn="r">
               <a:spcAft>
-                <a:spcPts val="428"/>
+                <a:spcPts val="278"/>
               </a:spcAft>
             </a:pPr>
             <a:r>
-              <a:rPr sz="2000" i="0" b="0">
+              <a:rPr sz="1300" i="0" b="0">
                 <a:solidFill>
                   <a:srgbClr val="858585"/>
                 </a:solidFill>
@@ -9789,11 +9789,11 @@
           <a:p>
             <a:pPr algn="r">
               <a:spcAft>
-                <a:spcPts val="428"/>
+                <a:spcPts val="278"/>
               </a:spcAft>
             </a:pPr>
             <a:r>
-              <a:rPr sz="2000" i="0" b="0">
+              <a:rPr sz="1300" i="0" b="0">
                 <a:solidFill>
                   <a:srgbClr val="858585"/>
                 </a:solidFill>
@@ -9805,11 +9805,11 @@
           <a:p>
             <a:pPr algn="r">
               <a:spcAft>
-                <a:spcPts val="428"/>
+                <a:spcPts val="278"/>
               </a:spcAft>
             </a:pPr>
             <a:r>
-              <a:rPr sz="2000" i="0" b="0">
+              <a:rPr sz="1300" i="0" b="0">
                 <a:solidFill>
                   <a:srgbClr val="858585"/>
                 </a:solidFill>
@@ -9821,11 +9821,11 @@
           <a:p>
             <a:pPr algn="r">
               <a:spcAft>
-                <a:spcPts val="428"/>
+                <a:spcPts val="278"/>
               </a:spcAft>
             </a:pPr>
             <a:r>
-              <a:rPr sz="2000" i="0" b="0">
+              <a:rPr sz="1300" i="0" b="0">
                 <a:solidFill>
                   <a:srgbClr val="858585"/>
                 </a:solidFill>
@@ -9837,11 +9837,11 @@
           <a:p>
             <a:pPr algn="r">
               <a:spcAft>
-                <a:spcPts val="428"/>
+                <a:spcPts val="278"/>
               </a:spcAft>
             </a:pPr>
             <a:r>
-              <a:rPr sz="2000" i="0" b="0">
+              <a:rPr sz="1300" i="0" b="0">
                 <a:solidFill>
                   <a:srgbClr val="858585"/>
                 </a:solidFill>
@@ -9861,7 +9861,7 @@
         <p:spPr>
           <a:xfrm>
             <a:off x="1188720" y="1719072"/>
-            <a:ext cx="10271455" cy="4322683"/>
+            <a:ext cx="5986083" cy="3020437"/>
           </a:xfrm>
           <a:prstGeom prst="rect">
             <a:avLst/>
@@ -9876,11 +9876,11 @@
           <a:p>
             <a:pPr>
               <a:spcAft>
-                <a:spcPts val="428"/>
+                <a:spcPts val="278"/>
               </a:spcAft>
             </a:pPr>
             <a:r>
-              <a:rPr sz="2000" i="0" b="0">
+              <a:rPr sz="1300" i="0" b="0">
                 <a:solidFill>
                   <a:srgbClr val="D4D4D4"/>
                 </a:solidFill>
@@ -9892,11 +9892,11 @@
           <a:p>
             <a:pPr>
               <a:spcAft>
-                <a:spcPts val="428"/>
+                <a:spcPts val="278"/>
               </a:spcAft>
             </a:pPr>
             <a:r>
-              <a:rPr sz="2000" i="0" b="0">
+              <a:rPr sz="1300" i="0" b="0">
                 <a:solidFill>
                   <a:srgbClr val="D4D4D4"/>
                 </a:solidFill>
@@ -9905,7 +9905,7 @@
               <a:t>title</a:t>
             </a:r>
             <a:r>
-              <a:rPr sz="2000" i="0" b="0">
+              <a:rPr sz="1300" i="0" b="0">
                 <a:solidFill>
                   <a:srgbClr val="D4D4D4"/>
                 </a:solidFill>
@@ -9914,7 +9914,7 @@
               <a:t> </a:t>
             </a:r>
             <a:r>
-              <a:rPr sz="2000" i="0" b="0">
+              <a:rPr sz="1300" i="0" b="0">
                 <a:solidFill>
                   <a:srgbClr val="D4D4D4"/>
                 </a:solidFill>
@@ -9923,7 +9923,7 @@
               <a:t>Contexto</a:t>
             </a:r>
             <a:r>
-              <a:rPr sz="2000" i="0" b="0">
+              <a:rPr sz="1300" i="0" b="0">
                 <a:solidFill>
                   <a:srgbClr val="D4D4D4"/>
                 </a:solidFill>
@@ -9932,16 +9932,16 @@
               <a:t> - </a:t>
             </a:r>
             <a:r>
-              <a:rPr sz="2000" i="0" b="0">
+              <a:rPr sz="1300" i="0" b="0">
                 <a:solidFill>
                   <a:srgbClr val="D4D4D4"/>
                 </a:solidFill>
                 <a:latin typeface="Consolas"/>
               </a:rPr>
-              <a:t>La app</a:t>
-            </a:r>
-            <a:r>
-              <a:rPr sz="2000" i="0" b="0">
+              <a:t>App</a:t>
+            </a:r>
+            <a:r>
+              <a:rPr sz="1300" i="0" b="0">
                 <a:solidFill>
                   <a:srgbClr val="D4D4D4"/>
                 </a:solidFill>
@@ -9950,23 +9950,41 @@
               <a:t> </a:t>
             </a:r>
             <a:r>
-              <a:rPr sz="2000" i="0" b="0">
+              <a:rPr sz="1300" i="0" b="0">
                 <a:solidFill>
                   <a:srgbClr val="D4D4D4"/>
                 </a:solidFill>
                 <a:latin typeface="Consolas"/>
               </a:rPr>
-              <a:t>Turnos</a:t>
+              <a:t>de</a:t>
+            </a:r>
+            <a:r>
+              <a:rPr sz="1300" i="0" b="0">
+                <a:solidFill>
+                  <a:srgbClr val="D4D4D4"/>
+                </a:solidFill>
+                <a:latin typeface="Consolas"/>
+              </a:rPr>
+              <a:t> </a:t>
+            </a:r>
+            <a:r>
+              <a:rPr sz="1300" i="0" b="0">
+                <a:solidFill>
+                  <a:srgbClr val="D4D4D4"/>
+                </a:solidFill>
+                <a:latin typeface="Consolas"/>
+              </a:rPr>
+              <a:t>turnos</a:t>
             </a:r>
           </a:p>
           <a:p>
             <a:pPr>
               <a:spcAft>
-                <a:spcPts val="428"/>
+                <a:spcPts val="278"/>
               </a:spcAft>
             </a:pPr>
             <a:r>
-              <a:rPr sz="2000" i="0" b="0">
+              <a:rPr sz="1300" i="0" b="0">
                 <a:solidFill>
                   <a:srgbClr val="DCDCAA"/>
                 </a:solidFill>
@@ -9975,7 +9993,7 @@
               <a:t>Person</a:t>
             </a:r>
             <a:r>
-              <a:rPr sz="2000" i="0" b="0">
+              <a:rPr sz="1300" i="0" b="0">
                 <a:solidFill>
                   <a:srgbClr val="D4D4D4"/>
                 </a:solidFill>
@@ -9984,7 +10002,7 @@
               <a:t>(</a:t>
             </a:r>
             <a:r>
-              <a:rPr sz="2000" i="0" b="0">
+              <a:rPr sz="1300" i="0" b="0">
                 <a:solidFill>
                   <a:srgbClr val="D4D4D4"/>
                 </a:solidFill>
@@ -9993,7 +10011,7 @@
               <a:t>cliente</a:t>
             </a:r>
             <a:r>
-              <a:rPr sz="2000" i="0" b="0">
+              <a:rPr sz="1300" i="0" b="0">
                 <a:solidFill>
                   <a:srgbClr val="D4D4D4"/>
                 </a:solidFill>
@@ -10002,7 +10020,7 @@
               <a:t>, </a:t>
             </a:r>
             <a:r>
-              <a:rPr sz="2000" i="0" b="0">
+              <a:rPr sz="1300" i="0" b="0">
                 <a:solidFill>
                   <a:srgbClr val="CE9178"/>
                 </a:solidFill>
@@ -10011,7 +10029,7 @@
               <a:t>"Cliente"</a:t>
             </a:r>
             <a:r>
-              <a:rPr sz="2000" i="0" b="0">
+              <a:rPr sz="1300" i="0" b="0">
                 <a:solidFill>
                   <a:srgbClr val="D4D4D4"/>
                 </a:solidFill>
@@ -10020,7 +10038,7 @@
               <a:t>, </a:t>
             </a:r>
             <a:r>
-              <a:rPr sz="2000" i="0" b="0">
+              <a:rPr sz="1300" i="0" b="0">
                 <a:solidFill>
                   <a:srgbClr val="CE9178"/>
                 </a:solidFill>
@@ -10029,7 +10047,7 @@
               <a:t>"Reserva turnos"</a:t>
             </a:r>
             <a:r>
-              <a:rPr sz="2000" i="0" b="0">
+              <a:rPr sz="1300" i="0" b="0">
                 <a:solidFill>
                   <a:srgbClr val="D4D4D4"/>
                 </a:solidFill>
@@ -10041,11 +10059,11 @@
           <a:p>
             <a:pPr>
               <a:spcAft>
-                <a:spcPts val="428"/>
+                <a:spcPts val="278"/>
               </a:spcAft>
             </a:pPr>
             <a:r>
-              <a:rPr sz="2000" i="0" b="0">
+              <a:rPr sz="1300" i="0" b="0">
                 <a:solidFill>
                   <a:srgbClr val="DCDCAA"/>
                 </a:solidFill>
@@ -10054,7 +10072,7 @@
               <a:t>Person</a:t>
             </a:r>
             <a:r>
-              <a:rPr sz="2000" i="0" b="0">
+              <a:rPr sz="1300" i="0" b="0">
                 <a:solidFill>
                   <a:srgbClr val="D4D4D4"/>
                 </a:solidFill>
@@ -10063,7 +10081,7 @@
               <a:t>(</a:t>
             </a:r>
             <a:r>
-              <a:rPr sz="2000" i="0" b="0">
+              <a:rPr sz="1300" i="0" b="0">
                 <a:solidFill>
                   <a:srgbClr val="D4D4D4"/>
                 </a:solidFill>
@@ -10072,7 +10090,7 @@
               <a:t>barbero</a:t>
             </a:r>
             <a:r>
-              <a:rPr sz="2000" i="0" b="0">
+              <a:rPr sz="1300" i="0" b="0">
                 <a:solidFill>
                   <a:srgbClr val="D4D4D4"/>
                 </a:solidFill>
@@ -10081,7 +10099,7 @@
               <a:t>, </a:t>
             </a:r>
             <a:r>
-              <a:rPr sz="2000" i="0" b="0">
+              <a:rPr sz="1300" i="0" b="0">
                 <a:solidFill>
                   <a:srgbClr val="CE9178"/>
                 </a:solidFill>
@@ -10090,7 +10108,7 @@
               <a:t>"Barbero"</a:t>
             </a:r>
             <a:r>
-              <a:rPr sz="2000" i="0" b="0">
+              <a:rPr sz="1300" i="0" b="0">
                 <a:solidFill>
                   <a:srgbClr val="D4D4D4"/>
                 </a:solidFill>
@@ -10099,7 +10117,7 @@
               <a:t>, </a:t>
             </a:r>
             <a:r>
-              <a:rPr sz="2000" i="0" b="0">
+              <a:rPr sz="1300" i="0" b="0">
                 <a:solidFill>
                   <a:srgbClr val="CE9178"/>
                 </a:solidFill>
@@ -10108,7 +10126,7 @@
               <a:t>"Ve su agenda"</a:t>
             </a:r>
             <a:r>
-              <a:rPr sz="2000" i="0" b="0">
+              <a:rPr sz="1300" i="0" b="0">
                 <a:solidFill>
                   <a:srgbClr val="D4D4D4"/>
                 </a:solidFill>
@@ -10120,11 +10138,11 @@
           <a:p>
             <a:pPr>
               <a:spcAft>
-                <a:spcPts val="428"/>
+                <a:spcPts val="278"/>
               </a:spcAft>
             </a:pPr>
             <a:r>
-              <a:rPr sz="2000" i="0" b="0">
+              <a:rPr sz="1300" i="0" b="0">
                 <a:solidFill>
                   <a:srgbClr val="DCDCAA"/>
                 </a:solidFill>
@@ -10133,7 +10151,7 @@
               <a:t>System</a:t>
             </a:r>
             <a:r>
-              <a:rPr sz="2000" i="0" b="0">
+              <a:rPr sz="1300" i="0" b="0">
                 <a:solidFill>
                   <a:srgbClr val="D4D4D4"/>
                 </a:solidFill>
@@ -10142,7 +10160,7 @@
               <a:t>(</a:t>
             </a:r>
             <a:r>
-              <a:rPr sz="2000" i="0" b="0">
+              <a:rPr sz="1300" i="0" b="0">
                 <a:solidFill>
                   <a:srgbClr val="D4D4D4"/>
                 </a:solidFill>
@@ -10151,7 +10169,7 @@
               <a:t>app</a:t>
             </a:r>
             <a:r>
-              <a:rPr sz="2000" i="0" b="0">
+              <a:rPr sz="1300" i="0" b="0">
                 <a:solidFill>
                   <a:srgbClr val="D4D4D4"/>
                 </a:solidFill>
@@ -10160,16 +10178,16 @@
               <a:t>, </a:t>
             </a:r>
             <a:r>
-              <a:rPr sz="2000" i="0" b="0">
+              <a:rPr sz="1300" i="0" b="0">
                 <a:solidFill>
                   <a:srgbClr val="CE9178"/>
                 </a:solidFill>
                 <a:latin typeface="Consolas"/>
               </a:rPr>
-              <a:t>"la app de turnos"</a:t>
-            </a:r>
-            <a:r>
-              <a:rPr sz="2000" i="0" b="0">
+              <a:t>"App de turnos"</a:t>
+            </a:r>
+            <a:r>
+              <a:rPr sz="1300" i="0" b="0">
                 <a:solidFill>
                   <a:srgbClr val="D4D4D4"/>
                 </a:solidFill>
@@ -10178,7 +10196,7 @@
               <a:t>, </a:t>
             </a:r>
             <a:r>
-              <a:rPr sz="2000" i="0" b="0">
+              <a:rPr sz="1300" i="0" b="0">
                 <a:solidFill>
                   <a:srgbClr val="CE9178"/>
                 </a:solidFill>
@@ -10187,7 +10205,7 @@
               <a:t>"Agenda turnos"</a:t>
             </a:r>
             <a:r>
-              <a:rPr sz="2000" i="0" b="0">
+              <a:rPr sz="1300" i="0" b="0">
                 <a:solidFill>
                   <a:srgbClr val="D4D4D4"/>
                 </a:solidFill>
@@ -10199,11 +10217,11 @@
           <a:p>
             <a:pPr>
               <a:spcAft>
-                <a:spcPts val="428"/>
+                <a:spcPts val="278"/>
               </a:spcAft>
             </a:pPr>
             <a:r>
-              <a:rPr sz="2000" i="0" b="0">
+              <a:rPr sz="1300" i="0" b="0">
                 <a:solidFill>
                   <a:srgbClr val="DCDCAA"/>
                 </a:solidFill>
@@ -10212,7 +10230,7 @@
               <a:t>System_Ext</a:t>
             </a:r>
             <a:r>
-              <a:rPr sz="2000" i="0" b="0">
+              <a:rPr sz="1300" i="0" b="0">
                 <a:solidFill>
                   <a:srgbClr val="D4D4D4"/>
                 </a:solidFill>
@@ -10221,7 +10239,7 @@
               <a:t>(</a:t>
             </a:r>
             <a:r>
-              <a:rPr sz="2000" i="0" b="0">
+              <a:rPr sz="1300" i="0" b="0">
                 <a:solidFill>
                   <a:srgbClr val="D4D4D4"/>
                 </a:solidFill>
@@ -10230,7 +10248,7 @@
               <a:t>idp</a:t>
             </a:r>
             <a:r>
-              <a:rPr sz="2000" i="0" b="0">
+              <a:rPr sz="1300" i="0" b="0">
                 <a:solidFill>
                   <a:srgbClr val="D4D4D4"/>
                 </a:solidFill>
@@ -10239,7 +10257,7 @@
               <a:t>, </a:t>
             </a:r>
             <a:r>
-              <a:rPr sz="2000" i="0" b="0">
+              <a:rPr sz="1300" i="0" b="0">
                 <a:solidFill>
                   <a:srgbClr val="CE9178"/>
                 </a:solidFill>
@@ -10248,7 +10266,7 @@
               <a:t>"Proveedor de identidad"</a:t>
             </a:r>
             <a:r>
-              <a:rPr sz="2000" i="0" b="0">
+              <a:rPr sz="1300" i="0" b="0">
                 <a:solidFill>
                   <a:srgbClr val="D4D4D4"/>
                 </a:solidFill>
@@ -10257,7 +10275,7 @@
               <a:t>, </a:t>
             </a:r>
             <a:r>
-              <a:rPr sz="2000" i="0" b="0">
+              <a:rPr sz="1300" i="0" b="0">
                 <a:solidFill>
                   <a:srgbClr val="CE9178"/>
                 </a:solidFill>
@@ -10266,7 +10284,7 @@
               <a:t>"Login"</a:t>
             </a:r>
             <a:r>
-              <a:rPr sz="2000" i="0" b="0">
+              <a:rPr sz="1300" i="0" b="0">
                 <a:solidFill>
                   <a:srgbClr val="D4D4D4"/>
                 </a:solidFill>
@@ -10278,11 +10296,11 @@
           <a:p>
             <a:pPr>
               <a:spcAft>
-                <a:spcPts val="428"/>
+                <a:spcPts val="278"/>
               </a:spcAft>
             </a:pPr>
             <a:r>
-              <a:rPr sz="2000" i="0" b="0">
+              <a:rPr sz="1300" i="0" b="0">
                 <a:solidFill>
                   <a:srgbClr val="DCDCAA"/>
                 </a:solidFill>
@@ -10291,7 +10309,7 @@
               <a:t>System_Ext</a:t>
             </a:r>
             <a:r>
-              <a:rPr sz="2000" i="0" b="0">
+              <a:rPr sz="1300" i="0" b="0">
                 <a:solidFill>
                   <a:srgbClr val="D4D4D4"/>
                 </a:solidFill>
@@ -10300,7 +10318,7 @@
               <a:t>(</a:t>
             </a:r>
             <a:r>
-              <a:rPr sz="2000" i="0" b="0">
+              <a:rPr sz="1300" i="0" b="0">
                 <a:solidFill>
                   <a:srgbClr val="D4D4D4"/>
                 </a:solidFill>
@@ -10309,7 +10327,7 @@
               <a:t>correo</a:t>
             </a:r>
             <a:r>
-              <a:rPr sz="2000" i="0" b="0">
+              <a:rPr sz="1300" i="0" b="0">
                 <a:solidFill>
                   <a:srgbClr val="D4D4D4"/>
                 </a:solidFill>
@@ -10318,7 +10336,7 @@
               <a:t>, </a:t>
             </a:r>
             <a:r>
-              <a:rPr sz="2000" i="0" b="0">
+              <a:rPr sz="1300" i="0" b="0">
                 <a:solidFill>
                   <a:srgbClr val="CE9178"/>
                 </a:solidFill>
@@ -10327,7 +10345,7 @@
               <a:t>"Correo transaccional"</a:t>
             </a:r>
             <a:r>
-              <a:rPr sz="2000" i="0" b="0">
+              <a:rPr sz="1300" i="0" b="0">
                 <a:solidFill>
                   <a:srgbClr val="D4D4D4"/>
                 </a:solidFill>
@@ -10336,7 +10354,7 @@
               <a:t>, </a:t>
             </a:r>
             <a:r>
-              <a:rPr sz="2000" i="0" b="0">
+              <a:rPr sz="1300" i="0" b="0">
                 <a:solidFill>
                   <a:srgbClr val="CE9178"/>
                 </a:solidFill>
@@ -10345,7 +10363,7 @@
               <a:t>"Envia correos"</a:t>
             </a:r>
             <a:r>
-              <a:rPr sz="2000" i="0" b="0">
+              <a:rPr sz="1300" i="0" b="0">
                 <a:solidFill>
                   <a:srgbClr val="D4D4D4"/>
                 </a:solidFill>
@@ -10357,11 +10375,11 @@
           <a:p>
             <a:pPr>
               <a:spcAft>
-                <a:spcPts val="428"/>
+                <a:spcPts val="278"/>
               </a:spcAft>
             </a:pPr>
             <a:r>
-              <a:rPr sz="2000" i="0" b="0">
+              <a:rPr sz="1300" i="0" b="0">
                 <a:solidFill>
                   <a:srgbClr val="DCDCAA"/>
                 </a:solidFill>
@@ -10370,7 +10388,7 @@
               <a:t>Rel</a:t>
             </a:r>
             <a:r>
-              <a:rPr sz="2000" i="0" b="0">
+              <a:rPr sz="1300" i="0" b="0">
                 <a:solidFill>
                   <a:srgbClr val="D4D4D4"/>
                 </a:solidFill>
@@ -10379,7 +10397,7 @@
               <a:t>(</a:t>
             </a:r>
             <a:r>
-              <a:rPr sz="2000" i="0" b="0">
+              <a:rPr sz="1300" i="0" b="0">
                 <a:solidFill>
                   <a:srgbClr val="D4D4D4"/>
                 </a:solidFill>
@@ -10388,7 +10406,7 @@
               <a:t>cliente</a:t>
             </a:r>
             <a:r>
-              <a:rPr sz="2000" i="0" b="0">
+              <a:rPr sz="1300" i="0" b="0">
                 <a:solidFill>
                   <a:srgbClr val="D4D4D4"/>
                 </a:solidFill>
@@ -10397,7 +10415,7 @@
               <a:t>, </a:t>
             </a:r>
             <a:r>
-              <a:rPr sz="2000" i="0" b="0">
+              <a:rPr sz="1300" i="0" b="0">
                 <a:solidFill>
                   <a:srgbClr val="D4D4D4"/>
                 </a:solidFill>
@@ -10406,7 +10424,7 @@
               <a:t>app</a:t>
             </a:r>
             <a:r>
-              <a:rPr sz="2000" i="0" b="0">
+              <a:rPr sz="1300" i="0" b="0">
                 <a:solidFill>
                   <a:srgbClr val="D4D4D4"/>
                 </a:solidFill>
@@ -10415,7 +10433,7 @@
               <a:t>, </a:t>
             </a:r>
             <a:r>
-              <a:rPr sz="2000" i="0" b="0">
+              <a:rPr sz="1300" i="0" b="0">
                 <a:solidFill>
                   <a:srgbClr val="CE9178"/>
                 </a:solidFill>
@@ -10424,7 +10442,7 @@
               <a:t>"Reserva un turno"</a:t>
             </a:r>
             <a:r>
-              <a:rPr sz="2000" i="0" b="0">
+              <a:rPr sz="1300" i="0" b="0">
                 <a:solidFill>
                   <a:srgbClr val="D4D4D4"/>
                 </a:solidFill>
@@ -10433,7 +10451,7 @@
               <a:t>, </a:t>
             </a:r>
             <a:r>
-              <a:rPr sz="2000" i="0" b="0">
+              <a:rPr sz="1300" i="0" b="0">
                 <a:solidFill>
                   <a:srgbClr val="CE9178"/>
                 </a:solidFill>
@@ -10442,7 +10460,7 @@
               <a:t>"HTTPS"</a:t>
             </a:r>
             <a:r>
-              <a:rPr sz="2000" i="0" b="0">
+              <a:rPr sz="1300" i="0" b="0">
                 <a:solidFill>
                   <a:srgbClr val="D4D4D4"/>
                 </a:solidFill>
@@ -10454,11 +10472,11 @@
           <a:p>
             <a:pPr>
               <a:spcAft>
-                <a:spcPts val="428"/>
+                <a:spcPts val="278"/>
               </a:spcAft>
             </a:pPr>
             <a:r>
-              <a:rPr sz="2000" i="0" b="0">
+              <a:rPr sz="1300" i="0" b="0">
                 <a:solidFill>
                   <a:srgbClr val="DCDCAA"/>
                 </a:solidFill>
@@ -10467,7 +10485,7 @@
               <a:t>Rel</a:t>
             </a:r>
             <a:r>
-              <a:rPr sz="2000" i="0" b="0">
+              <a:rPr sz="1300" i="0" b="0">
                 <a:solidFill>
                   <a:srgbClr val="D4D4D4"/>
                 </a:solidFill>
@@ -10476,7 +10494,7 @@
               <a:t>(</a:t>
             </a:r>
             <a:r>
-              <a:rPr sz="2000" i="0" b="0">
+              <a:rPr sz="1300" i="0" b="0">
                 <a:solidFill>
                   <a:srgbClr val="D4D4D4"/>
                 </a:solidFill>
@@ -10485,7 +10503,7 @@
               <a:t>barbero</a:t>
             </a:r>
             <a:r>
-              <a:rPr sz="2000" i="0" b="0">
+              <a:rPr sz="1300" i="0" b="0">
                 <a:solidFill>
                   <a:srgbClr val="D4D4D4"/>
                 </a:solidFill>
@@ -10494,7 +10512,7 @@
               <a:t>, </a:t>
             </a:r>
             <a:r>
-              <a:rPr sz="2000" i="0" b="0">
+              <a:rPr sz="1300" i="0" b="0">
                 <a:solidFill>
                   <a:srgbClr val="D4D4D4"/>
                 </a:solidFill>
@@ -10503,7 +10521,7 @@
               <a:t>app</a:t>
             </a:r>
             <a:r>
-              <a:rPr sz="2000" i="0" b="0">
+              <a:rPr sz="1300" i="0" b="0">
                 <a:solidFill>
                   <a:srgbClr val="D4D4D4"/>
                 </a:solidFill>
@@ -10512,7 +10530,7 @@
               <a:t>, </a:t>
             </a:r>
             <a:r>
-              <a:rPr sz="2000" i="0" b="0">
+              <a:rPr sz="1300" i="0" b="0">
                 <a:solidFill>
                   <a:srgbClr val="CE9178"/>
                 </a:solidFill>
@@ -10521,7 +10539,7 @@
               <a:t>"Consulta su agenda"</a:t>
             </a:r>
             <a:r>
-              <a:rPr sz="2000" i="0" b="0">
+              <a:rPr sz="1300" i="0" b="0">
                 <a:solidFill>
                   <a:srgbClr val="D4D4D4"/>
                 </a:solidFill>
@@ -10530,7 +10548,7 @@
               <a:t>, </a:t>
             </a:r>
             <a:r>
-              <a:rPr sz="2000" i="0" b="0">
+              <a:rPr sz="1300" i="0" b="0">
                 <a:solidFill>
                   <a:srgbClr val="CE9178"/>
                 </a:solidFill>
@@ -10539,7 +10557,7 @@
               <a:t>"HTTPS"</a:t>
             </a:r>
             <a:r>
-              <a:rPr sz="2000" i="0" b="0">
+              <a:rPr sz="1300" i="0" b="0">
                 <a:solidFill>
                   <a:srgbClr val="D4D4D4"/>
                 </a:solidFill>
@@ -10551,11 +10569,11 @@
           <a:p>
             <a:pPr>
               <a:spcAft>
-                <a:spcPts val="428"/>
+                <a:spcPts val="278"/>
               </a:spcAft>
             </a:pPr>
             <a:r>
-              <a:rPr sz="2000" i="0" b="0">
+              <a:rPr sz="1300" i="0" b="0">
                 <a:solidFill>
                   <a:srgbClr val="DCDCAA"/>
                 </a:solidFill>
@@ -10564,7 +10582,7 @@
               <a:t>Rel</a:t>
             </a:r>
             <a:r>
-              <a:rPr sz="2000" i="0" b="0">
+              <a:rPr sz="1300" i="0" b="0">
                 <a:solidFill>
                   <a:srgbClr val="D4D4D4"/>
                 </a:solidFill>
@@ -10573,7 +10591,7 @@
               <a:t>(</a:t>
             </a:r>
             <a:r>
-              <a:rPr sz="2000" i="0" b="0">
+              <a:rPr sz="1300" i="0" b="0">
                 <a:solidFill>
                   <a:srgbClr val="D4D4D4"/>
                 </a:solidFill>
@@ -10582,7 +10600,7 @@
               <a:t>app</a:t>
             </a:r>
             <a:r>
-              <a:rPr sz="2000" i="0" b="0">
+              <a:rPr sz="1300" i="0" b="0">
                 <a:solidFill>
                   <a:srgbClr val="D4D4D4"/>
                 </a:solidFill>
@@ -10591,7 +10609,7 @@
               <a:t>, </a:t>
             </a:r>
             <a:r>
-              <a:rPr sz="2000" i="0" b="0">
+              <a:rPr sz="1300" i="0" b="0">
                 <a:solidFill>
                   <a:srgbClr val="D4D4D4"/>
                 </a:solidFill>
@@ -10600,7 +10618,7 @@
               <a:t>idp</a:t>
             </a:r>
             <a:r>
-              <a:rPr sz="2000" i="0" b="0">
+              <a:rPr sz="1300" i="0" b="0">
                 <a:solidFill>
                   <a:srgbClr val="D4D4D4"/>
                 </a:solidFill>
@@ -10609,7 +10627,7 @@
               <a:t>, </a:t>
             </a:r>
             <a:r>
-              <a:rPr sz="2000" i="0" b="0">
+              <a:rPr sz="1300" i="0" b="0">
                 <a:solidFill>
                   <a:srgbClr val="CE9178"/>
                 </a:solidFill>
@@ -10618,7 +10636,7 @@
               <a:t>"Valida identidad"</a:t>
             </a:r>
             <a:r>
-              <a:rPr sz="2000" i="0" b="0">
+              <a:rPr sz="1300" i="0" b="0">
                 <a:solidFill>
                   <a:srgbClr val="D4D4D4"/>
                 </a:solidFill>
@@ -10627,7 +10645,7 @@
               <a:t>, </a:t>
             </a:r>
             <a:r>
-              <a:rPr sz="2000" i="0" b="0">
+              <a:rPr sz="1300" i="0" b="0">
                 <a:solidFill>
                   <a:srgbClr val="CE9178"/>
                 </a:solidFill>
@@ -10636,7 +10654,7 @@
               <a:t>"OIDC/HTTPS"</a:t>
             </a:r>
             <a:r>
-              <a:rPr sz="2000" i="0" b="0">
+              <a:rPr sz="1300" i="0" b="0">
                 <a:solidFill>
                   <a:srgbClr val="D4D4D4"/>
                 </a:solidFill>
@@ -10648,11 +10666,11 @@
           <a:p>
             <a:pPr>
               <a:spcAft>
-                <a:spcPts val="428"/>
+                <a:spcPts val="278"/>
               </a:spcAft>
             </a:pPr>
             <a:r>
-              <a:rPr sz="2000" i="0" b="0">
+              <a:rPr sz="1300" i="0" b="0">
                 <a:solidFill>
                   <a:srgbClr val="DCDCAA"/>
                 </a:solidFill>
@@ -10661,7 +10679,7 @@
               <a:t>Rel</a:t>
             </a:r>
             <a:r>
-              <a:rPr sz="2000" i="0" b="0">
+              <a:rPr sz="1300" i="0" b="0">
                 <a:solidFill>
                   <a:srgbClr val="D4D4D4"/>
                 </a:solidFill>
@@ -10670,7 +10688,7 @@
               <a:t>(</a:t>
             </a:r>
             <a:r>
-              <a:rPr sz="2000" i="0" b="0">
+              <a:rPr sz="1300" i="0" b="0">
                 <a:solidFill>
                   <a:srgbClr val="D4D4D4"/>
                 </a:solidFill>
@@ -10679,7 +10697,7 @@
               <a:t>app</a:t>
             </a:r>
             <a:r>
-              <a:rPr sz="2000" i="0" b="0">
+              <a:rPr sz="1300" i="0" b="0">
                 <a:solidFill>
                   <a:srgbClr val="D4D4D4"/>
                 </a:solidFill>
@@ -10688,7 +10706,7 @@
               <a:t>, </a:t>
             </a:r>
             <a:r>
-              <a:rPr sz="2000" i="0" b="0">
+              <a:rPr sz="1300" i="0" b="0">
                 <a:solidFill>
                   <a:srgbClr val="D4D4D4"/>
                 </a:solidFill>
@@ -10697,7 +10715,7 @@
               <a:t>correo</a:t>
             </a:r>
             <a:r>
-              <a:rPr sz="2000" i="0" b="0">
+              <a:rPr sz="1300" i="0" b="0">
                 <a:solidFill>
                   <a:srgbClr val="D4D4D4"/>
                 </a:solidFill>
@@ -10706,7 +10724,7 @@
               <a:t>, </a:t>
             </a:r>
             <a:r>
-              <a:rPr sz="2000" i="0" b="0">
+              <a:rPr sz="1300" i="0" b="0">
                 <a:solidFill>
                   <a:srgbClr val="CE9178"/>
                 </a:solidFill>
@@ -10715,7 +10733,7 @@
               <a:t>"Pide recordatorio"</a:t>
             </a:r>
             <a:r>
-              <a:rPr sz="2000" i="0" b="0">
+              <a:rPr sz="1300" i="0" b="0">
                 <a:solidFill>
                   <a:srgbClr val="D4D4D4"/>
                 </a:solidFill>
@@ -10724,7 +10742,7 @@
               <a:t>, </a:t>
             </a:r>
             <a:r>
-              <a:rPr sz="2000" i="0" b="0">
+              <a:rPr sz="1300" i="0" b="0">
                 <a:solidFill>
                   <a:srgbClr val="CE9178"/>
                 </a:solidFill>
@@ -10733,7 +10751,7 @@
               <a:t>"REST/HTTPS"</a:t>
             </a:r>
             <a:r>
-              <a:rPr sz="2000" i="0" b="0">
+              <a:rPr sz="1300" i="0" b="0">
                 <a:solidFill>
                   <a:srgbClr val="D4D4D4"/>
                 </a:solidFill>
@@ -10745,11 +10763,11 @@
           <a:p>
             <a:pPr>
               <a:spcAft>
-                <a:spcPts val="428"/>
+                <a:spcPts val="278"/>
               </a:spcAft>
             </a:pPr>
             <a:r>
-              <a:rPr sz="2000" i="0" b="0">
+              <a:rPr sz="1300" i="0" b="0">
                 <a:solidFill>
                   <a:srgbClr val="DCDCAA"/>
                 </a:solidFill>
@@ -10758,7 +10776,7 @@
               <a:t>Rel</a:t>
             </a:r>
             <a:r>
-              <a:rPr sz="2000" i="0" b="0">
+              <a:rPr sz="1300" i="0" b="0">
                 <a:solidFill>
                   <a:srgbClr val="D4D4D4"/>
                 </a:solidFill>
@@ -10767,7 +10785,7 @@
               <a:t>(</a:t>
             </a:r>
             <a:r>
-              <a:rPr sz="2000" i="0" b="0">
+              <a:rPr sz="1300" i="0" b="0">
                 <a:solidFill>
                   <a:srgbClr val="D4D4D4"/>
                 </a:solidFill>
@@ -10776,7 +10794,7 @@
               <a:t>correo</a:t>
             </a:r>
             <a:r>
-              <a:rPr sz="2000" i="0" b="0">
+              <a:rPr sz="1300" i="0" b="0">
                 <a:solidFill>
                   <a:srgbClr val="D4D4D4"/>
                 </a:solidFill>
@@ -10785,7 +10803,7 @@
               <a:t>, </a:t>
             </a:r>
             <a:r>
-              <a:rPr sz="2000" i="0" b="0">
+              <a:rPr sz="1300" i="0" b="0">
                 <a:solidFill>
                   <a:srgbClr val="D4D4D4"/>
                 </a:solidFill>
@@ -10794,7 +10812,7 @@
               <a:t>cliente</a:t>
             </a:r>
             <a:r>
-              <a:rPr sz="2000" i="0" b="0">
+              <a:rPr sz="1300" i="0" b="0">
                 <a:solidFill>
                   <a:srgbClr val="D4D4D4"/>
                 </a:solidFill>
@@ -10803,7 +10821,7 @@
               <a:t>, </a:t>
             </a:r>
             <a:r>
-              <a:rPr sz="2000" i="0" b="0">
+              <a:rPr sz="1300" i="0" b="0">
                 <a:solidFill>
                   <a:srgbClr val="CE9178"/>
                 </a:solidFill>
@@ -10812,7 +10830,7 @@
               <a:t>"Entrega el recordatorio"</a:t>
             </a:r>
             <a:r>
-              <a:rPr sz="2000" i="0" b="0">
+              <a:rPr sz="1300" i="0" b="0">
                 <a:solidFill>
                   <a:srgbClr val="D4D4D4"/>
                 </a:solidFill>
@@ -10821,7 +10839,7 @@
               <a:t>, </a:t>
             </a:r>
             <a:r>
-              <a:rPr sz="2000" i="0" b="0">
+              <a:rPr sz="1300" i="0" b="0">
                 <a:solidFill>
                   <a:srgbClr val="CE9178"/>
                 </a:solidFill>
@@ -10830,7 +10848,7 @@
               <a:t>"SMTP"</a:t>
             </a:r>
             <a:r>
-              <a:rPr sz="2000" i="0" b="0">
+              <a:rPr sz="1300" i="0" b="0">
                 <a:solidFill>
                   <a:srgbClr val="D4D4D4"/>
                 </a:solidFill>
@@ -10843,7 +10861,111 @@
       </p:sp>
       <p:sp>
         <p:nvSpPr>
-          <p:cNvPr id="13" name="TextBox 12"/>
+          <p:cNvPr id="13" name="Rounded Rectangle 12"/>
+          <p:cNvSpPr/>
+          <p:nvPr/>
+        </p:nvSpPr>
+        <p:spPr>
+          <a:xfrm>
+            <a:off x="7668579" y="1261872"/>
+            <a:ext cx="4120780" cy="3318569"/>
+          </a:xfrm>
+          <a:prstGeom prst="roundRect">
+            <a:avLst>
+              <a:gd name="adj" fmla="val 4000"/>
+            </a:avLst>
+          </a:prstGeom>
+          <a:solidFill>
+            <a:srgbClr val="E8EEF4"/>
+          </a:solidFill>
+          <a:ln>
+            <a:noFill/>
+          </a:ln>
+        </p:spPr>
+        <p:style>
+          <a:lnRef idx="1">
+            <a:schemeClr val="accent1"/>
+          </a:lnRef>
+          <a:fillRef idx="3">
+            <a:schemeClr val="accent1"/>
+          </a:fillRef>
+          <a:effectRef idx="2">
+            <a:schemeClr val="accent1"/>
+          </a:effectRef>
+          <a:fontRef idx="minor">
+            <a:schemeClr val="lt1"/>
+          </a:fontRef>
+        </p:style>
+        <p:txBody>
+          <a:bodyPr rtlCol="0" anchor="ctr"/>
+          <a:lstStyle/>
+          <a:p>
+            <a:pPr algn="ctr"/>
+          </a:p>
+        </p:txBody>
+      </p:sp>
+      <p:pic>
+        <p:nvPicPr>
+          <p:cNvPr id="14" name="Picture 13" descr="dg-c4-context-paso1.png"/>
+          <p:cNvPicPr>
+            <a:picLocks noChangeAspect="1"/>
+          </p:cNvPicPr>
+          <p:nvPr/>
+        </p:nvPicPr>
+        <p:blipFill>
+          <a:blip r:embed="rId2"/>
+          <a:stretch>
+            <a:fillRect/>
+          </a:stretch>
+        </p:blipFill>
+        <p:spPr>
+          <a:xfrm>
+            <a:off x="7723443" y="1316736"/>
+            <a:ext cx="4011052" cy="3208841"/>
+          </a:xfrm>
+          <a:prstGeom prst="rect">
+            <a:avLst/>
+          </a:prstGeom>
+        </p:spPr>
+      </p:pic>
+      <p:sp>
+        <p:nvSpPr>
+          <p:cNvPr id="15" name="TextBox 14"/>
+          <p:cNvSpPr txBox="1"/>
+          <p:nvPr/>
+        </p:nvSpPr>
+        <p:spPr>
+          <a:xfrm>
+            <a:off x="7723443" y="4580441"/>
+            <a:ext cx="4011052" cy="320040"/>
+          </a:xfrm>
+          <a:prstGeom prst="rect">
+            <a:avLst/>
+          </a:prstGeom>
+          <a:noFill/>
+        </p:spPr>
+        <p:txBody>
+          <a:bodyPr wrap="square">
+            <a:spAutoFit/>
+          </a:bodyPr>
+          <a:lstStyle/>
+          <a:p>
+            <a:pPr algn="ctr"/>
+            <a:r>
+              <a:rPr sz="1200" b="0" i="1">
+                <a:solidFill>
+                  <a:srgbClr val="666666"/>
+                </a:solidFill>
+                <a:latin typeface="Calibri"/>
+              </a:rPr>
+              <a:t>Lo que dibuja este código</a:t>
+            </a:r>
+          </a:p>
+        </p:txBody>
+      </p:sp>
+      <p:sp>
+        <p:nvSpPr>
+          <p:cNvPr id="16" name="TextBox 15"/>
           <p:cNvSpPr txBox="1"/>
           <p:nvPr/>
         </p:nvSpPr>

</xml_diff>

<commit_message>
Palabras mas sencillas en el material de los cinco cursos y enunciado de Introduccion resumido con el informe como punto clave
Co-Authored-By: Claude Opus 5.5 <noreply@anthropic.com>
</commit_message>
<xml_diff>
--- a/Arquitectura de Sistemas Computacionales/Clases/Clase 1 - Introduccion a arquitecturas cloud/Presentacion.pptx
+++ b/Arquitectura de Sistemas Computacionales/Clases/Clase 1 - Introduccion a arquitecturas cloud/Presentacion.pptx
@@ -555,7 +555,7 @@
           <a:p/>
           <a:p>
             <a:r>
-              <a:t>DOMINIO fija en una linea el problema de negocio elegido (AgendaU, BiblioLite, InventarioLab, TurnosClinica, EventosCampus u otro del mismo tamano); un dominio generico (una red social, una tienda en linea sin mas detalle) hace imposible evaluar las decisiones de las clases siguientes, porque no hay nada concreto que arquitecturar.</a:t>
+              <a:t>DOMINIO fija en una linea el problema de negocio elegido (AgendaU, BiblioLite, InventarioLab, TurnosClinica, EventosCampus u otro del mismo tamano); un dominio generico (una red social, una tienda en linea sin mas detalle) hace imposible evaluar las decisiones de las clases siguientes, porque no hay nada concreto que disenar.</a:t>
             </a:r>
           </a:p>
           <a:p/>
@@ -739,7 +739,7 @@
           <a:p/>
           <a:p>
             <a:r>
-              <a:t>El cambio economico que esto produce es lo relevante para la arquitectura, porque la infraestructura deja de ser una compra que se hace por adelantado y se amortiza a largo plazo, y pasa a ser un gasto operativo que cambia con cada decision de diseno.</a:t>
+              <a:t>El cambio economico que esto produce es lo relevante para la arquitectura, porque la infraestructura deja de ser una compra que se hace por adelantado y su costo se reparte en el tiempo, y pasa a ser un gasto operativo que cambia con cada decision de diseno.</a:t>
             </a:r>
           </a:p>
           <a:p/>

</xml_diff>